<commit_message>
20260804 commit : finished, today_2
</commit_message>
<xml_diff>
--- a/create_notion_img.pptx
+++ b/create_notion_img.pptx
@@ -5058,21 +5058,21 @@
       </p:grpSp>
       <p:grpSp>
         <p:nvGrpSpPr>
-          <p:cNvPr id="3" name="그룹 2"/>
+          <p:cNvPr id="6" name="그룹 5"/>
           <p:cNvGrpSpPr/>
           <p:nvPr/>
         </p:nvGrpSpPr>
         <p:grpSpPr>
           <a:xfrm>
-            <a:off x="6736801" y="-2113175"/>
-            <a:ext cx="3600000" cy="4992617"/>
-            <a:chOff x="6736801" y="-2113175"/>
-            <a:chExt cx="3600000" cy="4992617"/>
+            <a:off x="6985301" y="-2113175"/>
+            <a:ext cx="5400000" cy="4902579"/>
+            <a:chOff x="6985301" y="-2113175"/>
+            <a:chExt cx="5400000" cy="4902579"/>
           </a:xfrm>
         </p:grpSpPr>
         <p:sp>
           <p:nvSpPr>
-            <p:cNvPr id="121" name="직사각형 120"/>
+            <p:cNvPr id="68" name="직사각형 67"/>
             <p:cNvSpPr>
               <a:spLocks noChangeAspect="1"/>
             </p:cNvSpPr>
@@ -5080,7 +5080,53 @@
           </p:nvSpPr>
           <p:spPr>
             <a:xfrm>
-              <a:off x="6736801" y="-529656"/>
+              <a:off x="6985301" y="-561885"/>
+              <a:ext cx="900000" cy="900000"/>
+            </a:xfrm>
+            <a:prstGeom prst="rect">
+              <a:avLst/>
+            </a:prstGeom>
+            <a:noFill/>
+            <a:ln>
+              <a:noFill/>
+            </a:ln>
+          </p:spPr>
+          <p:style>
+            <a:lnRef idx="2">
+              <a:schemeClr val="accent1">
+                <a:shade val="50000"/>
+              </a:schemeClr>
+            </a:lnRef>
+            <a:fillRef idx="1">
+              <a:schemeClr val="accent1"/>
+            </a:fillRef>
+            <a:effectRef idx="0">
+              <a:schemeClr val="accent1"/>
+            </a:effectRef>
+            <a:fontRef idx="minor">
+              <a:schemeClr val="lt1"/>
+            </a:fontRef>
+          </p:style>
+          <p:txBody>
+            <a:bodyPr rtlCol="0" anchor="ctr"/>
+            <a:lstStyle/>
+            <a:p>
+              <a:pPr algn="ctr"/>
+              <a:endParaRPr lang="ko-KR" altLang="en-US"/>
+            </a:p>
+          </p:txBody>
+        </p:sp>
+        <p:sp>
+          <p:nvSpPr>
+            <p:cNvPr id="69" name="직사각형 68"/>
+            <p:cNvSpPr>
+              <a:spLocks noChangeAspect="1"/>
+            </p:cNvSpPr>
+            <p:nvPr/>
+          </p:nvSpPr>
+          <p:spPr>
+            <a:xfrm>
+              <a:off x="7885301" y="-561885"/>
               <a:ext cx="900000" cy="900000"/>
             </a:xfrm>
             <a:prstGeom prst="rect">
@@ -5120,7 +5166,7 @@
         </p:sp>
         <p:sp>
           <p:nvSpPr>
-            <p:cNvPr id="122" name="직사각형 121"/>
+            <p:cNvPr id="70" name="직사각형 69"/>
             <p:cNvSpPr>
               <a:spLocks noChangeAspect="1"/>
             </p:cNvSpPr>
@@ -5128,7 +5174,7 @@
           </p:nvSpPr>
           <p:spPr>
             <a:xfrm>
-              <a:off x="7636801" y="-529656"/>
+              <a:off x="8785301" y="-561885"/>
               <a:ext cx="900000" cy="900000"/>
             </a:xfrm>
             <a:prstGeom prst="rect">
@@ -5168,7 +5214,7 @@
         </p:sp>
         <p:sp>
           <p:nvSpPr>
-            <p:cNvPr id="123" name="직사각형 122"/>
+            <p:cNvPr id="71" name="직사각형 70"/>
             <p:cNvSpPr>
               <a:spLocks noChangeAspect="1"/>
             </p:cNvSpPr>
@@ -5176,7 +5222,7 @@
           </p:nvSpPr>
           <p:spPr>
             <a:xfrm>
-              <a:off x="8536801" y="-529656"/>
+              <a:off x="9685301" y="-561885"/>
               <a:ext cx="900000" cy="900000"/>
             </a:xfrm>
             <a:prstGeom prst="rect">
@@ -5216,7 +5262,7 @@
         </p:sp>
         <p:sp>
           <p:nvSpPr>
-            <p:cNvPr id="124" name="직사각형 123"/>
+            <p:cNvPr id="72" name="직사각형 71"/>
             <p:cNvSpPr>
               <a:spLocks noChangeAspect="1"/>
             </p:cNvSpPr>
@@ -5224,7 +5270,7 @@
           </p:nvSpPr>
           <p:spPr>
             <a:xfrm>
-              <a:off x="9436801" y="-529656"/>
+              <a:off x="10585301" y="-561885"/>
               <a:ext cx="900000" cy="900000"/>
             </a:xfrm>
             <a:prstGeom prst="rect">
@@ -5264,7 +5310,7 @@
         </p:sp>
         <p:sp>
           <p:nvSpPr>
-            <p:cNvPr id="131" name="직사각형 130"/>
+            <p:cNvPr id="73" name="직사각형 72"/>
             <p:cNvSpPr>
               <a:spLocks noChangeAspect="1"/>
             </p:cNvSpPr>
@@ -5272,22 +5318,15 @@
           </p:nvSpPr>
           <p:spPr>
             <a:xfrm>
-              <a:off x="6736801" y="370344"/>
+              <a:off x="11485301" y="-561885"/>
               <a:ext cx="900000" cy="900000"/>
             </a:xfrm>
             <a:prstGeom prst="rect">
               <a:avLst/>
             </a:prstGeom>
-            <a:solidFill>
-              <a:schemeClr val="accent3">
-                <a:lumMod val="20000"/>
-                <a:lumOff val="80000"/>
-              </a:schemeClr>
-            </a:solidFill>
+            <a:noFill/>
             <a:ln>
-              <a:solidFill>
-                <a:schemeClr val="tx1"/>
-              </a:solidFill>
+              <a:noFill/>
             </a:ln>
           </p:spPr>
           <p:style>
@@ -5317,7 +5356,7 @@
         </p:sp>
         <p:sp>
           <p:nvSpPr>
-            <p:cNvPr id="132" name="직사각형 131"/>
+            <p:cNvPr id="74" name="직사각형 73"/>
             <p:cNvSpPr>
               <a:spLocks noChangeAspect="1"/>
             </p:cNvSpPr>
@@ -5325,22 +5364,15 @@
           </p:nvSpPr>
           <p:spPr>
             <a:xfrm>
-              <a:off x="7636801" y="370344"/>
+              <a:off x="6985301" y="338115"/>
               <a:ext cx="900000" cy="900000"/>
             </a:xfrm>
             <a:prstGeom prst="rect">
               <a:avLst/>
             </a:prstGeom>
-            <a:solidFill>
-              <a:schemeClr val="accent3">
-                <a:lumMod val="20000"/>
-                <a:lumOff val="80000"/>
-              </a:schemeClr>
-            </a:solidFill>
+            <a:noFill/>
             <a:ln>
-              <a:solidFill>
-                <a:schemeClr val="tx1"/>
-              </a:solidFill>
+              <a:noFill/>
             </a:ln>
           </p:spPr>
           <p:style>
@@ -5370,7 +5402,7 @@
         </p:sp>
         <p:sp>
           <p:nvSpPr>
-            <p:cNvPr id="133" name="직사각형 132"/>
+            <p:cNvPr id="75" name="직사각형 74"/>
             <p:cNvSpPr>
               <a:spLocks noChangeAspect="1"/>
             </p:cNvSpPr>
@@ -5378,7 +5410,7 @@
           </p:nvSpPr>
           <p:spPr>
             <a:xfrm>
-              <a:off x="8536801" y="370344"/>
+              <a:off x="7885301" y="338115"/>
               <a:ext cx="900000" cy="900000"/>
             </a:xfrm>
             <a:prstGeom prst="rect">
@@ -5423,7 +5455,7 @@
         </p:sp>
         <p:sp>
           <p:nvSpPr>
-            <p:cNvPr id="134" name="직사각형 133"/>
+            <p:cNvPr id="76" name="직사각형 75"/>
             <p:cNvSpPr>
               <a:spLocks noChangeAspect="1"/>
             </p:cNvSpPr>
@@ -5431,7 +5463,7 @@
           </p:nvSpPr>
           <p:spPr>
             <a:xfrm>
-              <a:off x="9436801" y="370344"/>
+              <a:off x="8785301" y="338115"/>
               <a:ext cx="900000" cy="900000"/>
             </a:xfrm>
             <a:prstGeom prst="rect">
@@ -5476,18 +5508,31 @@
         </p:sp>
         <p:sp>
           <p:nvSpPr>
-            <p:cNvPr id="46" name="아래쪽 화살표 45"/>
-            <p:cNvSpPr/>
+            <p:cNvPr id="77" name="직사각형 76"/>
+            <p:cNvSpPr>
+              <a:spLocks noChangeAspect="1"/>
+            </p:cNvSpPr>
             <p:nvPr/>
           </p:nvSpPr>
           <p:spPr>
             <a:xfrm>
-              <a:off x="8320801" y="-1528400"/>
-              <a:ext cx="432000" cy="720000"/>
+              <a:off x="9685301" y="338115"/>
+              <a:ext cx="900000" cy="900000"/>
             </a:xfrm>
-            <a:prstGeom prst="downArrow">
+            <a:prstGeom prst="rect">
               <a:avLst/>
             </a:prstGeom>
+            <a:solidFill>
+              <a:schemeClr val="accent3">
+                <a:lumMod val="20000"/>
+                <a:lumOff val="80000"/>
+              </a:schemeClr>
+            </a:solidFill>
+            <a:ln>
+              <a:solidFill>
+                <a:schemeClr val="tx1"/>
+              </a:solidFill>
+            </a:ln>
           </p:spPr>
           <p:style>
             <a:lnRef idx="2">
@@ -5516,13 +5561,192 @@
         </p:sp>
         <p:sp>
           <p:nvSpPr>
-            <p:cNvPr id="47" name="TextBox 46"/>
+            <p:cNvPr id="78" name="직사각형 77"/>
+            <p:cNvSpPr>
+              <a:spLocks noChangeAspect="1"/>
+            </p:cNvSpPr>
+            <p:nvPr/>
+          </p:nvSpPr>
+          <p:spPr>
+            <a:xfrm>
+              <a:off x="10585301" y="338115"/>
+              <a:ext cx="900000" cy="900000"/>
+            </a:xfrm>
+            <a:prstGeom prst="rect">
+              <a:avLst/>
+            </a:prstGeom>
+            <a:solidFill>
+              <a:schemeClr val="accent3">
+                <a:lumMod val="20000"/>
+                <a:lumOff val="80000"/>
+              </a:schemeClr>
+            </a:solidFill>
+            <a:ln>
+              <a:solidFill>
+                <a:schemeClr val="tx1"/>
+              </a:solidFill>
+            </a:ln>
+          </p:spPr>
+          <p:style>
+            <a:lnRef idx="2">
+              <a:schemeClr val="accent1">
+                <a:shade val="50000"/>
+              </a:schemeClr>
+            </a:lnRef>
+            <a:fillRef idx="1">
+              <a:schemeClr val="accent1"/>
+            </a:fillRef>
+            <a:effectRef idx="0">
+              <a:schemeClr val="accent1"/>
+            </a:effectRef>
+            <a:fontRef idx="minor">
+              <a:schemeClr val="lt1"/>
+            </a:fontRef>
+          </p:style>
+          <p:txBody>
+            <a:bodyPr rtlCol="0" anchor="ctr"/>
+            <a:lstStyle/>
+            <a:p>
+              <a:pPr algn="ctr"/>
+              <a:endParaRPr lang="ko-KR" altLang="en-US"/>
+            </a:p>
+          </p:txBody>
+        </p:sp>
+        <p:sp>
+          <p:nvSpPr>
+            <p:cNvPr id="79" name="직사각형 78"/>
+            <p:cNvSpPr>
+              <a:spLocks noChangeAspect="1"/>
+            </p:cNvSpPr>
+            <p:nvPr/>
+          </p:nvSpPr>
+          <p:spPr>
+            <a:xfrm>
+              <a:off x="11485301" y="338115"/>
+              <a:ext cx="900000" cy="900000"/>
+            </a:xfrm>
+            <a:prstGeom prst="rect">
+              <a:avLst/>
+            </a:prstGeom>
+            <a:noFill/>
+            <a:ln>
+              <a:noFill/>
+            </a:ln>
+          </p:spPr>
+          <p:style>
+            <a:lnRef idx="2">
+              <a:schemeClr val="accent1">
+                <a:shade val="50000"/>
+              </a:schemeClr>
+            </a:lnRef>
+            <a:fillRef idx="1">
+              <a:schemeClr val="accent1"/>
+            </a:fillRef>
+            <a:effectRef idx="0">
+              <a:schemeClr val="accent1"/>
+            </a:effectRef>
+            <a:fontRef idx="minor">
+              <a:schemeClr val="lt1"/>
+            </a:fontRef>
+          </p:style>
+          <p:txBody>
+            <a:bodyPr rtlCol="0" anchor="ctr"/>
+            <a:lstStyle/>
+            <a:p>
+              <a:pPr algn="ctr"/>
+              <a:endParaRPr lang="ko-KR" altLang="en-US"/>
+            </a:p>
+          </p:txBody>
+        </p:sp>
+        <p:sp>
+          <p:nvSpPr>
+            <p:cNvPr id="80" name="아래쪽 화살표 79"/>
+            <p:cNvSpPr/>
+            <p:nvPr/>
+          </p:nvSpPr>
+          <p:spPr>
+            <a:xfrm>
+              <a:off x="9449744" y="-1528399"/>
+              <a:ext cx="432000" cy="720000"/>
+            </a:xfrm>
+            <a:prstGeom prst="downArrow">
+              <a:avLst/>
+            </a:prstGeom>
+          </p:spPr>
+          <p:style>
+            <a:lnRef idx="2">
+              <a:schemeClr val="accent1">
+                <a:shade val="50000"/>
+              </a:schemeClr>
+            </a:lnRef>
+            <a:fillRef idx="1">
+              <a:schemeClr val="accent1"/>
+            </a:fillRef>
+            <a:effectRef idx="0">
+              <a:schemeClr val="accent1"/>
+            </a:effectRef>
+            <a:fontRef idx="minor">
+              <a:schemeClr val="lt1"/>
+            </a:fontRef>
+          </p:style>
+          <p:txBody>
+            <a:bodyPr rtlCol="0" anchor="ctr"/>
+            <a:lstStyle/>
+            <a:p>
+              <a:pPr algn="ctr"/>
+              <a:endParaRPr lang="ko-KR" altLang="en-US"/>
+            </a:p>
+          </p:txBody>
+        </p:sp>
+        <p:sp>
+          <p:nvSpPr>
+            <p:cNvPr id="81" name="아래쪽 화살표 80"/>
+            <p:cNvSpPr/>
+            <p:nvPr/>
+          </p:nvSpPr>
+          <p:spPr>
+            <a:xfrm rot="10800000">
+              <a:off x="9449745" y="1484629"/>
+              <a:ext cx="432000" cy="720000"/>
+            </a:xfrm>
+            <a:prstGeom prst="downArrow">
+              <a:avLst/>
+            </a:prstGeom>
+          </p:spPr>
+          <p:style>
+            <a:lnRef idx="2">
+              <a:schemeClr val="accent1">
+                <a:shade val="50000"/>
+              </a:schemeClr>
+            </a:lnRef>
+            <a:fillRef idx="1">
+              <a:schemeClr val="accent1"/>
+            </a:fillRef>
+            <a:effectRef idx="0">
+              <a:schemeClr val="accent1"/>
+            </a:effectRef>
+            <a:fontRef idx="minor">
+              <a:schemeClr val="lt1"/>
+            </a:fontRef>
+          </p:style>
+          <p:txBody>
+            <a:bodyPr rtlCol="0" anchor="ctr"/>
+            <a:lstStyle/>
+            <a:p>
+              <a:pPr algn="ctr"/>
+              <a:endParaRPr lang="ko-KR" altLang="en-US"/>
+            </a:p>
+          </p:txBody>
+        </p:sp>
+        <p:sp>
+          <p:nvSpPr>
+            <p:cNvPr id="82" name="TextBox 81"/>
             <p:cNvSpPr txBox="1"/>
             <p:nvPr/>
           </p:nvSpPr>
           <p:spPr>
             <a:xfrm>
-              <a:off x="8034099" y="-2113175"/>
+              <a:off x="9163042" y="-2113175"/>
               <a:ext cx="1005403" cy="584775"/>
             </a:xfrm>
             <a:prstGeom prst="rect">
@@ -5547,53 +5771,13 @@
         </p:sp>
         <p:sp>
           <p:nvSpPr>
-            <p:cNvPr id="58" name="아래쪽 화살표 57"/>
-            <p:cNvSpPr/>
-            <p:nvPr/>
-          </p:nvSpPr>
-          <p:spPr>
-            <a:xfrm rot="10800000">
-              <a:off x="8319244" y="1578728"/>
-              <a:ext cx="432000" cy="720000"/>
-            </a:xfrm>
-            <a:prstGeom prst="downArrow">
-              <a:avLst/>
-            </a:prstGeom>
-          </p:spPr>
-          <p:style>
-            <a:lnRef idx="2">
-              <a:schemeClr val="accent1">
-                <a:shade val="50000"/>
-              </a:schemeClr>
-            </a:lnRef>
-            <a:fillRef idx="1">
-              <a:schemeClr val="accent1"/>
-            </a:fillRef>
-            <a:effectRef idx="0">
-              <a:schemeClr val="accent1"/>
-            </a:effectRef>
-            <a:fontRef idx="minor">
-              <a:schemeClr val="lt1"/>
-            </a:fontRef>
-          </p:style>
-          <p:txBody>
-            <a:bodyPr rtlCol="0" anchor="ctr"/>
-            <a:lstStyle/>
-            <a:p>
-              <a:pPr algn="ctr"/>
-              <a:endParaRPr lang="ko-KR" altLang="en-US"/>
-            </a:p>
-          </p:txBody>
-        </p:sp>
-        <p:sp>
-          <p:nvSpPr>
-            <p:cNvPr id="64" name="TextBox 63"/>
+            <p:cNvPr id="83" name="TextBox 82"/>
             <p:cNvSpPr txBox="1"/>
             <p:nvPr/>
           </p:nvSpPr>
           <p:spPr>
             <a:xfrm>
-              <a:off x="7139669" y="2294667"/>
+              <a:off x="8270168" y="2204629"/>
               <a:ext cx="2791149" cy="584775"/>
             </a:xfrm>
             <a:prstGeom prst="rect">

</xml_diff>

<commit_message>
20260805 commit : finished, today
</commit_message>
<xml_diff>
--- a/create_notion_img.pptx
+++ b/create_notion_img.pptx
@@ -243,7 +243,7 @@
           <a:p>
             <a:fld id="{7237CE1A-8831-48B5-BA93-72483C6E34E8}" type="datetimeFigureOut">
               <a:rPr lang="ko-KR" altLang="en-US" smtClean="0"/>
-              <a:t>2026-08-05</a:t>
+              <a:t>26-08-05(Wed)</a:t>
             </a:fld>
             <a:endParaRPr lang="ko-KR" altLang="en-US"/>
           </a:p>
@@ -413,7 +413,7 @@
           <a:p>
             <a:fld id="{7237CE1A-8831-48B5-BA93-72483C6E34E8}" type="datetimeFigureOut">
               <a:rPr lang="ko-KR" altLang="en-US" smtClean="0"/>
-              <a:t>2026-08-05</a:t>
+              <a:t>26-08-05(Wed)</a:t>
             </a:fld>
             <a:endParaRPr lang="ko-KR" altLang="en-US"/>
           </a:p>
@@ -593,7 +593,7 @@
           <a:p>
             <a:fld id="{7237CE1A-8831-48B5-BA93-72483C6E34E8}" type="datetimeFigureOut">
               <a:rPr lang="ko-KR" altLang="en-US" smtClean="0"/>
-              <a:t>2026-08-05</a:t>
+              <a:t>26-08-05(Wed)</a:t>
             </a:fld>
             <a:endParaRPr lang="ko-KR" altLang="en-US"/>
           </a:p>
@@ -763,7 +763,7 @@
           <a:p>
             <a:fld id="{7237CE1A-8831-48B5-BA93-72483C6E34E8}" type="datetimeFigureOut">
               <a:rPr lang="ko-KR" altLang="en-US" smtClean="0"/>
-              <a:t>2026-08-05</a:t>
+              <a:t>26-08-05(Wed)</a:t>
             </a:fld>
             <a:endParaRPr lang="ko-KR" altLang="en-US"/>
           </a:p>
@@ -1009,7 +1009,7 @@
           <a:p>
             <a:fld id="{7237CE1A-8831-48B5-BA93-72483C6E34E8}" type="datetimeFigureOut">
               <a:rPr lang="ko-KR" altLang="en-US" smtClean="0"/>
-              <a:t>2026-08-05</a:t>
+              <a:t>26-08-05(Wed)</a:t>
             </a:fld>
             <a:endParaRPr lang="ko-KR" altLang="en-US"/>
           </a:p>
@@ -1241,7 +1241,7 @@
           <a:p>
             <a:fld id="{7237CE1A-8831-48B5-BA93-72483C6E34E8}" type="datetimeFigureOut">
               <a:rPr lang="ko-KR" altLang="en-US" smtClean="0"/>
-              <a:t>2026-08-05</a:t>
+              <a:t>26-08-05(Wed)</a:t>
             </a:fld>
             <a:endParaRPr lang="ko-KR" altLang="en-US"/>
           </a:p>
@@ -1608,7 +1608,7 @@
           <a:p>
             <a:fld id="{7237CE1A-8831-48B5-BA93-72483C6E34E8}" type="datetimeFigureOut">
               <a:rPr lang="ko-KR" altLang="en-US" smtClean="0"/>
-              <a:t>2026-08-05</a:t>
+              <a:t>26-08-05(Wed)</a:t>
             </a:fld>
             <a:endParaRPr lang="ko-KR" altLang="en-US"/>
           </a:p>
@@ -1726,7 +1726,7 @@
           <a:p>
             <a:fld id="{7237CE1A-8831-48B5-BA93-72483C6E34E8}" type="datetimeFigureOut">
               <a:rPr lang="ko-KR" altLang="en-US" smtClean="0"/>
-              <a:t>2026-08-05</a:t>
+              <a:t>26-08-05(Wed)</a:t>
             </a:fld>
             <a:endParaRPr lang="ko-KR" altLang="en-US"/>
           </a:p>
@@ -1821,7 +1821,7 @@
           <a:p>
             <a:fld id="{7237CE1A-8831-48B5-BA93-72483C6E34E8}" type="datetimeFigureOut">
               <a:rPr lang="ko-KR" altLang="en-US" smtClean="0"/>
-              <a:t>2026-08-05</a:t>
+              <a:t>26-08-05(Wed)</a:t>
             </a:fld>
             <a:endParaRPr lang="ko-KR" altLang="en-US"/>
           </a:p>
@@ -2098,7 +2098,7 @@
           <a:p>
             <a:fld id="{7237CE1A-8831-48B5-BA93-72483C6E34E8}" type="datetimeFigureOut">
               <a:rPr lang="ko-KR" altLang="en-US" smtClean="0"/>
-              <a:t>2026-08-05</a:t>
+              <a:t>26-08-05(Wed)</a:t>
             </a:fld>
             <a:endParaRPr lang="ko-KR" altLang="en-US"/>
           </a:p>
@@ -2351,7 +2351,7 @@
           <a:p>
             <a:fld id="{7237CE1A-8831-48B5-BA93-72483C6E34E8}" type="datetimeFigureOut">
               <a:rPr lang="ko-KR" altLang="en-US" smtClean="0"/>
-              <a:t>2026-08-05</a:t>
+              <a:t>26-08-05(Wed)</a:t>
             </a:fld>
             <a:endParaRPr lang="ko-KR" altLang="en-US"/>
           </a:p>
@@ -2564,7 +2564,7 @@
           <a:p>
             <a:fld id="{7237CE1A-8831-48B5-BA93-72483C6E34E8}" type="datetimeFigureOut">
               <a:rPr lang="ko-KR" altLang="en-US" smtClean="0"/>
-              <a:t>2026-08-05</a:t>
+              <a:t>26-08-05(Wed)</a:t>
             </a:fld>
             <a:endParaRPr lang="ko-KR" altLang="en-US"/>
           </a:p>
@@ -2971,64 +2971,126 @@
       </p:grpSpPr>
       <p:grpSp>
         <p:nvGrpSpPr>
-          <p:cNvPr id="5" name="그룹 4"/>
+          <p:cNvPr id="16" name="그룹 15"/>
           <p:cNvGrpSpPr/>
           <p:nvPr/>
         </p:nvGrpSpPr>
         <p:grpSpPr>
           <a:xfrm>
-            <a:off x="0" y="1310472"/>
-            <a:ext cx="12192000" cy="4237055"/>
-            <a:chOff x="0" y="1310472"/>
-            <a:chExt cx="12192000" cy="4237055"/>
+            <a:off x="4138862" y="425880"/>
+            <a:ext cx="5195653" cy="3489652"/>
+            <a:chOff x="4138862" y="425880"/>
+            <a:chExt cx="5195653" cy="3489652"/>
           </a:xfrm>
         </p:grpSpPr>
-        <p:pic>
-          <p:nvPicPr>
-            <p:cNvPr id="2" name="그림 1"/>
-            <p:cNvPicPr>
-              <a:picLocks noChangeAspect="1"/>
-            </p:cNvPicPr>
+        <p:sp>
+          <p:nvSpPr>
+            <p:cNvPr id="6" name="TextBox 5"/>
+            <p:cNvSpPr txBox="1"/>
             <p:nvPr/>
-          </p:nvPicPr>
-          <p:blipFill>
-            <a:blip r:embed="rId2">
-              <a:extLst>
-                <a:ext uri="{28A0092B-C50C-407E-A947-70E740481C1C}">
-                  <a14:useLocalDpi xmlns:a14="http://schemas.microsoft.com/office/drawing/2010/main" val="0"/>
-                </a:ext>
-              </a:extLst>
-            </a:blip>
-            <a:stretch>
-              <a:fillRect/>
-            </a:stretch>
-          </p:blipFill>
+          </p:nvSpPr>
           <p:spPr>
             <a:xfrm>
-              <a:off x="0" y="1310472"/>
-              <a:ext cx="12192000" cy="4237055"/>
+              <a:off x="4138862" y="1792706"/>
+              <a:ext cx="5195653" cy="1015663"/>
             </a:xfrm>
             <a:prstGeom prst="rect">
               <a:avLst/>
             </a:prstGeom>
+            <a:noFill/>
           </p:spPr>
-        </p:pic>
+          <p:txBody>
+            <a:bodyPr wrap="none" rtlCol="0">
+              <a:spAutoFit/>
+            </a:bodyPr>
+            <a:lstStyle/>
+            <a:p>
+              <a:pPr algn="ctr"/>
+              <a:r>
+                <a:rPr lang="en-US" altLang="ko-KR" sz="6000" dirty="0">
+                  <a:latin typeface="나눔스퀘어 Bold" panose="020B0600000101010101" pitchFamily="50" charset="-127"/>
+                  <a:ea typeface="나눔스퀘어 Bold" panose="020B0600000101010101" pitchFamily="50" charset="-127"/>
+                </a:rPr>
+                <a:t>n</a:t>
+              </a:r>
+              <a:r>
+                <a:rPr lang="en-US" altLang="ko-KR" sz="6000" dirty="0" smtClean="0">
+                  <a:latin typeface="나눔스퀘어 Bold" panose="020B0600000101010101" pitchFamily="50" charset="-127"/>
+                  <a:ea typeface="나눔스퀘어 Bold" panose="020B0600000101010101" pitchFamily="50" charset="-127"/>
+                </a:rPr>
+                <a:t>um1 + num2</a:t>
+              </a:r>
+              <a:endParaRPr lang="ko-KR" altLang="en-US" sz="6000" dirty="0">
+                <a:latin typeface="나눔스퀘어 Bold" panose="020B0600000101010101" pitchFamily="50" charset="-127"/>
+                <a:ea typeface="나눔스퀘어 Bold" panose="020B0600000101010101" pitchFamily="50" charset="-127"/>
+              </a:endParaRPr>
+            </a:p>
+          </p:txBody>
+        </p:sp>
         <p:sp>
           <p:nvSpPr>
-            <p:cNvPr id="3" name="직사각형 2"/>
+            <p:cNvPr id="7" name="직사각형 6"/>
             <p:cNvSpPr/>
             <p:nvPr/>
           </p:nvSpPr>
           <p:spPr>
             <a:xfrm>
-              <a:off x="10039350" y="5071277"/>
-              <a:ext cx="2038350" cy="476250"/>
+              <a:off x="4216689" y="1792706"/>
+              <a:ext cx="5040000" cy="36000"/>
             </a:xfrm>
             <a:prstGeom prst="rect">
               <a:avLst/>
             </a:prstGeom>
             <a:solidFill>
-              <a:srgbClr val="FFFFFF"/>
+              <a:schemeClr val="tx1"/>
+            </a:solidFill>
+            <a:ln>
+              <a:solidFill>
+                <a:schemeClr val="tx1"/>
+              </a:solidFill>
+            </a:ln>
+          </p:spPr>
+          <p:style>
+            <a:lnRef idx="2">
+              <a:schemeClr val="accent1">
+                <a:shade val="50000"/>
+              </a:schemeClr>
+            </a:lnRef>
+            <a:fillRef idx="1">
+              <a:schemeClr val="accent1"/>
+            </a:fillRef>
+            <a:effectRef idx="0">
+              <a:schemeClr val="accent1"/>
+            </a:effectRef>
+            <a:fontRef idx="minor">
+              <a:schemeClr val="lt1"/>
+            </a:fontRef>
+          </p:style>
+          <p:txBody>
+            <a:bodyPr rtlCol="0" anchor="ctr"/>
+            <a:lstStyle/>
+            <a:p>
+              <a:pPr algn="ctr"/>
+              <a:endParaRPr lang="ko-KR" altLang="en-US"/>
+            </a:p>
+          </p:txBody>
+        </p:sp>
+        <p:sp>
+          <p:nvSpPr>
+            <p:cNvPr id="8" name="아래쪽 화살표 7"/>
+            <p:cNvSpPr/>
+            <p:nvPr/>
+          </p:nvSpPr>
+          <p:spPr>
+            <a:xfrm>
+              <a:off x="6519692" y="887545"/>
+              <a:ext cx="432000" cy="720000"/>
+            </a:xfrm>
+            <a:prstGeom prst="downArrow">
+              <a:avLst/>
+            </a:prstGeom>
+            <a:solidFill>
+              <a:schemeClr val="accent2"/>
             </a:solidFill>
             <a:ln>
               <a:noFill/>
@@ -3061,14 +3123,152 @@
         </p:sp>
         <p:sp>
           <p:nvSpPr>
-            <p:cNvPr id="4" name="TextBox 3"/>
+            <p:cNvPr id="9" name="아래쪽 화살표 8"/>
+            <p:cNvSpPr/>
+            <p:nvPr/>
+          </p:nvSpPr>
+          <p:spPr>
+            <a:xfrm rot="10800000">
+              <a:off x="6520688" y="2733867"/>
+              <a:ext cx="432000" cy="720000"/>
+            </a:xfrm>
+            <a:prstGeom prst="downArrow">
+              <a:avLst/>
+            </a:prstGeom>
+            <a:solidFill>
+              <a:schemeClr val="accent2"/>
+            </a:solidFill>
+            <a:ln>
+              <a:noFill/>
+            </a:ln>
+          </p:spPr>
+          <p:style>
+            <a:lnRef idx="2">
+              <a:schemeClr val="accent1">
+                <a:shade val="50000"/>
+              </a:schemeClr>
+            </a:lnRef>
+            <a:fillRef idx="1">
+              <a:schemeClr val="accent1"/>
+            </a:fillRef>
+            <a:effectRef idx="0">
+              <a:schemeClr val="accent1"/>
+            </a:effectRef>
+            <a:fontRef idx="minor">
+              <a:schemeClr val="lt1"/>
+            </a:fontRef>
+          </p:style>
+          <p:txBody>
+            <a:bodyPr rtlCol="0" anchor="ctr"/>
+            <a:lstStyle/>
+            <a:p>
+              <a:pPr algn="ctr"/>
+              <a:endParaRPr lang="ko-KR" altLang="en-US"/>
+            </a:p>
+          </p:txBody>
+        </p:sp>
+        <p:sp>
+          <p:nvSpPr>
+            <p:cNvPr id="10" name="아래쪽 화살표 9"/>
+            <p:cNvSpPr/>
+            <p:nvPr/>
+          </p:nvSpPr>
+          <p:spPr>
+            <a:xfrm rot="10800000">
+              <a:off x="5094035" y="2733867"/>
+              <a:ext cx="432000" cy="720000"/>
+            </a:xfrm>
+            <a:prstGeom prst="downArrow">
+              <a:avLst/>
+            </a:prstGeom>
+            <a:solidFill>
+              <a:schemeClr val="accent2"/>
+            </a:solidFill>
+            <a:ln>
+              <a:noFill/>
+            </a:ln>
+          </p:spPr>
+          <p:style>
+            <a:lnRef idx="2">
+              <a:schemeClr val="accent1">
+                <a:shade val="50000"/>
+              </a:schemeClr>
+            </a:lnRef>
+            <a:fillRef idx="1">
+              <a:schemeClr val="accent1"/>
+            </a:fillRef>
+            <a:effectRef idx="0">
+              <a:schemeClr val="accent1"/>
+            </a:effectRef>
+            <a:fontRef idx="minor">
+              <a:schemeClr val="lt1"/>
+            </a:fontRef>
+          </p:style>
+          <p:txBody>
+            <a:bodyPr rtlCol="0" anchor="ctr"/>
+            <a:lstStyle/>
+            <a:p>
+              <a:pPr algn="ctr"/>
+              <a:endParaRPr lang="ko-KR" altLang="en-US"/>
+            </a:p>
+          </p:txBody>
+        </p:sp>
+        <p:sp>
+          <p:nvSpPr>
+            <p:cNvPr id="11" name="아래쪽 화살표 10"/>
+            <p:cNvSpPr/>
+            <p:nvPr/>
+          </p:nvSpPr>
+          <p:spPr>
+            <a:xfrm rot="10800000">
+              <a:off x="7947341" y="2733867"/>
+              <a:ext cx="432000" cy="720000"/>
+            </a:xfrm>
+            <a:prstGeom prst="downArrow">
+              <a:avLst/>
+            </a:prstGeom>
+            <a:solidFill>
+              <a:schemeClr val="accent2"/>
+            </a:solidFill>
+            <a:ln>
+              <a:noFill/>
+            </a:ln>
+          </p:spPr>
+          <p:style>
+            <a:lnRef idx="2">
+              <a:schemeClr val="accent1">
+                <a:shade val="50000"/>
+              </a:schemeClr>
+            </a:lnRef>
+            <a:fillRef idx="1">
+              <a:schemeClr val="accent1"/>
+            </a:fillRef>
+            <a:effectRef idx="0">
+              <a:schemeClr val="accent1"/>
+            </a:effectRef>
+            <a:fontRef idx="minor">
+              <a:schemeClr val="lt1"/>
+            </a:fontRef>
+          </p:style>
+          <p:txBody>
+            <a:bodyPr rtlCol="0" anchor="ctr"/>
+            <a:lstStyle/>
+            <a:p>
+              <a:pPr algn="ctr"/>
+              <a:endParaRPr lang="ko-KR" altLang="en-US"/>
+            </a:p>
+          </p:txBody>
+        </p:sp>
+        <p:sp>
+          <p:nvSpPr>
+            <p:cNvPr id="12" name="TextBox 11"/>
             <p:cNvSpPr txBox="1"/>
             <p:nvPr/>
           </p:nvSpPr>
           <p:spPr>
             <a:xfrm>
-              <a:off x="10583503" y="4933950"/>
-              <a:ext cx="1026243" cy="461665"/>
+              <a:off x="6222570" y="425880"/>
+              <a:ext cx="1026242" cy="461665"/>
             </a:xfrm>
             <a:prstGeom prst="rect">
               <a:avLst/>
@@ -3081,12 +3281,124 @@
             </a:bodyPr>
             <a:lstStyle/>
             <a:p>
+              <a:pPr algn="ctr"/>
               <a:r>
                 <a:rPr lang="ko-KR" altLang="en-US" sz="2400" dirty="0" err="1" smtClean="0">
                   <a:latin typeface="나눔스퀘어 Bold" panose="020B0600000101010101" pitchFamily="50" charset="-127"/>
                   <a:ea typeface="나눔스퀘어 Bold" panose="020B0600000101010101" pitchFamily="50" charset="-127"/>
                 </a:rPr>
-                <a:t>리터럴</a:t>
+                <a:t>연산식</a:t>
+              </a:r>
+              <a:endParaRPr lang="ko-KR" altLang="en-US" sz="2400" dirty="0">
+                <a:latin typeface="나눔스퀘어 Bold" panose="020B0600000101010101" pitchFamily="50" charset="-127"/>
+                <a:ea typeface="나눔스퀘어 Bold" panose="020B0600000101010101" pitchFamily="50" charset="-127"/>
+              </a:endParaRPr>
+            </a:p>
+          </p:txBody>
+        </p:sp>
+        <p:sp>
+          <p:nvSpPr>
+            <p:cNvPr id="13" name="TextBox 12"/>
+            <p:cNvSpPr txBox="1"/>
+            <p:nvPr/>
+          </p:nvSpPr>
+          <p:spPr>
+            <a:xfrm>
+              <a:off x="6222570" y="3453867"/>
+              <a:ext cx="1026242" cy="461665"/>
+            </a:xfrm>
+            <a:prstGeom prst="rect">
+              <a:avLst/>
+            </a:prstGeom>
+            <a:noFill/>
+          </p:spPr>
+          <p:txBody>
+            <a:bodyPr wrap="none" rtlCol="0">
+              <a:spAutoFit/>
+            </a:bodyPr>
+            <a:lstStyle/>
+            <a:p>
+              <a:pPr algn="ctr"/>
+              <a:r>
+                <a:rPr lang="ko-KR" altLang="en-US" sz="2400" smtClean="0">
+                  <a:latin typeface="나눔스퀘어 Bold" panose="020B0600000101010101" pitchFamily="50" charset="-127"/>
+                  <a:ea typeface="나눔스퀘어 Bold" panose="020B0600000101010101" pitchFamily="50" charset="-127"/>
+                </a:rPr>
+                <a:t>연산자</a:t>
+              </a:r>
+              <a:endParaRPr lang="ko-KR" altLang="en-US" sz="2400" dirty="0">
+                <a:latin typeface="나눔스퀘어 Bold" panose="020B0600000101010101" pitchFamily="50" charset="-127"/>
+                <a:ea typeface="나눔스퀘어 Bold" panose="020B0600000101010101" pitchFamily="50" charset="-127"/>
+              </a:endParaRPr>
+            </a:p>
+          </p:txBody>
+        </p:sp>
+        <p:sp>
+          <p:nvSpPr>
+            <p:cNvPr id="14" name="TextBox 13"/>
+            <p:cNvSpPr txBox="1"/>
+            <p:nvPr/>
+          </p:nvSpPr>
+          <p:spPr>
+            <a:xfrm>
+              <a:off x="4654658" y="3453867"/>
+              <a:ext cx="1306768" cy="461665"/>
+            </a:xfrm>
+            <a:prstGeom prst="rect">
+              <a:avLst/>
+            </a:prstGeom>
+            <a:noFill/>
+          </p:spPr>
+          <p:txBody>
+            <a:bodyPr wrap="none" rtlCol="0">
+              <a:spAutoFit/>
+            </a:bodyPr>
+            <a:lstStyle/>
+            <a:p>
+              <a:pPr algn="ctr"/>
+              <a:r>
+                <a:rPr lang="ko-KR" altLang="en-US" sz="2400" dirty="0" err="1" smtClean="0">
+                  <a:latin typeface="나눔스퀘어 Bold" panose="020B0600000101010101" pitchFamily="50" charset="-127"/>
+                  <a:ea typeface="나눔스퀘어 Bold" panose="020B0600000101010101" pitchFamily="50" charset="-127"/>
+                </a:rPr>
+                <a:t>피연산자</a:t>
+              </a:r>
+              <a:endParaRPr lang="ko-KR" altLang="en-US" sz="2400" dirty="0">
+                <a:latin typeface="나눔스퀘어 Bold" panose="020B0600000101010101" pitchFamily="50" charset="-127"/>
+                <a:ea typeface="나눔스퀘어 Bold" panose="020B0600000101010101" pitchFamily="50" charset="-127"/>
+              </a:endParaRPr>
+            </a:p>
+          </p:txBody>
+        </p:sp>
+        <p:sp>
+          <p:nvSpPr>
+            <p:cNvPr id="15" name="TextBox 14"/>
+            <p:cNvSpPr txBox="1"/>
+            <p:nvPr/>
+          </p:nvSpPr>
+          <p:spPr>
+            <a:xfrm>
+              <a:off x="7509957" y="3453867"/>
+              <a:ext cx="1306768" cy="461665"/>
+            </a:xfrm>
+            <a:prstGeom prst="rect">
+              <a:avLst/>
+            </a:prstGeom>
+            <a:noFill/>
+          </p:spPr>
+          <p:txBody>
+            <a:bodyPr wrap="none" rtlCol="0">
+              <a:spAutoFit/>
+            </a:bodyPr>
+            <a:lstStyle/>
+            <a:p>
+              <a:pPr algn="ctr"/>
+              <a:r>
+                <a:rPr lang="ko-KR" altLang="en-US" sz="2400" dirty="0" err="1" smtClean="0">
+                  <a:latin typeface="나눔스퀘어 Bold" panose="020B0600000101010101" pitchFamily="50" charset="-127"/>
+                  <a:ea typeface="나눔스퀘어 Bold" panose="020B0600000101010101" pitchFamily="50" charset="-127"/>
+                </a:rPr>
+                <a:t>피연산자</a:t>
               </a:r>
               <a:endParaRPr lang="ko-KR" altLang="en-US" sz="2400" dirty="0">
                 <a:latin typeface="나눔스퀘어 Bold" panose="020B0600000101010101" pitchFamily="50" charset="-127"/>

</xml_diff>

<commit_message>
20260806 commit : tomorrow, plus, create image2
</commit_message>
<xml_diff>
--- a/create_notion_img.pptx
+++ b/create_notion_img.pptx
@@ -7,6 +7,7 @@
   <p:sldIdLst>
     <p:sldId id="256" r:id="rId2"/>
     <p:sldId id="257" r:id="rId3"/>
+    <p:sldId id="258" r:id="rId4"/>
   </p:sldIdLst>
   <p:sldSz cx="12192000" cy="6858000"/>
   <p:notesSz cx="6858000" cy="9144000"/>
@@ -244,7 +245,7 @@
           <a:p>
             <a:fld id="{7237CE1A-8831-48B5-BA93-72483C6E34E8}" type="datetimeFigureOut">
               <a:rPr lang="ko-KR" altLang="en-US" smtClean="0"/>
-              <a:t>2026-08-06</a:t>
+              <a:t>26-08-06(Thu)</a:t>
             </a:fld>
             <a:endParaRPr lang="ko-KR" altLang="en-US"/>
           </a:p>
@@ -414,7 +415,7 @@
           <a:p>
             <a:fld id="{7237CE1A-8831-48B5-BA93-72483C6E34E8}" type="datetimeFigureOut">
               <a:rPr lang="ko-KR" altLang="en-US" smtClean="0"/>
-              <a:t>2026-08-06</a:t>
+              <a:t>26-08-06(Thu)</a:t>
             </a:fld>
             <a:endParaRPr lang="ko-KR" altLang="en-US"/>
           </a:p>
@@ -594,7 +595,7 @@
           <a:p>
             <a:fld id="{7237CE1A-8831-48B5-BA93-72483C6E34E8}" type="datetimeFigureOut">
               <a:rPr lang="ko-KR" altLang="en-US" smtClean="0"/>
-              <a:t>2026-08-06</a:t>
+              <a:t>26-08-06(Thu)</a:t>
             </a:fld>
             <a:endParaRPr lang="ko-KR" altLang="en-US"/>
           </a:p>
@@ -764,7 +765,7 @@
           <a:p>
             <a:fld id="{7237CE1A-8831-48B5-BA93-72483C6E34E8}" type="datetimeFigureOut">
               <a:rPr lang="ko-KR" altLang="en-US" smtClean="0"/>
-              <a:t>2026-08-06</a:t>
+              <a:t>26-08-06(Thu)</a:t>
             </a:fld>
             <a:endParaRPr lang="ko-KR" altLang="en-US"/>
           </a:p>
@@ -1010,7 +1011,7 @@
           <a:p>
             <a:fld id="{7237CE1A-8831-48B5-BA93-72483C6E34E8}" type="datetimeFigureOut">
               <a:rPr lang="ko-KR" altLang="en-US" smtClean="0"/>
-              <a:t>2026-08-06</a:t>
+              <a:t>26-08-06(Thu)</a:t>
             </a:fld>
             <a:endParaRPr lang="ko-KR" altLang="en-US"/>
           </a:p>
@@ -1242,7 +1243,7 @@
           <a:p>
             <a:fld id="{7237CE1A-8831-48B5-BA93-72483C6E34E8}" type="datetimeFigureOut">
               <a:rPr lang="ko-KR" altLang="en-US" smtClean="0"/>
-              <a:t>2026-08-06</a:t>
+              <a:t>26-08-06(Thu)</a:t>
             </a:fld>
             <a:endParaRPr lang="ko-KR" altLang="en-US"/>
           </a:p>
@@ -1609,7 +1610,7 @@
           <a:p>
             <a:fld id="{7237CE1A-8831-48B5-BA93-72483C6E34E8}" type="datetimeFigureOut">
               <a:rPr lang="ko-KR" altLang="en-US" smtClean="0"/>
-              <a:t>2026-08-06</a:t>
+              <a:t>26-08-06(Thu)</a:t>
             </a:fld>
             <a:endParaRPr lang="ko-KR" altLang="en-US"/>
           </a:p>
@@ -1727,7 +1728,7 @@
           <a:p>
             <a:fld id="{7237CE1A-8831-48B5-BA93-72483C6E34E8}" type="datetimeFigureOut">
               <a:rPr lang="ko-KR" altLang="en-US" smtClean="0"/>
-              <a:t>2026-08-06</a:t>
+              <a:t>26-08-06(Thu)</a:t>
             </a:fld>
             <a:endParaRPr lang="ko-KR" altLang="en-US"/>
           </a:p>
@@ -1822,7 +1823,7 @@
           <a:p>
             <a:fld id="{7237CE1A-8831-48B5-BA93-72483C6E34E8}" type="datetimeFigureOut">
               <a:rPr lang="ko-KR" altLang="en-US" smtClean="0"/>
-              <a:t>2026-08-06</a:t>
+              <a:t>26-08-06(Thu)</a:t>
             </a:fld>
             <a:endParaRPr lang="ko-KR" altLang="en-US"/>
           </a:p>
@@ -2099,7 +2100,7 @@
           <a:p>
             <a:fld id="{7237CE1A-8831-48B5-BA93-72483C6E34E8}" type="datetimeFigureOut">
               <a:rPr lang="ko-KR" altLang="en-US" smtClean="0"/>
-              <a:t>2026-08-06</a:t>
+              <a:t>26-08-06(Thu)</a:t>
             </a:fld>
             <a:endParaRPr lang="ko-KR" altLang="en-US"/>
           </a:p>
@@ -2352,7 +2353,7 @@
           <a:p>
             <a:fld id="{7237CE1A-8831-48B5-BA93-72483C6E34E8}" type="datetimeFigureOut">
               <a:rPr lang="ko-KR" altLang="en-US" smtClean="0"/>
-              <a:t>2026-08-06</a:t>
+              <a:t>26-08-06(Thu)</a:t>
             </a:fld>
             <a:endParaRPr lang="ko-KR" altLang="en-US"/>
           </a:p>
@@ -2565,7 +2566,7 @@
           <a:p>
             <a:fld id="{7237CE1A-8831-48B5-BA93-72483C6E34E8}" type="datetimeFigureOut">
               <a:rPr lang="ko-KR" altLang="en-US" smtClean="0"/>
-              <a:t>2026-08-06</a:t>
+              <a:t>26-08-06(Thu)</a:t>
             </a:fld>
             <a:endParaRPr lang="ko-KR" altLang="en-US"/>
           </a:p>
@@ -8375,28 +8376,1067 @@
       </p:grpSpPr>
       <p:grpSp>
         <p:nvGrpSpPr>
-          <p:cNvPr id="40" name="그룹 39"/>
+          <p:cNvPr id="62" name="그룹 61"/>
           <p:cNvGrpSpPr/>
           <p:nvPr/>
         </p:nvGrpSpPr>
         <p:grpSpPr>
           <a:xfrm>
-            <a:off x="-126254" y="-685216"/>
-            <a:ext cx="13015997" cy="5226736"/>
-            <a:chOff x="-126254" y="-685216"/>
-            <a:chExt cx="13015997" cy="5226736"/>
+            <a:off x="3351038" y="2660123"/>
+            <a:ext cx="6873215" cy="2258549"/>
+            <a:chOff x="3351038" y="2660123"/>
+            <a:chExt cx="6873215" cy="2258549"/>
           </a:xfrm>
         </p:grpSpPr>
         <p:sp>
           <p:nvSpPr>
-            <p:cNvPr id="6" name="TextBox 5"/>
+            <p:cNvPr id="20" name="직사각형 19"/>
+            <p:cNvSpPr>
+              <a:spLocks/>
+            </p:cNvSpPr>
+            <p:nvPr/>
+          </p:nvSpPr>
+          <p:spPr>
+            <a:xfrm>
+              <a:off x="3351038" y="4054672"/>
+              <a:ext cx="1296000" cy="864000"/>
+            </a:xfrm>
+            <a:prstGeom prst="rect">
+              <a:avLst/>
+            </a:prstGeom>
+            <a:noFill/>
+            <a:ln w="28575">
+              <a:solidFill>
+                <a:schemeClr val="tx1"/>
+              </a:solidFill>
+            </a:ln>
+          </p:spPr>
+          <p:style>
+            <a:lnRef idx="2">
+              <a:schemeClr val="accent1">
+                <a:shade val="50000"/>
+              </a:schemeClr>
+            </a:lnRef>
+            <a:fillRef idx="1">
+              <a:schemeClr val="accent1"/>
+            </a:fillRef>
+            <a:effectRef idx="0">
+              <a:schemeClr val="accent1"/>
+            </a:effectRef>
+            <a:fontRef idx="minor">
+              <a:schemeClr val="lt1"/>
+            </a:fontRef>
+          </p:style>
+          <p:txBody>
+            <a:bodyPr rtlCol="0" anchor="ctr"/>
+            <a:lstStyle/>
+            <a:p>
+              <a:pPr algn="ctr"/>
+              <a:r>
+                <a:rPr lang="en-US" altLang="ko-KR" dirty="0" smtClean="0">
+                  <a:solidFill>
+                    <a:schemeClr val="tx1"/>
+                  </a:solidFill>
+                  <a:latin typeface="나눔스퀘어 Bold" panose="020B0600000101010101" pitchFamily="50" charset="-127"/>
+                  <a:ea typeface="나눔스퀘어 Bold" panose="020B0600000101010101" pitchFamily="50" charset="-127"/>
+                </a:rPr>
+                <a:t>0</a:t>
+              </a:r>
+              <a:r>
+                <a:rPr lang="en-US" altLang="ko-KR" dirty="0">
+                  <a:solidFill>
+                    <a:schemeClr val="tx1"/>
+                  </a:solidFill>
+                  <a:latin typeface="나눔스퀘어 Bold" panose="020B0600000101010101" pitchFamily="50" charset="-127"/>
+                  <a:ea typeface="나눔스퀘어 Bold" panose="020B0600000101010101" pitchFamily="50" charset="-127"/>
+                </a:rPr>
+                <a:t>x</a:t>
+              </a:r>
+              <a:r>
+                <a:rPr lang="en-US" altLang="ko-KR" dirty="0" smtClean="0">
+                  <a:solidFill>
+                    <a:schemeClr val="tx1"/>
+                  </a:solidFill>
+                  <a:latin typeface="나눔스퀘어 Bold" panose="020B0600000101010101" pitchFamily="50" charset="-127"/>
+                  <a:ea typeface="나눔스퀘어 Bold" panose="020B0600000101010101" pitchFamily="50" charset="-127"/>
+                </a:rPr>
+                <a:t>100</a:t>
+              </a:r>
+              <a:endParaRPr lang="ko-KR" altLang="en-US" dirty="0">
+                <a:solidFill>
+                  <a:schemeClr val="tx1"/>
+                </a:solidFill>
+                <a:latin typeface="나눔스퀘어 Bold" panose="020B0600000101010101" pitchFamily="50" charset="-127"/>
+                <a:ea typeface="나눔스퀘어 Bold" panose="020B0600000101010101" pitchFamily="50" charset="-127"/>
+              </a:endParaRPr>
+            </a:p>
+          </p:txBody>
+        </p:sp>
+        <p:grpSp>
+          <p:nvGrpSpPr>
+            <p:cNvPr id="58" name="그룹 57"/>
+            <p:cNvGrpSpPr/>
+            <p:nvPr/>
+          </p:nvGrpSpPr>
+          <p:grpSpPr>
+            <a:xfrm>
+              <a:off x="6482759" y="3157431"/>
+              <a:ext cx="2700455" cy="1761241"/>
+              <a:chOff x="6482759" y="3157431"/>
+              <a:chExt cx="2700455" cy="1761241"/>
+            </a:xfrm>
+          </p:grpSpPr>
+          <p:sp>
+            <p:nvSpPr>
+              <p:cNvPr id="2" name="직사각형 1"/>
+              <p:cNvSpPr>
+                <a:spLocks noChangeAspect="1"/>
+              </p:cNvSpPr>
+              <p:nvPr/>
+            </p:nvSpPr>
+            <p:spPr>
+              <a:xfrm>
+                <a:off x="6536987" y="3190672"/>
+                <a:ext cx="864000" cy="864000"/>
+              </a:xfrm>
+              <a:prstGeom prst="rect">
+                <a:avLst/>
+              </a:prstGeom>
+              <a:noFill/>
+              <a:ln w="28575">
+                <a:solidFill>
+                  <a:schemeClr val="tx1"/>
+                </a:solidFill>
+              </a:ln>
+            </p:spPr>
+            <p:style>
+              <a:lnRef idx="2">
+                <a:schemeClr val="accent1">
+                  <a:shade val="50000"/>
+                </a:schemeClr>
+              </a:lnRef>
+              <a:fillRef idx="1">
+                <a:schemeClr val="accent1"/>
+              </a:fillRef>
+              <a:effectRef idx="0">
+                <a:schemeClr val="accent1"/>
+              </a:effectRef>
+              <a:fontRef idx="minor">
+                <a:schemeClr val="lt1"/>
+              </a:fontRef>
+            </p:style>
+            <p:txBody>
+              <a:bodyPr rtlCol="0" anchor="ctr"/>
+              <a:lstStyle/>
+              <a:p>
+                <a:pPr algn="ctr"/>
+                <a:endParaRPr lang="ko-KR" altLang="en-US">
+                  <a:latin typeface="나눔스퀘어 Bold" panose="020B0600000101010101" pitchFamily="50" charset="-127"/>
+                  <a:ea typeface="나눔스퀘어 Bold" panose="020B0600000101010101" pitchFamily="50" charset="-127"/>
+                </a:endParaRPr>
+              </a:p>
+            </p:txBody>
+          </p:sp>
+          <p:sp>
+            <p:nvSpPr>
+              <p:cNvPr id="14" name="직사각형 13"/>
+              <p:cNvSpPr>
+                <a:spLocks noChangeAspect="1"/>
+              </p:cNvSpPr>
+              <p:nvPr/>
+            </p:nvSpPr>
+            <p:spPr>
+              <a:xfrm>
+                <a:off x="7400987" y="3190672"/>
+                <a:ext cx="864000" cy="864000"/>
+              </a:xfrm>
+              <a:prstGeom prst="rect">
+                <a:avLst/>
+              </a:prstGeom>
+              <a:noFill/>
+              <a:ln w="28575">
+                <a:solidFill>
+                  <a:schemeClr val="tx1"/>
+                </a:solidFill>
+              </a:ln>
+            </p:spPr>
+            <p:style>
+              <a:lnRef idx="2">
+                <a:schemeClr val="accent1">
+                  <a:shade val="50000"/>
+                </a:schemeClr>
+              </a:lnRef>
+              <a:fillRef idx="1">
+                <a:schemeClr val="accent1"/>
+              </a:fillRef>
+              <a:effectRef idx="0">
+                <a:schemeClr val="accent1"/>
+              </a:effectRef>
+              <a:fontRef idx="minor">
+                <a:schemeClr val="lt1"/>
+              </a:fontRef>
+            </p:style>
+            <p:txBody>
+              <a:bodyPr rtlCol="0" anchor="ctr"/>
+              <a:lstStyle/>
+              <a:p>
+                <a:pPr algn="ctr"/>
+                <a:endParaRPr lang="ko-KR" altLang="en-US">
+                  <a:latin typeface="나눔스퀘어 Bold" panose="020B0600000101010101" pitchFamily="50" charset="-127"/>
+                  <a:ea typeface="나눔스퀘어 Bold" panose="020B0600000101010101" pitchFamily="50" charset="-127"/>
+                </a:endParaRPr>
+              </a:p>
+            </p:txBody>
+          </p:sp>
+          <p:sp>
+            <p:nvSpPr>
+              <p:cNvPr id="16" name="직사각형 15"/>
+              <p:cNvSpPr>
+                <a:spLocks noChangeAspect="1"/>
+              </p:cNvSpPr>
+              <p:nvPr/>
+            </p:nvSpPr>
+            <p:spPr>
+              <a:xfrm>
+                <a:off x="8264987" y="3190672"/>
+                <a:ext cx="864000" cy="864000"/>
+              </a:xfrm>
+              <a:prstGeom prst="rect">
+                <a:avLst/>
+              </a:prstGeom>
+              <a:noFill/>
+              <a:ln w="28575">
+                <a:solidFill>
+                  <a:schemeClr val="tx1"/>
+                </a:solidFill>
+              </a:ln>
+            </p:spPr>
+            <p:style>
+              <a:lnRef idx="2">
+                <a:schemeClr val="accent1">
+                  <a:shade val="50000"/>
+                </a:schemeClr>
+              </a:lnRef>
+              <a:fillRef idx="1">
+                <a:schemeClr val="accent1"/>
+              </a:fillRef>
+              <a:effectRef idx="0">
+                <a:schemeClr val="accent1"/>
+              </a:effectRef>
+              <a:fontRef idx="minor">
+                <a:schemeClr val="lt1"/>
+              </a:fontRef>
+            </p:style>
+            <p:txBody>
+              <a:bodyPr rtlCol="0" anchor="ctr"/>
+              <a:lstStyle/>
+              <a:p>
+                <a:pPr algn="ctr"/>
+                <a:endParaRPr lang="ko-KR" altLang="en-US">
+                  <a:latin typeface="나눔스퀘어 Bold" panose="020B0600000101010101" pitchFamily="50" charset="-127"/>
+                  <a:ea typeface="나눔스퀘어 Bold" panose="020B0600000101010101" pitchFamily="50" charset="-127"/>
+                </a:endParaRPr>
+              </a:p>
+            </p:txBody>
+          </p:sp>
+          <p:sp>
+            <p:nvSpPr>
+              <p:cNvPr id="4" name="직사각형 3"/>
+              <p:cNvSpPr/>
+              <p:nvPr/>
+            </p:nvSpPr>
+            <p:spPr>
+              <a:xfrm>
+                <a:off x="6614174" y="3489629"/>
+                <a:ext cx="720000" cy="504000"/>
+              </a:xfrm>
+              <a:prstGeom prst="rect">
+                <a:avLst/>
+              </a:prstGeom>
+              <a:solidFill>
+                <a:schemeClr val="accent1">
+                  <a:lumMod val="20000"/>
+                  <a:lumOff val="80000"/>
+                </a:schemeClr>
+              </a:solidFill>
+              <a:ln>
+                <a:solidFill>
+                  <a:schemeClr val="tx1"/>
+                </a:solidFill>
+              </a:ln>
+            </p:spPr>
+            <p:style>
+              <a:lnRef idx="2">
+                <a:schemeClr val="accent1">
+                  <a:shade val="50000"/>
+                </a:schemeClr>
+              </a:lnRef>
+              <a:fillRef idx="1">
+                <a:schemeClr val="accent1"/>
+              </a:fillRef>
+              <a:effectRef idx="0">
+                <a:schemeClr val="accent1"/>
+              </a:effectRef>
+              <a:fontRef idx="minor">
+                <a:schemeClr val="lt1"/>
+              </a:fontRef>
+            </p:style>
+            <p:txBody>
+              <a:bodyPr rtlCol="0" anchor="ctr"/>
+              <a:lstStyle/>
+              <a:p>
+                <a:pPr algn="ctr"/>
+                <a:r>
+                  <a:rPr lang="en-US" altLang="ko-KR" dirty="0" smtClean="0">
+                    <a:solidFill>
+                      <a:schemeClr val="tx1"/>
+                    </a:solidFill>
+                    <a:latin typeface="나눔스퀘어 Bold" panose="020B0600000101010101" pitchFamily="50" charset="-127"/>
+                    <a:ea typeface="나눔스퀘어 Bold" panose="020B0600000101010101" pitchFamily="50" charset="-127"/>
+                  </a:rPr>
+                  <a:t>0</a:t>
+                </a:r>
+                <a:endParaRPr lang="ko-KR" altLang="en-US" dirty="0">
+                  <a:solidFill>
+                    <a:schemeClr val="tx1"/>
+                  </a:solidFill>
+                  <a:latin typeface="나눔스퀘어 Bold" panose="020B0600000101010101" pitchFamily="50" charset="-127"/>
+                  <a:ea typeface="나눔스퀘어 Bold" panose="020B0600000101010101" pitchFamily="50" charset="-127"/>
+                </a:endParaRPr>
+              </a:p>
+            </p:txBody>
+          </p:sp>
+          <p:sp>
+            <p:nvSpPr>
+              <p:cNvPr id="21" name="TextBox 20"/>
+              <p:cNvSpPr txBox="1"/>
+              <p:nvPr/>
+            </p:nvSpPr>
+            <p:spPr>
+              <a:xfrm>
+                <a:off x="6482759" y="3157431"/>
+                <a:ext cx="972457" cy="338554"/>
+              </a:xfrm>
+              <a:prstGeom prst="rect">
+                <a:avLst/>
+              </a:prstGeom>
+              <a:noFill/>
+            </p:spPr>
+            <p:txBody>
+              <a:bodyPr wrap="square" rtlCol="0">
+                <a:spAutoFit/>
+              </a:bodyPr>
+              <a:lstStyle/>
+              <a:p>
+                <a:pPr algn="ctr"/>
+                <a:r>
+                  <a:rPr lang="en-US" altLang="ko-KR" sz="1600" dirty="0" smtClean="0">
+                    <a:latin typeface="나눔스퀘어 Bold" panose="020B0600000101010101" pitchFamily="50" charset="-127"/>
+                    <a:ea typeface="나눔스퀘어 Bold" panose="020B0600000101010101" pitchFamily="50" charset="-127"/>
+                  </a:rPr>
+                  <a:t>22381</a:t>
+                </a:r>
+                <a:endParaRPr lang="ko-KR" altLang="en-US" sz="1600" dirty="0">
+                  <a:latin typeface="나눔스퀘어 Bold" panose="020B0600000101010101" pitchFamily="50" charset="-127"/>
+                  <a:ea typeface="나눔스퀘어 Bold" panose="020B0600000101010101" pitchFamily="50" charset="-127"/>
+                </a:endParaRPr>
+              </a:p>
+            </p:txBody>
+          </p:sp>
+          <p:sp>
+            <p:nvSpPr>
+              <p:cNvPr id="22" name="TextBox 21"/>
+              <p:cNvSpPr txBox="1"/>
+              <p:nvPr/>
+            </p:nvSpPr>
+            <p:spPr>
+              <a:xfrm>
+                <a:off x="7346758" y="3163775"/>
+                <a:ext cx="972457" cy="338554"/>
+              </a:xfrm>
+              <a:prstGeom prst="rect">
+                <a:avLst/>
+              </a:prstGeom>
+              <a:noFill/>
+            </p:spPr>
+            <p:txBody>
+              <a:bodyPr wrap="square" rtlCol="0">
+                <a:spAutoFit/>
+              </a:bodyPr>
+              <a:lstStyle/>
+              <a:p>
+                <a:pPr algn="ctr"/>
+                <a:r>
+                  <a:rPr lang="en-US" altLang="ko-KR" sz="1600" dirty="0" smtClean="0">
+                    <a:latin typeface="나눔스퀘어 Bold" panose="020B0600000101010101" pitchFamily="50" charset="-127"/>
+                    <a:ea typeface="나눔스퀘어 Bold" panose="020B0600000101010101" pitchFamily="50" charset="-127"/>
+                  </a:rPr>
+                  <a:t>22382</a:t>
+                </a:r>
+                <a:endParaRPr lang="ko-KR" altLang="en-US" sz="1600" dirty="0">
+                  <a:latin typeface="나눔스퀘어 Bold" panose="020B0600000101010101" pitchFamily="50" charset="-127"/>
+                  <a:ea typeface="나눔스퀘어 Bold" panose="020B0600000101010101" pitchFamily="50" charset="-127"/>
+                </a:endParaRPr>
+              </a:p>
+            </p:txBody>
+          </p:sp>
+          <p:sp>
+            <p:nvSpPr>
+              <p:cNvPr id="23" name="TextBox 22"/>
+              <p:cNvSpPr txBox="1"/>
+              <p:nvPr/>
+            </p:nvSpPr>
+            <p:spPr>
+              <a:xfrm>
+                <a:off x="8210757" y="3163898"/>
+                <a:ext cx="972457" cy="338554"/>
+              </a:xfrm>
+              <a:prstGeom prst="rect">
+                <a:avLst/>
+              </a:prstGeom>
+              <a:noFill/>
+            </p:spPr>
+            <p:txBody>
+              <a:bodyPr wrap="square" rtlCol="0">
+                <a:spAutoFit/>
+              </a:bodyPr>
+              <a:lstStyle/>
+              <a:p>
+                <a:pPr algn="ctr"/>
+                <a:r>
+                  <a:rPr lang="en-US" altLang="ko-KR" sz="1600" dirty="0" smtClean="0">
+                    <a:latin typeface="나눔스퀘어 Bold" panose="020B0600000101010101" pitchFamily="50" charset="-127"/>
+                    <a:ea typeface="나눔스퀘어 Bold" panose="020B0600000101010101" pitchFamily="50" charset="-127"/>
+                  </a:rPr>
+                  <a:t>22383</a:t>
+                </a:r>
+                <a:endParaRPr lang="ko-KR" altLang="en-US" sz="1600" dirty="0">
+                  <a:latin typeface="나눔스퀘어 Bold" panose="020B0600000101010101" pitchFamily="50" charset="-127"/>
+                  <a:ea typeface="나눔스퀘어 Bold" panose="020B0600000101010101" pitchFamily="50" charset="-127"/>
+                </a:endParaRPr>
+              </a:p>
+            </p:txBody>
+          </p:sp>
+          <p:sp>
+            <p:nvSpPr>
+              <p:cNvPr id="44" name="직사각형 43"/>
+              <p:cNvSpPr/>
+              <p:nvPr/>
+            </p:nvSpPr>
+            <p:spPr>
+              <a:xfrm>
+                <a:off x="7467800" y="3489629"/>
+                <a:ext cx="720000" cy="504000"/>
+              </a:xfrm>
+              <a:prstGeom prst="rect">
+                <a:avLst/>
+              </a:prstGeom>
+              <a:solidFill>
+                <a:schemeClr val="accent1">
+                  <a:lumMod val="20000"/>
+                  <a:lumOff val="80000"/>
+                </a:schemeClr>
+              </a:solidFill>
+              <a:ln>
+                <a:solidFill>
+                  <a:schemeClr val="tx1"/>
+                </a:solidFill>
+              </a:ln>
+            </p:spPr>
+            <p:style>
+              <a:lnRef idx="2">
+                <a:schemeClr val="accent1">
+                  <a:shade val="50000"/>
+                </a:schemeClr>
+              </a:lnRef>
+              <a:fillRef idx="1">
+                <a:schemeClr val="accent1"/>
+              </a:fillRef>
+              <a:effectRef idx="0">
+                <a:schemeClr val="accent1"/>
+              </a:effectRef>
+              <a:fontRef idx="minor">
+                <a:schemeClr val="lt1"/>
+              </a:fontRef>
+            </p:style>
+            <p:txBody>
+              <a:bodyPr rtlCol="0" anchor="ctr"/>
+              <a:lstStyle/>
+              <a:p>
+                <a:pPr algn="ctr"/>
+                <a:r>
+                  <a:rPr lang="en-US" altLang="ko-KR" dirty="0" smtClean="0">
+                    <a:solidFill>
+                      <a:schemeClr val="tx1"/>
+                    </a:solidFill>
+                    <a:latin typeface="나눔스퀘어 Bold" panose="020B0600000101010101" pitchFamily="50" charset="-127"/>
+                    <a:ea typeface="나눔스퀘어 Bold" panose="020B0600000101010101" pitchFamily="50" charset="-127"/>
+                  </a:rPr>
+                  <a:t>1</a:t>
+                </a:r>
+                <a:endParaRPr lang="ko-KR" altLang="en-US" dirty="0">
+                  <a:solidFill>
+                    <a:schemeClr val="tx1"/>
+                  </a:solidFill>
+                  <a:latin typeface="나눔스퀘어 Bold" panose="020B0600000101010101" pitchFamily="50" charset="-127"/>
+                  <a:ea typeface="나눔스퀘어 Bold" panose="020B0600000101010101" pitchFamily="50" charset="-127"/>
+                </a:endParaRPr>
+              </a:p>
+            </p:txBody>
+          </p:sp>
+          <p:sp>
+            <p:nvSpPr>
+              <p:cNvPr id="45" name="직사각형 44"/>
+              <p:cNvSpPr/>
+              <p:nvPr/>
+            </p:nvSpPr>
+            <p:spPr>
+              <a:xfrm>
+                <a:off x="8342172" y="3489629"/>
+                <a:ext cx="720000" cy="504000"/>
+              </a:xfrm>
+              <a:prstGeom prst="rect">
+                <a:avLst/>
+              </a:prstGeom>
+              <a:solidFill>
+                <a:schemeClr val="accent1">
+                  <a:lumMod val="20000"/>
+                  <a:lumOff val="80000"/>
+                </a:schemeClr>
+              </a:solidFill>
+              <a:ln>
+                <a:solidFill>
+                  <a:schemeClr val="tx1"/>
+                </a:solidFill>
+              </a:ln>
+            </p:spPr>
+            <p:style>
+              <a:lnRef idx="2">
+                <a:schemeClr val="accent1">
+                  <a:shade val="50000"/>
+                </a:schemeClr>
+              </a:lnRef>
+              <a:fillRef idx="1">
+                <a:schemeClr val="accent1"/>
+              </a:fillRef>
+              <a:effectRef idx="0">
+                <a:schemeClr val="accent1"/>
+              </a:effectRef>
+              <a:fontRef idx="minor">
+                <a:schemeClr val="lt1"/>
+              </a:fontRef>
+            </p:style>
+            <p:txBody>
+              <a:bodyPr rtlCol="0" anchor="ctr"/>
+              <a:lstStyle/>
+              <a:p>
+                <a:pPr algn="ctr"/>
+                <a:r>
+                  <a:rPr lang="en-US" altLang="ko-KR" dirty="0">
+                    <a:solidFill>
+                      <a:schemeClr val="tx1"/>
+                    </a:solidFill>
+                    <a:latin typeface="나눔스퀘어 Bold" panose="020B0600000101010101" pitchFamily="50" charset="-127"/>
+                    <a:ea typeface="나눔스퀘어 Bold" panose="020B0600000101010101" pitchFamily="50" charset="-127"/>
+                  </a:rPr>
+                  <a:t>2</a:t>
+                </a:r>
+                <a:endParaRPr lang="ko-KR" altLang="en-US" dirty="0">
+                  <a:solidFill>
+                    <a:schemeClr val="tx1"/>
+                  </a:solidFill>
+                  <a:latin typeface="나눔스퀘어 Bold" panose="020B0600000101010101" pitchFamily="50" charset="-127"/>
+                  <a:ea typeface="나눔스퀘어 Bold" panose="020B0600000101010101" pitchFamily="50" charset="-127"/>
+                </a:endParaRPr>
+              </a:p>
+            </p:txBody>
+          </p:sp>
+          <p:sp>
+            <p:nvSpPr>
+              <p:cNvPr id="47" name="직사각형 46"/>
+              <p:cNvSpPr>
+                <a:spLocks noChangeAspect="1"/>
+              </p:cNvSpPr>
+              <p:nvPr/>
+            </p:nvSpPr>
+            <p:spPr>
+              <a:xfrm>
+                <a:off x="6536987" y="4054672"/>
+                <a:ext cx="864000" cy="864000"/>
+              </a:xfrm>
+              <a:prstGeom prst="rect">
+                <a:avLst/>
+              </a:prstGeom>
+              <a:noFill/>
+              <a:ln w="28575">
+                <a:solidFill>
+                  <a:schemeClr val="tx1"/>
+                </a:solidFill>
+              </a:ln>
+            </p:spPr>
+            <p:style>
+              <a:lnRef idx="2">
+                <a:schemeClr val="accent1">
+                  <a:shade val="50000"/>
+                </a:schemeClr>
+              </a:lnRef>
+              <a:fillRef idx="1">
+                <a:schemeClr val="accent1"/>
+              </a:fillRef>
+              <a:effectRef idx="0">
+                <a:schemeClr val="accent1"/>
+              </a:effectRef>
+              <a:fontRef idx="minor">
+                <a:schemeClr val="lt1"/>
+              </a:fontRef>
+            </p:style>
+            <p:txBody>
+              <a:bodyPr rtlCol="0" anchor="ctr"/>
+              <a:lstStyle/>
+              <a:p>
+                <a:pPr algn="ctr"/>
+                <a:endParaRPr lang="ko-KR" altLang="en-US">
+                  <a:latin typeface="나눔스퀘어 Bold" panose="020B0600000101010101" pitchFamily="50" charset="-127"/>
+                  <a:ea typeface="나눔스퀘어 Bold" panose="020B0600000101010101" pitchFamily="50" charset="-127"/>
+                </a:endParaRPr>
+              </a:p>
+            </p:txBody>
+          </p:sp>
+          <p:sp>
+            <p:nvSpPr>
+              <p:cNvPr id="48" name="직사각형 47"/>
+              <p:cNvSpPr>
+                <a:spLocks noChangeAspect="1"/>
+              </p:cNvSpPr>
+              <p:nvPr/>
+            </p:nvSpPr>
+            <p:spPr>
+              <a:xfrm>
+                <a:off x="7400987" y="4054672"/>
+                <a:ext cx="864000" cy="864000"/>
+              </a:xfrm>
+              <a:prstGeom prst="rect">
+                <a:avLst/>
+              </a:prstGeom>
+              <a:noFill/>
+              <a:ln w="28575">
+                <a:solidFill>
+                  <a:schemeClr val="tx1"/>
+                </a:solidFill>
+              </a:ln>
+            </p:spPr>
+            <p:style>
+              <a:lnRef idx="2">
+                <a:schemeClr val="accent1">
+                  <a:shade val="50000"/>
+                </a:schemeClr>
+              </a:lnRef>
+              <a:fillRef idx="1">
+                <a:schemeClr val="accent1"/>
+              </a:fillRef>
+              <a:effectRef idx="0">
+                <a:schemeClr val="accent1"/>
+              </a:effectRef>
+              <a:fontRef idx="minor">
+                <a:schemeClr val="lt1"/>
+              </a:fontRef>
+            </p:style>
+            <p:txBody>
+              <a:bodyPr rtlCol="0" anchor="ctr"/>
+              <a:lstStyle/>
+              <a:p>
+                <a:pPr algn="ctr"/>
+                <a:endParaRPr lang="ko-KR" altLang="en-US">
+                  <a:latin typeface="나눔스퀘어 Bold" panose="020B0600000101010101" pitchFamily="50" charset="-127"/>
+                  <a:ea typeface="나눔스퀘어 Bold" panose="020B0600000101010101" pitchFamily="50" charset="-127"/>
+                </a:endParaRPr>
+              </a:p>
+            </p:txBody>
+          </p:sp>
+          <p:sp>
+            <p:nvSpPr>
+              <p:cNvPr id="49" name="직사각형 48"/>
+              <p:cNvSpPr>
+                <a:spLocks noChangeAspect="1"/>
+              </p:cNvSpPr>
+              <p:nvPr/>
+            </p:nvSpPr>
+            <p:spPr>
+              <a:xfrm>
+                <a:off x="8264987" y="4054672"/>
+                <a:ext cx="864000" cy="864000"/>
+              </a:xfrm>
+              <a:prstGeom prst="rect">
+                <a:avLst/>
+              </a:prstGeom>
+              <a:noFill/>
+              <a:ln w="28575">
+                <a:solidFill>
+                  <a:schemeClr val="tx1"/>
+                </a:solidFill>
+              </a:ln>
+            </p:spPr>
+            <p:style>
+              <a:lnRef idx="2">
+                <a:schemeClr val="accent1">
+                  <a:shade val="50000"/>
+                </a:schemeClr>
+              </a:lnRef>
+              <a:fillRef idx="1">
+                <a:schemeClr val="accent1"/>
+              </a:fillRef>
+              <a:effectRef idx="0">
+                <a:schemeClr val="accent1"/>
+              </a:effectRef>
+              <a:fontRef idx="minor">
+                <a:schemeClr val="lt1"/>
+              </a:fontRef>
+            </p:style>
+            <p:txBody>
+              <a:bodyPr rtlCol="0" anchor="ctr"/>
+              <a:lstStyle/>
+              <a:p>
+                <a:pPr algn="ctr"/>
+                <a:endParaRPr lang="ko-KR" altLang="en-US">
+                  <a:latin typeface="나눔스퀘어 Bold" panose="020B0600000101010101" pitchFamily="50" charset="-127"/>
+                  <a:ea typeface="나눔스퀘어 Bold" panose="020B0600000101010101" pitchFamily="50" charset="-127"/>
+                </a:endParaRPr>
+              </a:p>
+            </p:txBody>
+          </p:sp>
+          <p:sp>
+            <p:nvSpPr>
+              <p:cNvPr id="50" name="직사각형 49"/>
+              <p:cNvSpPr/>
+              <p:nvPr/>
+            </p:nvSpPr>
+            <p:spPr>
+              <a:xfrm>
+                <a:off x="6614174" y="4353629"/>
+                <a:ext cx="720000" cy="504000"/>
+              </a:xfrm>
+              <a:prstGeom prst="rect">
+                <a:avLst/>
+              </a:prstGeom>
+              <a:solidFill>
+                <a:schemeClr val="accent1">
+                  <a:lumMod val="20000"/>
+                  <a:lumOff val="80000"/>
+                </a:schemeClr>
+              </a:solidFill>
+              <a:ln>
+                <a:solidFill>
+                  <a:schemeClr val="tx1"/>
+                </a:solidFill>
+              </a:ln>
+            </p:spPr>
+            <p:style>
+              <a:lnRef idx="2">
+                <a:schemeClr val="accent1">
+                  <a:shade val="50000"/>
+                </a:schemeClr>
+              </a:lnRef>
+              <a:fillRef idx="1">
+                <a:schemeClr val="accent1"/>
+              </a:fillRef>
+              <a:effectRef idx="0">
+                <a:schemeClr val="accent1"/>
+              </a:effectRef>
+              <a:fontRef idx="minor">
+                <a:schemeClr val="lt1"/>
+              </a:fontRef>
+            </p:style>
+            <p:txBody>
+              <a:bodyPr rtlCol="0" anchor="ctr"/>
+              <a:lstStyle/>
+              <a:p>
+                <a:pPr algn="ctr"/>
+                <a:r>
+                  <a:rPr lang="en-US" altLang="ko-KR" dirty="0">
+                    <a:solidFill>
+                      <a:schemeClr val="tx1"/>
+                    </a:solidFill>
+                    <a:latin typeface="나눔스퀘어 Bold" panose="020B0600000101010101" pitchFamily="50" charset="-127"/>
+                    <a:ea typeface="나눔스퀘어 Bold" panose="020B0600000101010101" pitchFamily="50" charset="-127"/>
+                  </a:rPr>
+                  <a:t>8</a:t>
+                </a:r>
+                <a:r>
+                  <a:rPr lang="en-US" altLang="ko-KR" dirty="0" smtClean="0">
+                    <a:solidFill>
+                      <a:schemeClr val="tx1"/>
+                    </a:solidFill>
+                    <a:latin typeface="나눔스퀘어 Bold" panose="020B0600000101010101" pitchFamily="50" charset="-127"/>
+                    <a:ea typeface="나눔스퀘어 Bold" panose="020B0600000101010101" pitchFamily="50" charset="-127"/>
+                  </a:rPr>
+                  <a:t>0</a:t>
+                </a:r>
+                <a:endParaRPr lang="ko-KR" altLang="en-US" dirty="0">
+                  <a:solidFill>
+                    <a:schemeClr val="tx1"/>
+                  </a:solidFill>
+                  <a:latin typeface="나눔스퀘어 Bold" panose="020B0600000101010101" pitchFamily="50" charset="-127"/>
+                  <a:ea typeface="나눔스퀘어 Bold" panose="020B0600000101010101" pitchFamily="50" charset="-127"/>
+                </a:endParaRPr>
+              </a:p>
+            </p:txBody>
+          </p:sp>
+          <p:sp>
+            <p:nvSpPr>
+              <p:cNvPr id="51" name="TextBox 50"/>
+              <p:cNvSpPr txBox="1"/>
+              <p:nvPr/>
+            </p:nvSpPr>
+            <p:spPr>
+              <a:xfrm>
+                <a:off x="6482759" y="4021431"/>
+                <a:ext cx="972457" cy="338554"/>
+              </a:xfrm>
+              <a:prstGeom prst="rect">
+                <a:avLst/>
+              </a:prstGeom>
+              <a:noFill/>
+            </p:spPr>
+            <p:txBody>
+              <a:bodyPr wrap="square" rtlCol="0">
+                <a:spAutoFit/>
+              </a:bodyPr>
+              <a:lstStyle/>
+              <a:p>
+                <a:pPr algn="ctr"/>
+                <a:r>
+                  <a:rPr lang="en-US" altLang="ko-KR" sz="1600" dirty="0" smtClean="0">
+                    <a:latin typeface="나눔스퀘어 Bold" panose="020B0600000101010101" pitchFamily="50" charset="-127"/>
+                    <a:ea typeface="나눔스퀘어 Bold" panose="020B0600000101010101" pitchFamily="50" charset="-127"/>
+                  </a:rPr>
+                  <a:t>22391</a:t>
+                </a:r>
+                <a:endParaRPr lang="ko-KR" altLang="en-US" sz="1600" dirty="0">
+                  <a:latin typeface="나눔스퀘어 Bold" panose="020B0600000101010101" pitchFamily="50" charset="-127"/>
+                  <a:ea typeface="나눔스퀘어 Bold" panose="020B0600000101010101" pitchFamily="50" charset="-127"/>
+                </a:endParaRPr>
+              </a:p>
+            </p:txBody>
+          </p:sp>
+          <p:sp>
+            <p:nvSpPr>
+              <p:cNvPr id="52" name="TextBox 51"/>
+              <p:cNvSpPr txBox="1"/>
+              <p:nvPr/>
+            </p:nvSpPr>
+            <p:spPr>
+              <a:xfrm>
+                <a:off x="7346758" y="4027775"/>
+                <a:ext cx="972457" cy="338554"/>
+              </a:xfrm>
+              <a:prstGeom prst="rect">
+                <a:avLst/>
+              </a:prstGeom>
+              <a:noFill/>
+            </p:spPr>
+            <p:txBody>
+              <a:bodyPr wrap="square" rtlCol="0">
+                <a:spAutoFit/>
+              </a:bodyPr>
+              <a:lstStyle/>
+              <a:p>
+                <a:pPr algn="ctr"/>
+                <a:r>
+                  <a:rPr lang="en-US" altLang="ko-KR" sz="1600" dirty="0" smtClean="0">
+                    <a:latin typeface="나눔스퀘어 Bold" panose="020B0600000101010101" pitchFamily="50" charset="-127"/>
+                    <a:ea typeface="나눔스퀘어 Bold" panose="020B0600000101010101" pitchFamily="50" charset="-127"/>
+                  </a:rPr>
+                  <a:t>22392</a:t>
+                </a:r>
+                <a:endParaRPr lang="ko-KR" altLang="en-US" sz="1600" dirty="0">
+                  <a:latin typeface="나눔스퀘어 Bold" panose="020B0600000101010101" pitchFamily="50" charset="-127"/>
+                  <a:ea typeface="나눔스퀘어 Bold" panose="020B0600000101010101" pitchFamily="50" charset="-127"/>
+                </a:endParaRPr>
+              </a:p>
+            </p:txBody>
+          </p:sp>
+          <p:sp>
+            <p:nvSpPr>
+              <p:cNvPr id="53" name="TextBox 52"/>
+              <p:cNvSpPr txBox="1"/>
+              <p:nvPr/>
+            </p:nvSpPr>
+            <p:spPr>
+              <a:xfrm>
+                <a:off x="8210757" y="4027898"/>
+                <a:ext cx="972457" cy="338554"/>
+              </a:xfrm>
+              <a:prstGeom prst="rect">
+                <a:avLst/>
+              </a:prstGeom>
+              <a:noFill/>
+            </p:spPr>
+            <p:txBody>
+              <a:bodyPr wrap="square" rtlCol="0">
+                <a:spAutoFit/>
+              </a:bodyPr>
+              <a:lstStyle/>
+              <a:p>
+                <a:pPr algn="ctr"/>
+                <a:r>
+                  <a:rPr lang="en-US" altLang="ko-KR" sz="1600" dirty="0" smtClean="0">
+                    <a:latin typeface="나눔스퀘어 Bold" panose="020B0600000101010101" pitchFamily="50" charset="-127"/>
+                    <a:ea typeface="나눔스퀘어 Bold" panose="020B0600000101010101" pitchFamily="50" charset="-127"/>
+                  </a:rPr>
+                  <a:t>22393</a:t>
+                </a:r>
+                <a:endParaRPr lang="ko-KR" altLang="en-US" sz="1600" dirty="0">
+                  <a:latin typeface="나눔스퀘어 Bold" panose="020B0600000101010101" pitchFamily="50" charset="-127"/>
+                  <a:ea typeface="나눔스퀘어 Bold" panose="020B0600000101010101" pitchFamily="50" charset="-127"/>
+                </a:endParaRPr>
+              </a:p>
+            </p:txBody>
+          </p:sp>
+          <p:sp>
+            <p:nvSpPr>
+              <p:cNvPr id="54" name="직사각형 53"/>
+              <p:cNvSpPr/>
+              <p:nvPr/>
+            </p:nvSpPr>
+            <p:spPr>
+              <a:xfrm>
+                <a:off x="7467800" y="4353629"/>
+                <a:ext cx="720000" cy="504000"/>
+              </a:xfrm>
+              <a:prstGeom prst="rect">
+                <a:avLst/>
+              </a:prstGeom>
+              <a:solidFill>
+                <a:schemeClr val="accent1">
+                  <a:lumMod val="20000"/>
+                  <a:lumOff val="80000"/>
+                </a:schemeClr>
+              </a:solidFill>
+              <a:ln>
+                <a:solidFill>
+                  <a:schemeClr val="tx1"/>
+                </a:solidFill>
+              </a:ln>
+            </p:spPr>
+            <p:style>
+              <a:lnRef idx="2">
+                <a:schemeClr val="accent1">
+                  <a:shade val="50000"/>
+                </a:schemeClr>
+              </a:lnRef>
+              <a:fillRef idx="1">
+                <a:schemeClr val="accent1"/>
+              </a:fillRef>
+              <a:effectRef idx="0">
+                <a:schemeClr val="accent1"/>
+              </a:effectRef>
+              <a:fontRef idx="minor">
+                <a:schemeClr val="lt1"/>
+              </a:fontRef>
+            </p:style>
+            <p:txBody>
+              <a:bodyPr rtlCol="0" anchor="ctr"/>
+              <a:lstStyle/>
+              <a:p>
+                <a:pPr algn="ctr"/>
+                <a:r>
+                  <a:rPr lang="en-US" altLang="ko-KR" dirty="0" smtClean="0">
+                    <a:solidFill>
+                      <a:schemeClr val="tx1"/>
+                    </a:solidFill>
+                    <a:latin typeface="나눔스퀘어 Bold" panose="020B0600000101010101" pitchFamily="50" charset="-127"/>
+                    <a:ea typeface="나눔스퀘어 Bold" panose="020B0600000101010101" pitchFamily="50" charset="-127"/>
+                  </a:rPr>
+                  <a:t>75</a:t>
+                </a:r>
+                <a:endParaRPr lang="ko-KR" altLang="en-US" dirty="0">
+                  <a:solidFill>
+                    <a:schemeClr val="tx1"/>
+                  </a:solidFill>
+                  <a:latin typeface="나눔스퀘어 Bold" panose="020B0600000101010101" pitchFamily="50" charset="-127"/>
+                  <a:ea typeface="나눔스퀘어 Bold" panose="020B0600000101010101" pitchFamily="50" charset="-127"/>
+                </a:endParaRPr>
+              </a:p>
+            </p:txBody>
+          </p:sp>
+          <p:sp>
+            <p:nvSpPr>
+              <p:cNvPr id="55" name="직사각형 54"/>
+              <p:cNvSpPr/>
+              <p:nvPr/>
+            </p:nvSpPr>
+            <p:spPr>
+              <a:xfrm>
+                <a:off x="8342172" y="4353629"/>
+                <a:ext cx="720000" cy="504000"/>
+              </a:xfrm>
+              <a:prstGeom prst="rect">
+                <a:avLst/>
+              </a:prstGeom>
+              <a:solidFill>
+                <a:schemeClr val="accent1">
+                  <a:lumMod val="20000"/>
+                  <a:lumOff val="80000"/>
+                </a:schemeClr>
+              </a:solidFill>
+              <a:ln>
+                <a:solidFill>
+                  <a:schemeClr val="tx1"/>
+                </a:solidFill>
+              </a:ln>
+            </p:spPr>
+            <p:style>
+              <a:lnRef idx="2">
+                <a:schemeClr val="accent1">
+                  <a:shade val="50000"/>
+                </a:schemeClr>
+              </a:lnRef>
+              <a:fillRef idx="1">
+                <a:schemeClr val="accent1"/>
+              </a:fillRef>
+              <a:effectRef idx="0">
+                <a:schemeClr val="accent1"/>
+              </a:effectRef>
+              <a:fontRef idx="minor">
+                <a:schemeClr val="lt1"/>
+              </a:fontRef>
+            </p:style>
+            <p:txBody>
+              <a:bodyPr rtlCol="0" anchor="ctr"/>
+              <a:lstStyle/>
+              <a:p>
+                <a:pPr algn="ctr"/>
+                <a:r>
+                  <a:rPr lang="en-US" altLang="ko-KR" dirty="0" smtClean="0">
+                    <a:solidFill>
+                      <a:schemeClr val="tx1"/>
+                    </a:solidFill>
+                    <a:latin typeface="나눔스퀘어 Bold" panose="020B0600000101010101" pitchFamily="50" charset="-127"/>
+                    <a:ea typeface="나눔스퀘어 Bold" panose="020B0600000101010101" pitchFamily="50" charset="-127"/>
+                  </a:rPr>
+                  <a:t>95</a:t>
+                </a:r>
+                <a:endParaRPr lang="ko-KR" altLang="en-US" dirty="0">
+                  <a:solidFill>
+                    <a:schemeClr val="tx1"/>
+                  </a:solidFill>
+                  <a:latin typeface="나눔스퀘어 Bold" panose="020B0600000101010101" pitchFamily="50" charset="-127"/>
+                  <a:ea typeface="나눔스퀘어 Bold" panose="020B0600000101010101" pitchFamily="50" charset="-127"/>
+                </a:endParaRPr>
+              </a:p>
+            </p:txBody>
+          </p:sp>
+        </p:grpSp>
+        <p:sp>
+          <p:nvSpPr>
+            <p:cNvPr id="5" name="TextBox 4"/>
             <p:cNvSpPr txBox="1"/>
             <p:nvPr/>
           </p:nvSpPr>
           <p:spPr>
             <a:xfrm>
-              <a:off x="212875" y="518337"/>
-              <a:ext cx="12676868" cy="3785652"/>
+              <a:off x="9260399" y="3396675"/>
+              <a:ext cx="963854" cy="461665"/>
             </a:xfrm>
             <a:prstGeom prst="rect">
               <a:avLst/>
@@ -8410,117 +9450,225 @@
             <a:lstStyle/>
             <a:p>
               <a:r>
-                <a:rPr lang="en-US" altLang="ko-KR" sz="6000" dirty="0" smtClean="0">
+                <a:rPr lang="en-US" altLang="ko-KR" sz="2400" dirty="0" smtClean="0">
                   <a:latin typeface="나눔스퀘어 Bold" panose="020B0600000101010101" pitchFamily="50" charset="-127"/>
                   <a:ea typeface="나눔스퀘어 Bold" panose="020B0600000101010101" pitchFamily="50" charset="-127"/>
                 </a:rPr>
-                <a:t>while (</a:t>
+                <a:t>index</a:t>
+              </a:r>
+              <a:endParaRPr lang="ko-KR" altLang="en-US" sz="2400" dirty="0">
+                <a:latin typeface="나눔스퀘어 Bold" panose="020B0600000101010101" pitchFamily="50" charset="-127"/>
+                <a:ea typeface="나눔스퀘어 Bold" panose="020B0600000101010101" pitchFamily="50" charset="-127"/>
+              </a:endParaRPr>
+            </a:p>
+          </p:txBody>
+        </p:sp>
+        <p:sp>
+          <p:nvSpPr>
+            <p:cNvPr id="56" name="TextBox 55"/>
+            <p:cNvSpPr txBox="1"/>
+            <p:nvPr/>
+          </p:nvSpPr>
+          <p:spPr>
+            <a:xfrm>
+              <a:off x="9260399" y="4254208"/>
+              <a:ext cx="949299" cy="461665"/>
+            </a:xfrm>
+            <a:prstGeom prst="rect">
+              <a:avLst/>
+            </a:prstGeom>
+            <a:noFill/>
+          </p:spPr>
+          <p:txBody>
+            <a:bodyPr wrap="none" rtlCol="0">
+              <a:spAutoFit/>
+            </a:bodyPr>
+            <a:lstStyle/>
+            <a:p>
+              <a:r>
+                <a:rPr lang="en-US" altLang="ko-KR" sz="2400" dirty="0" smtClean="0">
+                  <a:latin typeface="나눔스퀘어 Bold" panose="020B0600000101010101" pitchFamily="50" charset="-127"/>
+                  <a:ea typeface="나눔스퀘어 Bold" panose="020B0600000101010101" pitchFamily="50" charset="-127"/>
+                </a:rPr>
+                <a:t>value</a:t>
+              </a:r>
+              <a:endParaRPr lang="ko-KR" altLang="en-US" sz="2400" dirty="0">
+                <a:latin typeface="나눔스퀘어 Bold" panose="020B0600000101010101" pitchFamily="50" charset="-127"/>
+                <a:ea typeface="나눔스퀘어 Bold" panose="020B0600000101010101" pitchFamily="50" charset="-127"/>
+              </a:endParaRPr>
+            </a:p>
+          </p:txBody>
+        </p:sp>
+        <p:sp>
+          <p:nvSpPr>
+            <p:cNvPr id="57" name="TextBox 56"/>
+            <p:cNvSpPr txBox="1"/>
+            <p:nvPr/>
+          </p:nvSpPr>
+          <p:spPr>
+            <a:xfrm>
+              <a:off x="7372386" y="2660123"/>
+              <a:ext cx="997389" cy="461665"/>
+            </a:xfrm>
+            <a:prstGeom prst="rect">
+              <a:avLst/>
+            </a:prstGeom>
+            <a:noFill/>
+          </p:spPr>
+          <p:txBody>
+            <a:bodyPr wrap="none" rtlCol="0">
+              <a:spAutoFit/>
+            </a:bodyPr>
+            <a:lstStyle/>
+            <a:p>
+              <a:r>
+                <a:rPr lang="en-US" altLang="ko-KR" sz="2400" dirty="0" err="1" smtClean="0">
+                  <a:latin typeface="나눔스퀘어 Bold" panose="020B0600000101010101" pitchFamily="50" charset="-127"/>
+                  <a:ea typeface="나눔스퀘어 Bold" panose="020B0600000101010101" pitchFamily="50" charset="-127"/>
+                </a:rPr>
+                <a:t>Int</a:t>
               </a:r>
               <a:r>
-                <a:rPr lang="en-US" altLang="ko-KR" sz="6000" dirty="0" err="1" smtClean="0">
+                <a:rPr lang="en-US" altLang="ko-KR" sz="2400" dirty="0" smtClean="0">
+                  <a:latin typeface="나눔스퀘어 Bold" panose="020B0600000101010101" pitchFamily="50" charset="-127"/>
+                  <a:ea typeface="나눔스퀘어 Bold" panose="020B0600000101010101" pitchFamily="50" charset="-127"/>
+                </a:rPr>
+                <a:t>[3]</a:t>
+              </a:r>
+              <a:endParaRPr lang="ko-KR" altLang="en-US" sz="2400" dirty="0">
+                <a:latin typeface="나눔스퀘어 Bold" panose="020B0600000101010101" pitchFamily="50" charset="-127"/>
+                <a:ea typeface="나눔스퀘어 Bold" panose="020B0600000101010101" pitchFamily="50" charset="-127"/>
+              </a:endParaRPr>
+            </a:p>
+          </p:txBody>
+        </p:sp>
+        <p:cxnSp>
+          <p:nvCxnSpPr>
+            <p:cNvPr id="9" name="꺾인 연결선 8"/>
+            <p:cNvCxnSpPr/>
+            <p:nvPr/>
+          </p:nvCxnSpPr>
+          <p:spPr>
+            <a:xfrm flipV="1">
+              <a:off x="4710537" y="3993629"/>
+              <a:ext cx="1800000" cy="493043"/>
+            </a:xfrm>
+            <a:prstGeom prst="bentConnector3">
+              <a:avLst>
+                <a:gd name="adj1" fmla="val 50000"/>
+              </a:avLst>
+            </a:prstGeom>
+            <a:ln w="76200">
+              <a:solidFill>
+                <a:schemeClr val="accent2"/>
+              </a:solidFill>
+              <a:tailEnd type="triangle"/>
+            </a:ln>
+          </p:spPr>
+          <p:style>
+            <a:lnRef idx="1">
+              <a:schemeClr val="accent1"/>
+            </a:lnRef>
+            <a:fillRef idx="0">
+              <a:schemeClr val="accent1"/>
+            </a:fillRef>
+            <a:effectRef idx="0">
+              <a:schemeClr val="accent1"/>
+            </a:effectRef>
+            <a:fontRef idx="minor">
+              <a:schemeClr val="tx1"/>
+            </a:fontRef>
+          </p:style>
+        </p:cxnSp>
+      </p:grpSp>
+    </p:spTree>
+    <p:extLst>
+      <p:ext uri="{BB962C8B-B14F-4D97-AF65-F5344CB8AC3E}">
+        <p14:creationId xmlns:p14="http://schemas.microsoft.com/office/powerpoint/2010/main" val="550415943"/>
+      </p:ext>
+    </p:extLst>
+  </p:cSld>
+  <p:clrMapOvr>
+    <a:masterClrMapping/>
+  </p:clrMapOvr>
+</p:sld>
+</file>
+
+<file path=ppt/slides/slide3.xml><?xml version="1.0" encoding="utf-8"?>
+<p:sld xmlns:a="http://schemas.openxmlformats.org/drawingml/2006/main" xmlns:r="http://schemas.openxmlformats.org/officeDocument/2006/relationships" xmlns:p="http://schemas.openxmlformats.org/presentationml/2006/main">
+  <p:cSld>
+    <p:spTree>
+      <p:nvGrpSpPr>
+        <p:cNvPr id="1" name=""/>
+        <p:cNvGrpSpPr/>
+        <p:nvPr/>
+      </p:nvGrpSpPr>
+      <p:grpSpPr>
+        <a:xfrm>
+          <a:off x="0" y="0"/>
+          <a:ext cx="0" cy="0"/>
+          <a:chOff x="0" y="0"/>
+          <a:chExt cx="0" cy="0"/>
+        </a:xfrm>
+      </p:grpSpPr>
+      <p:grpSp>
+        <p:nvGrpSpPr>
+          <p:cNvPr id="2" name="그룹 1"/>
+          <p:cNvGrpSpPr/>
+          <p:nvPr/>
+        </p:nvGrpSpPr>
+        <p:grpSpPr>
+          <a:xfrm>
+            <a:off x="-339731" y="847396"/>
+            <a:ext cx="15314641" cy="3762146"/>
+            <a:chOff x="-339731" y="847396"/>
+            <a:chExt cx="15314641" cy="3762146"/>
+          </a:xfrm>
+        </p:grpSpPr>
+        <p:sp>
+          <p:nvSpPr>
+            <p:cNvPr id="6" name="TextBox 5"/>
+            <p:cNvSpPr txBox="1"/>
+            <p:nvPr/>
+          </p:nvSpPr>
+          <p:spPr>
+            <a:xfrm>
+              <a:off x="893811" y="1913973"/>
+              <a:ext cx="14081099" cy="1323439"/>
+            </a:xfrm>
+            <a:prstGeom prst="rect">
+              <a:avLst/>
+            </a:prstGeom>
+            <a:noFill/>
+          </p:spPr>
+          <p:txBody>
+            <a:bodyPr wrap="none" rtlCol="0">
+              <a:spAutoFit/>
+            </a:bodyPr>
+            <a:lstStyle/>
+            <a:p>
+              <a:r>
+                <a:rPr lang="en-US" altLang="ko-KR" sz="8000" dirty="0" err="1">
                   <a:latin typeface="나눔스퀘어 Bold" panose="020B0600000101010101" pitchFamily="50" charset="-127"/>
                   <a:ea typeface="나눔스퀘어 Bold" panose="020B0600000101010101" pitchFamily="50" charset="-127"/>
                 </a:rPr>
                 <a:t>i</a:t>
               </a:r>
               <a:r>
-                <a:rPr lang="en-US" altLang="ko-KR" sz="6000" dirty="0" smtClean="0">
+                <a:rPr lang="en-US" altLang="ko-KR" sz="8000" dirty="0" err="1" smtClean="0">
                   <a:latin typeface="나눔스퀘어 Bold" panose="020B0600000101010101" pitchFamily="50" charset="-127"/>
                   <a:ea typeface="나눔스퀘어 Bold" panose="020B0600000101010101" pitchFamily="50" charset="-127"/>
                 </a:rPr>
-                <a:t> &gt; 10) {</a:t>
+                <a:t>nt</a:t>
               </a:r>
-            </a:p>
-            <a:p>
               <a:r>
-                <a:rPr lang="en-US" altLang="ko-KR" sz="6000" dirty="0">
+                <a:rPr lang="en-US" altLang="ko-KR" sz="8000" dirty="0" smtClean="0">
                   <a:latin typeface="나눔스퀘어 Bold" panose="020B0600000101010101" pitchFamily="50" charset="-127"/>
                   <a:ea typeface="나눔스퀘어 Bold" panose="020B0600000101010101" pitchFamily="50" charset="-127"/>
                 </a:rPr>
-                <a:t>	</a:t>
+                <a:t>[] numbers = {10, 20, 30};</a:t>
               </a:r>
-              <a:r>
-                <a:rPr lang="en-US" altLang="ko-KR" sz="6000" dirty="0" err="1" smtClean="0">
-                  <a:latin typeface="나눔스퀘어 Bold" panose="020B0600000101010101" pitchFamily="50" charset="-127"/>
-                  <a:ea typeface="나눔스퀘어 Bold" panose="020B0600000101010101" pitchFamily="50" charset="-127"/>
-                </a:rPr>
-                <a:t>System.out.println</a:t>
-              </a:r>
-              <a:r>
-                <a:rPr lang="en-US" altLang="ko-KR" sz="6000" dirty="0" smtClean="0">
-                  <a:latin typeface="나눔스퀘어 Bold" panose="020B0600000101010101" pitchFamily="50" charset="-127"/>
-                  <a:ea typeface="나눔스퀘어 Bold" panose="020B0600000101010101" pitchFamily="50" charset="-127"/>
-                </a:rPr>
-                <a:t>(“</a:t>
-              </a:r>
-              <a:r>
-                <a:rPr lang="ko-KR" altLang="en-US" sz="6000" dirty="0" smtClean="0">
-                  <a:latin typeface="나눔스퀘어 Bold" panose="020B0600000101010101" pitchFamily="50" charset="-127"/>
-                  <a:ea typeface="나눔스퀘어 Bold" panose="020B0600000101010101" pitchFamily="50" charset="-127"/>
-                </a:rPr>
-                <a:t>현재 </a:t>
-              </a:r>
-              <a:r>
-                <a:rPr lang="en-US" altLang="ko-KR" sz="6000" dirty="0" err="1">
-                  <a:latin typeface="나눔스퀘어 Bold" panose="020B0600000101010101" pitchFamily="50" charset="-127"/>
-                  <a:ea typeface="나눔스퀘어 Bold" panose="020B0600000101010101" pitchFamily="50" charset="-127"/>
-                </a:rPr>
-                <a:t>i</a:t>
-              </a:r>
-              <a:r>
-                <a:rPr lang="en-US" altLang="ko-KR" sz="6000" dirty="0" smtClean="0">
-                  <a:latin typeface="나눔스퀘어 Bold" panose="020B0600000101010101" pitchFamily="50" charset="-127"/>
-                  <a:ea typeface="나눔스퀘어 Bold" panose="020B0600000101010101" pitchFamily="50" charset="-127"/>
-                </a:rPr>
-                <a:t> : ” + </a:t>
-              </a:r>
-              <a:r>
-                <a:rPr lang="en-US" altLang="ko-KR" sz="6000" dirty="0" err="1" smtClean="0">
-                  <a:latin typeface="나눔스퀘어 Bold" panose="020B0600000101010101" pitchFamily="50" charset="-127"/>
-                  <a:ea typeface="나눔스퀘어 Bold" panose="020B0600000101010101" pitchFamily="50" charset="-127"/>
-                </a:rPr>
-                <a:t>i</a:t>
-              </a:r>
-              <a:r>
-                <a:rPr lang="en-US" altLang="ko-KR" sz="6000" dirty="0" smtClean="0">
-                  <a:latin typeface="나눔스퀘어 Bold" panose="020B0600000101010101" pitchFamily="50" charset="-127"/>
-                  <a:ea typeface="나눔스퀘어 Bold" panose="020B0600000101010101" pitchFamily="50" charset="-127"/>
-                </a:rPr>
-                <a:t>);</a:t>
-              </a:r>
-            </a:p>
-            <a:p>
-              <a:r>
-                <a:rPr lang="en-US" altLang="ko-KR" sz="6000" dirty="0">
-                  <a:latin typeface="나눔스퀘어 Bold" panose="020B0600000101010101" pitchFamily="50" charset="-127"/>
-                  <a:ea typeface="나눔스퀘어 Bold" panose="020B0600000101010101" pitchFamily="50" charset="-127"/>
-                </a:rPr>
-                <a:t>	</a:t>
-              </a:r>
-              <a:r>
-                <a:rPr lang="en-US" altLang="ko-KR" sz="6000" dirty="0" err="1" smtClean="0">
-                  <a:latin typeface="나눔스퀘어 Bold" panose="020B0600000101010101" pitchFamily="50" charset="-127"/>
-                  <a:ea typeface="나눔스퀘어 Bold" panose="020B0600000101010101" pitchFamily="50" charset="-127"/>
-                </a:rPr>
-                <a:t>i</a:t>
-              </a:r>
-              <a:r>
-                <a:rPr lang="en-US" altLang="ko-KR" sz="6000" dirty="0" smtClean="0">
-                  <a:latin typeface="나눔스퀘어 Bold" panose="020B0600000101010101" pitchFamily="50" charset="-127"/>
-                  <a:ea typeface="나눔스퀘어 Bold" panose="020B0600000101010101" pitchFamily="50" charset="-127"/>
-                </a:rPr>
-                <a:t>++;</a:t>
-              </a:r>
-            </a:p>
-            <a:p>
-              <a:r>
-                <a:rPr lang="en-US" altLang="ko-KR" sz="6000" dirty="0">
-                  <a:latin typeface="나눔스퀘어 Bold" panose="020B0600000101010101" pitchFamily="50" charset="-127"/>
-                  <a:ea typeface="나눔스퀘어 Bold" panose="020B0600000101010101" pitchFamily="50" charset="-127"/>
-                </a:rPr>
-                <a:t>}</a:t>
-              </a:r>
-              <a:endParaRPr lang="ko-KR" altLang="en-US" sz="6000" dirty="0">
+              <a:endParaRPr lang="ko-KR" altLang="en-US" sz="8000" dirty="0">
                 <a:latin typeface="나눔스퀘어 Bold" panose="020B0600000101010101" pitchFamily="50" charset="-127"/>
                 <a:ea typeface="나눔스퀘어 Bold" panose="020B0600000101010101" pitchFamily="50" charset="-127"/>
               </a:endParaRPr>
@@ -8535,7 +9683,7 @@
           </p:nvSpPr>
           <p:spPr>
             <a:xfrm rot="10800000">
-              <a:off x="1529747" y="3172290"/>
+              <a:off x="2424692" y="3198502"/>
               <a:ext cx="432000" cy="720000"/>
             </a:xfrm>
             <a:prstGeom prst="downArrow">
@@ -8581,8 +9729,8 @@
           </p:nvSpPr>
           <p:spPr>
             <a:xfrm>
-              <a:off x="2959045" y="-685216"/>
-              <a:ext cx="1444626" cy="646331"/>
+              <a:off x="4108403" y="847396"/>
+              <a:ext cx="2400017" cy="646331"/>
             </a:xfrm>
             <a:prstGeom prst="rect">
               <a:avLst/>
@@ -8601,7 +9749,14 @@
                   <a:latin typeface="나눔스퀘어 Bold" panose="020B0600000101010101" pitchFamily="50" charset="-127"/>
                   <a:ea typeface="나눔스퀘어 Bold" panose="020B0600000101010101" pitchFamily="50" charset="-127"/>
                 </a:rPr>
-                <a:t>조건식</a:t>
+                <a:t>배열 </a:t>
+              </a:r>
+              <a:r>
+                <a:rPr lang="ko-KR" altLang="en-US" sz="3600" dirty="0" err="1" smtClean="0">
+                  <a:latin typeface="나눔스퀘어 Bold" panose="020B0600000101010101" pitchFamily="50" charset="-127"/>
+                  <a:ea typeface="나눔스퀘어 Bold" panose="020B0600000101010101" pitchFamily="50" charset="-127"/>
+                </a:rPr>
+                <a:t>변수명</a:t>
               </a:r>
               <a:endParaRPr lang="ko-KR" altLang="en-US" sz="3600" dirty="0">
                 <a:latin typeface="나눔스퀘어 Bold" panose="020B0600000101010101" pitchFamily="50" charset="-127"/>
@@ -8618,7 +9773,7 @@
           </p:nvSpPr>
           <p:spPr>
             <a:xfrm>
-              <a:off x="3465358" y="-38885"/>
+              <a:off x="5092410" y="1493727"/>
               <a:ext cx="432000" cy="720000"/>
             </a:xfrm>
             <a:prstGeom prst="downArrow">
@@ -8664,8 +9819,8 @@
           </p:nvSpPr>
           <p:spPr>
             <a:xfrm>
-              <a:off x="7124362" y="195171"/>
-              <a:ext cx="1444626" cy="646331"/>
+              <a:off x="6395902" y="3963211"/>
+              <a:ext cx="5048178" cy="646331"/>
             </a:xfrm>
             <a:prstGeom prst="rect">
               <a:avLst/>
@@ -8680,11 +9835,39 @@
             <a:p>
               <a:pPr algn="ctr"/>
               <a:r>
+                <a:rPr lang="ko-KR" altLang="en-US" sz="3600" dirty="0" smtClean="0">
+                  <a:latin typeface="나눔스퀘어 Bold" panose="020B0600000101010101" pitchFamily="50" charset="-127"/>
+                  <a:ea typeface="나눔스퀘어 Bold" panose="020B0600000101010101" pitchFamily="50" charset="-127"/>
+                </a:rPr>
+                <a:t>배열 </a:t>
+              </a:r>
+              <a:r>
                 <a:rPr lang="ko-KR" altLang="en-US" sz="3600" dirty="0" err="1" smtClean="0">
                   <a:latin typeface="나눔스퀘어 Bold" panose="020B0600000101010101" pitchFamily="50" charset="-127"/>
                   <a:ea typeface="나눔스퀘어 Bold" panose="020B0600000101010101" pitchFamily="50" charset="-127"/>
                 </a:rPr>
-                <a:t>실행문</a:t>
+                <a:t>리터럴</a:t>
+              </a:r>
+              <a:r>
+                <a:rPr lang="ko-KR" altLang="en-US" sz="3600" dirty="0" smtClean="0">
+                  <a:latin typeface="나눔스퀘어 Bold" panose="020B0600000101010101" pitchFamily="50" charset="-127"/>
+                  <a:ea typeface="나눔스퀘어 Bold" panose="020B0600000101010101" pitchFamily="50" charset="-127"/>
+                </a:rPr>
+                <a:t> </a:t>
+              </a:r>
+              <a:r>
+                <a:rPr lang="en-US" altLang="ko-KR" sz="3600" dirty="0" smtClean="0">
+                  <a:latin typeface="나눔스퀘어 Bold" panose="020B0600000101010101" pitchFamily="50" charset="-127"/>
+                  <a:ea typeface="나눔스퀘어 Bold" panose="020B0600000101010101" pitchFamily="50" charset="-127"/>
+                </a:rPr>
+                <a:t>/ </a:t>
+              </a:r>
+              <a:r>
+                <a:rPr lang="ko-KR" altLang="en-US" sz="3600" dirty="0" smtClean="0">
+                  <a:latin typeface="나눔스퀘어 Bold" panose="020B0600000101010101" pitchFamily="50" charset="-127"/>
+                  <a:ea typeface="나눔스퀘어 Bold" panose="020B0600000101010101" pitchFamily="50" charset="-127"/>
+                </a:rPr>
+                <a:t>초기화 블록</a:t>
               </a:r>
               <a:endParaRPr lang="ko-KR" altLang="en-US" sz="3600" dirty="0">
                 <a:latin typeface="나눔스퀘어 Bold" panose="020B0600000101010101" pitchFamily="50" charset="-127"/>
@@ -8701,8 +9884,8 @@
           </p:nvSpPr>
           <p:spPr>
             <a:xfrm>
-              <a:off x="-126254" y="-685216"/>
-              <a:ext cx="2686953" cy="646331"/>
+              <a:off x="-339731" y="847396"/>
+              <a:ext cx="3775394" cy="646331"/>
             </a:xfrm>
             <a:prstGeom prst="rect">
               <a:avLst/>
@@ -8717,18 +9900,18 @@
             <a:p>
               <a:pPr algn="ctr"/>
               <a:r>
-                <a:rPr lang="en-US" altLang="ko-KR" sz="3600" dirty="0">
-                  <a:latin typeface="나눔스퀘어 Bold" panose="020B0600000101010101" pitchFamily="50" charset="-127"/>
-                  <a:ea typeface="나눔스퀘어 Bold" panose="020B0600000101010101" pitchFamily="50" charset="-127"/>
-                </a:rPr>
-                <a:t>while </a:t>
-              </a:r>
-              <a:r>
                 <a:rPr lang="ko-KR" altLang="en-US" sz="3600" dirty="0" smtClean="0">
                   <a:latin typeface="나눔스퀘어 Bold" panose="020B0600000101010101" pitchFamily="50" charset="-127"/>
                   <a:ea typeface="나눔스퀘어 Bold" panose="020B0600000101010101" pitchFamily="50" charset="-127"/>
                 </a:rPr>
-                <a:t>키워드</a:t>
+                <a:t>배열 선언의 </a:t>
+              </a:r>
+              <a:r>
+                <a:rPr lang="ko-KR" altLang="en-US" sz="3600" dirty="0" err="1" smtClean="0">
+                  <a:latin typeface="나눔스퀘어 Bold" panose="020B0600000101010101" pitchFamily="50" charset="-127"/>
+                  <a:ea typeface="나눔스퀘어 Bold" panose="020B0600000101010101" pitchFamily="50" charset="-127"/>
+                </a:rPr>
+                <a:t>자료형</a:t>
               </a:r>
               <a:endParaRPr lang="ko-KR" altLang="en-US" sz="3600" dirty="0">
                 <a:latin typeface="나눔스퀘어 Bold" panose="020B0600000101010101" pitchFamily="50" charset="-127"/>
@@ -8745,7 +9928,7 @@
           </p:nvSpPr>
           <p:spPr>
             <a:xfrm>
-              <a:off x="1001222" y="-38885"/>
+              <a:off x="1331963" y="1493727"/>
               <a:ext cx="432000" cy="720000"/>
             </a:xfrm>
             <a:prstGeom prst="downArrow">
@@ -8791,8 +9974,8 @@
           </p:nvSpPr>
           <p:spPr>
             <a:xfrm>
-              <a:off x="1023434" y="3895189"/>
-              <a:ext cx="1444626" cy="646331"/>
+              <a:off x="1172983" y="3921401"/>
+              <a:ext cx="2935420" cy="646331"/>
             </a:xfrm>
             <a:prstGeom prst="rect">
               <a:avLst/>
@@ -8807,11 +9990,11 @@
             <a:p>
               <a:pPr algn="ctr"/>
               <a:r>
-                <a:rPr lang="ko-KR" altLang="en-US" sz="3600" dirty="0" err="1" smtClean="0">
+                <a:rPr lang="ko-KR" altLang="en-US" sz="3600" dirty="0" smtClean="0">
                   <a:latin typeface="나눔스퀘어 Bold" panose="020B0600000101010101" pitchFamily="50" charset="-127"/>
                   <a:ea typeface="나눔스퀘어 Bold" panose="020B0600000101010101" pitchFamily="50" charset="-127"/>
                 </a:rPr>
-                <a:t>증감식</a:t>
+                <a:t>배열 선언 기호</a:t>
               </a:r>
               <a:endParaRPr lang="ko-KR" altLang="en-US" sz="3600" dirty="0">
                 <a:latin typeface="나눔스퀘어 Bold" panose="020B0600000101010101" pitchFamily="50" charset="-127"/>
@@ -8828,7 +10011,7 @@
           </p:nvSpPr>
           <p:spPr>
             <a:xfrm>
-              <a:off x="7630675" y="847301"/>
+              <a:off x="11307732" y="1499526"/>
               <a:ext cx="432000" cy="720000"/>
             </a:xfrm>
             <a:prstGeom prst="downArrow">
@@ -8866,11 +10049,94 @@
             </a:p>
           </p:txBody>
         </p:sp>
+        <p:sp>
+          <p:nvSpPr>
+            <p:cNvPr id="12" name="아래쪽 화살표 11"/>
+            <p:cNvSpPr/>
+            <p:nvPr/>
+          </p:nvSpPr>
+          <p:spPr>
+            <a:xfrm rot="10800000">
+              <a:off x="8703987" y="3237412"/>
+              <a:ext cx="432000" cy="720000"/>
+            </a:xfrm>
+            <a:prstGeom prst="downArrow">
+              <a:avLst/>
+            </a:prstGeom>
+            <a:solidFill>
+              <a:schemeClr val="accent2"/>
+            </a:solidFill>
+            <a:ln>
+              <a:noFill/>
+            </a:ln>
+          </p:spPr>
+          <p:style>
+            <a:lnRef idx="2">
+              <a:schemeClr val="accent1">
+                <a:shade val="50000"/>
+              </a:schemeClr>
+            </a:lnRef>
+            <a:fillRef idx="1">
+              <a:schemeClr val="accent1"/>
+            </a:fillRef>
+            <a:effectRef idx="0">
+              <a:schemeClr val="accent1"/>
+            </a:effectRef>
+            <a:fontRef idx="minor">
+              <a:schemeClr val="lt1"/>
+            </a:fontRef>
+          </p:style>
+          <p:txBody>
+            <a:bodyPr rtlCol="0" anchor="ctr"/>
+            <a:lstStyle/>
+            <a:p>
+              <a:pPr algn="ctr"/>
+              <a:endParaRPr lang="ko-KR" altLang="en-US" sz="3600"/>
+            </a:p>
+          </p:txBody>
+        </p:sp>
+        <p:sp>
+          <p:nvSpPr>
+            <p:cNvPr id="13" name="TextBox 12"/>
+            <p:cNvSpPr txBox="1"/>
+            <p:nvPr/>
+          </p:nvSpPr>
+          <p:spPr>
+            <a:xfrm>
+              <a:off x="10323724" y="847396"/>
+              <a:ext cx="2400017" cy="646331"/>
+            </a:xfrm>
+            <a:prstGeom prst="rect">
+              <a:avLst/>
+            </a:prstGeom>
+            <a:noFill/>
+          </p:spPr>
+          <p:txBody>
+            <a:bodyPr wrap="none" rtlCol="0">
+              <a:spAutoFit/>
+            </a:bodyPr>
+            <a:lstStyle/>
+            <a:p>
+              <a:pPr algn="ctr"/>
+              <a:r>
+                <a:rPr lang="ko-KR" altLang="en-US" sz="3600" dirty="0" smtClean="0">
+                  <a:latin typeface="나눔스퀘어 Bold" panose="020B0600000101010101" pitchFamily="50" charset="-127"/>
+                  <a:ea typeface="나눔스퀘어 Bold" panose="020B0600000101010101" pitchFamily="50" charset="-127"/>
+                </a:rPr>
+                <a:t>배열의 요소</a:t>
+              </a:r>
+              <a:endParaRPr lang="ko-KR" altLang="en-US" sz="3600" dirty="0">
+                <a:latin typeface="나눔스퀘어 Bold" panose="020B0600000101010101" pitchFamily="50" charset="-127"/>
+                <a:ea typeface="나눔스퀘어 Bold" panose="020B0600000101010101" pitchFamily="50" charset="-127"/>
+              </a:endParaRPr>
+            </a:p>
+          </p:txBody>
+        </p:sp>
       </p:grpSp>
     </p:spTree>
     <p:extLst>
       <p:ext uri="{BB962C8B-B14F-4D97-AF65-F5344CB8AC3E}">
-        <p14:creationId xmlns:p14="http://schemas.microsoft.com/office/powerpoint/2010/main" val="550415943"/>
+        <p14:creationId xmlns:p14="http://schemas.microsoft.com/office/powerpoint/2010/main" val="1679211822"/>
       </p:ext>
     </p:extLst>
   </p:cSld>

</xml_diff>

<commit_message>
20260810 commit : Notion Clear at Home
</commit_message>
<xml_diff>
--- a/create_notion_img.pptx
+++ b/create_notion_img.pptx
@@ -6,9 +6,10 @@
   </p:sldMasterIdLst>
   <p:sldIdLst>
     <p:sldId id="256" r:id="rId2"/>
-    <p:sldId id="259" r:id="rId3"/>
-    <p:sldId id="257" r:id="rId4"/>
-    <p:sldId id="258" r:id="rId5"/>
+    <p:sldId id="260" r:id="rId3"/>
+    <p:sldId id="259" r:id="rId4"/>
+    <p:sldId id="257" r:id="rId5"/>
+    <p:sldId id="258" r:id="rId6"/>
   </p:sldIdLst>
   <p:sldSz cx="12192000" cy="6858000"/>
   <p:notesSz cx="6858000" cy="9144000"/>
@@ -246,7 +247,7 @@
           <a:p>
             <a:fld id="{7237CE1A-8831-48B5-BA93-72483C6E34E8}" type="datetimeFigureOut">
               <a:rPr lang="ko-KR" altLang="en-US" smtClean="0"/>
-              <a:t>26-08-09(Sun)</a:t>
+              <a:t>2026-08-10</a:t>
             </a:fld>
             <a:endParaRPr lang="ko-KR" altLang="en-US"/>
           </a:p>
@@ -416,7 +417,7 @@
           <a:p>
             <a:fld id="{7237CE1A-8831-48B5-BA93-72483C6E34E8}" type="datetimeFigureOut">
               <a:rPr lang="ko-KR" altLang="en-US" smtClean="0"/>
-              <a:t>26-08-09(Sun)</a:t>
+              <a:t>2026-08-10</a:t>
             </a:fld>
             <a:endParaRPr lang="ko-KR" altLang="en-US"/>
           </a:p>
@@ -596,7 +597,7 @@
           <a:p>
             <a:fld id="{7237CE1A-8831-48B5-BA93-72483C6E34E8}" type="datetimeFigureOut">
               <a:rPr lang="ko-KR" altLang="en-US" smtClean="0"/>
-              <a:t>26-08-09(Sun)</a:t>
+              <a:t>2026-08-10</a:t>
             </a:fld>
             <a:endParaRPr lang="ko-KR" altLang="en-US"/>
           </a:p>
@@ -766,7 +767,7 @@
           <a:p>
             <a:fld id="{7237CE1A-8831-48B5-BA93-72483C6E34E8}" type="datetimeFigureOut">
               <a:rPr lang="ko-KR" altLang="en-US" smtClean="0"/>
-              <a:t>26-08-09(Sun)</a:t>
+              <a:t>2026-08-10</a:t>
             </a:fld>
             <a:endParaRPr lang="ko-KR" altLang="en-US"/>
           </a:p>
@@ -1012,7 +1013,7 @@
           <a:p>
             <a:fld id="{7237CE1A-8831-48B5-BA93-72483C6E34E8}" type="datetimeFigureOut">
               <a:rPr lang="ko-KR" altLang="en-US" smtClean="0"/>
-              <a:t>26-08-09(Sun)</a:t>
+              <a:t>2026-08-10</a:t>
             </a:fld>
             <a:endParaRPr lang="ko-KR" altLang="en-US"/>
           </a:p>
@@ -1244,7 +1245,7 @@
           <a:p>
             <a:fld id="{7237CE1A-8831-48B5-BA93-72483C6E34E8}" type="datetimeFigureOut">
               <a:rPr lang="ko-KR" altLang="en-US" smtClean="0"/>
-              <a:t>26-08-09(Sun)</a:t>
+              <a:t>2026-08-10</a:t>
             </a:fld>
             <a:endParaRPr lang="ko-KR" altLang="en-US"/>
           </a:p>
@@ -1611,7 +1612,7 @@
           <a:p>
             <a:fld id="{7237CE1A-8831-48B5-BA93-72483C6E34E8}" type="datetimeFigureOut">
               <a:rPr lang="ko-KR" altLang="en-US" smtClean="0"/>
-              <a:t>26-08-09(Sun)</a:t>
+              <a:t>2026-08-10</a:t>
             </a:fld>
             <a:endParaRPr lang="ko-KR" altLang="en-US"/>
           </a:p>
@@ -1729,7 +1730,7 @@
           <a:p>
             <a:fld id="{7237CE1A-8831-48B5-BA93-72483C6E34E8}" type="datetimeFigureOut">
               <a:rPr lang="ko-KR" altLang="en-US" smtClean="0"/>
-              <a:t>26-08-09(Sun)</a:t>
+              <a:t>2026-08-10</a:t>
             </a:fld>
             <a:endParaRPr lang="ko-KR" altLang="en-US"/>
           </a:p>
@@ -1824,7 +1825,7 @@
           <a:p>
             <a:fld id="{7237CE1A-8831-48B5-BA93-72483C6E34E8}" type="datetimeFigureOut">
               <a:rPr lang="ko-KR" altLang="en-US" smtClean="0"/>
-              <a:t>26-08-09(Sun)</a:t>
+              <a:t>2026-08-10</a:t>
             </a:fld>
             <a:endParaRPr lang="ko-KR" altLang="en-US"/>
           </a:p>
@@ -2101,7 +2102,7 @@
           <a:p>
             <a:fld id="{7237CE1A-8831-48B5-BA93-72483C6E34E8}" type="datetimeFigureOut">
               <a:rPr lang="ko-KR" altLang="en-US" smtClean="0"/>
-              <a:t>26-08-09(Sun)</a:t>
+              <a:t>2026-08-10</a:t>
             </a:fld>
             <a:endParaRPr lang="ko-KR" altLang="en-US"/>
           </a:p>
@@ -2354,7 +2355,7 @@
           <a:p>
             <a:fld id="{7237CE1A-8831-48B5-BA93-72483C6E34E8}" type="datetimeFigureOut">
               <a:rPr lang="ko-KR" altLang="en-US" smtClean="0"/>
-              <a:t>26-08-09(Sun)</a:t>
+              <a:t>2026-08-10</a:t>
             </a:fld>
             <a:endParaRPr lang="ko-KR" altLang="en-US"/>
           </a:p>
@@ -2567,7 +2568,7 @@
           <a:p>
             <a:fld id="{7237CE1A-8831-48B5-BA93-72483C6E34E8}" type="datetimeFigureOut">
               <a:rPr lang="ko-KR" altLang="en-US" smtClean="0"/>
-              <a:t>26-08-09(Sun)</a:t>
+              <a:t>2026-08-10</a:t>
             </a:fld>
             <a:endParaRPr lang="ko-KR" altLang="en-US"/>
           </a:p>
@@ -2972,6 +2973,93 @@
           <a:chExt cx="0" cy="0"/>
         </a:xfrm>
       </p:grpSpPr>
+      <p:graphicFrame>
+        <p:nvGraphicFramePr>
+          <p:cNvPr id="3" name="개체 2"/>
+          <p:cNvGraphicFramePr>
+            <a:graphicFrameLocks noChangeAspect="1"/>
+          </p:cNvGraphicFramePr>
+          <p:nvPr>
+            <p:extLst>
+              <p:ext uri="{D42A27DB-BD31-4B8C-83A1-F6EECF244321}">
+                <p14:modId xmlns:p14="http://schemas.microsoft.com/office/powerpoint/2010/main" val="1477509955"/>
+              </p:ext>
+            </p:extLst>
+          </p:nvPr>
+        </p:nvGraphicFramePr>
+        <p:xfrm>
+          <a:off x="4291013" y="2184401"/>
+          <a:ext cx="4844354" cy="1981200"/>
+        </p:xfrm>
+        <a:graphic>
+          <a:graphicData uri="http://schemas.openxmlformats.org/presentationml/2006/ole">
+            <mc:AlternateContent xmlns:mc="http://schemas.openxmlformats.org/markup-compatibility/2006">
+              <mc:Choice xmlns:v="urn:schemas-microsoft-com:vml" Requires="v">
+                <p:oleObj spid="_x0000_s1025" name="워크시트" r:id="rId3" imgW="3610051" imgH="1476487" progId="Excel.Sheet.12">
+                  <p:embed/>
+                </p:oleObj>
+              </mc:Choice>
+              <mc:Fallback>
+                <p:oleObj name="워크시트" r:id="rId3" imgW="3610051" imgH="1476487" progId="Excel.Sheet.12">
+                  <p:embed/>
+                  <p:pic>
+                    <p:nvPicPr>
+                      <p:cNvPr id="0" name=""/>
+                      <p:cNvPicPr/>
+                      <p:nvPr/>
+                    </p:nvPicPr>
+                    <p:blipFill>
+                      <a:blip r:embed="rId4"/>
+                      <a:stretch>
+                        <a:fillRect/>
+                      </a:stretch>
+                    </p:blipFill>
+                    <p:spPr>
+                      <a:xfrm>
+                        <a:off x="4291013" y="2184401"/>
+                        <a:ext cx="4844354" cy="1981200"/>
+                      </a:xfrm>
+                      <a:prstGeom prst="rect">
+                        <a:avLst/>
+                      </a:prstGeom>
+                    </p:spPr>
+                  </p:pic>
+                </p:oleObj>
+              </mc:Fallback>
+            </mc:AlternateContent>
+          </a:graphicData>
+        </a:graphic>
+      </p:graphicFrame>
+    </p:spTree>
+    <p:extLst>
+      <p:ext uri="{BB962C8B-B14F-4D97-AF65-F5344CB8AC3E}">
+        <p14:creationId xmlns:p14="http://schemas.microsoft.com/office/powerpoint/2010/main" val="2040070256"/>
+      </p:ext>
+    </p:extLst>
+  </p:cSld>
+  <p:clrMapOvr>
+    <a:masterClrMapping/>
+  </p:clrMapOvr>
+</p:sld>
+</file>
+
+<file path=ppt/slides/slide2.xml><?xml version="1.0" encoding="utf-8"?>
+<p:sld xmlns:a="http://schemas.openxmlformats.org/drawingml/2006/main" xmlns:r="http://schemas.openxmlformats.org/officeDocument/2006/relationships" xmlns:p="http://schemas.openxmlformats.org/presentationml/2006/main">
+  <p:cSld>
+    <p:spTree>
+      <p:nvGrpSpPr>
+        <p:cNvPr id="1" name=""/>
+        <p:cNvGrpSpPr/>
+        <p:nvPr/>
+      </p:nvGrpSpPr>
+      <p:grpSpPr>
+        <a:xfrm>
+          <a:off x="0" y="0"/>
+          <a:ext cx="0" cy="0"/>
+          <a:chOff x="0" y="0"/>
+          <a:chExt cx="0" cy="0"/>
+        </a:xfrm>
+      </p:grpSpPr>
       <p:grpSp>
         <p:nvGrpSpPr>
           <p:cNvPr id="46" name="그룹 45"/>
@@ -5556,7 +5644,7 @@
     </p:spTree>
     <p:extLst>
       <p:ext uri="{BB962C8B-B14F-4D97-AF65-F5344CB8AC3E}">
-        <p14:creationId xmlns:p14="http://schemas.microsoft.com/office/powerpoint/2010/main" val="2040070256"/>
+        <p14:creationId xmlns:p14="http://schemas.microsoft.com/office/powerpoint/2010/main" val="2557989807"/>
       </p:ext>
     </p:extLst>
   </p:cSld>
@@ -5566,7 +5654,7 @@
 </p:sld>
 </file>
 
-<file path=ppt/slides/slide2.xml><?xml version="1.0" encoding="utf-8"?>
+<file path=ppt/slides/slide3.xml><?xml version="1.0" encoding="utf-8"?>
 <p:sld xmlns:a="http://schemas.openxmlformats.org/drawingml/2006/main" xmlns:r="http://schemas.openxmlformats.org/officeDocument/2006/relationships" xmlns:p="http://schemas.openxmlformats.org/presentationml/2006/main">
   <p:cSld>
     <p:spTree>
@@ -10969,7 +11057,7 @@
 </p:sld>
 </file>
 
-<file path=ppt/slides/slide3.xml><?xml version="1.0" encoding="utf-8"?>
+<file path=ppt/slides/slide4.xml><?xml version="1.0" encoding="utf-8"?>
 <p:sld xmlns:a="http://schemas.openxmlformats.org/drawingml/2006/main" xmlns:r="http://schemas.openxmlformats.org/officeDocument/2006/relationships" xmlns:p="http://schemas.openxmlformats.org/presentationml/2006/main">
   <p:cSld>
     <p:spTree>
@@ -12831,7 +12919,7 @@
 </p:sld>
 </file>
 
-<file path=ppt/slides/slide4.xml><?xml version="1.0" encoding="utf-8"?>
+<file path=ppt/slides/slide5.xml><?xml version="1.0" encoding="utf-8"?>
 <p:sld xmlns:a="http://schemas.openxmlformats.org/drawingml/2006/main" xmlns:r="http://schemas.openxmlformats.org/officeDocument/2006/relationships" xmlns:p="http://schemas.openxmlformats.org/presentationml/2006/main">
   <p:cSld>
     <p:spTree>

</xml_diff>

<commit_message>
20260810 commit : finished, today
</commit_message>
<xml_diff>
--- a/create_notion_img.pptx
+++ b/create_notion_img.pptx
@@ -247,7 +247,7 @@
           <a:p>
             <a:fld id="{7237CE1A-8831-48B5-BA93-72483C6E34E8}" type="datetimeFigureOut">
               <a:rPr lang="ko-KR" altLang="en-US" smtClean="0"/>
-              <a:t>2026-08-10</a:t>
+              <a:t>26-08-10(Mon)</a:t>
             </a:fld>
             <a:endParaRPr lang="ko-KR" altLang="en-US"/>
           </a:p>
@@ -417,7 +417,7 @@
           <a:p>
             <a:fld id="{7237CE1A-8831-48B5-BA93-72483C6E34E8}" type="datetimeFigureOut">
               <a:rPr lang="ko-KR" altLang="en-US" smtClean="0"/>
-              <a:t>2026-08-10</a:t>
+              <a:t>26-08-10(Mon)</a:t>
             </a:fld>
             <a:endParaRPr lang="ko-KR" altLang="en-US"/>
           </a:p>
@@ -597,7 +597,7 @@
           <a:p>
             <a:fld id="{7237CE1A-8831-48B5-BA93-72483C6E34E8}" type="datetimeFigureOut">
               <a:rPr lang="ko-KR" altLang="en-US" smtClean="0"/>
-              <a:t>2026-08-10</a:t>
+              <a:t>26-08-10(Mon)</a:t>
             </a:fld>
             <a:endParaRPr lang="ko-KR" altLang="en-US"/>
           </a:p>
@@ -767,7 +767,7 @@
           <a:p>
             <a:fld id="{7237CE1A-8831-48B5-BA93-72483C6E34E8}" type="datetimeFigureOut">
               <a:rPr lang="ko-KR" altLang="en-US" smtClean="0"/>
-              <a:t>2026-08-10</a:t>
+              <a:t>26-08-10(Mon)</a:t>
             </a:fld>
             <a:endParaRPr lang="ko-KR" altLang="en-US"/>
           </a:p>
@@ -1013,7 +1013,7 @@
           <a:p>
             <a:fld id="{7237CE1A-8831-48B5-BA93-72483C6E34E8}" type="datetimeFigureOut">
               <a:rPr lang="ko-KR" altLang="en-US" smtClean="0"/>
-              <a:t>2026-08-10</a:t>
+              <a:t>26-08-10(Mon)</a:t>
             </a:fld>
             <a:endParaRPr lang="ko-KR" altLang="en-US"/>
           </a:p>
@@ -1245,7 +1245,7 @@
           <a:p>
             <a:fld id="{7237CE1A-8831-48B5-BA93-72483C6E34E8}" type="datetimeFigureOut">
               <a:rPr lang="ko-KR" altLang="en-US" smtClean="0"/>
-              <a:t>2026-08-10</a:t>
+              <a:t>26-08-10(Mon)</a:t>
             </a:fld>
             <a:endParaRPr lang="ko-KR" altLang="en-US"/>
           </a:p>
@@ -1612,7 +1612,7 @@
           <a:p>
             <a:fld id="{7237CE1A-8831-48B5-BA93-72483C6E34E8}" type="datetimeFigureOut">
               <a:rPr lang="ko-KR" altLang="en-US" smtClean="0"/>
-              <a:t>2026-08-10</a:t>
+              <a:t>26-08-10(Mon)</a:t>
             </a:fld>
             <a:endParaRPr lang="ko-KR" altLang="en-US"/>
           </a:p>
@@ -1730,7 +1730,7 @@
           <a:p>
             <a:fld id="{7237CE1A-8831-48B5-BA93-72483C6E34E8}" type="datetimeFigureOut">
               <a:rPr lang="ko-KR" altLang="en-US" smtClean="0"/>
-              <a:t>2026-08-10</a:t>
+              <a:t>26-08-10(Mon)</a:t>
             </a:fld>
             <a:endParaRPr lang="ko-KR" altLang="en-US"/>
           </a:p>
@@ -1825,7 +1825,7 @@
           <a:p>
             <a:fld id="{7237CE1A-8831-48B5-BA93-72483C6E34E8}" type="datetimeFigureOut">
               <a:rPr lang="ko-KR" altLang="en-US" smtClean="0"/>
-              <a:t>2026-08-10</a:t>
+              <a:t>26-08-10(Mon)</a:t>
             </a:fld>
             <a:endParaRPr lang="ko-KR" altLang="en-US"/>
           </a:p>
@@ -2102,7 +2102,7 @@
           <a:p>
             <a:fld id="{7237CE1A-8831-48B5-BA93-72483C6E34E8}" type="datetimeFigureOut">
               <a:rPr lang="ko-KR" altLang="en-US" smtClean="0"/>
-              <a:t>2026-08-10</a:t>
+              <a:t>26-08-10(Mon)</a:t>
             </a:fld>
             <a:endParaRPr lang="ko-KR" altLang="en-US"/>
           </a:p>
@@ -2355,7 +2355,7 @@
           <a:p>
             <a:fld id="{7237CE1A-8831-48B5-BA93-72483C6E34E8}" type="datetimeFigureOut">
               <a:rPr lang="ko-KR" altLang="en-US" smtClean="0"/>
-              <a:t>2026-08-10</a:t>
+              <a:t>26-08-10(Mon)</a:t>
             </a:fld>
             <a:endParaRPr lang="ko-KR" altLang="en-US"/>
           </a:p>
@@ -2568,7 +2568,7 @@
           <a:p>
             <a:fld id="{7237CE1A-8831-48B5-BA93-72483C6E34E8}" type="datetimeFigureOut">
               <a:rPr lang="ko-KR" altLang="en-US" smtClean="0"/>
-              <a:t>2026-08-10</a:t>
+              <a:t>26-08-10(Mon)</a:t>
             </a:fld>
             <a:endParaRPr lang="ko-KR" altLang="en-US"/>
           </a:p>
@@ -2995,7 +2995,7 @@
           <a:graphicData uri="http://schemas.openxmlformats.org/presentationml/2006/ole">
             <mc:AlternateContent xmlns:mc="http://schemas.openxmlformats.org/markup-compatibility/2006">
               <mc:Choice xmlns:v="urn:schemas-microsoft-com:vml" Requires="v">
-                <p:oleObj spid="_x0000_s1025" name="워크시트" r:id="rId3" imgW="3610051" imgH="1476487" progId="Excel.Sheet.12">
+                <p:oleObj spid="_x0000_s1030" name="워크시트" r:id="rId3" imgW="3610051" imgH="1476487" progId="Excel.Sheet.12">
                   <p:embed/>
                 </p:oleObj>
               </mc:Choice>
@@ -11076,39 +11076,667 @@
       </p:grpSpPr>
       <p:grpSp>
         <p:nvGrpSpPr>
-          <p:cNvPr id="44" name="그룹 43"/>
+          <p:cNvPr id="60" name="그룹 59"/>
           <p:cNvGrpSpPr/>
           <p:nvPr/>
         </p:nvGrpSpPr>
         <p:grpSpPr>
           <a:xfrm>
-            <a:off x="2148327" y="2078669"/>
-            <a:ext cx="6911997" cy="4149109"/>
-            <a:chOff x="2148327" y="2078669"/>
-            <a:chExt cx="6911997" cy="4149109"/>
+            <a:off x="-956311" y="-477208"/>
+            <a:ext cx="16977739" cy="4430690"/>
+            <a:chOff x="-956311" y="-477208"/>
+            <a:chExt cx="16977739" cy="4430690"/>
           </a:xfrm>
         </p:grpSpPr>
         <p:sp>
           <p:nvSpPr>
-            <p:cNvPr id="84" name="직사각형 83"/>
-            <p:cNvSpPr>
-              <a:spLocks noChangeAspect="1"/>
-            </p:cNvSpPr>
+            <p:cNvPr id="63" name="TextBox 62"/>
+            <p:cNvSpPr txBox="1"/>
             <p:nvPr/>
           </p:nvSpPr>
           <p:spPr>
             <a:xfrm>
-              <a:off x="6468325" y="3636109"/>
-              <a:ext cx="864000" cy="863891"/>
+              <a:off x="253304" y="2047038"/>
+              <a:ext cx="1715534" cy="400110"/>
             </a:xfrm>
             <a:prstGeom prst="rect">
               <a:avLst/>
             </a:prstGeom>
             <a:noFill/>
-            <a:ln w="19050">
+          </p:spPr>
+          <p:txBody>
+            <a:bodyPr wrap="none" rtlCol="0">
+              <a:spAutoFit/>
+            </a:bodyPr>
+            <a:lstStyle/>
+            <a:p>
+              <a:pPr algn="ctr"/>
+              <a:r>
+                <a:rPr lang="en-US" altLang="ko-KR" sz="2000" dirty="0" smtClean="0">
+                  <a:latin typeface="나눔스퀘어 Bold" panose="020B0600000101010101" pitchFamily="50" charset="-127"/>
+                  <a:ea typeface="나눔스퀘어 Bold" panose="020B0600000101010101" pitchFamily="50" charset="-127"/>
+                </a:rPr>
+                <a:t>4. </a:t>
+              </a:r>
+              <a:r>
+                <a:rPr lang="ko-KR" altLang="en-US" sz="2000" dirty="0" smtClean="0">
+                  <a:latin typeface="나눔스퀘어 Bold" panose="020B0600000101010101" pitchFamily="50" charset="-127"/>
+                  <a:ea typeface="나눔스퀘어 Bold" panose="020B0600000101010101" pitchFamily="50" charset="-127"/>
+                </a:rPr>
+                <a:t>데이터 할당</a:t>
+              </a:r>
+              <a:endParaRPr lang="ko-KR" altLang="en-US" sz="2000" dirty="0">
+                <a:latin typeface="나눔스퀘어 Bold" panose="020B0600000101010101" pitchFamily="50" charset="-127"/>
+                <a:ea typeface="나눔스퀘어 Bold" panose="020B0600000101010101" pitchFamily="50" charset="-127"/>
+              </a:endParaRPr>
+            </a:p>
+          </p:txBody>
+        </p:sp>
+        <p:sp>
+          <p:nvSpPr>
+            <p:cNvPr id="23" name="모서리가 둥근 직사각형 22"/>
+            <p:cNvSpPr/>
+            <p:nvPr/>
+          </p:nvSpPr>
+          <p:spPr>
+            <a:xfrm>
+              <a:off x="-956311" y="893482"/>
+              <a:ext cx="5400000" cy="900000"/>
+            </a:xfrm>
+            <a:prstGeom prst="roundRect">
+              <a:avLst/>
+            </a:prstGeom>
+            <a:solidFill>
+              <a:schemeClr val="bg2">
+                <a:lumMod val="90000"/>
+              </a:schemeClr>
+            </a:solidFill>
+            <a:ln>
+              <a:noFill/>
+            </a:ln>
+          </p:spPr>
+          <p:style>
+            <a:lnRef idx="2">
+              <a:schemeClr val="accent1">
+                <a:shade val="50000"/>
+              </a:schemeClr>
+            </a:lnRef>
+            <a:fillRef idx="1">
+              <a:schemeClr val="accent1"/>
+            </a:fillRef>
+            <a:effectRef idx="0">
+              <a:schemeClr val="accent1"/>
+            </a:effectRef>
+            <a:fontRef idx="minor">
+              <a:schemeClr val="lt1"/>
+            </a:fontRef>
+          </p:style>
+          <p:txBody>
+            <a:bodyPr rtlCol="0" anchor="ctr"/>
+            <a:lstStyle/>
+            <a:p>
+              <a:pPr algn="ctr"/>
+              <a:r>
+                <a:rPr lang="en-US" altLang="ko-KR" sz="2000" dirty="0">
+                  <a:solidFill>
+                    <a:schemeClr val="tx1"/>
+                  </a:solidFill>
+                  <a:latin typeface="나눔스퀘어 Bold" panose="020B0600000101010101" pitchFamily="50" charset="-127"/>
+                  <a:ea typeface="나눔스퀘어 Bold" panose="020B0600000101010101" pitchFamily="50" charset="-127"/>
+                </a:rPr>
+                <a:t>d</a:t>
+              </a:r>
+              <a:r>
+                <a:rPr lang="en-US" altLang="ko-KR" sz="2000" dirty="0" smtClean="0">
+                  <a:solidFill>
+                    <a:schemeClr val="tx1"/>
+                  </a:solidFill>
+                  <a:latin typeface="나눔스퀘어 Bold" panose="020B0600000101010101" pitchFamily="50" charset="-127"/>
+                  <a:ea typeface="나눔스퀘어 Bold" panose="020B0600000101010101" pitchFamily="50" charset="-127"/>
+                </a:rPr>
+                <a:t>ouble</a:t>
+              </a:r>
+              <a:r>
+                <a:rPr lang="ko-KR" altLang="en-US" sz="2000" dirty="0" smtClean="0">
+                  <a:solidFill>
+                    <a:schemeClr val="tx1"/>
+                  </a:solidFill>
+                  <a:latin typeface="나눔스퀘어 Bold" panose="020B0600000101010101" pitchFamily="50" charset="-127"/>
+                  <a:ea typeface="나눔스퀘어 Bold" panose="020B0600000101010101" pitchFamily="50" charset="-127"/>
+                </a:rPr>
+                <a:t> </a:t>
+              </a:r>
+              <a:r>
+                <a:rPr lang="en-US" altLang="ko-KR" sz="2000" dirty="0" smtClean="0">
+                  <a:solidFill>
+                    <a:schemeClr val="tx1"/>
+                  </a:solidFill>
+                  <a:latin typeface="나눔스퀘어 Bold" panose="020B0600000101010101" pitchFamily="50" charset="-127"/>
+                  <a:ea typeface="나눔스퀘어 Bold" panose="020B0600000101010101" pitchFamily="50" charset="-127"/>
+                </a:rPr>
+                <a:t>result = </a:t>
+              </a:r>
+              <a:r>
+                <a:rPr lang="en-US" altLang="ko-KR" sz="2000" dirty="0" err="1" smtClean="0">
+                  <a:solidFill>
+                    <a:schemeClr val="tx1"/>
+                  </a:solidFill>
+                  <a:latin typeface="나눔스퀘어 Bold" panose="020B0600000101010101" pitchFamily="50" charset="-127"/>
+                  <a:ea typeface="나눔스퀘어 Bold" panose="020B0600000101010101" pitchFamily="50" charset="-127"/>
+                </a:rPr>
+                <a:t>car.goForward</a:t>
+              </a:r>
+              <a:r>
+                <a:rPr lang="en-US" altLang="ko-KR" sz="2000" dirty="0" smtClean="0">
+                  <a:solidFill>
+                    <a:schemeClr val="tx1"/>
+                  </a:solidFill>
+                  <a:latin typeface="나눔스퀘어 Bold" panose="020B0600000101010101" pitchFamily="50" charset="-127"/>
+                  <a:ea typeface="나눔스퀘어 Bold" panose="020B0600000101010101" pitchFamily="50" charset="-127"/>
+                </a:rPr>
+                <a:t>(30, 2);</a:t>
+              </a:r>
+              <a:endParaRPr lang="ko-KR" altLang="en-US" sz="2000" dirty="0">
+                <a:solidFill>
+                  <a:schemeClr val="tx1"/>
+                </a:solidFill>
+                <a:latin typeface="나눔스퀘어 Bold" panose="020B0600000101010101" pitchFamily="50" charset="-127"/>
+                <a:ea typeface="나눔스퀘어 Bold" panose="020B0600000101010101" pitchFamily="50" charset="-127"/>
+              </a:endParaRPr>
+            </a:p>
+          </p:txBody>
+        </p:sp>
+        <p:sp>
+          <p:nvSpPr>
+            <p:cNvPr id="69" name="모서리가 둥근 직사각형 68"/>
+            <p:cNvSpPr/>
+            <p:nvPr/>
+          </p:nvSpPr>
+          <p:spPr>
+            <a:xfrm>
+              <a:off x="7381428" y="893482"/>
+              <a:ext cx="8640000" cy="3060000"/>
+            </a:xfrm>
+            <a:prstGeom prst="roundRect">
+              <a:avLst/>
+            </a:prstGeom>
+            <a:solidFill>
+              <a:schemeClr val="bg2">
+                <a:lumMod val="90000"/>
+              </a:schemeClr>
+            </a:solidFill>
+            <a:ln>
+              <a:noFill/>
+            </a:ln>
+          </p:spPr>
+          <p:style>
+            <a:lnRef idx="2">
+              <a:schemeClr val="accent1">
+                <a:shade val="50000"/>
+              </a:schemeClr>
+            </a:lnRef>
+            <a:fillRef idx="1">
+              <a:schemeClr val="accent1"/>
+            </a:fillRef>
+            <a:effectRef idx="0">
+              <a:schemeClr val="accent1"/>
+            </a:effectRef>
+            <a:fontRef idx="minor">
+              <a:schemeClr val="lt1"/>
+            </a:fontRef>
+          </p:style>
+          <p:txBody>
+            <a:bodyPr rtlCol="0" anchor="ctr"/>
+            <a:lstStyle/>
+            <a:p>
+              <a:r>
+                <a:rPr lang="en-US" altLang="ko-KR" sz="2000" dirty="0" smtClean="0">
+                  <a:solidFill>
+                    <a:schemeClr val="tx1"/>
+                  </a:solidFill>
+                  <a:latin typeface="나눔스퀘어 Bold" panose="020B0600000101010101" pitchFamily="50" charset="-127"/>
+                  <a:ea typeface="나눔스퀘어 Bold" panose="020B0600000101010101" pitchFamily="50" charset="-127"/>
+                </a:rPr>
+                <a:t>    // </a:t>
+              </a:r>
+              <a:r>
+                <a:rPr lang="ko-KR" altLang="en-US" sz="2000" dirty="0" smtClean="0">
+                  <a:solidFill>
+                    <a:schemeClr val="tx1"/>
+                  </a:solidFill>
+                  <a:latin typeface="나눔스퀘어 Bold" panose="020B0600000101010101" pitchFamily="50" charset="-127"/>
+                  <a:ea typeface="나눔스퀘어 Bold" panose="020B0600000101010101" pitchFamily="50" charset="-127"/>
+                </a:rPr>
+                <a:t>전진 기능</a:t>
+              </a:r>
+              <a:endParaRPr lang="en-US" altLang="ko-KR" sz="2000" dirty="0" smtClean="0">
+                <a:solidFill>
+                  <a:schemeClr val="tx1"/>
+                </a:solidFill>
+                <a:latin typeface="나눔스퀘어 Bold" panose="020B0600000101010101" pitchFamily="50" charset="-127"/>
+                <a:ea typeface="나눔스퀘어 Bold" panose="020B0600000101010101" pitchFamily="50" charset="-127"/>
+              </a:endParaRPr>
+            </a:p>
+            <a:p>
+              <a:r>
+                <a:rPr lang="en-US" altLang="ko-KR" sz="2000" dirty="0" smtClean="0">
+                  <a:solidFill>
+                    <a:schemeClr val="tx1"/>
+                  </a:solidFill>
+                  <a:latin typeface="나눔스퀘어 Bold" panose="020B0600000101010101" pitchFamily="50" charset="-127"/>
+                  <a:ea typeface="나눔스퀘어 Bold" panose="020B0600000101010101" pitchFamily="50" charset="-127"/>
+                </a:rPr>
+                <a:t>    public double </a:t>
+              </a:r>
+              <a:r>
+                <a:rPr lang="en-US" altLang="ko-KR" sz="2000" dirty="0" err="1" smtClean="0">
+                  <a:solidFill>
+                    <a:schemeClr val="tx1"/>
+                  </a:solidFill>
+                  <a:latin typeface="나눔스퀘어 Bold" panose="020B0600000101010101" pitchFamily="50" charset="-127"/>
+                  <a:ea typeface="나눔스퀘어 Bold" panose="020B0600000101010101" pitchFamily="50" charset="-127"/>
+                </a:rPr>
+                <a:t>goForward</a:t>
+              </a:r>
+              <a:r>
+                <a:rPr lang="en-US" altLang="ko-KR" sz="2000" dirty="0" smtClean="0">
+                  <a:solidFill>
+                    <a:schemeClr val="tx1"/>
+                  </a:solidFill>
+                  <a:latin typeface="나눔스퀘어 Bold" panose="020B0600000101010101" pitchFamily="50" charset="-127"/>
+                  <a:ea typeface="나눔스퀘어 Bold" panose="020B0600000101010101" pitchFamily="50" charset="-127"/>
+                </a:rPr>
+                <a:t>(</a:t>
+              </a:r>
+              <a:r>
+                <a:rPr lang="en-US" altLang="ko-KR" sz="2000" dirty="0" err="1" smtClean="0">
+                  <a:solidFill>
+                    <a:schemeClr val="tx1"/>
+                  </a:solidFill>
+                  <a:latin typeface="나눔스퀘어 Bold" panose="020B0600000101010101" pitchFamily="50" charset="-127"/>
+                  <a:ea typeface="나눔스퀘어 Bold" panose="020B0600000101010101" pitchFamily="50" charset="-127"/>
+                </a:rPr>
+                <a:t>int</a:t>
+              </a:r>
+              <a:r>
+                <a:rPr lang="en-US" altLang="ko-KR" sz="2000" dirty="0" smtClean="0">
+                  <a:solidFill>
+                    <a:schemeClr val="tx1"/>
+                  </a:solidFill>
+                  <a:latin typeface="나눔스퀘어 Bold" panose="020B0600000101010101" pitchFamily="50" charset="-127"/>
+                  <a:ea typeface="나눔스퀘어 Bold" panose="020B0600000101010101" pitchFamily="50" charset="-127"/>
+                </a:rPr>
+                <a:t> speed, </a:t>
+              </a:r>
+              <a:r>
+                <a:rPr lang="en-US" altLang="ko-KR" sz="2000" dirty="0" err="1" smtClean="0">
+                  <a:solidFill>
+                    <a:schemeClr val="tx1"/>
+                  </a:solidFill>
+                  <a:latin typeface="나눔스퀘어 Bold" panose="020B0600000101010101" pitchFamily="50" charset="-127"/>
+                  <a:ea typeface="나눔스퀘어 Bold" panose="020B0600000101010101" pitchFamily="50" charset="-127"/>
+                </a:rPr>
+                <a:t>int</a:t>
+              </a:r>
+              <a:r>
+                <a:rPr lang="en-US" altLang="ko-KR" sz="2000" dirty="0" smtClean="0">
+                  <a:solidFill>
+                    <a:schemeClr val="tx1"/>
+                  </a:solidFill>
+                  <a:latin typeface="나눔스퀘어 Bold" panose="020B0600000101010101" pitchFamily="50" charset="-127"/>
+                  <a:ea typeface="나눔스퀘어 Bold" panose="020B0600000101010101" pitchFamily="50" charset="-127"/>
+                </a:rPr>
+                <a:t> hour) {</a:t>
+              </a:r>
+            </a:p>
+            <a:p>
+              <a:r>
+                <a:rPr lang="en-US" altLang="ko-KR" sz="2000" dirty="0" smtClean="0">
+                  <a:solidFill>
+                    <a:schemeClr val="tx1"/>
+                  </a:solidFill>
+                  <a:latin typeface="나눔스퀘어 Bold" panose="020B0600000101010101" pitchFamily="50" charset="-127"/>
+                  <a:ea typeface="나눔스퀘어 Bold" panose="020B0600000101010101" pitchFamily="50" charset="-127"/>
+                </a:rPr>
+                <a:t>        </a:t>
+              </a:r>
+              <a:r>
+                <a:rPr lang="en-US" altLang="ko-KR" sz="2000" dirty="0" err="1" smtClean="0">
+                  <a:solidFill>
+                    <a:schemeClr val="tx1"/>
+                  </a:solidFill>
+                  <a:latin typeface="나눔스퀘어 Bold" panose="020B0600000101010101" pitchFamily="50" charset="-127"/>
+                  <a:ea typeface="나눔스퀘어 Bold" panose="020B0600000101010101" pitchFamily="50" charset="-127"/>
+                </a:rPr>
+                <a:t>System.out.println</a:t>
+              </a:r>
+              <a:r>
+                <a:rPr lang="en-US" altLang="ko-KR" sz="2000" dirty="0" smtClean="0">
+                  <a:solidFill>
+                    <a:schemeClr val="tx1"/>
+                  </a:solidFill>
+                  <a:latin typeface="나눔스퀘어 Bold" panose="020B0600000101010101" pitchFamily="50" charset="-127"/>
+                  <a:ea typeface="나눔스퀘어 Bold" panose="020B0600000101010101" pitchFamily="50" charset="-127"/>
+                </a:rPr>
+                <a:t>(speed + “km/h</a:t>
+              </a:r>
+              <a:r>
+                <a:rPr lang="ko-KR" altLang="en-US" sz="2000" dirty="0" smtClean="0">
+                  <a:solidFill>
+                    <a:schemeClr val="tx1"/>
+                  </a:solidFill>
+                  <a:latin typeface="나눔스퀘어 Bold" panose="020B0600000101010101" pitchFamily="50" charset="-127"/>
+                  <a:ea typeface="나눔스퀘어 Bold" panose="020B0600000101010101" pitchFamily="50" charset="-127"/>
+                </a:rPr>
+                <a:t>로 </a:t>
+              </a:r>
+              <a:r>
+                <a:rPr lang="en-US" altLang="ko-KR" sz="2000" dirty="0" smtClean="0">
+                  <a:solidFill>
+                    <a:schemeClr val="tx1"/>
+                  </a:solidFill>
+                  <a:latin typeface="나눔스퀘어 Bold" panose="020B0600000101010101" pitchFamily="50" charset="-127"/>
+                  <a:ea typeface="나눔스퀘어 Bold" panose="020B0600000101010101" pitchFamily="50" charset="-127"/>
+                </a:rPr>
+                <a:t>” + hour + “</a:t>
+              </a:r>
+              <a:r>
+                <a:rPr lang="ko-KR" altLang="en-US" sz="2000" dirty="0" smtClean="0">
+                  <a:solidFill>
+                    <a:schemeClr val="tx1"/>
+                  </a:solidFill>
+                  <a:latin typeface="나눔스퀘어 Bold" panose="020B0600000101010101" pitchFamily="50" charset="-127"/>
+                  <a:ea typeface="나눔스퀘어 Bold" panose="020B0600000101010101" pitchFamily="50" charset="-127"/>
+                </a:rPr>
+                <a:t>시간 동안 전진</a:t>
+              </a:r>
+              <a:r>
+                <a:rPr lang="en-US" altLang="ko-KR" sz="2000" dirty="0" smtClean="0">
+                  <a:solidFill>
+                    <a:schemeClr val="tx1"/>
+                  </a:solidFill>
+                  <a:latin typeface="나눔스퀘어 Bold" panose="020B0600000101010101" pitchFamily="50" charset="-127"/>
+                  <a:ea typeface="나눔스퀘어 Bold" panose="020B0600000101010101" pitchFamily="50" charset="-127"/>
+                </a:rPr>
+                <a:t>”);</a:t>
+              </a:r>
+            </a:p>
+            <a:p>
+              <a:endParaRPr lang="en-US" altLang="ko-KR" sz="2000" dirty="0" smtClean="0">
+                <a:solidFill>
+                  <a:schemeClr val="tx1"/>
+                </a:solidFill>
+                <a:latin typeface="나눔스퀘어 Bold" panose="020B0600000101010101" pitchFamily="50" charset="-127"/>
+                <a:ea typeface="나눔스퀘어 Bold" panose="020B0600000101010101" pitchFamily="50" charset="-127"/>
+              </a:endParaRPr>
+            </a:p>
+            <a:p>
+              <a:r>
+                <a:rPr lang="en-US" altLang="ko-KR" sz="2000" dirty="0" smtClean="0">
+                  <a:solidFill>
+                    <a:schemeClr val="tx1"/>
+                  </a:solidFill>
+                  <a:latin typeface="나눔스퀘어 Bold" panose="020B0600000101010101" pitchFamily="50" charset="-127"/>
+                  <a:ea typeface="나눔스퀘어 Bold" panose="020B0600000101010101" pitchFamily="50" charset="-127"/>
+                </a:rPr>
+                <a:t>        double</a:t>
+              </a:r>
+              <a:r>
+                <a:rPr lang="ko-KR" altLang="en-US" sz="2000" dirty="0" smtClean="0">
+                  <a:solidFill>
+                    <a:schemeClr val="tx1"/>
+                  </a:solidFill>
+                  <a:latin typeface="나눔스퀘어 Bold" panose="020B0600000101010101" pitchFamily="50" charset="-127"/>
+                  <a:ea typeface="나눔스퀘어 Bold" panose="020B0600000101010101" pitchFamily="50" charset="-127"/>
+                </a:rPr>
+                <a:t> </a:t>
+              </a:r>
+              <a:r>
+                <a:rPr lang="en-US" altLang="ko-KR" sz="2000" dirty="0" smtClean="0">
+                  <a:solidFill>
+                    <a:schemeClr val="tx1"/>
+                  </a:solidFill>
+                  <a:latin typeface="나눔스퀘어 Bold" panose="020B0600000101010101" pitchFamily="50" charset="-127"/>
+                  <a:ea typeface="나눔스퀘어 Bold" panose="020B0600000101010101" pitchFamily="50" charset="-127"/>
+                </a:rPr>
+                <a:t>distance = speed * hour;</a:t>
+              </a:r>
+            </a:p>
+            <a:p>
+              <a:endParaRPr lang="en-US" altLang="ko-KR" sz="2000" dirty="0">
+                <a:solidFill>
+                  <a:schemeClr val="tx1"/>
+                </a:solidFill>
+                <a:latin typeface="나눔스퀘어 Bold" panose="020B0600000101010101" pitchFamily="50" charset="-127"/>
+                <a:ea typeface="나눔스퀘어 Bold" panose="020B0600000101010101" pitchFamily="50" charset="-127"/>
+              </a:endParaRPr>
+            </a:p>
+            <a:p>
+              <a:r>
+                <a:rPr lang="en-US" altLang="ko-KR" sz="2000" dirty="0" smtClean="0">
+                  <a:solidFill>
+                    <a:schemeClr val="tx1"/>
+                  </a:solidFill>
+                  <a:latin typeface="나눔스퀘어 Bold" panose="020B0600000101010101" pitchFamily="50" charset="-127"/>
+                  <a:ea typeface="나눔스퀘어 Bold" panose="020B0600000101010101" pitchFamily="50" charset="-127"/>
+                </a:rPr>
+                <a:t>        return distance;</a:t>
+              </a:r>
+            </a:p>
+            <a:p>
+              <a:r>
+                <a:rPr lang="en-US" altLang="ko-KR" sz="2000" dirty="0" smtClean="0">
+                  <a:solidFill>
+                    <a:schemeClr val="tx1"/>
+                  </a:solidFill>
+                  <a:latin typeface="나눔스퀘어 Bold" panose="020B0600000101010101" pitchFamily="50" charset="-127"/>
+                  <a:ea typeface="나눔스퀘어 Bold" panose="020B0600000101010101" pitchFamily="50" charset="-127"/>
+                </a:rPr>
+                <a:t>    }</a:t>
+              </a:r>
+              <a:endParaRPr lang="ko-KR" altLang="en-US" sz="2000" dirty="0">
+                <a:solidFill>
+                  <a:schemeClr val="tx1"/>
+                </a:solidFill>
+                <a:latin typeface="나눔스퀘어 Bold" panose="020B0600000101010101" pitchFamily="50" charset="-127"/>
+                <a:ea typeface="나눔스퀘어 Bold" panose="020B0600000101010101" pitchFamily="50" charset="-127"/>
+              </a:endParaRPr>
+            </a:p>
+          </p:txBody>
+        </p:sp>
+        <p:sp>
+          <p:nvSpPr>
+            <p:cNvPr id="54" name="원호 53"/>
+            <p:cNvSpPr/>
+            <p:nvPr/>
+          </p:nvSpPr>
+          <p:spPr>
+            <a:xfrm rot="8425555">
+              <a:off x="714198" y="1077027"/>
+              <a:ext cx="900000" cy="900000"/>
+            </a:xfrm>
+            <a:prstGeom prst="arc">
+              <a:avLst>
+                <a:gd name="adj1" fmla="val 13530061"/>
+                <a:gd name="adj2" fmla="val 1870419"/>
+              </a:avLst>
+            </a:prstGeom>
+            <a:ln w="38100">
               <a:solidFill>
                 <a:schemeClr val="tx1"/>
               </a:solidFill>
+            </a:ln>
+          </p:spPr>
+          <p:style>
+            <a:lnRef idx="1">
+              <a:schemeClr val="accent1"/>
+            </a:lnRef>
+            <a:fillRef idx="0">
+              <a:schemeClr val="accent1"/>
+            </a:fillRef>
+            <a:effectRef idx="0">
+              <a:schemeClr val="accent1"/>
+            </a:effectRef>
+            <a:fontRef idx="minor">
+              <a:schemeClr val="tx1"/>
+            </a:fontRef>
+          </p:style>
+          <p:txBody>
+            <a:bodyPr rtlCol="0" anchor="ctr"/>
+            <a:lstStyle/>
+            <a:p>
+              <a:pPr algn="ctr"/>
+              <a:endParaRPr lang="ko-KR" altLang="en-US"/>
+            </a:p>
+          </p:txBody>
+        </p:sp>
+        <p:sp>
+          <p:nvSpPr>
+            <p:cNvPr id="103" name="원호 102"/>
+            <p:cNvSpPr/>
+            <p:nvPr/>
+          </p:nvSpPr>
+          <p:spPr>
+            <a:xfrm rot="5696533">
+              <a:off x="3581734" y="-2596670"/>
+              <a:ext cx="2741380" cy="6980304"/>
+            </a:xfrm>
+            <a:prstGeom prst="arc">
+              <a:avLst>
+                <a:gd name="adj1" fmla="val 17174190"/>
+                <a:gd name="adj2" fmla="val 4159039"/>
+              </a:avLst>
+            </a:prstGeom>
+            <a:ln w="38100">
+              <a:solidFill>
+                <a:schemeClr val="tx1"/>
+              </a:solidFill>
+            </a:ln>
+          </p:spPr>
+          <p:style>
+            <a:lnRef idx="1">
+              <a:schemeClr val="accent1"/>
+            </a:lnRef>
+            <a:fillRef idx="0">
+              <a:schemeClr val="accent1"/>
+            </a:fillRef>
+            <a:effectRef idx="0">
+              <a:schemeClr val="accent1"/>
+            </a:effectRef>
+            <a:fontRef idx="minor">
+              <a:schemeClr val="tx1"/>
+            </a:fontRef>
+          </p:style>
+          <p:txBody>
+            <a:bodyPr rtlCol="0" anchor="ctr"/>
+            <a:lstStyle/>
+            <a:p>
+              <a:pPr algn="ctr"/>
+              <a:endParaRPr lang="ko-KR" altLang="en-US"/>
+            </a:p>
+          </p:txBody>
+        </p:sp>
+        <p:sp>
+          <p:nvSpPr>
+            <p:cNvPr id="104" name="원호 103"/>
+            <p:cNvSpPr/>
+            <p:nvPr/>
+          </p:nvSpPr>
+          <p:spPr>
+            <a:xfrm rot="6264436">
+              <a:off x="3629377" y="-1735580"/>
+              <a:ext cx="3054061" cy="6980304"/>
+            </a:xfrm>
+            <a:prstGeom prst="arc">
+              <a:avLst>
+                <a:gd name="adj1" fmla="val 17096554"/>
+                <a:gd name="adj2" fmla="val 4395978"/>
+              </a:avLst>
+            </a:prstGeom>
+            <a:ln w="38100">
+              <a:solidFill>
+                <a:schemeClr val="tx1"/>
+              </a:solidFill>
+            </a:ln>
+          </p:spPr>
+          <p:style>
+            <a:lnRef idx="1">
+              <a:schemeClr val="accent1"/>
+            </a:lnRef>
+            <a:fillRef idx="0">
+              <a:schemeClr val="accent1"/>
+            </a:fillRef>
+            <a:effectRef idx="0">
+              <a:schemeClr val="accent1"/>
+            </a:effectRef>
+            <a:fontRef idx="minor">
+              <a:schemeClr val="tx1"/>
+            </a:fontRef>
+          </p:style>
+          <p:txBody>
+            <a:bodyPr rtlCol="0" anchor="ctr"/>
+            <a:lstStyle/>
+            <a:p>
+              <a:pPr algn="ctr"/>
+              <a:endParaRPr lang="ko-KR" altLang="en-US"/>
+            </a:p>
+          </p:txBody>
+        </p:sp>
+        <p:cxnSp>
+          <p:nvCxnSpPr>
+            <p:cNvPr id="56" name="직선 화살표 연결선 55"/>
+            <p:cNvCxnSpPr/>
+            <p:nvPr/>
+          </p:nvCxnSpPr>
+          <p:spPr>
+            <a:xfrm>
+              <a:off x="7898860" y="1983757"/>
+              <a:ext cx="0" cy="1152000"/>
+            </a:xfrm>
+            <a:prstGeom prst="straightConnector1">
+              <a:avLst/>
+            </a:prstGeom>
+            <a:ln w="38100">
+              <a:solidFill>
+                <a:schemeClr val="tx1"/>
+              </a:solidFill>
+              <a:tailEnd type="triangle"/>
+            </a:ln>
+          </p:spPr>
+          <p:style>
+            <a:lnRef idx="1">
+              <a:schemeClr val="accent1"/>
+            </a:lnRef>
+            <a:fillRef idx="0">
+              <a:schemeClr val="accent1"/>
+            </a:fillRef>
+            <a:effectRef idx="0">
+              <a:schemeClr val="accent1"/>
+            </a:effectRef>
+            <a:fontRef idx="minor">
+              <a:schemeClr val="tx1"/>
+            </a:fontRef>
+          </p:style>
+        </p:cxnSp>
+        <p:sp>
+          <p:nvSpPr>
+            <p:cNvPr id="57" name="이등변 삼각형 56"/>
+            <p:cNvSpPr/>
+            <p:nvPr/>
+          </p:nvSpPr>
+          <p:spPr>
+            <a:xfrm>
+              <a:off x="599319" y="1462286"/>
+              <a:ext cx="311285" cy="288000"/>
+            </a:xfrm>
+            <a:prstGeom prst="triangle">
+              <a:avLst/>
+            </a:prstGeom>
+            <a:solidFill>
+              <a:schemeClr val="tx1"/>
+            </a:solidFill>
+            <a:ln>
+              <a:noFill/>
             </a:ln>
           </p:spPr>
           <p:style>
@@ -11138,25 +11766,23 @@
         </p:sp>
         <p:sp>
           <p:nvSpPr>
-            <p:cNvPr id="86" name="직사각형 85"/>
-            <p:cNvSpPr>
-              <a:spLocks noChangeAspect="1"/>
-            </p:cNvSpPr>
+            <p:cNvPr id="109" name="이등변 삼각형 108"/>
+            <p:cNvSpPr/>
             <p:nvPr/>
           </p:nvSpPr>
           <p:spPr>
-            <a:xfrm>
-              <a:off x="7332325" y="3636109"/>
-              <a:ext cx="864000" cy="863891"/>
+            <a:xfrm rot="18731416">
+              <a:off x="1921304" y="1697677"/>
+              <a:ext cx="335641" cy="230520"/>
             </a:xfrm>
-            <a:prstGeom prst="rect">
+            <a:prstGeom prst="triangle">
               <a:avLst/>
             </a:prstGeom>
-            <a:noFill/>
-            <a:ln w="19050">
-              <a:solidFill>
-                <a:schemeClr val="tx1"/>
-              </a:solidFill>
+            <a:solidFill>
+              <a:schemeClr val="tx1"/>
+            </a:solidFill>
+            <a:ln>
+              <a:noFill/>
             </a:ln>
           </p:spPr>
           <p:style>
@@ -11186,25 +11812,23 @@
         </p:sp>
         <p:sp>
           <p:nvSpPr>
-            <p:cNvPr id="88" name="직사각형 87"/>
-            <p:cNvSpPr>
-              <a:spLocks noChangeAspect="1"/>
-            </p:cNvSpPr>
+            <p:cNvPr id="111" name="이등변 삼각형 110"/>
+            <p:cNvSpPr/>
             <p:nvPr/>
           </p:nvSpPr>
           <p:spPr>
-            <a:xfrm>
-              <a:off x="8196324" y="3636109"/>
-              <a:ext cx="864000" cy="863891"/>
+            <a:xfrm rot="2868584" flipH="1">
+              <a:off x="7521197" y="1791712"/>
+              <a:ext cx="335641" cy="230520"/>
             </a:xfrm>
-            <a:prstGeom prst="rect">
+            <a:prstGeom prst="triangle">
               <a:avLst/>
             </a:prstGeom>
-            <a:noFill/>
-            <a:ln w="19050">
-              <a:solidFill>
-                <a:schemeClr val="tx1"/>
-              </a:solidFill>
+            <a:solidFill>
+              <a:schemeClr val="tx1"/>
+            </a:solidFill>
+            <a:ln>
+              <a:noFill/>
             </a:ln>
           </p:spPr>
           <p:style>
@@ -11234,25 +11858,23 @@
         </p:sp>
         <p:sp>
           <p:nvSpPr>
-            <p:cNvPr id="94" name="직사각형 93"/>
-            <p:cNvSpPr>
-              <a:spLocks noChangeAspect="1"/>
-            </p:cNvSpPr>
+            <p:cNvPr id="112" name="이등변 삼각형 111"/>
+            <p:cNvSpPr/>
             <p:nvPr/>
           </p:nvSpPr>
           <p:spPr>
-            <a:xfrm>
-              <a:off x="6468325" y="4500000"/>
-              <a:ext cx="864000" cy="863891"/>
+            <a:xfrm flipV="1">
+              <a:off x="7743217" y="2922004"/>
+              <a:ext cx="311285" cy="288000"/>
             </a:xfrm>
-            <a:prstGeom prst="rect">
+            <a:prstGeom prst="triangle">
               <a:avLst/>
             </a:prstGeom>
-            <a:noFill/>
-            <a:ln w="19050">
-              <a:solidFill>
-                <a:schemeClr val="tx1"/>
-              </a:solidFill>
+            <a:solidFill>
+              <a:schemeClr val="tx1"/>
+            </a:solidFill>
+            <a:ln>
+              <a:noFill/>
             </a:ln>
           </p:spPr>
           <p:style>
@@ -11282,1518 +11904,14 @@
         </p:sp>
         <p:sp>
           <p:nvSpPr>
-            <p:cNvPr id="96" name="직사각형 95"/>
-            <p:cNvSpPr>
-              <a:spLocks noChangeAspect="1"/>
-            </p:cNvSpPr>
-            <p:nvPr/>
-          </p:nvSpPr>
-          <p:spPr>
-            <a:xfrm>
-              <a:off x="7332325" y="4500000"/>
-              <a:ext cx="864000" cy="863891"/>
-            </a:xfrm>
-            <a:prstGeom prst="rect">
-              <a:avLst/>
-            </a:prstGeom>
-            <a:noFill/>
-            <a:ln w="19050">
-              <a:solidFill>
-                <a:schemeClr val="tx1"/>
-              </a:solidFill>
-            </a:ln>
-          </p:spPr>
-          <p:style>
-            <a:lnRef idx="2">
-              <a:schemeClr val="accent1">
-                <a:shade val="50000"/>
-              </a:schemeClr>
-            </a:lnRef>
-            <a:fillRef idx="1">
-              <a:schemeClr val="accent1"/>
-            </a:fillRef>
-            <a:effectRef idx="0">
-              <a:schemeClr val="accent1"/>
-            </a:effectRef>
-            <a:fontRef idx="minor">
-              <a:schemeClr val="lt1"/>
-            </a:fontRef>
-          </p:style>
-          <p:txBody>
-            <a:bodyPr rtlCol="0" anchor="ctr"/>
-            <a:lstStyle/>
-            <a:p>
-              <a:pPr algn="ctr"/>
-              <a:endParaRPr lang="ko-KR" altLang="en-US"/>
-            </a:p>
-          </p:txBody>
-        </p:sp>
-        <p:sp>
-          <p:nvSpPr>
-            <p:cNvPr id="98" name="직사각형 97"/>
-            <p:cNvSpPr>
-              <a:spLocks noChangeAspect="1"/>
-            </p:cNvSpPr>
-            <p:nvPr/>
-          </p:nvSpPr>
-          <p:spPr>
-            <a:xfrm>
-              <a:off x="8196324" y="4500000"/>
-              <a:ext cx="864000" cy="863891"/>
-            </a:xfrm>
-            <a:prstGeom prst="rect">
-              <a:avLst/>
-            </a:prstGeom>
-            <a:noFill/>
-            <a:ln w="19050">
-              <a:solidFill>
-                <a:schemeClr val="tx1"/>
-              </a:solidFill>
-            </a:ln>
-          </p:spPr>
-          <p:style>
-            <a:lnRef idx="2">
-              <a:schemeClr val="accent1">
-                <a:shade val="50000"/>
-              </a:schemeClr>
-            </a:lnRef>
-            <a:fillRef idx="1">
-              <a:schemeClr val="accent1"/>
-            </a:fillRef>
-            <a:effectRef idx="0">
-              <a:schemeClr val="accent1"/>
-            </a:effectRef>
-            <a:fontRef idx="minor">
-              <a:schemeClr val="lt1"/>
-            </a:fontRef>
-          </p:style>
-          <p:txBody>
-            <a:bodyPr rtlCol="0" anchor="ctr"/>
-            <a:lstStyle/>
-            <a:p>
-              <a:pPr algn="ctr"/>
-              <a:endParaRPr lang="ko-KR" altLang="en-US"/>
-            </a:p>
-          </p:txBody>
-        </p:sp>
-        <p:sp>
-          <p:nvSpPr>
-            <p:cNvPr id="108" name="직사각형 107"/>
-            <p:cNvSpPr>
-              <a:spLocks noChangeAspect="1"/>
-            </p:cNvSpPr>
-            <p:nvPr/>
-          </p:nvSpPr>
-          <p:spPr>
-            <a:xfrm>
-              <a:off x="6468325" y="5363887"/>
-              <a:ext cx="864000" cy="863891"/>
-            </a:xfrm>
-            <a:prstGeom prst="rect">
-              <a:avLst/>
-            </a:prstGeom>
-            <a:noFill/>
-            <a:ln w="19050">
-              <a:solidFill>
-                <a:schemeClr val="tx1"/>
-              </a:solidFill>
-            </a:ln>
-          </p:spPr>
-          <p:style>
-            <a:lnRef idx="2">
-              <a:schemeClr val="accent1">
-                <a:shade val="50000"/>
-              </a:schemeClr>
-            </a:lnRef>
-            <a:fillRef idx="1">
-              <a:schemeClr val="accent1"/>
-            </a:fillRef>
-            <a:effectRef idx="0">
-              <a:schemeClr val="accent1"/>
-            </a:effectRef>
-            <a:fontRef idx="minor">
-              <a:schemeClr val="lt1"/>
-            </a:fontRef>
-          </p:style>
-          <p:txBody>
-            <a:bodyPr rtlCol="0" anchor="ctr"/>
-            <a:lstStyle/>
-            <a:p>
-              <a:pPr algn="ctr"/>
-              <a:endParaRPr lang="ko-KR" altLang="en-US"/>
-            </a:p>
-          </p:txBody>
-        </p:sp>
-        <p:sp>
-          <p:nvSpPr>
-            <p:cNvPr id="110" name="직사각형 109"/>
-            <p:cNvSpPr>
-              <a:spLocks noChangeAspect="1"/>
-            </p:cNvSpPr>
-            <p:nvPr/>
-          </p:nvSpPr>
-          <p:spPr>
-            <a:xfrm>
-              <a:off x="7332325" y="5363887"/>
-              <a:ext cx="864000" cy="863891"/>
-            </a:xfrm>
-            <a:prstGeom prst="rect">
-              <a:avLst/>
-            </a:prstGeom>
-            <a:noFill/>
-            <a:ln w="19050">
-              <a:solidFill>
-                <a:schemeClr val="tx1"/>
-              </a:solidFill>
-            </a:ln>
-          </p:spPr>
-          <p:style>
-            <a:lnRef idx="2">
-              <a:schemeClr val="accent1">
-                <a:shade val="50000"/>
-              </a:schemeClr>
-            </a:lnRef>
-            <a:fillRef idx="1">
-              <a:schemeClr val="accent1"/>
-            </a:fillRef>
-            <a:effectRef idx="0">
-              <a:schemeClr val="accent1"/>
-            </a:effectRef>
-            <a:fontRef idx="minor">
-              <a:schemeClr val="lt1"/>
-            </a:fontRef>
-          </p:style>
-          <p:txBody>
-            <a:bodyPr rtlCol="0" anchor="ctr"/>
-            <a:lstStyle/>
-            <a:p>
-              <a:pPr algn="ctr"/>
-              <a:endParaRPr lang="ko-KR" altLang="en-US"/>
-            </a:p>
-          </p:txBody>
-        </p:sp>
-        <p:sp>
-          <p:nvSpPr>
-            <p:cNvPr id="114" name="직사각형 113"/>
-            <p:cNvSpPr>
-              <a:spLocks noChangeAspect="1"/>
-            </p:cNvSpPr>
-            <p:nvPr/>
-          </p:nvSpPr>
-          <p:spPr>
-            <a:xfrm>
-              <a:off x="8196324" y="5363887"/>
-              <a:ext cx="864000" cy="863891"/>
-            </a:xfrm>
-            <a:prstGeom prst="rect">
-              <a:avLst/>
-            </a:prstGeom>
-            <a:noFill/>
-            <a:ln w="19050">
-              <a:solidFill>
-                <a:schemeClr val="tx1"/>
-              </a:solidFill>
-            </a:ln>
-          </p:spPr>
-          <p:style>
-            <a:lnRef idx="2">
-              <a:schemeClr val="accent1">
-                <a:shade val="50000"/>
-              </a:schemeClr>
-            </a:lnRef>
-            <a:fillRef idx="1">
-              <a:schemeClr val="accent1"/>
-            </a:fillRef>
-            <a:effectRef idx="0">
-              <a:schemeClr val="accent1"/>
-            </a:effectRef>
-            <a:fontRef idx="minor">
-              <a:schemeClr val="lt1"/>
-            </a:fontRef>
-          </p:style>
-          <p:txBody>
-            <a:bodyPr rtlCol="0" anchor="ctr"/>
-            <a:lstStyle/>
-            <a:p>
-              <a:pPr algn="ctr"/>
-              <a:endParaRPr lang="ko-KR" altLang="en-US"/>
-            </a:p>
-          </p:txBody>
-        </p:sp>
-        <p:sp>
-          <p:nvSpPr>
-            <p:cNvPr id="124" name="직사각형 123"/>
-            <p:cNvSpPr>
-              <a:spLocks noChangeAspect="1"/>
-            </p:cNvSpPr>
-            <p:nvPr/>
-          </p:nvSpPr>
-          <p:spPr>
-            <a:xfrm>
-              <a:off x="2148328" y="3636109"/>
-              <a:ext cx="864000" cy="863891"/>
-            </a:xfrm>
-            <a:prstGeom prst="rect">
-              <a:avLst/>
-            </a:prstGeom>
-            <a:noFill/>
-            <a:ln w="19050">
-              <a:solidFill>
-                <a:schemeClr val="tx1"/>
-              </a:solidFill>
-            </a:ln>
-          </p:spPr>
-          <p:style>
-            <a:lnRef idx="2">
-              <a:schemeClr val="accent1">
-                <a:shade val="50000"/>
-              </a:schemeClr>
-            </a:lnRef>
-            <a:fillRef idx="1">
-              <a:schemeClr val="accent1"/>
-            </a:fillRef>
-            <a:effectRef idx="0">
-              <a:schemeClr val="accent1"/>
-            </a:effectRef>
-            <a:fontRef idx="minor">
-              <a:schemeClr val="lt1"/>
-            </a:fontRef>
-          </p:style>
-          <p:txBody>
-            <a:bodyPr rtlCol="0" anchor="ctr"/>
-            <a:lstStyle/>
-            <a:p>
-              <a:pPr algn="ctr"/>
-              <a:endParaRPr lang="ko-KR" altLang="en-US"/>
-            </a:p>
-          </p:txBody>
-        </p:sp>
-        <p:sp>
-          <p:nvSpPr>
-            <p:cNvPr id="126" name="직사각형 125"/>
-            <p:cNvSpPr>
-              <a:spLocks noChangeAspect="1"/>
-            </p:cNvSpPr>
-            <p:nvPr/>
-          </p:nvSpPr>
-          <p:spPr>
-            <a:xfrm>
-              <a:off x="3012328" y="3636109"/>
-              <a:ext cx="864000" cy="863891"/>
-            </a:xfrm>
-            <a:prstGeom prst="rect">
-              <a:avLst/>
-            </a:prstGeom>
-            <a:noFill/>
-            <a:ln w="19050">
-              <a:solidFill>
-                <a:schemeClr val="tx1"/>
-              </a:solidFill>
-            </a:ln>
-          </p:spPr>
-          <p:style>
-            <a:lnRef idx="2">
-              <a:schemeClr val="accent1">
-                <a:shade val="50000"/>
-              </a:schemeClr>
-            </a:lnRef>
-            <a:fillRef idx="1">
-              <a:schemeClr val="accent1"/>
-            </a:fillRef>
-            <a:effectRef idx="0">
-              <a:schemeClr val="accent1"/>
-            </a:effectRef>
-            <a:fontRef idx="minor">
-              <a:schemeClr val="lt1"/>
-            </a:fontRef>
-          </p:style>
-          <p:txBody>
-            <a:bodyPr rtlCol="0" anchor="ctr"/>
-            <a:lstStyle/>
-            <a:p>
-              <a:pPr algn="ctr"/>
-              <a:endParaRPr lang="ko-KR" altLang="en-US"/>
-            </a:p>
-          </p:txBody>
-        </p:sp>
-        <p:sp>
-          <p:nvSpPr>
-            <p:cNvPr id="128" name="직사각형 127"/>
-            <p:cNvSpPr>
-              <a:spLocks noChangeAspect="1"/>
-            </p:cNvSpPr>
-            <p:nvPr/>
-          </p:nvSpPr>
-          <p:spPr>
-            <a:xfrm>
-              <a:off x="3876327" y="3636109"/>
-              <a:ext cx="864000" cy="863891"/>
-            </a:xfrm>
-            <a:prstGeom prst="rect">
-              <a:avLst/>
-            </a:prstGeom>
-            <a:noFill/>
-            <a:ln w="19050">
-              <a:solidFill>
-                <a:schemeClr val="tx1"/>
-              </a:solidFill>
-            </a:ln>
-          </p:spPr>
-          <p:style>
-            <a:lnRef idx="2">
-              <a:schemeClr val="accent1">
-                <a:shade val="50000"/>
-              </a:schemeClr>
-            </a:lnRef>
-            <a:fillRef idx="1">
-              <a:schemeClr val="accent1"/>
-            </a:fillRef>
-            <a:effectRef idx="0">
-              <a:schemeClr val="accent1"/>
-            </a:effectRef>
-            <a:fontRef idx="minor">
-              <a:schemeClr val="lt1"/>
-            </a:fontRef>
-          </p:style>
-          <p:txBody>
-            <a:bodyPr rtlCol="0" anchor="ctr"/>
-            <a:lstStyle/>
-            <a:p>
-              <a:pPr algn="ctr"/>
-              <a:endParaRPr lang="ko-KR" altLang="en-US"/>
-            </a:p>
-          </p:txBody>
-        </p:sp>
-        <p:sp>
-          <p:nvSpPr>
-            <p:cNvPr id="129" name="직사각형 128"/>
-            <p:cNvSpPr>
-              <a:spLocks noChangeAspect="1"/>
-            </p:cNvSpPr>
-            <p:nvPr/>
-          </p:nvSpPr>
-          <p:spPr>
-            <a:xfrm>
-              <a:off x="4740327" y="3636109"/>
-              <a:ext cx="864000" cy="863891"/>
-            </a:xfrm>
-            <a:prstGeom prst="rect">
-              <a:avLst/>
-            </a:prstGeom>
-            <a:noFill/>
-            <a:ln w="19050">
-              <a:solidFill>
-                <a:schemeClr val="tx1"/>
-              </a:solidFill>
-            </a:ln>
-          </p:spPr>
-          <p:style>
-            <a:lnRef idx="2">
-              <a:schemeClr val="accent1">
-                <a:shade val="50000"/>
-              </a:schemeClr>
-            </a:lnRef>
-            <a:fillRef idx="1">
-              <a:schemeClr val="accent1"/>
-            </a:fillRef>
-            <a:effectRef idx="0">
-              <a:schemeClr val="accent1"/>
-            </a:effectRef>
-            <a:fontRef idx="minor">
-              <a:schemeClr val="lt1"/>
-            </a:fontRef>
-          </p:style>
-          <p:txBody>
-            <a:bodyPr rtlCol="0" anchor="ctr"/>
-            <a:lstStyle/>
-            <a:p>
-              <a:pPr algn="ctr"/>
-              <a:endParaRPr lang="ko-KR" altLang="en-US"/>
-            </a:p>
-          </p:txBody>
-        </p:sp>
-        <p:sp>
-          <p:nvSpPr>
-            <p:cNvPr id="130" name="직사각형 129"/>
-            <p:cNvSpPr>
-              <a:spLocks noChangeAspect="1"/>
-            </p:cNvSpPr>
-            <p:nvPr/>
-          </p:nvSpPr>
-          <p:spPr>
-            <a:xfrm>
-              <a:off x="5604326" y="3636109"/>
-              <a:ext cx="864000" cy="863891"/>
-            </a:xfrm>
-            <a:prstGeom prst="rect">
-              <a:avLst/>
-            </a:prstGeom>
-            <a:noFill/>
-            <a:ln w="19050">
-              <a:solidFill>
-                <a:schemeClr val="tx1"/>
-              </a:solidFill>
-            </a:ln>
-          </p:spPr>
-          <p:style>
-            <a:lnRef idx="2">
-              <a:schemeClr val="accent1">
-                <a:shade val="50000"/>
-              </a:schemeClr>
-            </a:lnRef>
-            <a:fillRef idx="1">
-              <a:schemeClr val="accent1"/>
-            </a:fillRef>
-            <a:effectRef idx="0">
-              <a:schemeClr val="accent1"/>
-            </a:effectRef>
-            <a:fontRef idx="minor">
-              <a:schemeClr val="lt1"/>
-            </a:fontRef>
-          </p:style>
-          <p:txBody>
-            <a:bodyPr rtlCol="0" anchor="ctr"/>
-            <a:lstStyle/>
-            <a:p>
-              <a:pPr algn="ctr"/>
-              <a:endParaRPr lang="ko-KR" altLang="en-US"/>
-            </a:p>
-          </p:txBody>
-        </p:sp>
-        <p:sp>
-          <p:nvSpPr>
-            <p:cNvPr id="131" name="직사각형 130"/>
-            <p:cNvSpPr>
-              <a:spLocks noChangeAspect="1"/>
-            </p:cNvSpPr>
-            <p:nvPr/>
-          </p:nvSpPr>
-          <p:spPr>
-            <a:xfrm>
-              <a:off x="2148328" y="4500000"/>
-              <a:ext cx="864000" cy="863891"/>
-            </a:xfrm>
-            <a:prstGeom prst="rect">
-              <a:avLst/>
-            </a:prstGeom>
-            <a:noFill/>
-            <a:ln w="19050">
-              <a:solidFill>
-                <a:schemeClr val="tx1"/>
-              </a:solidFill>
-            </a:ln>
-          </p:spPr>
-          <p:style>
-            <a:lnRef idx="2">
-              <a:schemeClr val="accent1">
-                <a:shade val="50000"/>
-              </a:schemeClr>
-            </a:lnRef>
-            <a:fillRef idx="1">
-              <a:schemeClr val="accent1"/>
-            </a:fillRef>
-            <a:effectRef idx="0">
-              <a:schemeClr val="accent1"/>
-            </a:effectRef>
-            <a:fontRef idx="minor">
-              <a:schemeClr val="lt1"/>
-            </a:fontRef>
-          </p:style>
-          <p:txBody>
-            <a:bodyPr rtlCol="0" anchor="ctr"/>
-            <a:lstStyle/>
-            <a:p>
-              <a:pPr algn="ctr"/>
-              <a:endParaRPr lang="ko-KR" altLang="en-US"/>
-            </a:p>
-          </p:txBody>
-        </p:sp>
-        <p:sp>
-          <p:nvSpPr>
-            <p:cNvPr id="135" name="직사각형 134"/>
-            <p:cNvSpPr>
-              <a:spLocks noChangeAspect="1"/>
-            </p:cNvSpPr>
-            <p:nvPr/>
-          </p:nvSpPr>
-          <p:spPr>
-            <a:xfrm>
-              <a:off x="3012328" y="4500000"/>
-              <a:ext cx="864000" cy="863891"/>
-            </a:xfrm>
-            <a:prstGeom prst="rect">
-              <a:avLst/>
-            </a:prstGeom>
-            <a:noFill/>
-            <a:ln w="19050">
-              <a:solidFill>
-                <a:schemeClr val="tx1"/>
-              </a:solidFill>
-            </a:ln>
-          </p:spPr>
-          <p:style>
-            <a:lnRef idx="2">
-              <a:schemeClr val="accent1">
-                <a:shade val="50000"/>
-              </a:schemeClr>
-            </a:lnRef>
-            <a:fillRef idx="1">
-              <a:schemeClr val="accent1"/>
-            </a:fillRef>
-            <a:effectRef idx="0">
-              <a:schemeClr val="accent1"/>
-            </a:effectRef>
-            <a:fontRef idx="minor">
-              <a:schemeClr val="lt1"/>
-            </a:fontRef>
-          </p:style>
-          <p:txBody>
-            <a:bodyPr rtlCol="0" anchor="ctr"/>
-            <a:lstStyle/>
-            <a:p>
-              <a:pPr algn="ctr"/>
-              <a:endParaRPr lang="ko-KR" altLang="en-US"/>
-            </a:p>
-          </p:txBody>
-        </p:sp>
-        <p:sp>
-          <p:nvSpPr>
-            <p:cNvPr id="138" name="직사각형 137"/>
-            <p:cNvSpPr>
-              <a:spLocks noChangeAspect="1"/>
-            </p:cNvSpPr>
-            <p:nvPr/>
-          </p:nvSpPr>
-          <p:spPr>
-            <a:xfrm>
-              <a:off x="3876327" y="4500000"/>
-              <a:ext cx="864000" cy="863891"/>
-            </a:xfrm>
-            <a:prstGeom prst="rect">
-              <a:avLst/>
-            </a:prstGeom>
-            <a:noFill/>
-            <a:ln w="19050">
-              <a:solidFill>
-                <a:schemeClr val="tx1"/>
-              </a:solidFill>
-            </a:ln>
-          </p:spPr>
-          <p:style>
-            <a:lnRef idx="2">
-              <a:schemeClr val="accent1">
-                <a:shade val="50000"/>
-              </a:schemeClr>
-            </a:lnRef>
-            <a:fillRef idx="1">
-              <a:schemeClr val="accent1"/>
-            </a:fillRef>
-            <a:effectRef idx="0">
-              <a:schemeClr val="accent1"/>
-            </a:effectRef>
-            <a:fontRef idx="minor">
-              <a:schemeClr val="lt1"/>
-            </a:fontRef>
-          </p:style>
-          <p:txBody>
-            <a:bodyPr rtlCol="0" anchor="ctr"/>
-            <a:lstStyle/>
-            <a:p>
-              <a:pPr algn="ctr"/>
-              <a:endParaRPr lang="ko-KR" altLang="en-US"/>
-            </a:p>
-          </p:txBody>
-        </p:sp>
-        <p:sp>
-          <p:nvSpPr>
-            <p:cNvPr id="139" name="직사각형 138"/>
-            <p:cNvSpPr>
-              <a:spLocks noChangeAspect="1"/>
-            </p:cNvSpPr>
-            <p:nvPr/>
-          </p:nvSpPr>
-          <p:spPr>
-            <a:xfrm>
-              <a:off x="4740327" y="4500000"/>
-              <a:ext cx="864000" cy="863891"/>
-            </a:xfrm>
-            <a:prstGeom prst="rect">
-              <a:avLst/>
-            </a:prstGeom>
-            <a:noFill/>
-            <a:ln w="19050">
-              <a:solidFill>
-                <a:schemeClr val="tx1"/>
-              </a:solidFill>
-            </a:ln>
-          </p:spPr>
-          <p:style>
-            <a:lnRef idx="2">
-              <a:schemeClr val="accent1">
-                <a:shade val="50000"/>
-              </a:schemeClr>
-            </a:lnRef>
-            <a:fillRef idx="1">
-              <a:schemeClr val="accent1"/>
-            </a:fillRef>
-            <a:effectRef idx="0">
-              <a:schemeClr val="accent1"/>
-            </a:effectRef>
-            <a:fontRef idx="minor">
-              <a:schemeClr val="lt1"/>
-            </a:fontRef>
-          </p:style>
-          <p:txBody>
-            <a:bodyPr rtlCol="0" anchor="ctr"/>
-            <a:lstStyle/>
-            <a:p>
-              <a:pPr algn="ctr"/>
-              <a:endParaRPr lang="ko-KR" altLang="en-US"/>
-            </a:p>
-          </p:txBody>
-        </p:sp>
-        <p:sp>
-          <p:nvSpPr>
-            <p:cNvPr id="140" name="직사각형 139"/>
-            <p:cNvSpPr>
-              <a:spLocks noChangeAspect="1"/>
-            </p:cNvSpPr>
-            <p:nvPr/>
-          </p:nvSpPr>
-          <p:spPr>
-            <a:xfrm>
-              <a:off x="5604326" y="4500000"/>
-              <a:ext cx="864000" cy="863891"/>
-            </a:xfrm>
-            <a:prstGeom prst="rect">
-              <a:avLst/>
-            </a:prstGeom>
-            <a:noFill/>
-            <a:ln w="19050">
-              <a:solidFill>
-                <a:schemeClr val="tx1"/>
-              </a:solidFill>
-            </a:ln>
-          </p:spPr>
-          <p:style>
-            <a:lnRef idx="2">
-              <a:schemeClr val="accent1">
-                <a:shade val="50000"/>
-              </a:schemeClr>
-            </a:lnRef>
-            <a:fillRef idx="1">
-              <a:schemeClr val="accent1"/>
-            </a:fillRef>
-            <a:effectRef idx="0">
-              <a:schemeClr val="accent1"/>
-            </a:effectRef>
-            <a:fontRef idx="minor">
-              <a:schemeClr val="lt1"/>
-            </a:fontRef>
-          </p:style>
-          <p:txBody>
-            <a:bodyPr rtlCol="0" anchor="ctr"/>
-            <a:lstStyle/>
-            <a:p>
-              <a:pPr algn="ctr"/>
-              <a:endParaRPr lang="ko-KR" altLang="en-US"/>
-            </a:p>
-          </p:txBody>
-        </p:sp>
-        <p:sp>
-          <p:nvSpPr>
-            <p:cNvPr id="145" name="직사각형 144"/>
-            <p:cNvSpPr>
-              <a:spLocks noChangeAspect="1"/>
-            </p:cNvSpPr>
-            <p:nvPr/>
-          </p:nvSpPr>
-          <p:spPr>
-            <a:xfrm>
-              <a:off x="2148328" y="5363887"/>
-              <a:ext cx="864000" cy="863891"/>
-            </a:xfrm>
-            <a:prstGeom prst="rect">
-              <a:avLst/>
-            </a:prstGeom>
-            <a:noFill/>
-            <a:ln w="19050">
-              <a:solidFill>
-                <a:schemeClr val="tx1"/>
-              </a:solidFill>
-            </a:ln>
-          </p:spPr>
-          <p:style>
-            <a:lnRef idx="2">
-              <a:schemeClr val="accent1">
-                <a:shade val="50000"/>
-              </a:schemeClr>
-            </a:lnRef>
-            <a:fillRef idx="1">
-              <a:schemeClr val="accent1"/>
-            </a:fillRef>
-            <a:effectRef idx="0">
-              <a:schemeClr val="accent1"/>
-            </a:effectRef>
-            <a:fontRef idx="minor">
-              <a:schemeClr val="lt1"/>
-            </a:fontRef>
-          </p:style>
-          <p:txBody>
-            <a:bodyPr rtlCol="0" anchor="ctr"/>
-            <a:lstStyle/>
-            <a:p>
-              <a:pPr algn="ctr"/>
-              <a:endParaRPr lang="ko-KR" altLang="en-US"/>
-            </a:p>
-          </p:txBody>
-        </p:sp>
-        <p:sp>
-          <p:nvSpPr>
-            <p:cNvPr id="159" name="직사각형 158"/>
-            <p:cNvSpPr>
-              <a:spLocks noChangeAspect="1"/>
-            </p:cNvSpPr>
-            <p:nvPr/>
-          </p:nvSpPr>
-          <p:spPr>
-            <a:xfrm>
-              <a:off x="3012328" y="5363887"/>
-              <a:ext cx="864000" cy="863891"/>
-            </a:xfrm>
-            <a:prstGeom prst="rect">
-              <a:avLst/>
-            </a:prstGeom>
-            <a:noFill/>
-            <a:ln w="19050">
-              <a:solidFill>
-                <a:schemeClr val="tx1"/>
-              </a:solidFill>
-            </a:ln>
-          </p:spPr>
-          <p:style>
-            <a:lnRef idx="2">
-              <a:schemeClr val="accent1">
-                <a:shade val="50000"/>
-              </a:schemeClr>
-            </a:lnRef>
-            <a:fillRef idx="1">
-              <a:schemeClr val="accent1"/>
-            </a:fillRef>
-            <a:effectRef idx="0">
-              <a:schemeClr val="accent1"/>
-            </a:effectRef>
-            <a:fontRef idx="minor">
-              <a:schemeClr val="lt1"/>
-            </a:fontRef>
-          </p:style>
-          <p:txBody>
-            <a:bodyPr rtlCol="0" anchor="ctr"/>
-            <a:lstStyle/>
-            <a:p>
-              <a:pPr algn="ctr"/>
-              <a:endParaRPr lang="ko-KR" altLang="en-US"/>
-            </a:p>
-          </p:txBody>
-        </p:sp>
-        <p:sp>
-          <p:nvSpPr>
-            <p:cNvPr id="160" name="직사각형 159"/>
-            <p:cNvSpPr>
-              <a:spLocks noChangeAspect="1"/>
-            </p:cNvSpPr>
-            <p:nvPr/>
-          </p:nvSpPr>
-          <p:spPr>
-            <a:xfrm>
-              <a:off x="3876327" y="5363887"/>
-              <a:ext cx="864000" cy="863891"/>
-            </a:xfrm>
-            <a:prstGeom prst="rect">
-              <a:avLst/>
-            </a:prstGeom>
-            <a:noFill/>
-            <a:ln w="19050">
-              <a:solidFill>
-                <a:schemeClr val="tx1"/>
-              </a:solidFill>
-            </a:ln>
-          </p:spPr>
-          <p:style>
-            <a:lnRef idx="2">
-              <a:schemeClr val="accent1">
-                <a:shade val="50000"/>
-              </a:schemeClr>
-            </a:lnRef>
-            <a:fillRef idx="1">
-              <a:schemeClr val="accent1"/>
-            </a:fillRef>
-            <a:effectRef idx="0">
-              <a:schemeClr val="accent1"/>
-            </a:effectRef>
-            <a:fontRef idx="minor">
-              <a:schemeClr val="lt1"/>
-            </a:fontRef>
-          </p:style>
-          <p:txBody>
-            <a:bodyPr rtlCol="0" anchor="ctr"/>
-            <a:lstStyle/>
-            <a:p>
-              <a:pPr algn="ctr"/>
-              <a:endParaRPr lang="ko-KR" altLang="en-US"/>
-            </a:p>
-          </p:txBody>
-        </p:sp>
-        <p:sp>
-          <p:nvSpPr>
-            <p:cNvPr id="177" name="직사각형 176"/>
-            <p:cNvSpPr>
-              <a:spLocks noChangeAspect="1"/>
-            </p:cNvSpPr>
-            <p:nvPr/>
-          </p:nvSpPr>
-          <p:spPr>
-            <a:xfrm>
-              <a:off x="4740327" y="5363887"/>
-              <a:ext cx="864000" cy="863891"/>
-            </a:xfrm>
-            <a:prstGeom prst="rect">
-              <a:avLst/>
-            </a:prstGeom>
-            <a:noFill/>
-            <a:ln w="19050">
-              <a:solidFill>
-                <a:schemeClr val="tx1"/>
-              </a:solidFill>
-            </a:ln>
-          </p:spPr>
-          <p:style>
-            <a:lnRef idx="2">
-              <a:schemeClr val="accent1">
-                <a:shade val="50000"/>
-              </a:schemeClr>
-            </a:lnRef>
-            <a:fillRef idx="1">
-              <a:schemeClr val="accent1"/>
-            </a:fillRef>
-            <a:effectRef idx="0">
-              <a:schemeClr val="accent1"/>
-            </a:effectRef>
-            <a:fontRef idx="minor">
-              <a:schemeClr val="lt1"/>
-            </a:fontRef>
-          </p:style>
-          <p:txBody>
-            <a:bodyPr rtlCol="0" anchor="ctr"/>
-            <a:lstStyle/>
-            <a:p>
-              <a:pPr algn="ctr"/>
-              <a:endParaRPr lang="ko-KR" altLang="en-US"/>
-            </a:p>
-          </p:txBody>
-        </p:sp>
-        <p:sp>
-          <p:nvSpPr>
-            <p:cNvPr id="178" name="직사각형 177"/>
-            <p:cNvSpPr>
-              <a:spLocks noChangeAspect="1"/>
-            </p:cNvSpPr>
-            <p:nvPr/>
-          </p:nvSpPr>
-          <p:spPr>
-            <a:xfrm>
-              <a:off x="5604326" y="5363887"/>
-              <a:ext cx="864000" cy="863891"/>
-            </a:xfrm>
-            <a:prstGeom prst="rect">
-              <a:avLst/>
-            </a:prstGeom>
-            <a:noFill/>
-            <a:ln w="19050">
-              <a:solidFill>
-                <a:schemeClr val="tx1"/>
-              </a:solidFill>
-            </a:ln>
-          </p:spPr>
-          <p:style>
-            <a:lnRef idx="2">
-              <a:schemeClr val="accent1">
-                <a:shade val="50000"/>
-              </a:schemeClr>
-            </a:lnRef>
-            <a:fillRef idx="1">
-              <a:schemeClr val="accent1"/>
-            </a:fillRef>
-            <a:effectRef idx="0">
-              <a:schemeClr val="accent1"/>
-            </a:effectRef>
-            <a:fontRef idx="minor">
-              <a:schemeClr val="lt1"/>
-            </a:fontRef>
-          </p:style>
-          <p:txBody>
-            <a:bodyPr rtlCol="0" anchor="ctr"/>
-            <a:lstStyle/>
-            <a:p>
-              <a:pPr algn="ctr"/>
-              <a:endParaRPr lang="ko-KR" altLang="en-US"/>
-            </a:p>
-          </p:txBody>
-        </p:sp>
-        <p:sp>
-          <p:nvSpPr>
-            <p:cNvPr id="187" name="직사각형 186"/>
-            <p:cNvSpPr>
-              <a:spLocks noChangeAspect="1"/>
-            </p:cNvSpPr>
-            <p:nvPr/>
-          </p:nvSpPr>
-          <p:spPr>
-            <a:xfrm>
-              <a:off x="6468324" y="2772222"/>
-              <a:ext cx="864000" cy="863891"/>
-            </a:xfrm>
-            <a:prstGeom prst="rect">
-              <a:avLst/>
-            </a:prstGeom>
-            <a:noFill/>
-            <a:ln w="19050">
-              <a:solidFill>
-                <a:schemeClr val="tx1"/>
-              </a:solidFill>
-            </a:ln>
-          </p:spPr>
-          <p:style>
-            <a:lnRef idx="2">
-              <a:schemeClr val="accent1">
-                <a:shade val="50000"/>
-              </a:schemeClr>
-            </a:lnRef>
-            <a:fillRef idx="1">
-              <a:schemeClr val="accent1"/>
-            </a:fillRef>
-            <a:effectRef idx="0">
-              <a:schemeClr val="accent1"/>
-            </a:effectRef>
-            <a:fontRef idx="minor">
-              <a:schemeClr val="lt1"/>
-            </a:fontRef>
-          </p:style>
-          <p:txBody>
-            <a:bodyPr rtlCol="0" anchor="ctr"/>
-            <a:lstStyle/>
-            <a:p>
-              <a:pPr algn="ctr"/>
-              <a:endParaRPr lang="ko-KR" altLang="en-US"/>
-            </a:p>
-          </p:txBody>
-        </p:sp>
-        <p:sp>
-          <p:nvSpPr>
-            <p:cNvPr id="188" name="직사각형 187"/>
-            <p:cNvSpPr>
-              <a:spLocks noChangeAspect="1"/>
-            </p:cNvSpPr>
-            <p:nvPr/>
-          </p:nvSpPr>
-          <p:spPr>
-            <a:xfrm>
-              <a:off x="7332324" y="2772222"/>
-              <a:ext cx="864000" cy="863891"/>
-            </a:xfrm>
-            <a:prstGeom prst="rect">
-              <a:avLst/>
-            </a:prstGeom>
-            <a:noFill/>
-            <a:ln w="19050">
-              <a:solidFill>
-                <a:schemeClr val="tx1"/>
-              </a:solidFill>
-            </a:ln>
-          </p:spPr>
-          <p:style>
-            <a:lnRef idx="2">
-              <a:schemeClr val="accent1">
-                <a:shade val="50000"/>
-              </a:schemeClr>
-            </a:lnRef>
-            <a:fillRef idx="1">
-              <a:schemeClr val="accent1"/>
-            </a:fillRef>
-            <a:effectRef idx="0">
-              <a:schemeClr val="accent1"/>
-            </a:effectRef>
-            <a:fontRef idx="minor">
-              <a:schemeClr val="lt1"/>
-            </a:fontRef>
-          </p:style>
-          <p:txBody>
-            <a:bodyPr rtlCol="0" anchor="ctr"/>
-            <a:lstStyle/>
-            <a:p>
-              <a:pPr algn="ctr"/>
-              <a:endParaRPr lang="ko-KR" altLang="en-US"/>
-            </a:p>
-          </p:txBody>
-        </p:sp>
-        <p:sp>
-          <p:nvSpPr>
-            <p:cNvPr id="189" name="직사각형 188"/>
-            <p:cNvSpPr>
-              <a:spLocks noChangeAspect="1"/>
-            </p:cNvSpPr>
-            <p:nvPr/>
-          </p:nvSpPr>
-          <p:spPr>
-            <a:xfrm>
-              <a:off x="8196323" y="2772222"/>
-              <a:ext cx="864000" cy="863891"/>
-            </a:xfrm>
-            <a:prstGeom prst="rect">
-              <a:avLst/>
-            </a:prstGeom>
-            <a:noFill/>
-            <a:ln w="19050">
-              <a:solidFill>
-                <a:schemeClr val="tx1"/>
-              </a:solidFill>
-            </a:ln>
-          </p:spPr>
-          <p:style>
-            <a:lnRef idx="2">
-              <a:schemeClr val="accent1">
-                <a:shade val="50000"/>
-              </a:schemeClr>
-            </a:lnRef>
-            <a:fillRef idx="1">
-              <a:schemeClr val="accent1"/>
-            </a:fillRef>
-            <a:effectRef idx="0">
-              <a:schemeClr val="accent1"/>
-            </a:effectRef>
-            <a:fontRef idx="minor">
-              <a:schemeClr val="lt1"/>
-            </a:fontRef>
-          </p:style>
-          <p:txBody>
-            <a:bodyPr rtlCol="0" anchor="ctr"/>
-            <a:lstStyle/>
-            <a:p>
-              <a:pPr algn="ctr"/>
-              <a:endParaRPr lang="ko-KR" altLang="en-US"/>
-            </a:p>
-          </p:txBody>
-        </p:sp>
-        <p:sp>
-          <p:nvSpPr>
-            <p:cNvPr id="197" name="직사각형 196"/>
-            <p:cNvSpPr>
-              <a:spLocks noChangeAspect="1"/>
-            </p:cNvSpPr>
-            <p:nvPr/>
-          </p:nvSpPr>
-          <p:spPr>
-            <a:xfrm>
-              <a:off x="2148327" y="2772222"/>
-              <a:ext cx="864000" cy="863891"/>
-            </a:xfrm>
-            <a:prstGeom prst="rect">
-              <a:avLst/>
-            </a:prstGeom>
-            <a:noFill/>
-            <a:ln w="19050">
-              <a:solidFill>
-                <a:schemeClr val="tx1"/>
-              </a:solidFill>
-            </a:ln>
-          </p:spPr>
-          <p:style>
-            <a:lnRef idx="2">
-              <a:schemeClr val="accent1">
-                <a:shade val="50000"/>
-              </a:schemeClr>
-            </a:lnRef>
-            <a:fillRef idx="1">
-              <a:schemeClr val="accent1"/>
-            </a:fillRef>
-            <a:effectRef idx="0">
-              <a:schemeClr val="accent1"/>
-            </a:effectRef>
-            <a:fontRef idx="minor">
-              <a:schemeClr val="lt1"/>
-            </a:fontRef>
-          </p:style>
-          <p:txBody>
-            <a:bodyPr rtlCol="0" anchor="ctr"/>
-            <a:lstStyle/>
-            <a:p>
-              <a:pPr algn="ctr"/>
-              <a:endParaRPr lang="ko-KR" altLang="en-US"/>
-            </a:p>
-          </p:txBody>
-        </p:sp>
-        <p:sp>
-          <p:nvSpPr>
-            <p:cNvPr id="198" name="직사각형 197"/>
-            <p:cNvSpPr>
-              <a:spLocks noChangeAspect="1"/>
-            </p:cNvSpPr>
-            <p:nvPr/>
-          </p:nvSpPr>
-          <p:spPr>
-            <a:xfrm>
-              <a:off x="3012327" y="2772222"/>
-              <a:ext cx="864000" cy="863891"/>
-            </a:xfrm>
-            <a:prstGeom prst="rect">
-              <a:avLst/>
-            </a:prstGeom>
-            <a:noFill/>
-            <a:ln w="19050">
-              <a:solidFill>
-                <a:schemeClr val="tx1"/>
-              </a:solidFill>
-            </a:ln>
-          </p:spPr>
-          <p:style>
-            <a:lnRef idx="2">
-              <a:schemeClr val="accent1">
-                <a:shade val="50000"/>
-              </a:schemeClr>
-            </a:lnRef>
-            <a:fillRef idx="1">
-              <a:schemeClr val="accent1"/>
-            </a:fillRef>
-            <a:effectRef idx="0">
-              <a:schemeClr val="accent1"/>
-            </a:effectRef>
-            <a:fontRef idx="minor">
-              <a:schemeClr val="lt1"/>
-            </a:fontRef>
-          </p:style>
-          <p:txBody>
-            <a:bodyPr rtlCol="0" anchor="ctr"/>
-            <a:lstStyle/>
-            <a:p>
-              <a:pPr algn="ctr"/>
-              <a:endParaRPr lang="ko-KR" altLang="en-US"/>
-            </a:p>
-          </p:txBody>
-        </p:sp>
-        <p:sp>
-          <p:nvSpPr>
-            <p:cNvPr id="199" name="직사각형 198"/>
-            <p:cNvSpPr>
-              <a:spLocks noChangeAspect="1"/>
-            </p:cNvSpPr>
-            <p:nvPr/>
-          </p:nvSpPr>
-          <p:spPr>
-            <a:xfrm>
-              <a:off x="3876326" y="2772222"/>
-              <a:ext cx="864000" cy="863891"/>
-            </a:xfrm>
-            <a:prstGeom prst="rect">
-              <a:avLst/>
-            </a:prstGeom>
-            <a:noFill/>
-            <a:ln w="19050">
-              <a:solidFill>
-                <a:schemeClr val="tx1"/>
-              </a:solidFill>
-            </a:ln>
-          </p:spPr>
-          <p:style>
-            <a:lnRef idx="2">
-              <a:schemeClr val="accent1">
-                <a:shade val="50000"/>
-              </a:schemeClr>
-            </a:lnRef>
-            <a:fillRef idx="1">
-              <a:schemeClr val="accent1"/>
-            </a:fillRef>
-            <a:effectRef idx="0">
-              <a:schemeClr val="accent1"/>
-            </a:effectRef>
-            <a:fontRef idx="minor">
-              <a:schemeClr val="lt1"/>
-            </a:fontRef>
-          </p:style>
-          <p:txBody>
-            <a:bodyPr rtlCol="0" anchor="ctr"/>
-            <a:lstStyle/>
-            <a:p>
-              <a:pPr algn="ctr"/>
-              <a:endParaRPr lang="ko-KR" altLang="en-US"/>
-            </a:p>
-          </p:txBody>
-        </p:sp>
-        <p:sp>
-          <p:nvSpPr>
-            <p:cNvPr id="200" name="직사각형 199"/>
-            <p:cNvSpPr>
-              <a:spLocks noChangeAspect="1"/>
-            </p:cNvSpPr>
-            <p:nvPr/>
-          </p:nvSpPr>
-          <p:spPr>
-            <a:xfrm>
-              <a:off x="4740326" y="2772222"/>
-              <a:ext cx="864000" cy="863891"/>
-            </a:xfrm>
-            <a:prstGeom prst="rect">
-              <a:avLst/>
-            </a:prstGeom>
-            <a:noFill/>
-            <a:ln w="19050">
-              <a:solidFill>
-                <a:schemeClr val="tx1"/>
-              </a:solidFill>
-            </a:ln>
-          </p:spPr>
-          <p:style>
-            <a:lnRef idx="2">
-              <a:schemeClr val="accent1">
-                <a:shade val="50000"/>
-              </a:schemeClr>
-            </a:lnRef>
-            <a:fillRef idx="1">
-              <a:schemeClr val="accent1"/>
-            </a:fillRef>
-            <a:effectRef idx="0">
-              <a:schemeClr val="accent1"/>
-            </a:effectRef>
-            <a:fontRef idx="minor">
-              <a:schemeClr val="lt1"/>
-            </a:fontRef>
-          </p:style>
-          <p:txBody>
-            <a:bodyPr rtlCol="0" anchor="ctr"/>
-            <a:lstStyle/>
-            <a:p>
-              <a:pPr algn="ctr"/>
-              <a:endParaRPr lang="ko-KR" altLang="en-US"/>
-            </a:p>
-          </p:txBody>
-        </p:sp>
-        <p:sp>
-          <p:nvSpPr>
-            <p:cNvPr id="201" name="직사각형 200"/>
-            <p:cNvSpPr>
-              <a:spLocks noChangeAspect="1"/>
-            </p:cNvSpPr>
-            <p:nvPr/>
-          </p:nvSpPr>
-          <p:spPr>
-            <a:xfrm>
-              <a:off x="5604325" y="2772222"/>
-              <a:ext cx="864000" cy="863891"/>
-            </a:xfrm>
-            <a:prstGeom prst="rect">
-              <a:avLst/>
-            </a:prstGeom>
-            <a:noFill/>
-            <a:ln w="19050">
-              <a:solidFill>
-                <a:schemeClr val="tx1"/>
-              </a:solidFill>
-            </a:ln>
-          </p:spPr>
-          <p:style>
-            <a:lnRef idx="2">
-              <a:schemeClr val="accent1">
-                <a:shade val="50000"/>
-              </a:schemeClr>
-            </a:lnRef>
-            <a:fillRef idx="1">
-              <a:schemeClr val="accent1"/>
-            </a:fillRef>
-            <a:effectRef idx="0">
-              <a:schemeClr val="accent1"/>
-            </a:effectRef>
-            <a:fontRef idx="minor">
-              <a:schemeClr val="lt1"/>
-            </a:fontRef>
-          </p:style>
-          <p:txBody>
-            <a:bodyPr rtlCol="0" anchor="ctr"/>
-            <a:lstStyle/>
-            <a:p>
-              <a:pPr algn="ctr"/>
-              <a:endParaRPr lang="ko-KR" altLang="en-US"/>
-            </a:p>
-          </p:txBody>
-        </p:sp>
-        <p:sp>
-          <p:nvSpPr>
-            <p:cNvPr id="24" name="직사각형 23"/>
-            <p:cNvSpPr/>
-            <p:nvPr/>
-          </p:nvSpPr>
-          <p:spPr>
-            <a:xfrm>
-              <a:off x="3951753" y="3780054"/>
-              <a:ext cx="720000" cy="576000"/>
-            </a:xfrm>
-            <a:prstGeom prst="rect">
-              <a:avLst/>
-            </a:prstGeom>
-            <a:solidFill>
-              <a:schemeClr val="accent6">
-                <a:lumMod val="20000"/>
-                <a:lumOff val="80000"/>
-              </a:schemeClr>
-            </a:solidFill>
-            <a:ln w="19050">
-              <a:solidFill>
-                <a:schemeClr val="tx1"/>
-              </a:solidFill>
-            </a:ln>
-          </p:spPr>
-          <p:style>
-            <a:lnRef idx="2">
-              <a:schemeClr val="accent1">
-                <a:shade val="50000"/>
-              </a:schemeClr>
-            </a:lnRef>
-            <a:fillRef idx="1">
-              <a:schemeClr val="accent1"/>
-            </a:fillRef>
-            <a:effectRef idx="0">
-              <a:schemeClr val="accent1"/>
-            </a:effectRef>
-            <a:fontRef idx="minor">
-              <a:schemeClr val="lt1"/>
-            </a:fontRef>
-          </p:style>
-          <p:txBody>
-            <a:bodyPr rtlCol="0" anchor="ctr"/>
-            <a:lstStyle/>
-            <a:p>
-              <a:pPr algn="ctr"/>
-              <a:r>
-                <a:rPr lang="en-US" altLang="ko-KR" sz="1400" dirty="0" smtClean="0">
-                  <a:solidFill>
-                    <a:schemeClr val="tx1"/>
-                  </a:solidFill>
-                  <a:latin typeface="나눔스퀘어 Bold" panose="020B0600000101010101" pitchFamily="50" charset="-127"/>
-                  <a:ea typeface="나눔스퀘어 Bold" panose="020B0600000101010101" pitchFamily="50" charset="-127"/>
-                </a:rPr>
-                <a:t>Cat</a:t>
-              </a:r>
-            </a:p>
-            <a:p>
-              <a:pPr algn="ctr"/>
-              <a:r>
-                <a:rPr lang="ko-KR" altLang="en-US" sz="1400" dirty="0" smtClean="0">
-                  <a:solidFill>
-                    <a:schemeClr val="tx1"/>
-                  </a:solidFill>
-                  <a:latin typeface="나눔스퀘어 Bold" panose="020B0600000101010101" pitchFamily="50" charset="-127"/>
-                  <a:ea typeface="나눔스퀘어 Bold" panose="020B0600000101010101" pitchFamily="50" charset="-127"/>
-                </a:rPr>
-                <a:t>클래스</a:t>
-              </a:r>
-              <a:endParaRPr lang="ko-KR" altLang="en-US" sz="1400" dirty="0">
-                <a:solidFill>
-                  <a:schemeClr val="tx1"/>
-                </a:solidFill>
-                <a:latin typeface="나눔스퀘어 Bold" panose="020B0600000101010101" pitchFamily="50" charset="-127"/>
-                <a:ea typeface="나눔스퀘어 Bold" panose="020B0600000101010101" pitchFamily="50" charset="-127"/>
-              </a:endParaRPr>
-            </a:p>
-          </p:txBody>
-        </p:sp>
-        <p:sp>
-          <p:nvSpPr>
-            <p:cNvPr id="202" name="직사각형 201"/>
-            <p:cNvSpPr/>
-            <p:nvPr/>
-          </p:nvSpPr>
-          <p:spPr>
-            <a:xfrm>
-              <a:off x="6529977" y="4643943"/>
-              <a:ext cx="720000" cy="576000"/>
-            </a:xfrm>
-            <a:prstGeom prst="rect">
-              <a:avLst/>
-            </a:prstGeom>
-            <a:solidFill>
-              <a:schemeClr val="accent6">
-                <a:lumMod val="20000"/>
-                <a:lumOff val="80000"/>
-              </a:schemeClr>
-            </a:solidFill>
-            <a:ln w="19050">
-              <a:solidFill>
-                <a:schemeClr val="tx1"/>
-              </a:solidFill>
-            </a:ln>
-          </p:spPr>
-          <p:style>
-            <a:lnRef idx="2">
-              <a:schemeClr val="accent1">
-                <a:shade val="50000"/>
-              </a:schemeClr>
-            </a:lnRef>
-            <a:fillRef idx="1">
-              <a:schemeClr val="accent1"/>
-            </a:fillRef>
-            <a:effectRef idx="0">
-              <a:schemeClr val="accent1"/>
-            </a:effectRef>
-            <a:fontRef idx="minor">
-              <a:schemeClr val="lt1"/>
-            </a:fontRef>
-          </p:style>
-          <p:txBody>
-            <a:bodyPr rtlCol="0" anchor="ctr"/>
-            <a:lstStyle/>
-            <a:p>
-              <a:pPr algn="ctr"/>
-              <a:r>
-                <a:rPr lang="en-US" altLang="ko-KR" sz="1400" dirty="0" smtClean="0">
-                  <a:solidFill>
-                    <a:schemeClr val="tx1"/>
-                  </a:solidFill>
-                  <a:latin typeface="나눔스퀘어 Bold" panose="020B0600000101010101" pitchFamily="50" charset="-127"/>
-                  <a:ea typeface="나눔스퀘어 Bold" panose="020B0600000101010101" pitchFamily="50" charset="-127"/>
-                </a:rPr>
-                <a:t>Cat</a:t>
-              </a:r>
-            </a:p>
-            <a:p>
-              <a:pPr algn="ctr"/>
-              <a:r>
-                <a:rPr lang="ko-KR" altLang="en-US" sz="1400" dirty="0" smtClean="0">
-                  <a:solidFill>
-                    <a:schemeClr val="tx1"/>
-                  </a:solidFill>
-                  <a:latin typeface="나눔스퀘어 Bold" panose="020B0600000101010101" pitchFamily="50" charset="-127"/>
-                  <a:ea typeface="나눔스퀘어 Bold" panose="020B0600000101010101" pitchFamily="50" charset="-127"/>
-                </a:rPr>
-                <a:t>객체</a:t>
-              </a:r>
-              <a:endParaRPr lang="ko-KR" altLang="en-US" sz="1400" dirty="0">
-                <a:solidFill>
-                  <a:schemeClr val="tx1"/>
-                </a:solidFill>
-                <a:latin typeface="나눔스퀘어 Bold" panose="020B0600000101010101" pitchFamily="50" charset="-127"/>
-                <a:ea typeface="나눔스퀘어 Bold" panose="020B0600000101010101" pitchFamily="50" charset="-127"/>
-              </a:endParaRPr>
-            </a:p>
-          </p:txBody>
-        </p:sp>
-        <p:sp>
-          <p:nvSpPr>
-            <p:cNvPr id="25" name="TextBox 24"/>
+            <p:cNvPr id="113" name="TextBox 112"/>
             <p:cNvSpPr txBox="1"/>
             <p:nvPr/>
           </p:nvSpPr>
           <p:spPr>
             <a:xfrm>
-              <a:off x="4861173" y="2078669"/>
-              <a:ext cx="1486304" cy="523220"/>
+              <a:off x="4509159" y="1846983"/>
+              <a:ext cx="1715534" cy="400110"/>
             </a:xfrm>
             <a:prstGeom prst="rect">
               <a:avLst/>
@@ -12806,105 +11924,116 @@
             </a:bodyPr>
             <a:lstStyle/>
             <a:p>
+              <a:pPr algn="ctr"/>
               <a:r>
-                <a:rPr lang="en-US" altLang="ko-KR" sz="2800" dirty="0">
+                <a:rPr lang="en-US" altLang="ko-KR" sz="2000" dirty="0" smtClean="0">
                   <a:latin typeface="나눔스퀘어 Bold" panose="020B0600000101010101" pitchFamily="50" charset="-127"/>
                   <a:ea typeface="나눔스퀘어 Bold" panose="020B0600000101010101" pitchFamily="50" charset="-127"/>
                 </a:rPr>
-                <a:t>n</a:t>
+                <a:t>1. </a:t>
               </a:r>
               <a:r>
-                <a:rPr lang="en-US" altLang="ko-KR" sz="2800" dirty="0" smtClean="0">
+                <a:rPr lang="ko-KR" altLang="en-US" sz="2000" dirty="0" smtClean="0">
                   <a:latin typeface="나눔스퀘어 Bold" panose="020B0600000101010101" pitchFamily="50" charset="-127"/>
                   <a:ea typeface="나눔스퀘어 Bold" panose="020B0600000101010101" pitchFamily="50" charset="-127"/>
                 </a:rPr>
-                <a:t>ew cat</a:t>
+                <a:t>메서드 호출</a:t>
               </a:r>
-              <a:endParaRPr lang="ko-KR" altLang="en-US" sz="2800" dirty="0">
+              <a:endParaRPr lang="ko-KR" altLang="en-US" sz="2000" dirty="0">
                 <a:latin typeface="나눔스퀘어 Bold" panose="020B0600000101010101" pitchFamily="50" charset="-127"/>
                 <a:ea typeface="나눔스퀘어 Bold" panose="020B0600000101010101" pitchFamily="50" charset="-127"/>
               </a:endParaRPr>
             </a:p>
           </p:txBody>
         </p:sp>
-        <p:cxnSp>
-          <p:nvCxnSpPr>
-            <p:cNvPr id="30" name="꺾인 연결선 29"/>
-            <p:cNvCxnSpPr>
-              <a:stCxn id="25" idx="1"/>
-              <a:endCxn id="24" idx="0"/>
-            </p:cNvCxnSpPr>
+        <p:sp>
+          <p:nvSpPr>
+            <p:cNvPr id="115" name="TextBox 114"/>
+            <p:cNvSpPr txBox="1"/>
             <p:nvPr/>
-          </p:nvCxnSpPr>
+          </p:nvSpPr>
           <p:spPr>
-            <a:xfrm rot="10800000" flipV="1">
-              <a:off x="4311753" y="2340278"/>
-              <a:ext cx="549420" cy="1439775"/>
+            <a:xfrm>
+              <a:off x="6217404" y="2470969"/>
+              <a:ext cx="1715534" cy="400110"/>
             </a:xfrm>
-            <a:prstGeom prst="bentConnector2">
+            <a:prstGeom prst="rect">
               <a:avLst/>
             </a:prstGeom>
-            <a:ln w="76200">
-              <a:solidFill>
-                <a:schemeClr val="accent2"/>
-              </a:solidFill>
-              <a:tailEnd type="triangle"/>
-            </a:ln>
+            <a:noFill/>
           </p:spPr>
-          <p:style>
-            <a:lnRef idx="1">
-              <a:schemeClr val="accent1"/>
-            </a:lnRef>
-            <a:fillRef idx="0">
-              <a:schemeClr val="accent1"/>
-            </a:fillRef>
-            <a:effectRef idx="0">
-              <a:schemeClr val="accent1"/>
-            </a:effectRef>
-            <a:fontRef idx="minor">
-              <a:schemeClr val="tx1"/>
-            </a:fontRef>
-          </p:style>
-        </p:cxnSp>
-        <p:cxnSp>
-          <p:nvCxnSpPr>
-            <p:cNvPr id="203" name="꺾인 연결선 202"/>
-            <p:cNvCxnSpPr>
-              <a:stCxn id="24" idx="2"/>
-              <a:endCxn id="202" idx="1"/>
-            </p:cNvCxnSpPr>
+          <p:txBody>
+            <a:bodyPr wrap="none" rtlCol="0">
+              <a:spAutoFit/>
+            </a:bodyPr>
+            <a:lstStyle/>
+            <a:p>
+              <a:pPr algn="ctr"/>
+              <a:r>
+                <a:rPr lang="en-US" altLang="ko-KR" sz="2000" dirty="0" smtClean="0">
+                  <a:latin typeface="나눔스퀘어 Bold" panose="020B0600000101010101" pitchFamily="50" charset="-127"/>
+                  <a:ea typeface="나눔스퀘어 Bold" panose="020B0600000101010101" pitchFamily="50" charset="-127"/>
+                </a:rPr>
+                <a:t>2. </a:t>
+              </a:r>
+              <a:r>
+                <a:rPr lang="ko-KR" altLang="en-US" sz="2000" dirty="0" smtClean="0">
+                  <a:latin typeface="나눔스퀘어 Bold" panose="020B0600000101010101" pitchFamily="50" charset="-127"/>
+                  <a:ea typeface="나눔스퀘어 Bold" panose="020B0600000101010101" pitchFamily="50" charset="-127"/>
+                </a:rPr>
+                <a:t>메서드 실행</a:t>
+              </a:r>
+              <a:endParaRPr lang="ko-KR" altLang="en-US" sz="2000" dirty="0">
+                <a:latin typeface="나눔스퀘어 Bold" panose="020B0600000101010101" pitchFamily="50" charset="-127"/>
+                <a:ea typeface="나눔스퀘어 Bold" panose="020B0600000101010101" pitchFamily="50" charset="-127"/>
+              </a:endParaRPr>
+            </a:p>
+          </p:txBody>
+        </p:sp>
+        <p:sp>
+          <p:nvSpPr>
+            <p:cNvPr id="116" name="TextBox 115"/>
+            <p:cNvSpPr txBox="1"/>
             <p:nvPr/>
-          </p:nvCxnSpPr>
+          </p:nvSpPr>
           <p:spPr>
-            <a:xfrm rot="16200000" flipH="1">
-              <a:off x="5132921" y="3534886"/>
-              <a:ext cx="575889" cy="2218224"/>
+            <a:xfrm>
+              <a:off x="4298641" y="3460399"/>
+              <a:ext cx="1715534" cy="400110"/>
             </a:xfrm>
-            <a:prstGeom prst="bentConnector2">
+            <a:prstGeom prst="rect">
               <a:avLst/>
             </a:prstGeom>
-            <a:ln w="76200">
-              <a:solidFill>
-                <a:schemeClr val="accent2"/>
-              </a:solidFill>
-              <a:tailEnd type="triangle"/>
-            </a:ln>
+            <a:noFill/>
           </p:spPr>
-          <p:style>
-            <a:lnRef idx="1">
-              <a:schemeClr val="accent1"/>
-            </a:lnRef>
-            <a:fillRef idx="0">
-              <a:schemeClr val="accent1"/>
-            </a:fillRef>
-            <a:effectRef idx="0">
-              <a:schemeClr val="accent1"/>
-            </a:effectRef>
-            <a:fontRef idx="minor">
-              <a:schemeClr val="tx1"/>
-            </a:fontRef>
-          </p:style>
-        </p:cxnSp>
+          <p:txBody>
+            <a:bodyPr wrap="none" rtlCol="0">
+              <a:spAutoFit/>
+            </a:bodyPr>
+            <a:lstStyle/>
+            <a:p>
+              <a:pPr algn="ctr"/>
+              <a:r>
+                <a:rPr lang="en-US" altLang="ko-KR" sz="2000" dirty="0" smtClean="0">
+                  <a:latin typeface="나눔스퀘어 Bold" panose="020B0600000101010101" pitchFamily="50" charset="-127"/>
+                  <a:ea typeface="나눔스퀘어 Bold" panose="020B0600000101010101" pitchFamily="50" charset="-127"/>
+                </a:rPr>
+                <a:t>3. </a:t>
+              </a:r>
+              <a:r>
+                <a:rPr lang="ko-KR" altLang="en-US" sz="2000" dirty="0" smtClean="0">
+                  <a:latin typeface="나눔스퀘어 Bold" panose="020B0600000101010101" pitchFamily="50" charset="-127"/>
+                  <a:ea typeface="나눔스퀘어 Bold" panose="020B0600000101010101" pitchFamily="50" charset="-127"/>
+                </a:rPr>
+                <a:t>데이터 반환</a:t>
+              </a:r>
+              <a:endParaRPr lang="ko-KR" altLang="en-US" sz="2000" dirty="0">
+                <a:latin typeface="나눔스퀘어 Bold" panose="020B0600000101010101" pitchFamily="50" charset="-127"/>
+                <a:ea typeface="나눔스퀘어 Bold" panose="020B0600000101010101" pitchFamily="50" charset="-127"/>
+              </a:endParaRPr>
+            </a:p>
+          </p:txBody>
+        </p:sp>
       </p:grpSp>
     </p:spTree>
     <p:extLst>

</xml_diff>

<commit_message>
20260811 commit : capsule part, perfectly complete?
</commit_message>
<xml_diff>
--- a/create_notion_img.pptx
+++ b/create_notion_img.pptx
@@ -247,7 +247,7 @@
           <a:p>
             <a:fld id="{7237CE1A-8831-48B5-BA93-72483C6E34E8}" type="datetimeFigureOut">
               <a:rPr lang="ko-KR" altLang="en-US" smtClean="0"/>
-              <a:t>26-08-10(Mon)</a:t>
+              <a:t>2026-08-11</a:t>
             </a:fld>
             <a:endParaRPr lang="ko-KR" altLang="en-US"/>
           </a:p>
@@ -417,7 +417,7 @@
           <a:p>
             <a:fld id="{7237CE1A-8831-48B5-BA93-72483C6E34E8}" type="datetimeFigureOut">
               <a:rPr lang="ko-KR" altLang="en-US" smtClean="0"/>
-              <a:t>26-08-10(Mon)</a:t>
+              <a:t>2026-08-11</a:t>
             </a:fld>
             <a:endParaRPr lang="ko-KR" altLang="en-US"/>
           </a:p>
@@ -597,7 +597,7 @@
           <a:p>
             <a:fld id="{7237CE1A-8831-48B5-BA93-72483C6E34E8}" type="datetimeFigureOut">
               <a:rPr lang="ko-KR" altLang="en-US" smtClean="0"/>
-              <a:t>26-08-10(Mon)</a:t>
+              <a:t>2026-08-11</a:t>
             </a:fld>
             <a:endParaRPr lang="ko-KR" altLang="en-US"/>
           </a:p>
@@ -767,7 +767,7 @@
           <a:p>
             <a:fld id="{7237CE1A-8831-48B5-BA93-72483C6E34E8}" type="datetimeFigureOut">
               <a:rPr lang="ko-KR" altLang="en-US" smtClean="0"/>
-              <a:t>26-08-10(Mon)</a:t>
+              <a:t>2026-08-11</a:t>
             </a:fld>
             <a:endParaRPr lang="ko-KR" altLang="en-US"/>
           </a:p>
@@ -1013,7 +1013,7 @@
           <a:p>
             <a:fld id="{7237CE1A-8831-48B5-BA93-72483C6E34E8}" type="datetimeFigureOut">
               <a:rPr lang="ko-KR" altLang="en-US" smtClean="0"/>
-              <a:t>26-08-10(Mon)</a:t>
+              <a:t>2026-08-11</a:t>
             </a:fld>
             <a:endParaRPr lang="ko-KR" altLang="en-US"/>
           </a:p>
@@ -1245,7 +1245,7 @@
           <a:p>
             <a:fld id="{7237CE1A-8831-48B5-BA93-72483C6E34E8}" type="datetimeFigureOut">
               <a:rPr lang="ko-KR" altLang="en-US" smtClean="0"/>
-              <a:t>26-08-10(Mon)</a:t>
+              <a:t>2026-08-11</a:t>
             </a:fld>
             <a:endParaRPr lang="ko-KR" altLang="en-US"/>
           </a:p>
@@ -1612,7 +1612,7 @@
           <a:p>
             <a:fld id="{7237CE1A-8831-48B5-BA93-72483C6E34E8}" type="datetimeFigureOut">
               <a:rPr lang="ko-KR" altLang="en-US" smtClean="0"/>
-              <a:t>26-08-10(Mon)</a:t>
+              <a:t>2026-08-11</a:t>
             </a:fld>
             <a:endParaRPr lang="ko-KR" altLang="en-US"/>
           </a:p>
@@ -1730,7 +1730,7 @@
           <a:p>
             <a:fld id="{7237CE1A-8831-48B5-BA93-72483C6E34E8}" type="datetimeFigureOut">
               <a:rPr lang="ko-KR" altLang="en-US" smtClean="0"/>
-              <a:t>26-08-10(Mon)</a:t>
+              <a:t>2026-08-11</a:t>
             </a:fld>
             <a:endParaRPr lang="ko-KR" altLang="en-US"/>
           </a:p>
@@ -1825,7 +1825,7 @@
           <a:p>
             <a:fld id="{7237CE1A-8831-48B5-BA93-72483C6E34E8}" type="datetimeFigureOut">
               <a:rPr lang="ko-KR" altLang="en-US" smtClean="0"/>
-              <a:t>26-08-10(Mon)</a:t>
+              <a:t>2026-08-11</a:t>
             </a:fld>
             <a:endParaRPr lang="ko-KR" altLang="en-US"/>
           </a:p>
@@ -2102,7 +2102,7 @@
           <a:p>
             <a:fld id="{7237CE1A-8831-48B5-BA93-72483C6E34E8}" type="datetimeFigureOut">
               <a:rPr lang="ko-KR" altLang="en-US" smtClean="0"/>
-              <a:t>26-08-10(Mon)</a:t>
+              <a:t>2026-08-11</a:t>
             </a:fld>
             <a:endParaRPr lang="ko-KR" altLang="en-US"/>
           </a:p>
@@ -2355,7 +2355,7 @@
           <a:p>
             <a:fld id="{7237CE1A-8831-48B5-BA93-72483C6E34E8}" type="datetimeFigureOut">
               <a:rPr lang="ko-KR" altLang="en-US" smtClean="0"/>
-              <a:t>26-08-10(Mon)</a:t>
+              <a:t>2026-08-11</a:t>
             </a:fld>
             <a:endParaRPr lang="ko-KR" altLang="en-US"/>
           </a:p>
@@ -2568,7 +2568,7 @@
           <a:p>
             <a:fld id="{7237CE1A-8831-48B5-BA93-72483C6E34E8}" type="datetimeFigureOut">
               <a:rPr lang="ko-KR" altLang="en-US" smtClean="0"/>
-              <a:t>26-08-10(Mon)</a:t>
+              <a:t>2026-08-11</a:t>
             </a:fld>
             <a:endParaRPr lang="ko-KR" altLang="en-US"/>
           </a:p>
@@ -2973,63 +2973,705 @@
           <a:chExt cx="0" cy="0"/>
         </a:xfrm>
       </p:grpSpPr>
-      <p:graphicFrame>
-        <p:nvGraphicFramePr>
-          <p:cNvPr id="3" name="개체 2"/>
-          <p:cNvGraphicFramePr>
-            <a:graphicFrameLocks noChangeAspect="1"/>
-          </p:cNvGraphicFramePr>
-          <p:nvPr>
-            <p:extLst>
-              <p:ext uri="{D42A27DB-BD31-4B8C-83A1-F6EECF244321}">
-                <p14:modId xmlns:p14="http://schemas.microsoft.com/office/powerpoint/2010/main" val="1477509955"/>
-              </p:ext>
-            </p:extLst>
-          </p:nvPr>
-        </p:nvGraphicFramePr>
-        <p:xfrm>
-          <a:off x="4291013" y="2184401"/>
-          <a:ext cx="4844354" cy="1981200"/>
-        </p:xfrm>
-        <a:graphic>
-          <a:graphicData uri="http://schemas.openxmlformats.org/presentationml/2006/ole">
-            <mc:AlternateContent xmlns:mc="http://schemas.openxmlformats.org/markup-compatibility/2006">
-              <mc:Choice xmlns:v="urn:schemas-microsoft-com:vml" Requires="v">
-                <p:oleObj spid="_x0000_s1030" name="워크시트" r:id="rId3" imgW="3610051" imgH="1476487" progId="Excel.Sheet.12">
-                  <p:embed/>
-                </p:oleObj>
-              </mc:Choice>
-              <mc:Fallback>
-                <p:oleObj name="워크시트" r:id="rId3" imgW="3610051" imgH="1476487" progId="Excel.Sheet.12">
-                  <p:embed/>
-                  <p:pic>
-                    <p:nvPicPr>
-                      <p:cNvPr id="0" name=""/>
-                      <p:cNvPicPr/>
-                      <p:nvPr/>
-                    </p:nvPicPr>
-                    <p:blipFill>
-                      <a:blip r:embed="rId4"/>
-                      <a:stretch>
-                        <a:fillRect/>
-                      </a:stretch>
-                    </p:blipFill>
-                    <p:spPr>
-                      <a:xfrm>
-                        <a:off x="4291013" y="2184401"/>
-                        <a:ext cx="4844354" cy="1981200"/>
-                      </a:xfrm>
-                      <a:prstGeom prst="rect">
-                        <a:avLst/>
-                      </a:prstGeom>
-                    </p:spPr>
-                  </p:pic>
-                </p:oleObj>
-              </mc:Fallback>
-            </mc:AlternateContent>
-          </a:graphicData>
-        </a:graphic>
-      </p:graphicFrame>
+      <p:cxnSp>
+        <p:nvCxnSpPr>
+          <p:cNvPr id="45" name="직선 화살표 연결선 44"/>
+          <p:cNvCxnSpPr/>
+          <p:nvPr/>
+        </p:nvCxnSpPr>
+        <p:spPr>
+          <a:xfrm>
+            <a:off x="1776300" y="2705100"/>
+            <a:ext cx="7920000" cy="0"/>
+          </a:xfrm>
+          <a:prstGeom prst="straightConnector1">
+            <a:avLst/>
+          </a:prstGeom>
+          <a:ln w="57150">
+            <a:solidFill>
+              <a:schemeClr val="tx1"/>
+            </a:solidFill>
+            <a:headEnd type="triangle"/>
+            <a:tailEnd type="triangle"/>
+          </a:ln>
+        </p:spPr>
+        <p:style>
+          <a:lnRef idx="1">
+            <a:schemeClr val="accent1"/>
+          </a:lnRef>
+          <a:fillRef idx="0">
+            <a:schemeClr val="accent1"/>
+          </a:fillRef>
+          <a:effectRef idx="0">
+            <a:schemeClr val="accent1"/>
+          </a:effectRef>
+          <a:fontRef idx="minor">
+            <a:schemeClr val="tx1"/>
+          </a:fontRef>
+        </p:style>
+      </p:cxnSp>
+      <p:sp>
+        <p:nvSpPr>
+          <p:cNvPr id="52" name="모서리가 둥근 직사각형 51"/>
+          <p:cNvSpPr/>
+          <p:nvPr/>
+        </p:nvSpPr>
+        <p:spPr>
+          <a:xfrm>
+            <a:off x="1777600" y="1549614"/>
+            <a:ext cx="1440000" cy="540000"/>
+          </a:xfrm>
+          <a:prstGeom prst="roundRect">
+            <a:avLst/>
+          </a:prstGeom>
+          <a:solidFill>
+            <a:schemeClr val="bg1">
+              <a:lumMod val="75000"/>
+            </a:schemeClr>
+          </a:solidFill>
+          <a:ln>
+            <a:noFill/>
+          </a:ln>
+        </p:spPr>
+        <p:style>
+          <a:lnRef idx="2">
+            <a:schemeClr val="accent1">
+              <a:shade val="50000"/>
+            </a:schemeClr>
+          </a:lnRef>
+          <a:fillRef idx="1">
+            <a:schemeClr val="accent1"/>
+          </a:fillRef>
+          <a:effectRef idx="0">
+            <a:schemeClr val="accent1"/>
+          </a:effectRef>
+          <a:fontRef idx="minor">
+            <a:schemeClr val="lt1"/>
+          </a:fontRef>
+        </p:style>
+        <p:txBody>
+          <a:bodyPr rtlCol="0" anchor="ctr"/>
+          <a:lstStyle/>
+          <a:p>
+            <a:pPr algn="ctr"/>
+            <a:r>
+              <a:rPr lang="en-US" altLang="ko-KR" sz="2000" dirty="0" smtClean="0">
+                <a:solidFill>
+                  <a:schemeClr val="tx1"/>
+                </a:solidFill>
+                <a:latin typeface="나눔스퀘어 Bold" panose="020B0600000101010101" pitchFamily="50" charset="-127"/>
+                <a:ea typeface="나눔스퀘어 Bold" panose="020B0600000101010101" pitchFamily="50" charset="-127"/>
+              </a:rPr>
+              <a:t>private</a:t>
+            </a:r>
+            <a:endParaRPr lang="ko-KR" altLang="en-US" sz="2000" dirty="0">
+              <a:solidFill>
+                <a:schemeClr val="tx1"/>
+              </a:solidFill>
+              <a:latin typeface="나눔스퀘어 Bold" panose="020B0600000101010101" pitchFamily="50" charset="-127"/>
+              <a:ea typeface="나눔스퀘어 Bold" panose="020B0600000101010101" pitchFamily="50" charset="-127"/>
+            </a:endParaRPr>
+          </a:p>
+        </p:txBody>
+      </p:sp>
+      <p:sp>
+        <p:nvSpPr>
+          <p:cNvPr id="53" name="모서리가 둥근 직사각형 52"/>
+          <p:cNvSpPr/>
+          <p:nvPr/>
+        </p:nvSpPr>
+        <p:spPr>
+          <a:xfrm>
+            <a:off x="3936950" y="1549614"/>
+            <a:ext cx="1440000" cy="540000"/>
+          </a:xfrm>
+          <a:prstGeom prst="roundRect">
+            <a:avLst/>
+          </a:prstGeom>
+          <a:solidFill>
+            <a:schemeClr val="bg1">
+              <a:lumMod val="75000"/>
+            </a:schemeClr>
+          </a:solidFill>
+          <a:ln>
+            <a:noFill/>
+          </a:ln>
+        </p:spPr>
+        <p:style>
+          <a:lnRef idx="2">
+            <a:schemeClr val="accent1">
+              <a:shade val="50000"/>
+            </a:schemeClr>
+          </a:lnRef>
+          <a:fillRef idx="1">
+            <a:schemeClr val="accent1"/>
+          </a:fillRef>
+          <a:effectRef idx="0">
+            <a:schemeClr val="accent1"/>
+          </a:effectRef>
+          <a:fontRef idx="minor">
+            <a:schemeClr val="lt1"/>
+          </a:fontRef>
+        </p:style>
+        <p:txBody>
+          <a:bodyPr rtlCol="0" anchor="ctr"/>
+          <a:lstStyle/>
+          <a:p>
+            <a:pPr algn="ctr"/>
+            <a:r>
+              <a:rPr lang="en-US" altLang="ko-KR" sz="2000" dirty="0">
+                <a:solidFill>
+                  <a:schemeClr val="tx1"/>
+                </a:solidFill>
+                <a:latin typeface="나눔스퀘어 Bold" panose="020B0600000101010101" pitchFamily="50" charset="-127"/>
+                <a:ea typeface="나눔스퀘어 Bold" panose="020B0600000101010101" pitchFamily="50" charset="-127"/>
+              </a:rPr>
+              <a:t>default</a:t>
+            </a:r>
+            <a:endParaRPr lang="ko-KR" altLang="en-US" sz="2000" dirty="0">
+              <a:solidFill>
+                <a:schemeClr val="tx1"/>
+              </a:solidFill>
+              <a:latin typeface="나눔스퀘어 Bold" panose="020B0600000101010101" pitchFamily="50" charset="-127"/>
+              <a:ea typeface="나눔스퀘어 Bold" panose="020B0600000101010101" pitchFamily="50" charset="-127"/>
+            </a:endParaRPr>
+          </a:p>
+        </p:txBody>
+      </p:sp>
+      <p:sp>
+        <p:nvSpPr>
+          <p:cNvPr id="54" name="모서리가 둥근 직사각형 53"/>
+          <p:cNvSpPr/>
+          <p:nvPr/>
+        </p:nvSpPr>
+        <p:spPr>
+          <a:xfrm>
+            <a:off x="6094444" y="1549614"/>
+            <a:ext cx="1440000" cy="540000"/>
+          </a:xfrm>
+          <a:prstGeom prst="roundRect">
+            <a:avLst/>
+          </a:prstGeom>
+          <a:solidFill>
+            <a:schemeClr val="bg1">
+              <a:lumMod val="75000"/>
+            </a:schemeClr>
+          </a:solidFill>
+          <a:ln>
+            <a:noFill/>
+          </a:ln>
+        </p:spPr>
+        <p:style>
+          <a:lnRef idx="2">
+            <a:schemeClr val="accent1">
+              <a:shade val="50000"/>
+            </a:schemeClr>
+          </a:lnRef>
+          <a:fillRef idx="1">
+            <a:schemeClr val="accent1"/>
+          </a:fillRef>
+          <a:effectRef idx="0">
+            <a:schemeClr val="accent1"/>
+          </a:effectRef>
+          <a:fontRef idx="minor">
+            <a:schemeClr val="lt1"/>
+          </a:fontRef>
+        </p:style>
+        <p:txBody>
+          <a:bodyPr rtlCol="0" anchor="ctr"/>
+          <a:lstStyle/>
+          <a:p>
+            <a:pPr algn="ctr"/>
+            <a:r>
+              <a:rPr lang="en-US" altLang="ko-KR" sz="2000" dirty="0">
+                <a:solidFill>
+                  <a:schemeClr val="tx1"/>
+                </a:solidFill>
+                <a:latin typeface="나눔스퀘어 Bold" panose="020B0600000101010101" pitchFamily="50" charset="-127"/>
+                <a:ea typeface="나눔스퀘어 Bold" panose="020B0600000101010101" pitchFamily="50" charset="-127"/>
+              </a:rPr>
+              <a:t>protected</a:t>
+            </a:r>
+            <a:endParaRPr lang="ko-KR" altLang="en-US" sz="2000" dirty="0">
+              <a:solidFill>
+                <a:schemeClr val="tx1"/>
+              </a:solidFill>
+              <a:latin typeface="나눔스퀘어 Bold" panose="020B0600000101010101" pitchFamily="50" charset="-127"/>
+              <a:ea typeface="나눔스퀘어 Bold" panose="020B0600000101010101" pitchFamily="50" charset="-127"/>
+            </a:endParaRPr>
+          </a:p>
+        </p:txBody>
+      </p:sp>
+      <p:sp>
+        <p:nvSpPr>
+          <p:cNvPr id="55" name="모서리가 둥근 직사각형 54"/>
+          <p:cNvSpPr/>
+          <p:nvPr/>
+        </p:nvSpPr>
+        <p:spPr>
+          <a:xfrm>
+            <a:off x="8256300" y="1549614"/>
+            <a:ext cx="1440000" cy="540000"/>
+          </a:xfrm>
+          <a:prstGeom prst="roundRect">
+            <a:avLst/>
+          </a:prstGeom>
+          <a:solidFill>
+            <a:schemeClr val="bg1">
+              <a:lumMod val="75000"/>
+            </a:schemeClr>
+          </a:solidFill>
+          <a:ln>
+            <a:noFill/>
+          </a:ln>
+        </p:spPr>
+        <p:style>
+          <a:lnRef idx="2">
+            <a:schemeClr val="accent1">
+              <a:shade val="50000"/>
+            </a:schemeClr>
+          </a:lnRef>
+          <a:fillRef idx="1">
+            <a:schemeClr val="accent1"/>
+          </a:fillRef>
+          <a:effectRef idx="0">
+            <a:schemeClr val="accent1"/>
+          </a:effectRef>
+          <a:fontRef idx="minor">
+            <a:schemeClr val="lt1"/>
+          </a:fontRef>
+        </p:style>
+        <p:txBody>
+          <a:bodyPr rtlCol="0" anchor="ctr"/>
+          <a:lstStyle/>
+          <a:p>
+            <a:pPr algn="ctr"/>
+            <a:r>
+              <a:rPr lang="en-US" altLang="ko-KR" sz="2000" dirty="0">
+                <a:solidFill>
+                  <a:schemeClr val="tx1"/>
+                </a:solidFill>
+                <a:latin typeface="나눔스퀘어 Bold" panose="020B0600000101010101" pitchFamily="50" charset="-127"/>
+                <a:ea typeface="나눔스퀘어 Bold" panose="020B0600000101010101" pitchFamily="50" charset="-127"/>
+              </a:rPr>
+              <a:t>public</a:t>
+            </a:r>
+            <a:endParaRPr lang="ko-KR" altLang="en-US" sz="2000" dirty="0">
+              <a:solidFill>
+                <a:schemeClr val="tx1"/>
+              </a:solidFill>
+              <a:latin typeface="나눔스퀘어 Bold" panose="020B0600000101010101" pitchFamily="50" charset="-127"/>
+              <a:ea typeface="나눔스퀘어 Bold" panose="020B0600000101010101" pitchFamily="50" charset="-127"/>
+            </a:endParaRPr>
+          </a:p>
+        </p:txBody>
+      </p:sp>
+      <p:sp>
+        <p:nvSpPr>
+          <p:cNvPr id="56" name="아래쪽 화살표 55"/>
+          <p:cNvSpPr/>
+          <p:nvPr/>
+        </p:nvSpPr>
+        <p:spPr>
+          <a:xfrm>
+            <a:off x="2227600" y="2089614"/>
+            <a:ext cx="540000" cy="540000"/>
+          </a:xfrm>
+          <a:prstGeom prst="downArrow">
+            <a:avLst/>
+          </a:prstGeom>
+          <a:solidFill>
+            <a:schemeClr val="accent5"/>
+          </a:solidFill>
+          <a:ln>
+            <a:noFill/>
+          </a:ln>
+        </p:spPr>
+        <p:style>
+          <a:lnRef idx="2">
+            <a:schemeClr val="accent1">
+              <a:shade val="50000"/>
+            </a:schemeClr>
+          </a:lnRef>
+          <a:fillRef idx="1">
+            <a:schemeClr val="accent1"/>
+          </a:fillRef>
+          <a:effectRef idx="0">
+            <a:schemeClr val="accent1"/>
+          </a:effectRef>
+          <a:fontRef idx="minor">
+            <a:schemeClr val="lt1"/>
+          </a:fontRef>
+        </p:style>
+        <p:txBody>
+          <a:bodyPr rtlCol="0" anchor="ctr"/>
+          <a:lstStyle/>
+          <a:p>
+            <a:pPr algn="ctr"/>
+            <a:endParaRPr lang="ko-KR" altLang="en-US"/>
+          </a:p>
+        </p:txBody>
+      </p:sp>
+      <p:sp>
+        <p:nvSpPr>
+          <p:cNvPr id="57" name="아래쪽 화살표 56"/>
+          <p:cNvSpPr/>
+          <p:nvPr/>
+        </p:nvSpPr>
+        <p:spPr>
+          <a:xfrm>
+            <a:off x="4401113" y="2086314"/>
+            <a:ext cx="540000" cy="540000"/>
+          </a:xfrm>
+          <a:prstGeom prst="downArrow">
+            <a:avLst/>
+          </a:prstGeom>
+          <a:solidFill>
+            <a:schemeClr val="accent5"/>
+          </a:solidFill>
+          <a:ln>
+            <a:noFill/>
+          </a:ln>
+        </p:spPr>
+        <p:style>
+          <a:lnRef idx="2">
+            <a:schemeClr val="accent1">
+              <a:shade val="50000"/>
+            </a:schemeClr>
+          </a:lnRef>
+          <a:fillRef idx="1">
+            <a:schemeClr val="accent1"/>
+          </a:fillRef>
+          <a:effectRef idx="0">
+            <a:schemeClr val="accent1"/>
+          </a:effectRef>
+          <a:fontRef idx="minor">
+            <a:schemeClr val="lt1"/>
+          </a:fontRef>
+        </p:style>
+        <p:txBody>
+          <a:bodyPr rtlCol="0" anchor="ctr"/>
+          <a:lstStyle/>
+          <a:p>
+            <a:pPr algn="ctr"/>
+            <a:endParaRPr lang="ko-KR" altLang="en-US"/>
+          </a:p>
+        </p:txBody>
+      </p:sp>
+      <p:sp>
+        <p:nvSpPr>
+          <p:cNvPr id="58" name="아래쪽 화살표 57"/>
+          <p:cNvSpPr/>
+          <p:nvPr/>
+        </p:nvSpPr>
+        <p:spPr>
+          <a:xfrm>
+            <a:off x="6560112" y="2086314"/>
+            <a:ext cx="540000" cy="540000"/>
+          </a:xfrm>
+          <a:prstGeom prst="downArrow">
+            <a:avLst/>
+          </a:prstGeom>
+          <a:solidFill>
+            <a:schemeClr val="accent5"/>
+          </a:solidFill>
+          <a:ln>
+            <a:noFill/>
+          </a:ln>
+        </p:spPr>
+        <p:style>
+          <a:lnRef idx="2">
+            <a:schemeClr val="accent1">
+              <a:shade val="50000"/>
+            </a:schemeClr>
+          </a:lnRef>
+          <a:fillRef idx="1">
+            <a:schemeClr val="accent1"/>
+          </a:fillRef>
+          <a:effectRef idx="0">
+            <a:schemeClr val="accent1"/>
+          </a:effectRef>
+          <a:fontRef idx="minor">
+            <a:schemeClr val="lt1"/>
+          </a:fontRef>
+        </p:style>
+        <p:txBody>
+          <a:bodyPr rtlCol="0" anchor="ctr"/>
+          <a:lstStyle/>
+          <a:p>
+            <a:pPr algn="ctr"/>
+            <a:endParaRPr lang="ko-KR" altLang="en-US"/>
+          </a:p>
+        </p:txBody>
+      </p:sp>
+      <p:sp>
+        <p:nvSpPr>
+          <p:cNvPr id="59" name="아래쪽 화살표 58"/>
+          <p:cNvSpPr/>
+          <p:nvPr/>
+        </p:nvSpPr>
+        <p:spPr>
+          <a:xfrm>
+            <a:off x="8704600" y="2086314"/>
+            <a:ext cx="540000" cy="540000"/>
+          </a:xfrm>
+          <a:prstGeom prst="downArrow">
+            <a:avLst/>
+          </a:prstGeom>
+          <a:solidFill>
+            <a:schemeClr val="accent5"/>
+          </a:solidFill>
+          <a:ln>
+            <a:noFill/>
+          </a:ln>
+        </p:spPr>
+        <p:style>
+          <a:lnRef idx="2">
+            <a:schemeClr val="accent1">
+              <a:shade val="50000"/>
+            </a:schemeClr>
+          </a:lnRef>
+          <a:fillRef idx="1">
+            <a:schemeClr val="accent1"/>
+          </a:fillRef>
+          <a:effectRef idx="0">
+            <a:schemeClr val="accent1"/>
+          </a:effectRef>
+          <a:fontRef idx="minor">
+            <a:schemeClr val="lt1"/>
+          </a:fontRef>
+        </p:style>
+        <p:txBody>
+          <a:bodyPr rtlCol="0" anchor="ctr"/>
+          <a:lstStyle/>
+          <a:p>
+            <a:pPr algn="ctr"/>
+            <a:endParaRPr lang="ko-KR" altLang="en-US"/>
+          </a:p>
+        </p:txBody>
+      </p:sp>
+      <p:sp>
+        <p:nvSpPr>
+          <p:cNvPr id="60" name="모서리가 둥근 직사각형 59"/>
+          <p:cNvSpPr/>
+          <p:nvPr/>
+        </p:nvSpPr>
+        <p:spPr>
+          <a:xfrm>
+            <a:off x="4566300" y="2805930"/>
+            <a:ext cx="2340000" cy="540000"/>
+          </a:xfrm>
+          <a:prstGeom prst="roundRect">
+            <a:avLst/>
+          </a:prstGeom>
+          <a:solidFill>
+            <a:schemeClr val="bg1">
+              <a:lumMod val="85000"/>
+            </a:schemeClr>
+          </a:solidFill>
+          <a:ln>
+            <a:noFill/>
+          </a:ln>
+        </p:spPr>
+        <p:style>
+          <a:lnRef idx="2">
+            <a:schemeClr val="accent1">
+              <a:shade val="50000"/>
+            </a:schemeClr>
+          </a:lnRef>
+          <a:fillRef idx="1">
+            <a:schemeClr val="accent1"/>
+          </a:fillRef>
+          <a:effectRef idx="0">
+            <a:schemeClr val="accent1"/>
+          </a:effectRef>
+          <a:fontRef idx="minor">
+            <a:schemeClr val="lt1"/>
+          </a:fontRef>
+        </p:style>
+        <p:txBody>
+          <a:bodyPr rtlCol="0" anchor="ctr"/>
+          <a:lstStyle/>
+          <a:p>
+            <a:pPr algn="ctr"/>
+            <a:r>
+              <a:rPr lang="ko-KR" altLang="en-US" sz="3200" dirty="0" smtClean="0">
+                <a:solidFill>
+                  <a:schemeClr val="tx1"/>
+                </a:solidFill>
+                <a:latin typeface="나눔스퀘어 Bold" panose="020B0600000101010101" pitchFamily="50" charset="-127"/>
+                <a:ea typeface="나눔스퀘어 Bold" panose="020B0600000101010101" pitchFamily="50" charset="-127"/>
+              </a:rPr>
+              <a:t>접근 범위</a:t>
+            </a:r>
+            <a:endParaRPr lang="ko-KR" altLang="en-US" sz="3200" dirty="0">
+              <a:solidFill>
+                <a:schemeClr val="tx1"/>
+              </a:solidFill>
+              <a:latin typeface="나눔스퀘어 Bold" panose="020B0600000101010101" pitchFamily="50" charset="-127"/>
+              <a:ea typeface="나눔스퀘어 Bold" panose="020B0600000101010101" pitchFamily="50" charset="-127"/>
+            </a:endParaRPr>
+          </a:p>
+        </p:txBody>
+      </p:sp>
+      <p:sp>
+        <p:nvSpPr>
+          <p:cNvPr id="61" name="모서리가 둥근 직사각형 60"/>
+          <p:cNvSpPr/>
+          <p:nvPr/>
+        </p:nvSpPr>
+        <p:spPr>
+          <a:xfrm>
+            <a:off x="9859088" y="2435100"/>
+            <a:ext cx="1980000" cy="540000"/>
+          </a:xfrm>
+          <a:prstGeom prst="roundRect">
+            <a:avLst/>
+          </a:prstGeom>
+          <a:solidFill>
+            <a:schemeClr val="bg1">
+              <a:lumMod val="85000"/>
+            </a:schemeClr>
+          </a:solidFill>
+          <a:ln>
+            <a:noFill/>
+          </a:ln>
+        </p:spPr>
+        <p:style>
+          <a:lnRef idx="2">
+            <a:schemeClr val="accent1">
+              <a:shade val="50000"/>
+            </a:schemeClr>
+          </a:lnRef>
+          <a:fillRef idx="1">
+            <a:schemeClr val="accent1"/>
+          </a:fillRef>
+          <a:effectRef idx="0">
+            <a:schemeClr val="accent1"/>
+          </a:effectRef>
+          <a:fontRef idx="minor">
+            <a:schemeClr val="lt1"/>
+          </a:fontRef>
+        </p:style>
+        <p:txBody>
+          <a:bodyPr rtlCol="0" anchor="ctr"/>
+          <a:lstStyle/>
+          <a:p>
+            <a:pPr algn="ctr"/>
+            <a:r>
+              <a:rPr lang="ko-KR" altLang="en-US" sz="2400" dirty="0" err="1" smtClean="0">
+                <a:solidFill>
+                  <a:schemeClr val="tx1"/>
+                </a:solidFill>
+                <a:latin typeface="나눔스퀘어 Bold" panose="020B0600000101010101" pitchFamily="50" charset="-127"/>
+                <a:ea typeface="나눔스퀘어 Bold" panose="020B0600000101010101" pitchFamily="50" charset="-127"/>
+              </a:rPr>
+              <a:t>넓은접근</a:t>
+            </a:r>
+            <a:r>
+              <a:rPr lang="ko-KR" altLang="en-US" sz="2400" dirty="0" smtClean="0">
+                <a:solidFill>
+                  <a:schemeClr val="tx1"/>
+                </a:solidFill>
+                <a:latin typeface="나눔스퀘어 Bold" panose="020B0600000101010101" pitchFamily="50" charset="-127"/>
+                <a:ea typeface="나눔스퀘어 Bold" panose="020B0600000101010101" pitchFamily="50" charset="-127"/>
+              </a:rPr>
+              <a:t> 범위</a:t>
+            </a:r>
+            <a:endParaRPr lang="ko-KR" altLang="en-US" sz="2400" dirty="0">
+              <a:solidFill>
+                <a:schemeClr val="tx1"/>
+              </a:solidFill>
+              <a:latin typeface="나눔스퀘어 Bold" panose="020B0600000101010101" pitchFamily="50" charset="-127"/>
+              <a:ea typeface="나눔스퀘어 Bold" panose="020B0600000101010101" pitchFamily="50" charset="-127"/>
+            </a:endParaRPr>
+          </a:p>
+        </p:txBody>
+      </p:sp>
+      <p:sp>
+        <p:nvSpPr>
+          <p:cNvPr id="62" name="모서리가 둥근 직사각형 61"/>
+          <p:cNvSpPr/>
+          <p:nvPr/>
+        </p:nvSpPr>
+        <p:spPr>
+          <a:xfrm>
+            <a:off x="-366888" y="2435100"/>
+            <a:ext cx="1980000" cy="540000"/>
+          </a:xfrm>
+          <a:prstGeom prst="roundRect">
+            <a:avLst/>
+          </a:prstGeom>
+          <a:solidFill>
+            <a:schemeClr val="bg1">
+              <a:lumMod val="85000"/>
+            </a:schemeClr>
+          </a:solidFill>
+          <a:ln>
+            <a:noFill/>
+          </a:ln>
+        </p:spPr>
+        <p:style>
+          <a:lnRef idx="2">
+            <a:schemeClr val="accent1">
+              <a:shade val="50000"/>
+            </a:schemeClr>
+          </a:lnRef>
+          <a:fillRef idx="1">
+            <a:schemeClr val="accent1"/>
+          </a:fillRef>
+          <a:effectRef idx="0">
+            <a:schemeClr val="accent1"/>
+          </a:effectRef>
+          <a:fontRef idx="minor">
+            <a:schemeClr val="lt1"/>
+          </a:fontRef>
+        </p:style>
+        <p:txBody>
+          <a:bodyPr rtlCol="0" anchor="ctr"/>
+          <a:lstStyle/>
+          <a:p>
+            <a:pPr algn="ctr"/>
+            <a:r>
+              <a:rPr lang="ko-KR" altLang="en-US" sz="2400" dirty="0" err="1">
+                <a:solidFill>
+                  <a:schemeClr val="tx1"/>
+                </a:solidFill>
+                <a:latin typeface="나눔스퀘어 Bold" panose="020B0600000101010101" pitchFamily="50" charset="-127"/>
+                <a:ea typeface="나눔스퀘어 Bold" panose="020B0600000101010101" pitchFamily="50" charset="-127"/>
+              </a:rPr>
+              <a:t>좁</a:t>
+            </a:r>
+            <a:r>
+              <a:rPr lang="ko-KR" altLang="en-US" sz="2400" smtClean="0">
+                <a:solidFill>
+                  <a:schemeClr val="tx1"/>
+                </a:solidFill>
+                <a:latin typeface="나눔스퀘어 Bold" panose="020B0600000101010101" pitchFamily="50" charset="-127"/>
+                <a:ea typeface="나눔스퀘어 Bold" panose="020B0600000101010101" pitchFamily="50" charset="-127"/>
+              </a:rPr>
+              <a:t>은접근 </a:t>
+            </a:r>
+            <a:r>
+              <a:rPr lang="ko-KR" altLang="en-US" sz="2400" dirty="0" smtClean="0">
+                <a:solidFill>
+                  <a:schemeClr val="tx1"/>
+                </a:solidFill>
+                <a:latin typeface="나눔스퀘어 Bold" panose="020B0600000101010101" pitchFamily="50" charset="-127"/>
+                <a:ea typeface="나눔스퀘어 Bold" panose="020B0600000101010101" pitchFamily="50" charset="-127"/>
+              </a:rPr>
+              <a:t>범위</a:t>
+            </a:r>
+            <a:endParaRPr lang="ko-KR" altLang="en-US" sz="2400" dirty="0">
+              <a:solidFill>
+                <a:schemeClr val="tx1"/>
+              </a:solidFill>
+              <a:latin typeface="나눔스퀘어 Bold" panose="020B0600000101010101" pitchFamily="50" charset="-127"/>
+              <a:ea typeface="나눔스퀘어 Bold" panose="020B0600000101010101" pitchFamily="50" charset="-127"/>
+            </a:endParaRPr>
+          </a:p>
+        </p:txBody>
+      </p:sp>
     </p:spTree>
     <p:extLst>
       <p:ext uri="{BB962C8B-B14F-4D97-AF65-F5344CB8AC3E}">

</xml_diff>

<commit_message>
20260811 commit : capsule part, perfectly complete_2_?
</commit_message>
<xml_diff>
--- a/create_notion_img.pptx
+++ b/create_notion_img.pptx
@@ -2973,705 +2973,668 @@
           <a:chExt cx="0" cy="0"/>
         </a:xfrm>
       </p:grpSpPr>
-      <p:cxnSp>
-        <p:nvCxnSpPr>
-          <p:cNvPr id="45" name="직선 화살표 연결선 44"/>
-          <p:cNvCxnSpPr/>
+      <p:grpSp>
+        <p:nvGrpSpPr>
+          <p:cNvPr id="63" name="그룹 62"/>
+          <p:cNvGrpSpPr/>
           <p:nvPr/>
-        </p:nvCxnSpPr>
-        <p:spPr>
-          <a:xfrm>
-            <a:off x="1776300" y="2705100"/>
-            <a:ext cx="7920000" cy="0"/>
-          </a:xfrm>
-          <a:prstGeom prst="straightConnector1">
-            <a:avLst/>
-          </a:prstGeom>
-          <a:ln w="57150">
+        </p:nvGrpSpPr>
+        <p:grpSpPr>
+          <a:xfrm>
+            <a:off x="-366888" y="1549614"/>
+            <a:ext cx="12205976" cy="1425486"/>
+            <a:chOff x="-366888" y="1549614"/>
+            <a:chExt cx="12205976" cy="1425486"/>
+          </a:xfrm>
+        </p:grpSpPr>
+        <p:cxnSp>
+          <p:nvCxnSpPr>
+            <p:cNvPr id="45" name="직선 화살표 연결선 44"/>
+            <p:cNvCxnSpPr/>
+            <p:nvPr/>
+          </p:nvCxnSpPr>
+          <p:spPr>
+            <a:xfrm>
+              <a:off x="1776300" y="2705100"/>
+              <a:ext cx="7920000" cy="0"/>
+            </a:xfrm>
+            <a:prstGeom prst="straightConnector1">
+              <a:avLst/>
+            </a:prstGeom>
+            <a:ln w="57150">
+              <a:solidFill>
+                <a:schemeClr val="tx1"/>
+              </a:solidFill>
+              <a:headEnd type="triangle"/>
+              <a:tailEnd type="triangle"/>
+            </a:ln>
+          </p:spPr>
+          <p:style>
+            <a:lnRef idx="1">
+              <a:schemeClr val="accent1"/>
+            </a:lnRef>
+            <a:fillRef idx="0">
+              <a:schemeClr val="accent1"/>
+            </a:fillRef>
+            <a:effectRef idx="0">
+              <a:schemeClr val="accent1"/>
+            </a:effectRef>
+            <a:fontRef idx="minor">
+              <a:schemeClr val="tx1"/>
+            </a:fontRef>
+          </p:style>
+        </p:cxnSp>
+        <p:sp>
+          <p:nvSpPr>
+            <p:cNvPr id="52" name="모서리가 둥근 직사각형 51"/>
+            <p:cNvSpPr/>
+            <p:nvPr/>
+          </p:nvSpPr>
+          <p:spPr>
+            <a:xfrm>
+              <a:off x="1777600" y="1549614"/>
+              <a:ext cx="1440000" cy="540000"/>
+            </a:xfrm>
+            <a:prstGeom prst="roundRect">
+              <a:avLst/>
+            </a:prstGeom>
             <a:solidFill>
-              <a:schemeClr val="tx1"/>
+              <a:schemeClr val="bg1">
+                <a:lumMod val="75000"/>
+              </a:schemeClr>
             </a:solidFill>
-            <a:headEnd type="triangle"/>
-            <a:tailEnd type="triangle"/>
-          </a:ln>
-        </p:spPr>
-        <p:style>
-          <a:lnRef idx="1">
-            <a:schemeClr val="accent1"/>
-          </a:lnRef>
-          <a:fillRef idx="0">
-            <a:schemeClr val="accent1"/>
-          </a:fillRef>
-          <a:effectRef idx="0">
-            <a:schemeClr val="accent1"/>
-          </a:effectRef>
-          <a:fontRef idx="minor">
-            <a:schemeClr val="tx1"/>
-          </a:fontRef>
-        </p:style>
-      </p:cxnSp>
-      <p:sp>
-        <p:nvSpPr>
-          <p:cNvPr id="52" name="모서리가 둥근 직사각형 51"/>
-          <p:cNvSpPr/>
-          <p:nvPr/>
-        </p:nvSpPr>
-        <p:spPr>
-          <a:xfrm>
-            <a:off x="1777600" y="1549614"/>
-            <a:ext cx="1440000" cy="540000"/>
-          </a:xfrm>
-          <a:prstGeom prst="roundRect">
-            <a:avLst/>
-          </a:prstGeom>
-          <a:solidFill>
-            <a:schemeClr val="bg1">
-              <a:lumMod val="75000"/>
-            </a:schemeClr>
-          </a:solidFill>
-          <a:ln>
-            <a:noFill/>
-          </a:ln>
-        </p:spPr>
-        <p:style>
-          <a:lnRef idx="2">
-            <a:schemeClr val="accent1">
-              <a:shade val="50000"/>
-            </a:schemeClr>
-          </a:lnRef>
-          <a:fillRef idx="1">
-            <a:schemeClr val="accent1"/>
-          </a:fillRef>
-          <a:effectRef idx="0">
-            <a:schemeClr val="accent1"/>
-          </a:effectRef>
-          <a:fontRef idx="minor">
-            <a:schemeClr val="lt1"/>
-          </a:fontRef>
-        </p:style>
-        <p:txBody>
-          <a:bodyPr rtlCol="0" anchor="ctr"/>
-          <a:lstStyle/>
-          <a:p>
-            <a:pPr algn="ctr"/>
-            <a:r>
-              <a:rPr lang="en-US" altLang="ko-KR" sz="2000" dirty="0" smtClean="0">
+            <a:ln>
+              <a:noFill/>
+            </a:ln>
+          </p:spPr>
+          <p:style>
+            <a:lnRef idx="2">
+              <a:schemeClr val="accent1">
+                <a:shade val="50000"/>
+              </a:schemeClr>
+            </a:lnRef>
+            <a:fillRef idx="1">
+              <a:schemeClr val="accent1"/>
+            </a:fillRef>
+            <a:effectRef idx="0">
+              <a:schemeClr val="accent1"/>
+            </a:effectRef>
+            <a:fontRef idx="minor">
+              <a:schemeClr val="lt1"/>
+            </a:fontRef>
+          </p:style>
+          <p:txBody>
+            <a:bodyPr rtlCol="0" anchor="ctr"/>
+            <a:lstStyle/>
+            <a:p>
+              <a:pPr algn="ctr"/>
+              <a:r>
+                <a:rPr lang="en-US" altLang="ko-KR" sz="2000" dirty="0" smtClean="0">
+                  <a:solidFill>
+                    <a:schemeClr val="tx1"/>
+                  </a:solidFill>
+                  <a:latin typeface="나눔스퀘어 Bold" panose="020B0600000101010101" pitchFamily="50" charset="-127"/>
+                  <a:ea typeface="나눔스퀘어 Bold" panose="020B0600000101010101" pitchFamily="50" charset="-127"/>
+                </a:rPr>
+                <a:t>private</a:t>
+              </a:r>
+              <a:endParaRPr lang="ko-KR" altLang="en-US" sz="2000" dirty="0">
                 <a:solidFill>
                   <a:schemeClr val="tx1"/>
                 </a:solidFill>
                 <a:latin typeface="나눔스퀘어 Bold" panose="020B0600000101010101" pitchFamily="50" charset="-127"/>
                 <a:ea typeface="나눔스퀘어 Bold" panose="020B0600000101010101" pitchFamily="50" charset="-127"/>
-              </a:rPr>
-              <a:t>private</a:t>
-            </a:r>
-            <a:endParaRPr lang="ko-KR" altLang="en-US" sz="2000" dirty="0">
-              <a:solidFill>
-                <a:schemeClr val="tx1"/>
-              </a:solidFill>
-              <a:latin typeface="나눔스퀘어 Bold" panose="020B0600000101010101" pitchFamily="50" charset="-127"/>
-              <a:ea typeface="나눔스퀘어 Bold" panose="020B0600000101010101" pitchFamily="50" charset="-127"/>
-            </a:endParaRPr>
-          </a:p>
-        </p:txBody>
-      </p:sp>
-      <p:sp>
-        <p:nvSpPr>
-          <p:cNvPr id="53" name="모서리가 둥근 직사각형 52"/>
-          <p:cNvSpPr/>
-          <p:nvPr/>
-        </p:nvSpPr>
-        <p:spPr>
-          <a:xfrm>
-            <a:off x="3936950" y="1549614"/>
-            <a:ext cx="1440000" cy="540000"/>
-          </a:xfrm>
-          <a:prstGeom prst="roundRect">
-            <a:avLst/>
-          </a:prstGeom>
-          <a:solidFill>
-            <a:schemeClr val="bg1">
-              <a:lumMod val="75000"/>
-            </a:schemeClr>
-          </a:solidFill>
-          <a:ln>
-            <a:noFill/>
-          </a:ln>
-        </p:spPr>
-        <p:style>
-          <a:lnRef idx="2">
-            <a:schemeClr val="accent1">
-              <a:shade val="50000"/>
-            </a:schemeClr>
-          </a:lnRef>
-          <a:fillRef idx="1">
-            <a:schemeClr val="accent1"/>
-          </a:fillRef>
-          <a:effectRef idx="0">
-            <a:schemeClr val="accent1"/>
-          </a:effectRef>
-          <a:fontRef idx="minor">
-            <a:schemeClr val="lt1"/>
-          </a:fontRef>
-        </p:style>
-        <p:txBody>
-          <a:bodyPr rtlCol="0" anchor="ctr"/>
-          <a:lstStyle/>
-          <a:p>
-            <a:pPr algn="ctr"/>
-            <a:r>
-              <a:rPr lang="en-US" altLang="ko-KR" sz="2000" dirty="0">
+              </a:endParaRPr>
+            </a:p>
+          </p:txBody>
+        </p:sp>
+        <p:sp>
+          <p:nvSpPr>
+            <p:cNvPr id="53" name="모서리가 둥근 직사각형 52"/>
+            <p:cNvSpPr/>
+            <p:nvPr/>
+          </p:nvSpPr>
+          <p:spPr>
+            <a:xfrm>
+              <a:off x="3936950" y="1549614"/>
+              <a:ext cx="1440000" cy="540000"/>
+            </a:xfrm>
+            <a:prstGeom prst="roundRect">
+              <a:avLst/>
+            </a:prstGeom>
+            <a:solidFill>
+              <a:schemeClr val="bg1">
+                <a:lumMod val="75000"/>
+              </a:schemeClr>
+            </a:solidFill>
+            <a:ln>
+              <a:noFill/>
+            </a:ln>
+          </p:spPr>
+          <p:style>
+            <a:lnRef idx="2">
+              <a:schemeClr val="accent1">
+                <a:shade val="50000"/>
+              </a:schemeClr>
+            </a:lnRef>
+            <a:fillRef idx="1">
+              <a:schemeClr val="accent1"/>
+            </a:fillRef>
+            <a:effectRef idx="0">
+              <a:schemeClr val="accent1"/>
+            </a:effectRef>
+            <a:fontRef idx="minor">
+              <a:schemeClr val="lt1"/>
+            </a:fontRef>
+          </p:style>
+          <p:txBody>
+            <a:bodyPr rtlCol="0" anchor="ctr"/>
+            <a:lstStyle/>
+            <a:p>
+              <a:pPr algn="ctr"/>
+              <a:r>
+                <a:rPr lang="en-US" altLang="ko-KR" sz="2000" dirty="0">
+                  <a:solidFill>
+                    <a:schemeClr val="tx1"/>
+                  </a:solidFill>
+                  <a:latin typeface="나눔스퀘어 Bold" panose="020B0600000101010101" pitchFamily="50" charset="-127"/>
+                  <a:ea typeface="나눔스퀘어 Bold" panose="020B0600000101010101" pitchFamily="50" charset="-127"/>
+                </a:rPr>
+                <a:t>default</a:t>
+              </a:r>
+              <a:endParaRPr lang="ko-KR" altLang="en-US" sz="2000" dirty="0">
                 <a:solidFill>
                   <a:schemeClr val="tx1"/>
                 </a:solidFill>
                 <a:latin typeface="나눔스퀘어 Bold" panose="020B0600000101010101" pitchFamily="50" charset="-127"/>
                 <a:ea typeface="나눔스퀘어 Bold" panose="020B0600000101010101" pitchFamily="50" charset="-127"/>
-              </a:rPr>
-              <a:t>default</a:t>
-            </a:r>
-            <a:endParaRPr lang="ko-KR" altLang="en-US" sz="2000" dirty="0">
-              <a:solidFill>
-                <a:schemeClr val="tx1"/>
-              </a:solidFill>
-              <a:latin typeface="나눔스퀘어 Bold" panose="020B0600000101010101" pitchFamily="50" charset="-127"/>
-              <a:ea typeface="나눔스퀘어 Bold" panose="020B0600000101010101" pitchFamily="50" charset="-127"/>
-            </a:endParaRPr>
-          </a:p>
-        </p:txBody>
-      </p:sp>
-      <p:sp>
-        <p:nvSpPr>
-          <p:cNvPr id="54" name="모서리가 둥근 직사각형 53"/>
-          <p:cNvSpPr/>
-          <p:nvPr/>
-        </p:nvSpPr>
-        <p:spPr>
-          <a:xfrm>
-            <a:off x="6094444" y="1549614"/>
-            <a:ext cx="1440000" cy="540000"/>
-          </a:xfrm>
-          <a:prstGeom prst="roundRect">
-            <a:avLst/>
-          </a:prstGeom>
-          <a:solidFill>
-            <a:schemeClr val="bg1">
-              <a:lumMod val="75000"/>
-            </a:schemeClr>
-          </a:solidFill>
-          <a:ln>
-            <a:noFill/>
-          </a:ln>
-        </p:spPr>
-        <p:style>
-          <a:lnRef idx="2">
-            <a:schemeClr val="accent1">
-              <a:shade val="50000"/>
-            </a:schemeClr>
-          </a:lnRef>
-          <a:fillRef idx="1">
-            <a:schemeClr val="accent1"/>
-          </a:fillRef>
-          <a:effectRef idx="0">
-            <a:schemeClr val="accent1"/>
-          </a:effectRef>
-          <a:fontRef idx="minor">
-            <a:schemeClr val="lt1"/>
-          </a:fontRef>
-        </p:style>
-        <p:txBody>
-          <a:bodyPr rtlCol="0" anchor="ctr"/>
-          <a:lstStyle/>
-          <a:p>
-            <a:pPr algn="ctr"/>
-            <a:r>
-              <a:rPr lang="en-US" altLang="ko-KR" sz="2000" dirty="0">
+              </a:endParaRPr>
+            </a:p>
+          </p:txBody>
+        </p:sp>
+        <p:sp>
+          <p:nvSpPr>
+            <p:cNvPr id="54" name="모서리가 둥근 직사각형 53"/>
+            <p:cNvSpPr/>
+            <p:nvPr/>
+          </p:nvSpPr>
+          <p:spPr>
+            <a:xfrm>
+              <a:off x="6094444" y="1549614"/>
+              <a:ext cx="1440000" cy="540000"/>
+            </a:xfrm>
+            <a:prstGeom prst="roundRect">
+              <a:avLst/>
+            </a:prstGeom>
+            <a:solidFill>
+              <a:schemeClr val="bg1">
+                <a:lumMod val="75000"/>
+              </a:schemeClr>
+            </a:solidFill>
+            <a:ln>
+              <a:noFill/>
+            </a:ln>
+          </p:spPr>
+          <p:style>
+            <a:lnRef idx="2">
+              <a:schemeClr val="accent1">
+                <a:shade val="50000"/>
+              </a:schemeClr>
+            </a:lnRef>
+            <a:fillRef idx="1">
+              <a:schemeClr val="accent1"/>
+            </a:fillRef>
+            <a:effectRef idx="0">
+              <a:schemeClr val="accent1"/>
+            </a:effectRef>
+            <a:fontRef idx="minor">
+              <a:schemeClr val="lt1"/>
+            </a:fontRef>
+          </p:style>
+          <p:txBody>
+            <a:bodyPr rtlCol="0" anchor="ctr"/>
+            <a:lstStyle/>
+            <a:p>
+              <a:pPr algn="ctr"/>
+              <a:r>
+                <a:rPr lang="en-US" altLang="ko-KR" sz="2000" dirty="0">
+                  <a:solidFill>
+                    <a:schemeClr val="tx1"/>
+                  </a:solidFill>
+                  <a:latin typeface="나눔스퀘어 Bold" panose="020B0600000101010101" pitchFamily="50" charset="-127"/>
+                  <a:ea typeface="나눔스퀘어 Bold" panose="020B0600000101010101" pitchFamily="50" charset="-127"/>
+                </a:rPr>
+                <a:t>protected</a:t>
+              </a:r>
+              <a:endParaRPr lang="ko-KR" altLang="en-US" sz="2000" dirty="0">
                 <a:solidFill>
                   <a:schemeClr val="tx1"/>
                 </a:solidFill>
                 <a:latin typeface="나눔스퀘어 Bold" panose="020B0600000101010101" pitchFamily="50" charset="-127"/>
                 <a:ea typeface="나눔스퀘어 Bold" panose="020B0600000101010101" pitchFamily="50" charset="-127"/>
-              </a:rPr>
-              <a:t>protected</a:t>
-            </a:r>
-            <a:endParaRPr lang="ko-KR" altLang="en-US" sz="2000" dirty="0">
-              <a:solidFill>
-                <a:schemeClr val="tx1"/>
-              </a:solidFill>
-              <a:latin typeface="나눔스퀘어 Bold" panose="020B0600000101010101" pitchFamily="50" charset="-127"/>
-              <a:ea typeface="나눔스퀘어 Bold" panose="020B0600000101010101" pitchFamily="50" charset="-127"/>
-            </a:endParaRPr>
-          </a:p>
-        </p:txBody>
-      </p:sp>
-      <p:sp>
-        <p:nvSpPr>
-          <p:cNvPr id="55" name="모서리가 둥근 직사각형 54"/>
-          <p:cNvSpPr/>
-          <p:nvPr/>
-        </p:nvSpPr>
-        <p:spPr>
-          <a:xfrm>
-            <a:off x="8256300" y="1549614"/>
-            <a:ext cx="1440000" cy="540000"/>
-          </a:xfrm>
-          <a:prstGeom prst="roundRect">
-            <a:avLst/>
-          </a:prstGeom>
-          <a:solidFill>
-            <a:schemeClr val="bg1">
-              <a:lumMod val="75000"/>
-            </a:schemeClr>
-          </a:solidFill>
-          <a:ln>
-            <a:noFill/>
-          </a:ln>
-        </p:spPr>
-        <p:style>
-          <a:lnRef idx="2">
-            <a:schemeClr val="accent1">
-              <a:shade val="50000"/>
-            </a:schemeClr>
-          </a:lnRef>
-          <a:fillRef idx="1">
-            <a:schemeClr val="accent1"/>
-          </a:fillRef>
-          <a:effectRef idx="0">
-            <a:schemeClr val="accent1"/>
-          </a:effectRef>
-          <a:fontRef idx="minor">
-            <a:schemeClr val="lt1"/>
-          </a:fontRef>
-        </p:style>
-        <p:txBody>
-          <a:bodyPr rtlCol="0" anchor="ctr"/>
-          <a:lstStyle/>
-          <a:p>
-            <a:pPr algn="ctr"/>
-            <a:r>
-              <a:rPr lang="en-US" altLang="ko-KR" sz="2000" dirty="0">
+              </a:endParaRPr>
+            </a:p>
+          </p:txBody>
+        </p:sp>
+        <p:sp>
+          <p:nvSpPr>
+            <p:cNvPr id="55" name="모서리가 둥근 직사각형 54"/>
+            <p:cNvSpPr/>
+            <p:nvPr/>
+          </p:nvSpPr>
+          <p:spPr>
+            <a:xfrm>
+              <a:off x="8256300" y="1549614"/>
+              <a:ext cx="1440000" cy="540000"/>
+            </a:xfrm>
+            <a:prstGeom prst="roundRect">
+              <a:avLst/>
+            </a:prstGeom>
+            <a:solidFill>
+              <a:schemeClr val="bg1">
+                <a:lumMod val="75000"/>
+              </a:schemeClr>
+            </a:solidFill>
+            <a:ln>
+              <a:noFill/>
+            </a:ln>
+          </p:spPr>
+          <p:style>
+            <a:lnRef idx="2">
+              <a:schemeClr val="accent1">
+                <a:shade val="50000"/>
+              </a:schemeClr>
+            </a:lnRef>
+            <a:fillRef idx="1">
+              <a:schemeClr val="accent1"/>
+            </a:fillRef>
+            <a:effectRef idx="0">
+              <a:schemeClr val="accent1"/>
+            </a:effectRef>
+            <a:fontRef idx="minor">
+              <a:schemeClr val="lt1"/>
+            </a:fontRef>
+          </p:style>
+          <p:txBody>
+            <a:bodyPr rtlCol="0" anchor="ctr"/>
+            <a:lstStyle/>
+            <a:p>
+              <a:pPr algn="ctr"/>
+              <a:r>
+                <a:rPr lang="en-US" altLang="ko-KR" sz="2000" dirty="0">
+                  <a:solidFill>
+                    <a:schemeClr val="tx1"/>
+                  </a:solidFill>
+                  <a:latin typeface="나눔스퀘어 Bold" panose="020B0600000101010101" pitchFamily="50" charset="-127"/>
+                  <a:ea typeface="나눔스퀘어 Bold" panose="020B0600000101010101" pitchFamily="50" charset="-127"/>
+                </a:rPr>
+                <a:t>public</a:t>
+              </a:r>
+              <a:endParaRPr lang="ko-KR" altLang="en-US" sz="2000" dirty="0">
                 <a:solidFill>
                   <a:schemeClr val="tx1"/>
                 </a:solidFill>
                 <a:latin typeface="나눔스퀘어 Bold" panose="020B0600000101010101" pitchFamily="50" charset="-127"/>
                 <a:ea typeface="나눔스퀘어 Bold" panose="020B0600000101010101" pitchFamily="50" charset="-127"/>
-              </a:rPr>
-              <a:t>public</a:t>
-            </a:r>
-            <a:endParaRPr lang="ko-KR" altLang="en-US" sz="2000" dirty="0">
-              <a:solidFill>
-                <a:schemeClr val="tx1"/>
-              </a:solidFill>
-              <a:latin typeface="나눔스퀘어 Bold" panose="020B0600000101010101" pitchFamily="50" charset="-127"/>
-              <a:ea typeface="나눔스퀘어 Bold" panose="020B0600000101010101" pitchFamily="50" charset="-127"/>
-            </a:endParaRPr>
-          </a:p>
-        </p:txBody>
-      </p:sp>
-      <p:sp>
-        <p:nvSpPr>
-          <p:cNvPr id="56" name="아래쪽 화살표 55"/>
-          <p:cNvSpPr/>
-          <p:nvPr/>
-        </p:nvSpPr>
-        <p:spPr>
-          <a:xfrm>
-            <a:off x="2227600" y="2089614"/>
-            <a:ext cx="540000" cy="540000"/>
-          </a:xfrm>
-          <a:prstGeom prst="downArrow">
-            <a:avLst/>
-          </a:prstGeom>
-          <a:solidFill>
-            <a:schemeClr val="accent5"/>
-          </a:solidFill>
-          <a:ln>
-            <a:noFill/>
-          </a:ln>
-        </p:spPr>
-        <p:style>
-          <a:lnRef idx="2">
-            <a:schemeClr val="accent1">
-              <a:shade val="50000"/>
-            </a:schemeClr>
-          </a:lnRef>
-          <a:fillRef idx="1">
-            <a:schemeClr val="accent1"/>
-          </a:fillRef>
-          <a:effectRef idx="0">
-            <a:schemeClr val="accent1"/>
-          </a:effectRef>
-          <a:fontRef idx="minor">
-            <a:schemeClr val="lt1"/>
-          </a:fontRef>
-        </p:style>
-        <p:txBody>
-          <a:bodyPr rtlCol="0" anchor="ctr"/>
-          <a:lstStyle/>
-          <a:p>
-            <a:pPr algn="ctr"/>
-            <a:endParaRPr lang="ko-KR" altLang="en-US"/>
-          </a:p>
-        </p:txBody>
-      </p:sp>
-      <p:sp>
-        <p:nvSpPr>
-          <p:cNvPr id="57" name="아래쪽 화살표 56"/>
-          <p:cNvSpPr/>
-          <p:nvPr/>
-        </p:nvSpPr>
-        <p:spPr>
-          <a:xfrm>
-            <a:off x="4401113" y="2086314"/>
-            <a:ext cx="540000" cy="540000"/>
-          </a:xfrm>
-          <a:prstGeom prst="downArrow">
-            <a:avLst/>
-          </a:prstGeom>
-          <a:solidFill>
-            <a:schemeClr val="accent5"/>
-          </a:solidFill>
-          <a:ln>
-            <a:noFill/>
-          </a:ln>
-        </p:spPr>
-        <p:style>
-          <a:lnRef idx="2">
-            <a:schemeClr val="accent1">
-              <a:shade val="50000"/>
-            </a:schemeClr>
-          </a:lnRef>
-          <a:fillRef idx="1">
-            <a:schemeClr val="accent1"/>
-          </a:fillRef>
-          <a:effectRef idx="0">
-            <a:schemeClr val="accent1"/>
-          </a:effectRef>
-          <a:fontRef idx="minor">
-            <a:schemeClr val="lt1"/>
-          </a:fontRef>
-        </p:style>
-        <p:txBody>
-          <a:bodyPr rtlCol="0" anchor="ctr"/>
-          <a:lstStyle/>
-          <a:p>
-            <a:pPr algn="ctr"/>
-            <a:endParaRPr lang="ko-KR" altLang="en-US"/>
-          </a:p>
-        </p:txBody>
-      </p:sp>
-      <p:sp>
-        <p:nvSpPr>
-          <p:cNvPr id="58" name="아래쪽 화살표 57"/>
-          <p:cNvSpPr/>
-          <p:nvPr/>
-        </p:nvSpPr>
-        <p:spPr>
-          <a:xfrm>
-            <a:off x="6560112" y="2086314"/>
-            <a:ext cx="540000" cy="540000"/>
-          </a:xfrm>
-          <a:prstGeom prst="downArrow">
-            <a:avLst/>
-          </a:prstGeom>
-          <a:solidFill>
-            <a:schemeClr val="accent5"/>
-          </a:solidFill>
-          <a:ln>
-            <a:noFill/>
-          </a:ln>
-        </p:spPr>
-        <p:style>
-          <a:lnRef idx="2">
-            <a:schemeClr val="accent1">
-              <a:shade val="50000"/>
-            </a:schemeClr>
-          </a:lnRef>
-          <a:fillRef idx="1">
-            <a:schemeClr val="accent1"/>
-          </a:fillRef>
-          <a:effectRef idx="0">
-            <a:schemeClr val="accent1"/>
-          </a:effectRef>
-          <a:fontRef idx="minor">
-            <a:schemeClr val="lt1"/>
-          </a:fontRef>
-        </p:style>
-        <p:txBody>
-          <a:bodyPr rtlCol="0" anchor="ctr"/>
-          <a:lstStyle/>
-          <a:p>
-            <a:pPr algn="ctr"/>
-            <a:endParaRPr lang="ko-KR" altLang="en-US"/>
-          </a:p>
-        </p:txBody>
-      </p:sp>
-      <p:sp>
-        <p:nvSpPr>
-          <p:cNvPr id="59" name="아래쪽 화살표 58"/>
-          <p:cNvSpPr/>
-          <p:nvPr/>
-        </p:nvSpPr>
-        <p:spPr>
-          <a:xfrm>
-            <a:off x="8704600" y="2086314"/>
-            <a:ext cx="540000" cy="540000"/>
-          </a:xfrm>
-          <a:prstGeom prst="downArrow">
-            <a:avLst/>
-          </a:prstGeom>
-          <a:solidFill>
-            <a:schemeClr val="accent5"/>
-          </a:solidFill>
-          <a:ln>
-            <a:noFill/>
-          </a:ln>
-        </p:spPr>
-        <p:style>
-          <a:lnRef idx="2">
-            <a:schemeClr val="accent1">
-              <a:shade val="50000"/>
-            </a:schemeClr>
-          </a:lnRef>
-          <a:fillRef idx="1">
-            <a:schemeClr val="accent1"/>
-          </a:fillRef>
-          <a:effectRef idx="0">
-            <a:schemeClr val="accent1"/>
-          </a:effectRef>
-          <a:fontRef idx="minor">
-            <a:schemeClr val="lt1"/>
-          </a:fontRef>
-        </p:style>
-        <p:txBody>
-          <a:bodyPr rtlCol="0" anchor="ctr"/>
-          <a:lstStyle/>
-          <a:p>
-            <a:pPr algn="ctr"/>
-            <a:endParaRPr lang="ko-KR" altLang="en-US"/>
-          </a:p>
-        </p:txBody>
-      </p:sp>
-      <p:sp>
-        <p:nvSpPr>
-          <p:cNvPr id="60" name="모서리가 둥근 직사각형 59"/>
-          <p:cNvSpPr/>
-          <p:nvPr/>
-        </p:nvSpPr>
-        <p:spPr>
-          <a:xfrm>
-            <a:off x="4566300" y="2805930"/>
-            <a:ext cx="2340000" cy="540000"/>
-          </a:xfrm>
-          <a:prstGeom prst="roundRect">
-            <a:avLst/>
-          </a:prstGeom>
-          <a:solidFill>
-            <a:schemeClr val="bg1">
-              <a:lumMod val="85000"/>
-            </a:schemeClr>
-          </a:solidFill>
-          <a:ln>
-            <a:noFill/>
-          </a:ln>
-        </p:spPr>
-        <p:style>
-          <a:lnRef idx="2">
-            <a:schemeClr val="accent1">
-              <a:shade val="50000"/>
-            </a:schemeClr>
-          </a:lnRef>
-          <a:fillRef idx="1">
-            <a:schemeClr val="accent1"/>
-          </a:fillRef>
-          <a:effectRef idx="0">
-            <a:schemeClr val="accent1"/>
-          </a:effectRef>
-          <a:fontRef idx="minor">
-            <a:schemeClr val="lt1"/>
-          </a:fontRef>
-        </p:style>
-        <p:txBody>
-          <a:bodyPr rtlCol="0" anchor="ctr"/>
-          <a:lstStyle/>
-          <a:p>
-            <a:pPr algn="ctr"/>
-            <a:r>
-              <a:rPr lang="ko-KR" altLang="en-US" sz="3200" dirty="0" smtClean="0">
+              </a:endParaRPr>
+            </a:p>
+          </p:txBody>
+        </p:sp>
+        <p:sp>
+          <p:nvSpPr>
+            <p:cNvPr id="56" name="아래쪽 화살표 55"/>
+            <p:cNvSpPr/>
+            <p:nvPr/>
+          </p:nvSpPr>
+          <p:spPr>
+            <a:xfrm>
+              <a:off x="2227600" y="2089614"/>
+              <a:ext cx="540000" cy="540000"/>
+            </a:xfrm>
+            <a:prstGeom prst="downArrow">
+              <a:avLst/>
+            </a:prstGeom>
+            <a:solidFill>
+              <a:schemeClr val="accent5"/>
+            </a:solidFill>
+            <a:ln>
+              <a:noFill/>
+            </a:ln>
+          </p:spPr>
+          <p:style>
+            <a:lnRef idx="2">
+              <a:schemeClr val="accent1">
+                <a:shade val="50000"/>
+              </a:schemeClr>
+            </a:lnRef>
+            <a:fillRef idx="1">
+              <a:schemeClr val="accent1"/>
+            </a:fillRef>
+            <a:effectRef idx="0">
+              <a:schemeClr val="accent1"/>
+            </a:effectRef>
+            <a:fontRef idx="minor">
+              <a:schemeClr val="lt1"/>
+            </a:fontRef>
+          </p:style>
+          <p:txBody>
+            <a:bodyPr rtlCol="0" anchor="ctr"/>
+            <a:lstStyle/>
+            <a:p>
+              <a:pPr algn="ctr"/>
+              <a:endParaRPr lang="ko-KR" altLang="en-US">
+                <a:latin typeface="나눔스퀘어 Bold" panose="020B0600000101010101" pitchFamily="50" charset="-127"/>
+                <a:ea typeface="나눔스퀘어 Bold" panose="020B0600000101010101" pitchFamily="50" charset="-127"/>
+              </a:endParaRPr>
+            </a:p>
+          </p:txBody>
+        </p:sp>
+        <p:sp>
+          <p:nvSpPr>
+            <p:cNvPr id="57" name="아래쪽 화살표 56"/>
+            <p:cNvSpPr/>
+            <p:nvPr/>
+          </p:nvSpPr>
+          <p:spPr>
+            <a:xfrm>
+              <a:off x="4401113" y="2086314"/>
+              <a:ext cx="540000" cy="540000"/>
+            </a:xfrm>
+            <a:prstGeom prst="downArrow">
+              <a:avLst/>
+            </a:prstGeom>
+            <a:solidFill>
+              <a:schemeClr val="accent5"/>
+            </a:solidFill>
+            <a:ln>
+              <a:noFill/>
+            </a:ln>
+          </p:spPr>
+          <p:style>
+            <a:lnRef idx="2">
+              <a:schemeClr val="accent1">
+                <a:shade val="50000"/>
+              </a:schemeClr>
+            </a:lnRef>
+            <a:fillRef idx="1">
+              <a:schemeClr val="accent1"/>
+            </a:fillRef>
+            <a:effectRef idx="0">
+              <a:schemeClr val="accent1"/>
+            </a:effectRef>
+            <a:fontRef idx="minor">
+              <a:schemeClr val="lt1"/>
+            </a:fontRef>
+          </p:style>
+          <p:txBody>
+            <a:bodyPr rtlCol="0" anchor="ctr"/>
+            <a:lstStyle/>
+            <a:p>
+              <a:pPr algn="ctr"/>
+              <a:endParaRPr lang="ko-KR" altLang="en-US">
+                <a:latin typeface="나눔스퀘어 Bold" panose="020B0600000101010101" pitchFamily="50" charset="-127"/>
+                <a:ea typeface="나눔스퀘어 Bold" panose="020B0600000101010101" pitchFamily="50" charset="-127"/>
+              </a:endParaRPr>
+            </a:p>
+          </p:txBody>
+        </p:sp>
+        <p:sp>
+          <p:nvSpPr>
+            <p:cNvPr id="58" name="아래쪽 화살표 57"/>
+            <p:cNvSpPr/>
+            <p:nvPr/>
+          </p:nvSpPr>
+          <p:spPr>
+            <a:xfrm>
+              <a:off x="6560112" y="2086314"/>
+              <a:ext cx="540000" cy="540000"/>
+            </a:xfrm>
+            <a:prstGeom prst="downArrow">
+              <a:avLst/>
+            </a:prstGeom>
+            <a:solidFill>
+              <a:schemeClr val="accent5"/>
+            </a:solidFill>
+            <a:ln>
+              <a:noFill/>
+            </a:ln>
+          </p:spPr>
+          <p:style>
+            <a:lnRef idx="2">
+              <a:schemeClr val="accent1">
+                <a:shade val="50000"/>
+              </a:schemeClr>
+            </a:lnRef>
+            <a:fillRef idx="1">
+              <a:schemeClr val="accent1"/>
+            </a:fillRef>
+            <a:effectRef idx="0">
+              <a:schemeClr val="accent1"/>
+            </a:effectRef>
+            <a:fontRef idx="minor">
+              <a:schemeClr val="lt1"/>
+            </a:fontRef>
+          </p:style>
+          <p:txBody>
+            <a:bodyPr rtlCol="0" anchor="ctr"/>
+            <a:lstStyle/>
+            <a:p>
+              <a:pPr algn="ctr"/>
+              <a:endParaRPr lang="ko-KR" altLang="en-US">
+                <a:latin typeface="나눔스퀘어 Bold" panose="020B0600000101010101" pitchFamily="50" charset="-127"/>
+                <a:ea typeface="나눔스퀘어 Bold" panose="020B0600000101010101" pitchFamily="50" charset="-127"/>
+              </a:endParaRPr>
+            </a:p>
+          </p:txBody>
+        </p:sp>
+        <p:sp>
+          <p:nvSpPr>
+            <p:cNvPr id="59" name="아래쪽 화살표 58"/>
+            <p:cNvSpPr/>
+            <p:nvPr/>
+          </p:nvSpPr>
+          <p:spPr>
+            <a:xfrm>
+              <a:off x="8704600" y="2086314"/>
+              <a:ext cx="540000" cy="540000"/>
+            </a:xfrm>
+            <a:prstGeom prst="downArrow">
+              <a:avLst/>
+            </a:prstGeom>
+            <a:solidFill>
+              <a:schemeClr val="accent5"/>
+            </a:solidFill>
+            <a:ln>
+              <a:noFill/>
+            </a:ln>
+          </p:spPr>
+          <p:style>
+            <a:lnRef idx="2">
+              <a:schemeClr val="accent1">
+                <a:shade val="50000"/>
+              </a:schemeClr>
+            </a:lnRef>
+            <a:fillRef idx="1">
+              <a:schemeClr val="accent1"/>
+            </a:fillRef>
+            <a:effectRef idx="0">
+              <a:schemeClr val="accent1"/>
+            </a:effectRef>
+            <a:fontRef idx="minor">
+              <a:schemeClr val="lt1"/>
+            </a:fontRef>
+          </p:style>
+          <p:txBody>
+            <a:bodyPr rtlCol="0" anchor="ctr"/>
+            <a:lstStyle/>
+            <a:p>
+              <a:pPr algn="ctr"/>
+              <a:endParaRPr lang="ko-KR" altLang="en-US">
+                <a:latin typeface="나눔스퀘어 Bold" panose="020B0600000101010101" pitchFamily="50" charset="-127"/>
+                <a:ea typeface="나눔스퀘어 Bold" panose="020B0600000101010101" pitchFamily="50" charset="-127"/>
+              </a:endParaRPr>
+            </a:p>
+          </p:txBody>
+        </p:sp>
+        <p:sp>
+          <p:nvSpPr>
+            <p:cNvPr id="61" name="모서리가 둥근 직사각형 60"/>
+            <p:cNvSpPr/>
+            <p:nvPr/>
+          </p:nvSpPr>
+          <p:spPr>
+            <a:xfrm>
+              <a:off x="9859088" y="2435100"/>
+              <a:ext cx="1980000" cy="540000"/>
+            </a:xfrm>
+            <a:prstGeom prst="roundRect">
+              <a:avLst/>
+            </a:prstGeom>
+            <a:solidFill>
+              <a:schemeClr val="bg1">
+                <a:lumMod val="85000"/>
+              </a:schemeClr>
+            </a:solidFill>
+            <a:ln>
+              <a:noFill/>
+            </a:ln>
+          </p:spPr>
+          <p:style>
+            <a:lnRef idx="2">
+              <a:schemeClr val="accent1">
+                <a:shade val="50000"/>
+              </a:schemeClr>
+            </a:lnRef>
+            <a:fillRef idx="1">
+              <a:schemeClr val="accent1"/>
+            </a:fillRef>
+            <a:effectRef idx="0">
+              <a:schemeClr val="accent1"/>
+            </a:effectRef>
+            <a:fontRef idx="minor">
+              <a:schemeClr val="lt1"/>
+            </a:fontRef>
+          </p:style>
+          <p:txBody>
+            <a:bodyPr rtlCol="0" anchor="ctr"/>
+            <a:lstStyle/>
+            <a:p>
+              <a:pPr algn="ctr"/>
+              <a:r>
+                <a:rPr lang="ko-KR" altLang="en-US" sz="2000" dirty="0" err="1" smtClean="0">
+                  <a:solidFill>
+                    <a:schemeClr val="tx1"/>
+                  </a:solidFill>
+                  <a:latin typeface="나눔스퀘어 Bold" panose="020B0600000101010101" pitchFamily="50" charset="-127"/>
+                  <a:ea typeface="나눔스퀘어 Bold" panose="020B0600000101010101" pitchFamily="50" charset="-127"/>
+                </a:rPr>
+                <a:t>넓은접근</a:t>
+              </a:r>
+              <a:r>
+                <a:rPr lang="ko-KR" altLang="en-US" sz="2000" dirty="0" smtClean="0">
+                  <a:solidFill>
+                    <a:schemeClr val="tx1"/>
+                  </a:solidFill>
+                  <a:latin typeface="나눔스퀘어 Bold" panose="020B0600000101010101" pitchFamily="50" charset="-127"/>
+                  <a:ea typeface="나눔스퀘어 Bold" panose="020B0600000101010101" pitchFamily="50" charset="-127"/>
+                </a:rPr>
+                <a:t> 범위</a:t>
+              </a:r>
+              <a:endParaRPr lang="ko-KR" altLang="en-US" sz="2000" dirty="0">
                 <a:solidFill>
                   <a:schemeClr val="tx1"/>
                 </a:solidFill>
                 <a:latin typeface="나눔스퀘어 Bold" panose="020B0600000101010101" pitchFamily="50" charset="-127"/>
                 <a:ea typeface="나눔스퀘어 Bold" panose="020B0600000101010101" pitchFamily="50" charset="-127"/>
-              </a:rPr>
-              <a:t>접근 범위</a:t>
-            </a:r>
-            <a:endParaRPr lang="ko-KR" altLang="en-US" sz="3200" dirty="0">
-              <a:solidFill>
-                <a:schemeClr val="tx1"/>
-              </a:solidFill>
-              <a:latin typeface="나눔스퀘어 Bold" panose="020B0600000101010101" pitchFamily="50" charset="-127"/>
-              <a:ea typeface="나눔스퀘어 Bold" panose="020B0600000101010101" pitchFamily="50" charset="-127"/>
-            </a:endParaRPr>
-          </a:p>
-        </p:txBody>
-      </p:sp>
-      <p:sp>
-        <p:nvSpPr>
-          <p:cNvPr id="61" name="모서리가 둥근 직사각형 60"/>
-          <p:cNvSpPr/>
-          <p:nvPr/>
-        </p:nvSpPr>
-        <p:spPr>
-          <a:xfrm>
-            <a:off x="9859088" y="2435100"/>
-            <a:ext cx="1980000" cy="540000"/>
-          </a:xfrm>
-          <a:prstGeom prst="roundRect">
-            <a:avLst/>
-          </a:prstGeom>
-          <a:solidFill>
-            <a:schemeClr val="bg1">
-              <a:lumMod val="85000"/>
-            </a:schemeClr>
-          </a:solidFill>
-          <a:ln>
-            <a:noFill/>
-          </a:ln>
-        </p:spPr>
-        <p:style>
-          <a:lnRef idx="2">
-            <a:schemeClr val="accent1">
-              <a:shade val="50000"/>
-            </a:schemeClr>
-          </a:lnRef>
-          <a:fillRef idx="1">
-            <a:schemeClr val="accent1"/>
-          </a:fillRef>
-          <a:effectRef idx="0">
-            <a:schemeClr val="accent1"/>
-          </a:effectRef>
-          <a:fontRef idx="minor">
-            <a:schemeClr val="lt1"/>
-          </a:fontRef>
-        </p:style>
-        <p:txBody>
-          <a:bodyPr rtlCol="0" anchor="ctr"/>
-          <a:lstStyle/>
-          <a:p>
-            <a:pPr algn="ctr"/>
-            <a:r>
-              <a:rPr lang="ko-KR" altLang="en-US" sz="2400" dirty="0" err="1" smtClean="0">
+              </a:endParaRPr>
+            </a:p>
+          </p:txBody>
+        </p:sp>
+        <p:sp>
+          <p:nvSpPr>
+            <p:cNvPr id="62" name="모서리가 둥근 직사각형 61"/>
+            <p:cNvSpPr/>
+            <p:nvPr/>
+          </p:nvSpPr>
+          <p:spPr>
+            <a:xfrm>
+              <a:off x="-366888" y="2435100"/>
+              <a:ext cx="1980000" cy="540000"/>
+            </a:xfrm>
+            <a:prstGeom prst="roundRect">
+              <a:avLst/>
+            </a:prstGeom>
+            <a:solidFill>
+              <a:schemeClr val="bg1">
+                <a:lumMod val="85000"/>
+              </a:schemeClr>
+            </a:solidFill>
+            <a:ln>
+              <a:noFill/>
+            </a:ln>
+          </p:spPr>
+          <p:style>
+            <a:lnRef idx="2">
+              <a:schemeClr val="accent1">
+                <a:shade val="50000"/>
+              </a:schemeClr>
+            </a:lnRef>
+            <a:fillRef idx="1">
+              <a:schemeClr val="accent1"/>
+            </a:fillRef>
+            <a:effectRef idx="0">
+              <a:schemeClr val="accent1"/>
+            </a:effectRef>
+            <a:fontRef idx="minor">
+              <a:schemeClr val="lt1"/>
+            </a:fontRef>
+          </p:style>
+          <p:txBody>
+            <a:bodyPr rtlCol="0" anchor="ctr"/>
+            <a:lstStyle/>
+            <a:p>
+              <a:pPr algn="ctr"/>
+              <a:r>
+                <a:rPr lang="ko-KR" altLang="en-US" sz="2000" dirty="0" err="1">
+                  <a:solidFill>
+                    <a:schemeClr val="tx1"/>
+                  </a:solidFill>
+                  <a:latin typeface="나눔스퀘어 Bold" panose="020B0600000101010101" pitchFamily="50" charset="-127"/>
+                  <a:ea typeface="나눔스퀘어 Bold" panose="020B0600000101010101" pitchFamily="50" charset="-127"/>
+                </a:rPr>
+                <a:t>좁</a:t>
+              </a:r>
+              <a:r>
+                <a:rPr lang="ko-KR" altLang="en-US" sz="2000" dirty="0" err="1" smtClean="0">
+                  <a:solidFill>
+                    <a:schemeClr val="tx1"/>
+                  </a:solidFill>
+                  <a:latin typeface="나눔스퀘어 Bold" panose="020B0600000101010101" pitchFamily="50" charset="-127"/>
+                  <a:ea typeface="나눔스퀘어 Bold" panose="020B0600000101010101" pitchFamily="50" charset="-127"/>
+                </a:rPr>
+                <a:t>은접근</a:t>
+              </a:r>
+              <a:r>
+                <a:rPr lang="ko-KR" altLang="en-US" sz="2000" dirty="0" smtClean="0">
+                  <a:solidFill>
+                    <a:schemeClr val="tx1"/>
+                  </a:solidFill>
+                  <a:latin typeface="나눔스퀘어 Bold" panose="020B0600000101010101" pitchFamily="50" charset="-127"/>
+                  <a:ea typeface="나눔스퀘어 Bold" panose="020B0600000101010101" pitchFamily="50" charset="-127"/>
+                </a:rPr>
+                <a:t> 범위</a:t>
+              </a:r>
+              <a:endParaRPr lang="ko-KR" altLang="en-US" sz="2000" dirty="0">
                 <a:solidFill>
                   <a:schemeClr val="tx1"/>
                 </a:solidFill>
                 <a:latin typeface="나눔스퀘어 Bold" panose="020B0600000101010101" pitchFamily="50" charset="-127"/>
                 <a:ea typeface="나눔스퀘어 Bold" panose="020B0600000101010101" pitchFamily="50" charset="-127"/>
-              </a:rPr>
-              <a:t>넓은접근</a:t>
-            </a:r>
-            <a:r>
-              <a:rPr lang="ko-KR" altLang="en-US" sz="2400" dirty="0" smtClean="0">
-                <a:solidFill>
-                  <a:schemeClr val="tx1"/>
-                </a:solidFill>
-                <a:latin typeface="나눔스퀘어 Bold" panose="020B0600000101010101" pitchFamily="50" charset="-127"/>
-                <a:ea typeface="나눔스퀘어 Bold" panose="020B0600000101010101" pitchFamily="50" charset="-127"/>
-              </a:rPr>
-              <a:t> 범위</a:t>
-            </a:r>
-            <a:endParaRPr lang="ko-KR" altLang="en-US" sz="2400" dirty="0">
-              <a:solidFill>
-                <a:schemeClr val="tx1"/>
-              </a:solidFill>
-              <a:latin typeface="나눔스퀘어 Bold" panose="020B0600000101010101" pitchFamily="50" charset="-127"/>
-              <a:ea typeface="나눔스퀘어 Bold" panose="020B0600000101010101" pitchFamily="50" charset="-127"/>
-            </a:endParaRPr>
-          </a:p>
-        </p:txBody>
-      </p:sp>
-      <p:sp>
-        <p:nvSpPr>
-          <p:cNvPr id="62" name="모서리가 둥근 직사각형 61"/>
-          <p:cNvSpPr/>
-          <p:nvPr/>
-        </p:nvSpPr>
-        <p:spPr>
-          <a:xfrm>
-            <a:off x="-366888" y="2435100"/>
-            <a:ext cx="1980000" cy="540000"/>
-          </a:xfrm>
-          <a:prstGeom prst="roundRect">
-            <a:avLst/>
-          </a:prstGeom>
-          <a:solidFill>
-            <a:schemeClr val="bg1">
-              <a:lumMod val="85000"/>
-            </a:schemeClr>
-          </a:solidFill>
-          <a:ln>
-            <a:noFill/>
-          </a:ln>
-        </p:spPr>
-        <p:style>
-          <a:lnRef idx="2">
-            <a:schemeClr val="accent1">
-              <a:shade val="50000"/>
-            </a:schemeClr>
-          </a:lnRef>
-          <a:fillRef idx="1">
-            <a:schemeClr val="accent1"/>
-          </a:fillRef>
-          <a:effectRef idx="0">
-            <a:schemeClr val="accent1"/>
-          </a:effectRef>
-          <a:fontRef idx="minor">
-            <a:schemeClr val="lt1"/>
-          </a:fontRef>
-        </p:style>
-        <p:txBody>
-          <a:bodyPr rtlCol="0" anchor="ctr"/>
-          <a:lstStyle/>
-          <a:p>
-            <a:pPr algn="ctr"/>
-            <a:r>
-              <a:rPr lang="ko-KR" altLang="en-US" sz="2400" dirty="0" err="1">
-                <a:solidFill>
-                  <a:schemeClr val="tx1"/>
-                </a:solidFill>
-                <a:latin typeface="나눔스퀘어 Bold" panose="020B0600000101010101" pitchFamily="50" charset="-127"/>
-                <a:ea typeface="나눔스퀘어 Bold" panose="020B0600000101010101" pitchFamily="50" charset="-127"/>
-              </a:rPr>
-              <a:t>좁</a:t>
-            </a:r>
-            <a:r>
-              <a:rPr lang="ko-KR" altLang="en-US" sz="2400" smtClean="0">
-                <a:solidFill>
-                  <a:schemeClr val="tx1"/>
-                </a:solidFill>
-                <a:latin typeface="나눔스퀘어 Bold" panose="020B0600000101010101" pitchFamily="50" charset="-127"/>
-                <a:ea typeface="나눔스퀘어 Bold" panose="020B0600000101010101" pitchFamily="50" charset="-127"/>
-              </a:rPr>
-              <a:t>은접근 </a:t>
-            </a:r>
-            <a:r>
-              <a:rPr lang="ko-KR" altLang="en-US" sz="2400" dirty="0" smtClean="0">
-                <a:solidFill>
-                  <a:schemeClr val="tx1"/>
-                </a:solidFill>
-                <a:latin typeface="나눔스퀘어 Bold" panose="020B0600000101010101" pitchFamily="50" charset="-127"/>
-                <a:ea typeface="나눔스퀘어 Bold" panose="020B0600000101010101" pitchFamily="50" charset="-127"/>
-              </a:rPr>
-              <a:t>범위</a:t>
-            </a:r>
-            <a:endParaRPr lang="ko-KR" altLang="en-US" sz="2400" dirty="0">
-              <a:solidFill>
-                <a:schemeClr val="tx1"/>
-              </a:solidFill>
-              <a:latin typeface="나눔스퀘어 Bold" panose="020B0600000101010101" pitchFamily="50" charset="-127"/>
-              <a:ea typeface="나눔스퀘어 Bold" panose="020B0600000101010101" pitchFamily="50" charset="-127"/>
-            </a:endParaRPr>
-          </a:p>
-        </p:txBody>
-      </p:sp>
+              </a:endParaRPr>
+            </a:p>
+          </p:txBody>
+        </p:sp>
+      </p:grpSp>
     </p:spTree>
     <p:extLst>
       <p:ext uri="{BB962C8B-B14F-4D97-AF65-F5344CB8AC3E}">

</xml_diff>

<commit_message>
20260812 commit : finished, today_Notion
</commit_message>
<xml_diff>
--- a/create_notion_img.pptx
+++ b/create_notion_img.pptx
@@ -247,7 +247,7 @@
           <a:p>
             <a:fld id="{7237CE1A-8831-48B5-BA93-72483C6E34E8}" type="datetimeFigureOut">
               <a:rPr lang="ko-KR" altLang="en-US" smtClean="0"/>
-              <a:t>2026-08-11</a:t>
+              <a:t>2026-08-12</a:t>
             </a:fld>
             <a:endParaRPr lang="ko-KR" altLang="en-US"/>
           </a:p>
@@ -417,7 +417,7 @@
           <a:p>
             <a:fld id="{7237CE1A-8831-48B5-BA93-72483C6E34E8}" type="datetimeFigureOut">
               <a:rPr lang="ko-KR" altLang="en-US" smtClean="0"/>
-              <a:t>2026-08-11</a:t>
+              <a:t>2026-08-12</a:t>
             </a:fld>
             <a:endParaRPr lang="ko-KR" altLang="en-US"/>
           </a:p>
@@ -597,7 +597,7 @@
           <a:p>
             <a:fld id="{7237CE1A-8831-48B5-BA93-72483C6E34E8}" type="datetimeFigureOut">
               <a:rPr lang="ko-KR" altLang="en-US" smtClean="0"/>
-              <a:t>2026-08-11</a:t>
+              <a:t>2026-08-12</a:t>
             </a:fld>
             <a:endParaRPr lang="ko-KR" altLang="en-US"/>
           </a:p>
@@ -767,7 +767,7 @@
           <a:p>
             <a:fld id="{7237CE1A-8831-48B5-BA93-72483C6E34E8}" type="datetimeFigureOut">
               <a:rPr lang="ko-KR" altLang="en-US" smtClean="0"/>
-              <a:t>2026-08-11</a:t>
+              <a:t>2026-08-12</a:t>
             </a:fld>
             <a:endParaRPr lang="ko-KR" altLang="en-US"/>
           </a:p>
@@ -1013,7 +1013,7 @@
           <a:p>
             <a:fld id="{7237CE1A-8831-48B5-BA93-72483C6E34E8}" type="datetimeFigureOut">
               <a:rPr lang="ko-KR" altLang="en-US" smtClean="0"/>
-              <a:t>2026-08-11</a:t>
+              <a:t>2026-08-12</a:t>
             </a:fld>
             <a:endParaRPr lang="ko-KR" altLang="en-US"/>
           </a:p>
@@ -1245,7 +1245,7 @@
           <a:p>
             <a:fld id="{7237CE1A-8831-48B5-BA93-72483C6E34E8}" type="datetimeFigureOut">
               <a:rPr lang="ko-KR" altLang="en-US" smtClean="0"/>
-              <a:t>2026-08-11</a:t>
+              <a:t>2026-08-12</a:t>
             </a:fld>
             <a:endParaRPr lang="ko-KR" altLang="en-US"/>
           </a:p>
@@ -1612,7 +1612,7 @@
           <a:p>
             <a:fld id="{7237CE1A-8831-48B5-BA93-72483C6E34E8}" type="datetimeFigureOut">
               <a:rPr lang="ko-KR" altLang="en-US" smtClean="0"/>
-              <a:t>2026-08-11</a:t>
+              <a:t>2026-08-12</a:t>
             </a:fld>
             <a:endParaRPr lang="ko-KR" altLang="en-US"/>
           </a:p>
@@ -1730,7 +1730,7 @@
           <a:p>
             <a:fld id="{7237CE1A-8831-48B5-BA93-72483C6E34E8}" type="datetimeFigureOut">
               <a:rPr lang="ko-KR" altLang="en-US" smtClean="0"/>
-              <a:t>2026-08-11</a:t>
+              <a:t>2026-08-12</a:t>
             </a:fld>
             <a:endParaRPr lang="ko-KR" altLang="en-US"/>
           </a:p>
@@ -1825,7 +1825,7 @@
           <a:p>
             <a:fld id="{7237CE1A-8831-48B5-BA93-72483C6E34E8}" type="datetimeFigureOut">
               <a:rPr lang="ko-KR" altLang="en-US" smtClean="0"/>
-              <a:t>2026-08-11</a:t>
+              <a:t>2026-08-12</a:t>
             </a:fld>
             <a:endParaRPr lang="ko-KR" altLang="en-US"/>
           </a:p>
@@ -2102,7 +2102,7 @@
           <a:p>
             <a:fld id="{7237CE1A-8831-48B5-BA93-72483C6E34E8}" type="datetimeFigureOut">
               <a:rPr lang="ko-KR" altLang="en-US" smtClean="0"/>
-              <a:t>2026-08-11</a:t>
+              <a:t>2026-08-12</a:t>
             </a:fld>
             <a:endParaRPr lang="ko-KR" altLang="en-US"/>
           </a:p>
@@ -2355,7 +2355,7 @@
           <a:p>
             <a:fld id="{7237CE1A-8831-48B5-BA93-72483C6E34E8}" type="datetimeFigureOut">
               <a:rPr lang="ko-KR" altLang="en-US" smtClean="0"/>
-              <a:t>2026-08-11</a:t>
+              <a:t>2026-08-12</a:t>
             </a:fld>
             <a:endParaRPr lang="ko-KR" altLang="en-US"/>
           </a:p>
@@ -2568,7 +2568,7 @@
           <a:p>
             <a:fld id="{7237CE1A-8831-48B5-BA93-72483C6E34E8}" type="datetimeFigureOut">
               <a:rPr lang="ko-KR" altLang="en-US" smtClean="0"/>
-              <a:t>2026-08-11</a:t>
+              <a:t>2026-08-12</a:t>
             </a:fld>
             <a:endParaRPr lang="ko-KR" altLang="en-US"/>
           </a:p>
@@ -2975,76 +2975,41 @@
       </p:grpSpPr>
       <p:grpSp>
         <p:nvGrpSpPr>
-          <p:cNvPr id="63" name="그룹 62"/>
+          <p:cNvPr id="73" name="그룹 72"/>
           <p:cNvGrpSpPr/>
           <p:nvPr/>
         </p:nvGrpSpPr>
         <p:grpSpPr>
           <a:xfrm>
-            <a:off x="-366888" y="1549614"/>
-            <a:ext cx="12205976" cy="1425486"/>
-            <a:chOff x="-366888" y="1549614"/>
-            <a:chExt cx="12205976" cy="1425486"/>
+            <a:off x="649767" y="767507"/>
+            <a:ext cx="14514212" cy="5304499"/>
+            <a:chOff x="649767" y="767507"/>
+            <a:chExt cx="14514212" cy="5304499"/>
           </a:xfrm>
         </p:grpSpPr>
-        <p:cxnSp>
-          <p:nvCxnSpPr>
-            <p:cNvPr id="45" name="직선 화살표 연결선 44"/>
-            <p:cNvCxnSpPr/>
-            <p:nvPr/>
-          </p:nvCxnSpPr>
-          <p:spPr>
-            <a:xfrm>
-              <a:off x="1776300" y="2705100"/>
-              <a:ext cx="7920000" cy="0"/>
-            </a:xfrm>
-            <a:prstGeom prst="straightConnector1">
-              <a:avLst/>
-            </a:prstGeom>
-            <a:ln w="57150">
-              <a:solidFill>
-                <a:schemeClr val="tx1"/>
-              </a:solidFill>
-              <a:headEnd type="triangle"/>
-              <a:tailEnd type="triangle"/>
-            </a:ln>
-          </p:spPr>
-          <p:style>
-            <a:lnRef idx="1">
-              <a:schemeClr val="accent1"/>
-            </a:lnRef>
-            <a:fillRef idx="0">
-              <a:schemeClr val="accent1"/>
-            </a:fillRef>
-            <a:effectRef idx="0">
-              <a:schemeClr val="accent1"/>
-            </a:effectRef>
-            <a:fontRef idx="minor">
-              <a:schemeClr val="tx1"/>
-            </a:fontRef>
-          </p:style>
-        </p:cxnSp>
         <p:sp>
           <p:nvSpPr>
-            <p:cNvPr id="52" name="모서리가 둥근 직사각형 51"/>
+            <p:cNvPr id="69" name="모서리가 둥근 직사각형 68"/>
             <p:cNvSpPr/>
             <p:nvPr/>
           </p:nvSpPr>
           <p:spPr>
             <a:xfrm>
-              <a:off x="1777600" y="1549614"/>
-              <a:ext cx="1440000" cy="540000"/>
+              <a:off x="5210623" y="3192006"/>
+              <a:ext cx="6480000" cy="2880000"/>
             </a:xfrm>
             <a:prstGeom prst="roundRect">
-              <a:avLst/>
+              <a:avLst>
+                <a:gd name="adj" fmla="val 5620"/>
+              </a:avLst>
             </a:prstGeom>
             <a:solidFill>
-              <a:schemeClr val="bg1">
-                <a:lumMod val="75000"/>
-              </a:schemeClr>
+              <a:schemeClr val="bg2"/>
             </a:solidFill>
-            <a:ln>
-              <a:noFill/>
+            <a:ln w="28575">
+              <a:solidFill>
+                <a:schemeClr val="tx1"/>
+              </a:solidFill>
             </a:ln>
           </p:spPr>
           <p:style>
@@ -3067,7 +3032,11 @@
             <a:bodyPr rtlCol="0" anchor="ctr"/>
             <a:lstStyle/>
             <a:p>
-              <a:pPr algn="ctr"/>
+              <a:pPr>
+                <a:lnSpc>
+                  <a:spcPct val="150000"/>
+                </a:lnSpc>
+              </a:pPr>
               <a:r>
                 <a:rPr lang="en-US" altLang="ko-KR" sz="2000" dirty="0" smtClean="0">
                   <a:solidFill>
@@ -3076,7 +3045,222 @@
                   <a:latin typeface="나눔스퀘어 Bold" panose="020B0600000101010101" pitchFamily="50" charset="-127"/>
                   <a:ea typeface="나눔스퀘어 Bold" panose="020B0600000101010101" pitchFamily="50" charset="-127"/>
                 </a:rPr>
-                <a:t>private</a:t>
+                <a:t>public </a:t>
+              </a:r>
+              <a:r>
+                <a:rPr lang="en-US" altLang="ko-KR" sz="2000" dirty="0" err="1">
+                  <a:solidFill>
+                    <a:schemeClr val="tx1"/>
+                  </a:solidFill>
+                  <a:latin typeface="나눔스퀘어 Bold" panose="020B0600000101010101" pitchFamily="50" charset="-127"/>
+                  <a:ea typeface="나눔스퀘어 Bold" panose="020B0600000101010101" pitchFamily="50" charset="-127"/>
+                </a:rPr>
+                <a:t>C</a:t>
+              </a:r>
+              <a:r>
+                <a:rPr lang="en-US" altLang="ko-KR" sz="2000" dirty="0" err="1" smtClean="0">
+                  <a:solidFill>
+                    <a:schemeClr val="tx1"/>
+                  </a:solidFill>
+                  <a:latin typeface="나눔스퀘어 Bold" panose="020B0600000101010101" pitchFamily="50" charset="-127"/>
+                  <a:ea typeface="나눔스퀘어 Bold" panose="020B0600000101010101" pitchFamily="50" charset="-127"/>
+                </a:rPr>
+                <a:t>oolingSystem</a:t>
+              </a:r>
+              <a:r>
+                <a:rPr lang="en-US" altLang="ko-KR" sz="2000" dirty="0" smtClean="0">
+                  <a:solidFill>
+                    <a:schemeClr val="tx1"/>
+                  </a:solidFill>
+                  <a:latin typeface="나눔스퀘어 Bold" panose="020B0600000101010101" pitchFamily="50" charset="-127"/>
+                  <a:ea typeface="나눔스퀘어 Bold" panose="020B0600000101010101" pitchFamily="50" charset="-127"/>
+                </a:rPr>
+                <a:t>(String color) {</a:t>
+              </a:r>
+            </a:p>
+            <a:p>
+              <a:pPr>
+                <a:lnSpc>
+                  <a:spcPct val="150000"/>
+                </a:lnSpc>
+              </a:pPr>
+              <a:r>
+                <a:rPr lang="en-US" altLang="ko-KR" sz="2000" dirty="0">
+                  <a:solidFill>
+                    <a:schemeClr val="tx1"/>
+                  </a:solidFill>
+                  <a:latin typeface="나눔스퀘어 Bold" panose="020B0600000101010101" pitchFamily="50" charset="-127"/>
+                  <a:ea typeface="나눔스퀘어 Bold" panose="020B0600000101010101" pitchFamily="50" charset="-127"/>
+                </a:rPr>
+                <a:t> </a:t>
+              </a:r>
+              <a:r>
+                <a:rPr lang="en-US" altLang="ko-KR" sz="2000" dirty="0" smtClean="0">
+                  <a:solidFill>
+                    <a:schemeClr val="tx1"/>
+                  </a:solidFill>
+                  <a:latin typeface="나눔스퀘어 Bold" panose="020B0600000101010101" pitchFamily="50" charset="-127"/>
+                  <a:ea typeface="나눔스퀘어 Bold" panose="020B0600000101010101" pitchFamily="50" charset="-127"/>
+                </a:rPr>
+                <a:t>       power = false;</a:t>
+              </a:r>
+            </a:p>
+            <a:p>
+              <a:pPr>
+                <a:lnSpc>
+                  <a:spcPct val="150000"/>
+                </a:lnSpc>
+              </a:pPr>
+              <a:r>
+                <a:rPr lang="en-US" altLang="ko-KR" sz="2000" dirty="0" smtClean="0">
+                  <a:solidFill>
+                    <a:schemeClr val="tx1"/>
+                  </a:solidFill>
+                  <a:latin typeface="나눔스퀘어 Bold" panose="020B0600000101010101" pitchFamily="50" charset="-127"/>
+                  <a:ea typeface="나눔스퀘어 Bold" panose="020B0600000101010101" pitchFamily="50" charset="-127"/>
+                </a:rPr>
+                <a:t>        </a:t>
+              </a:r>
+              <a:r>
+                <a:rPr lang="en-US" altLang="ko-KR" sz="2000" dirty="0" err="1" smtClean="0">
+                  <a:solidFill>
+                    <a:schemeClr val="tx1"/>
+                  </a:solidFill>
+                  <a:latin typeface="나눔스퀘어 Bold" panose="020B0600000101010101" pitchFamily="50" charset="-127"/>
+                  <a:ea typeface="나눔스퀘어 Bold" panose="020B0600000101010101" pitchFamily="50" charset="-127"/>
+                </a:rPr>
+                <a:t>targetTemperature</a:t>
+              </a:r>
+              <a:r>
+                <a:rPr lang="en-US" altLang="ko-KR" sz="2000" dirty="0" smtClean="0">
+                  <a:solidFill>
+                    <a:schemeClr val="tx1"/>
+                  </a:solidFill>
+                  <a:latin typeface="나눔스퀘어 Bold" panose="020B0600000101010101" pitchFamily="50" charset="-127"/>
+                  <a:ea typeface="나눔스퀘어 Bold" panose="020B0600000101010101" pitchFamily="50" charset="-127"/>
+                </a:rPr>
+                <a:t> = 18;</a:t>
+              </a:r>
+            </a:p>
+            <a:p>
+              <a:pPr>
+                <a:lnSpc>
+                  <a:spcPct val="150000"/>
+                </a:lnSpc>
+              </a:pPr>
+              <a:r>
+                <a:rPr lang="en-US" altLang="ko-KR" sz="2000" dirty="0" smtClean="0">
+                  <a:solidFill>
+                    <a:schemeClr val="tx1"/>
+                  </a:solidFill>
+                  <a:latin typeface="나눔스퀘어 Bold" panose="020B0600000101010101" pitchFamily="50" charset="-127"/>
+                  <a:ea typeface="나눔스퀘어 Bold" panose="020B0600000101010101" pitchFamily="50" charset="-127"/>
+                </a:rPr>
+                <a:t>        </a:t>
+              </a:r>
+              <a:r>
+                <a:rPr lang="en-US" altLang="ko-KR" sz="2000" dirty="0" err="1" smtClean="0">
+                  <a:solidFill>
+                    <a:schemeClr val="tx1"/>
+                  </a:solidFill>
+                  <a:latin typeface="나눔스퀘어 Bold" panose="020B0600000101010101" pitchFamily="50" charset="-127"/>
+                  <a:ea typeface="나눔스퀘어 Bold" panose="020B0600000101010101" pitchFamily="50" charset="-127"/>
+                </a:rPr>
+                <a:t>dateOfManufacture</a:t>
+              </a:r>
+              <a:r>
+                <a:rPr lang="en-US" altLang="ko-KR" sz="2000" dirty="0" smtClean="0">
+                  <a:solidFill>
+                    <a:schemeClr val="tx1"/>
+                  </a:solidFill>
+                  <a:latin typeface="나눔스퀘어 Bold" panose="020B0600000101010101" pitchFamily="50" charset="-127"/>
+                  <a:ea typeface="나눔스퀘어 Bold" panose="020B0600000101010101" pitchFamily="50" charset="-127"/>
+                </a:rPr>
+                <a:t> = </a:t>
+              </a:r>
+              <a:r>
+                <a:rPr lang="en-US" altLang="ko-KR" sz="2000" dirty="0" err="1" smtClean="0">
+                  <a:solidFill>
+                    <a:schemeClr val="tx1"/>
+                  </a:solidFill>
+                  <a:latin typeface="나눔스퀘어 Bold" panose="020B0600000101010101" pitchFamily="50" charset="-127"/>
+                  <a:ea typeface="나눔스퀘어 Bold" panose="020B0600000101010101" pitchFamily="50" charset="-127"/>
+                </a:rPr>
+                <a:t>getSystemDateTime</a:t>
+              </a:r>
+              <a:r>
+                <a:rPr lang="en-US" altLang="ko-KR" sz="2000" dirty="0" smtClean="0">
+                  <a:solidFill>
+                    <a:schemeClr val="tx1"/>
+                  </a:solidFill>
+                  <a:latin typeface="나눔스퀘어 Bold" panose="020B0600000101010101" pitchFamily="50" charset="-127"/>
+                  <a:ea typeface="나눔스퀘어 Bold" panose="020B0600000101010101" pitchFamily="50" charset="-127"/>
+                </a:rPr>
+                <a:t>();</a:t>
+              </a:r>
+            </a:p>
+            <a:p>
+              <a:pPr>
+                <a:lnSpc>
+                  <a:spcPct val="150000"/>
+                </a:lnSpc>
+              </a:pPr>
+              <a:r>
+                <a:rPr lang="en-US" altLang="ko-KR" sz="2000" dirty="0">
+                  <a:solidFill>
+                    <a:schemeClr val="tx1"/>
+                  </a:solidFill>
+                  <a:latin typeface="나눔스퀘어 Bold" panose="020B0600000101010101" pitchFamily="50" charset="-127"/>
+                  <a:ea typeface="나눔스퀘어 Bold" panose="020B0600000101010101" pitchFamily="50" charset="-127"/>
+                </a:rPr>
+                <a:t> </a:t>
+              </a:r>
+              <a:r>
+                <a:rPr lang="en-US" altLang="ko-KR" sz="2000" dirty="0" smtClean="0">
+                  <a:solidFill>
+                    <a:schemeClr val="tx1"/>
+                  </a:solidFill>
+                  <a:latin typeface="나눔스퀘어 Bold" panose="020B0600000101010101" pitchFamily="50" charset="-127"/>
+                  <a:ea typeface="나눔스퀘어 Bold" panose="020B0600000101010101" pitchFamily="50" charset="-127"/>
+                </a:rPr>
+                <a:t>       </a:t>
+              </a:r>
+              <a:r>
+                <a:rPr lang="en-US" altLang="ko-KR" sz="2000" dirty="0" err="1" smtClean="0">
+                  <a:solidFill>
+                    <a:schemeClr val="tx1"/>
+                  </a:solidFill>
+                  <a:latin typeface="나눔스퀘어 Bold" panose="020B0600000101010101" pitchFamily="50" charset="-127"/>
+                  <a:ea typeface="나눔스퀘어 Bold" panose="020B0600000101010101" pitchFamily="50" charset="-127"/>
+                </a:rPr>
+                <a:t>this.color</a:t>
+              </a:r>
+              <a:r>
+                <a:rPr lang="en-US" altLang="ko-KR" sz="2000" dirty="0" smtClean="0">
+                  <a:solidFill>
+                    <a:schemeClr val="tx1"/>
+                  </a:solidFill>
+                  <a:latin typeface="나눔스퀘어 Bold" panose="020B0600000101010101" pitchFamily="50" charset="-127"/>
+                  <a:ea typeface="나눔스퀘어 Bold" panose="020B0600000101010101" pitchFamily="50" charset="-127"/>
+                </a:rPr>
+                <a:t> = color;</a:t>
+              </a:r>
+            </a:p>
+            <a:p>
+              <a:pPr>
+                <a:lnSpc>
+                  <a:spcPct val="150000"/>
+                </a:lnSpc>
+              </a:pPr>
+              <a:r>
+                <a:rPr lang="en-US" altLang="ko-KR" sz="2000" dirty="0" smtClean="0">
+                  <a:solidFill>
+                    <a:schemeClr val="tx1"/>
+                  </a:solidFill>
+                  <a:latin typeface="나눔스퀘어 Bold" panose="020B0600000101010101" pitchFamily="50" charset="-127"/>
+                  <a:ea typeface="나눔스퀘어 Bold" panose="020B0600000101010101" pitchFamily="50" charset="-127"/>
+                </a:rPr>
+                <a:t>}</a:t>
               </a:r>
               <a:endParaRPr lang="ko-KR" altLang="en-US" sz="2000" dirty="0">
                 <a:solidFill>
@@ -3090,25 +3274,27 @@
         </p:sp>
         <p:sp>
           <p:nvSpPr>
-            <p:cNvPr id="53" name="모서리가 둥근 직사각형 52"/>
+            <p:cNvPr id="2" name="모서리가 둥근 직사각형 1"/>
             <p:cNvSpPr/>
             <p:nvPr/>
           </p:nvSpPr>
           <p:spPr>
             <a:xfrm>
-              <a:off x="3936950" y="1549614"/>
-              <a:ext cx="1440000" cy="540000"/>
+              <a:off x="5210623" y="767507"/>
+              <a:ext cx="6480000" cy="2160000"/>
             </a:xfrm>
             <a:prstGeom prst="roundRect">
-              <a:avLst/>
+              <a:avLst>
+                <a:gd name="adj" fmla="val 5620"/>
+              </a:avLst>
             </a:prstGeom>
             <a:solidFill>
-              <a:schemeClr val="bg1">
-                <a:lumMod val="75000"/>
-              </a:schemeClr>
+              <a:schemeClr val="bg2"/>
             </a:solidFill>
-            <a:ln>
-              <a:noFill/>
+            <a:ln w="28575">
+              <a:solidFill>
+                <a:schemeClr val="tx1"/>
+              </a:solidFill>
             </a:ln>
           </p:spPr>
           <p:style>
@@ -3131,16 +3317,212 @@
             <a:bodyPr rtlCol="0" anchor="ctr"/>
             <a:lstStyle/>
             <a:p>
-              <a:pPr algn="ctr"/>
+              <a:pPr>
+                <a:lnSpc>
+                  <a:spcPct val="150000"/>
+                </a:lnSpc>
+              </a:pPr>
               <a:r>
-                <a:rPr lang="en-US" altLang="ko-KR" sz="2000" dirty="0">
+                <a:rPr lang="en-US" altLang="ko-KR" sz="2000" dirty="0" smtClean="0">
                   <a:solidFill>
                     <a:schemeClr val="tx1"/>
                   </a:solidFill>
                   <a:latin typeface="나눔스퀘어 Bold" panose="020B0600000101010101" pitchFamily="50" charset="-127"/>
                   <a:ea typeface="나눔스퀘어 Bold" panose="020B0600000101010101" pitchFamily="50" charset="-127"/>
                 </a:rPr>
-                <a:t>default</a:t>
+                <a:t>  private </a:t>
+              </a:r>
+              <a:r>
+                <a:rPr lang="en-US" altLang="ko-KR" sz="2000" dirty="0" err="1" smtClean="0">
+                  <a:solidFill>
+                    <a:schemeClr val="tx1"/>
+                  </a:solidFill>
+                  <a:latin typeface="나눔스퀘어 Bold" panose="020B0600000101010101" pitchFamily="50" charset="-127"/>
+                  <a:ea typeface="나눔스퀘어 Bold" panose="020B0600000101010101" pitchFamily="50" charset="-127"/>
+                </a:rPr>
+                <a:t>boolean</a:t>
+              </a:r>
+              <a:r>
+                <a:rPr lang="en-US" altLang="ko-KR" sz="2000" dirty="0" smtClean="0">
+                  <a:solidFill>
+                    <a:schemeClr val="tx1"/>
+                  </a:solidFill>
+                  <a:latin typeface="나눔스퀘어 Bold" panose="020B0600000101010101" pitchFamily="50" charset="-127"/>
+                  <a:ea typeface="나눔스퀘어 Bold" panose="020B0600000101010101" pitchFamily="50" charset="-127"/>
+                </a:rPr>
+                <a:t> power;		    // </a:t>
+              </a:r>
+              <a:r>
+                <a:rPr lang="ko-KR" altLang="en-US" sz="2000" dirty="0" smtClean="0">
+                  <a:solidFill>
+                    <a:schemeClr val="tx1"/>
+                  </a:solidFill>
+                  <a:latin typeface="나눔스퀘어 Bold" panose="020B0600000101010101" pitchFamily="50" charset="-127"/>
+                  <a:ea typeface="나눔스퀘어 Bold" panose="020B0600000101010101" pitchFamily="50" charset="-127"/>
+                </a:rPr>
+                <a:t>전원</a:t>
+              </a:r>
+              <a:endParaRPr lang="en-US" altLang="ko-KR" sz="2000" dirty="0" smtClean="0">
+                <a:solidFill>
+                  <a:schemeClr val="tx1"/>
+                </a:solidFill>
+                <a:latin typeface="나눔스퀘어 Bold" panose="020B0600000101010101" pitchFamily="50" charset="-127"/>
+                <a:ea typeface="나눔스퀘어 Bold" panose="020B0600000101010101" pitchFamily="50" charset="-127"/>
+              </a:endParaRPr>
+            </a:p>
+            <a:p>
+              <a:pPr>
+                <a:lnSpc>
+                  <a:spcPct val="150000"/>
+                </a:lnSpc>
+              </a:pPr>
+              <a:r>
+                <a:rPr lang="en-US" altLang="ko-KR" sz="2000" dirty="0" smtClean="0">
+                  <a:solidFill>
+                    <a:schemeClr val="tx1"/>
+                  </a:solidFill>
+                  <a:latin typeface="나눔스퀘어 Bold" panose="020B0600000101010101" pitchFamily="50" charset="-127"/>
+                  <a:ea typeface="나눔스퀘어 Bold" panose="020B0600000101010101" pitchFamily="50" charset="-127"/>
+                </a:rPr>
+                <a:t>  private </a:t>
+              </a:r>
+              <a:r>
+                <a:rPr lang="en-US" altLang="ko-KR" sz="2000" dirty="0" err="1" smtClean="0">
+                  <a:solidFill>
+                    <a:schemeClr val="tx1"/>
+                  </a:solidFill>
+                  <a:latin typeface="나눔스퀘어 Bold" panose="020B0600000101010101" pitchFamily="50" charset="-127"/>
+                  <a:ea typeface="나눔스퀘어 Bold" panose="020B0600000101010101" pitchFamily="50" charset="-127"/>
+                </a:rPr>
+                <a:t>int</a:t>
+              </a:r>
+              <a:r>
+                <a:rPr lang="en-US" altLang="ko-KR" sz="2000" dirty="0" smtClean="0">
+                  <a:solidFill>
+                    <a:schemeClr val="tx1"/>
+                  </a:solidFill>
+                  <a:latin typeface="나눔스퀘어 Bold" panose="020B0600000101010101" pitchFamily="50" charset="-127"/>
+                  <a:ea typeface="나눔스퀘어 Bold" panose="020B0600000101010101" pitchFamily="50" charset="-127"/>
+                </a:rPr>
+                <a:t> </a:t>
+              </a:r>
+              <a:r>
+                <a:rPr lang="en-US" altLang="ko-KR" sz="2000" dirty="0" err="1" smtClean="0">
+                  <a:solidFill>
+                    <a:schemeClr val="tx1"/>
+                  </a:solidFill>
+                  <a:latin typeface="나눔스퀘어 Bold" panose="020B0600000101010101" pitchFamily="50" charset="-127"/>
+                  <a:ea typeface="나눔스퀘어 Bold" panose="020B0600000101010101" pitchFamily="50" charset="-127"/>
+                </a:rPr>
+                <a:t>targetTemperature</a:t>
+              </a:r>
+              <a:r>
+                <a:rPr lang="en-US" altLang="ko-KR" sz="2000" dirty="0" smtClean="0">
+                  <a:solidFill>
+                    <a:schemeClr val="tx1"/>
+                  </a:solidFill>
+                  <a:latin typeface="나눔스퀘어 Bold" panose="020B0600000101010101" pitchFamily="50" charset="-127"/>
+                  <a:ea typeface="나눔스퀘어 Bold" panose="020B0600000101010101" pitchFamily="50" charset="-127"/>
+                </a:rPr>
+                <a:t>;	    // </a:t>
+              </a:r>
+              <a:r>
+                <a:rPr lang="ko-KR" altLang="en-US" sz="2000" dirty="0" smtClean="0">
+                  <a:solidFill>
+                    <a:schemeClr val="tx1"/>
+                  </a:solidFill>
+                  <a:latin typeface="나눔스퀘어 Bold" panose="020B0600000101010101" pitchFamily="50" charset="-127"/>
+                  <a:ea typeface="나눔스퀘어 Bold" panose="020B0600000101010101" pitchFamily="50" charset="-127"/>
+                </a:rPr>
+                <a:t>희망 온도</a:t>
+              </a:r>
+              <a:endParaRPr lang="ko-KR" altLang="en-US" sz="2000" dirty="0">
+                <a:solidFill>
+                  <a:schemeClr val="tx1"/>
+                </a:solidFill>
+                <a:latin typeface="나눔스퀘어 Bold" panose="020B0600000101010101" pitchFamily="50" charset="-127"/>
+                <a:ea typeface="나눔스퀘어 Bold" panose="020B0600000101010101" pitchFamily="50" charset="-127"/>
+              </a:endParaRPr>
+            </a:p>
+            <a:p>
+              <a:pPr>
+                <a:lnSpc>
+                  <a:spcPct val="150000"/>
+                </a:lnSpc>
+              </a:pPr>
+              <a:r>
+                <a:rPr lang="en-US" altLang="ko-KR" sz="2000" dirty="0" smtClean="0">
+                  <a:solidFill>
+                    <a:schemeClr val="tx1"/>
+                  </a:solidFill>
+                  <a:latin typeface="나눔스퀘어 Bold" panose="020B0600000101010101" pitchFamily="50" charset="-127"/>
+                  <a:ea typeface="나눔스퀘어 Bold" panose="020B0600000101010101" pitchFamily="50" charset="-127"/>
+                </a:rPr>
+                <a:t>  private String </a:t>
+              </a:r>
+              <a:r>
+                <a:rPr lang="en-US" altLang="ko-KR" sz="2000" dirty="0" err="1" smtClean="0">
+                  <a:solidFill>
+                    <a:schemeClr val="tx1"/>
+                  </a:solidFill>
+                  <a:latin typeface="나눔스퀘어 Bold" panose="020B0600000101010101" pitchFamily="50" charset="-127"/>
+                  <a:ea typeface="나눔스퀘어 Bold" panose="020B0600000101010101" pitchFamily="50" charset="-127"/>
+                </a:rPr>
+                <a:t>dateOfManufacture</a:t>
+              </a:r>
+              <a:r>
+                <a:rPr lang="en-US" altLang="ko-KR" sz="2000" dirty="0" smtClean="0">
+                  <a:solidFill>
+                    <a:schemeClr val="tx1"/>
+                  </a:solidFill>
+                  <a:latin typeface="나눔스퀘어 Bold" panose="020B0600000101010101" pitchFamily="50" charset="-127"/>
+                  <a:ea typeface="나눔스퀘어 Bold" panose="020B0600000101010101" pitchFamily="50" charset="-127"/>
+                </a:rPr>
+                <a:t>;	    // </a:t>
+              </a:r>
+              <a:r>
+                <a:rPr lang="ko-KR" altLang="en-US" sz="2000" dirty="0" smtClean="0">
+                  <a:solidFill>
+                    <a:schemeClr val="tx1"/>
+                  </a:solidFill>
+                  <a:latin typeface="나눔스퀘어 Bold" panose="020B0600000101010101" pitchFamily="50" charset="-127"/>
+                  <a:ea typeface="나눔스퀘어 Bold" panose="020B0600000101010101" pitchFamily="50" charset="-127"/>
+                </a:rPr>
+                <a:t>제조일</a:t>
+              </a:r>
+              <a:endParaRPr lang="ko-KR" altLang="en-US" sz="2000" dirty="0">
+                <a:solidFill>
+                  <a:schemeClr val="tx1"/>
+                </a:solidFill>
+                <a:latin typeface="나눔스퀘어 Bold" panose="020B0600000101010101" pitchFamily="50" charset="-127"/>
+                <a:ea typeface="나눔스퀘어 Bold" panose="020B0600000101010101" pitchFamily="50" charset="-127"/>
+              </a:endParaRPr>
+            </a:p>
+            <a:p>
+              <a:pPr>
+                <a:lnSpc>
+                  <a:spcPct val="150000"/>
+                </a:lnSpc>
+              </a:pPr>
+              <a:r>
+                <a:rPr lang="en-US" altLang="ko-KR" sz="2000" dirty="0" smtClean="0">
+                  <a:solidFill>
+                    <a:schemeClr val="tx1"/>
+                  </a:solidFill>
+                  <a:latin typeface="나눔스퀘어 Bold" panose="020B0600000101010101" pitchFamily="50" charset="-127"/>
+                  <a:ea typeface="나눔스퀘어 Bold" panose="020B0600000101010101" pitchFamily="50" charset="-127"/>
+                </a:rPr>
+                <a:t>  private String color;			    // </a:t>
+              </a:r>
+              <a:r>
+                <a:rPr lang="ko-KR" altLang="en-US" sz="2000" dirty="0" smtClean="0">
+                  <a:solidFill>
+                    <a:schemeClr val="tx1"/>
+                  </a:solidFill>
+                  <a:latin typeface="나눔스퀘어 Bold" panose="020B0600000101010101" pitchFamily="50" charset="-127"/>
+                  <a:ea typeface="나눔스퀘어 Bold" panose="020B0600000101010101" pitchFamily="50" charset="-127"/>
+                </a:rPr>
+                <a:t>색상</a:t>
               </a:r>
               <a:endParaRPr lang="ko-KR" altLang="en-US" sz="2000" dirty="0">
                 <a:solidFill>
@@ -3154,25 +3536,25 @@
         </p:sp>
         <p:sp>
           <p:nvSpPr>
-            <p:cNvPr id="54" name="모서리가 둥근 직사각형 53"/>
+            <p:cNvPr id="4" name="타원 3"/>
             <p:cNvSpPr/>
             <p:nvPr/>
           </p:nvSpPr>
           <p:spPr>
             <a:xfrm>
-              <a:off x="6094444" y="1549614"/>
-              <a:ext cx="1440000" cy="540000"/>
+              <a:off x="649767" y="4130106"/>
+              <a:ext cx="1080000" cy="1080000"/>
             </a:xfrm>
-            <a:prstGeom prst="roundRect">
+            <a:prstGeom prst="ellipse">
               <a:avLst/>
             </a:prstGeom>
             <a:solidFill>
-              <a:schemeClr val="bg1">
-                <a:lumMod val="75000"/>
-              </a:schemeClr>
+              <a:schemeClr val="accent2"/>
             </a:solidFill>
-            <a:ln>
-              <a:noFill/>
+            <a:ln w="28575">
+              <a:solidFill>
+                <a:schemeClr val="tx1"/>
+              </a:solidFill>
             </a:ln>
           </p:spPr>
           <p:style>
@@ -3196,20 +3578,76 @@
             <a:lstStyle/>
             <a:p>
               <a:pPr algn="ctr"/>
+              <a:endParaRPr lang="ko-KR" altLang="en-US"/>
+            </a:p>
+          </p:txBody>
+        </p:sp>
+        <p:cxnSp>
+          <p:nvCxnSpPr>
+            <p:cNvPr id="6" name="직선 화살표 연결선 5"/>
+            <p:cNvCxnSpPr/>
+            <p:nvPr/>
+          </p:nvCxnSpPr>
+          <p:spPr>
+            <a:xfrm>
+              <a:off x="1729767" y="4670106"/>
+              <a:ext cx="3420000" cy="0"/>
+            </a:xfrm>
+            <a:prstGeom prst="straightConnector1">
+              <a:avLst/>
+            </a:prstGeom>
+            <a:ln w="57150">
+              <a:solidFill>
+                <a:schemeClr val="tx1"/>
+              </a:solidFill>
+              <a:tailEnd type="triangle"/>
+            </a:ln>
+          </p:spPr>
+          <p:style>
+            <a:lnRef idx="1">
+              <a:schemeClr val="accent1"/>
+            </a:lnRef>
+            <a:fillRef idx="0">
+              <a:schemeClr val="accent1"/>
+            </a:fillRef>
+            <a:effectRef idx="0">
+              <a:schemeClr val="accent1"/>
+            </a:effectRef>
+            <a:fontRef idx="minor">
+              <a:schemeClr val="tx1"/>
+            </a:fontRef>
+          </p:style>
+        </p:cxnSp>
+        <p:sp>
+          <p:nvSpPr>
+            <p:cNvPr id="7" name="TextBox 6"/>
+            <p:cNvSpPr txBox="1"/>
+            <p:nvPr/>
+          </p:nvSpPr>
+          <p:spPr>
+            <a:xfrm>
+              <a:off x="2532070" y="4262674"/>
+              <a:ext cx="1560042" cy="369332"/>
+            </a:xfrm>
+            <a:prstGeom prst="rect">
+              <a:avLst/>
+            </a:prstGeom>
+            <a:noFill/>
+          </p:spPr>
+          <p:txBody>
+            <a:bodyPr wrap="none" rtlCol="0">
+              <a:spAutoFit/>
+            </a:bodyPr>
+            <a:lstStyle/>
+            <a:p>
               <a:r>
-                <a:rPr lang="en-US" altLang="ko-KR" sz="2000" dirty="0">
-                  <a:solidFill>
-                    <a:schemeClr val="tx1"/>
-                  </a:solidFill>
+                <a:rPr lang="ko-KR" altLang="en-US" smtClean="0">
                   <a:latin typeface="나눔스퀘어 Bold" panose="020B0600000101010101" pitchFamily="50" charset="-127"/>
                   <a:ea typeface="나눔스퀘어 Bold" panose="020B0600000101010101" pitchFamily="50" charset="-127"/>
                 </a:rPr>
-                <a:t>protected</a:t>
+                <a:t>외부 접근 가능</a:t>
               </a:r>
-              <a:endParaRPr lang="ko-KR" altLang="en-US" sz="2000" dirty="0">
-                <a:solidFill>
-                  <a:schemeClr val="tx1"/>
-                </a:solidFill>
+              <a:endParaRPr lang="ko-KR" altLang="en-US" dirty="0">
                 <a:latin typeface="나눔스퀘어 Bold" panose="020B0600000101010101" pitchFamily="50" charset="-127"/>
                 <a:ea typeface="나눔스퀘어 Bold" panose="020B0600000101010101" pitchFamily="50" charset="-127"/>
               </a:endParaRPr>
@@ -3218,25 +3656,25 @@
         </p:sp>
         <p:sp>
           <p:nvSpPr>
-            <p:cNvPr id="55" name="모서리가 둥근 직사각형 54"/>
+            <p:cNvPr id="47" name="타원 46"/>
             <p:cNvSpPr/>
             <p:nvPr/>
           </p:nvSpPr>
           <p:spPr>
             <a:xfrm>
-              <a:off x="8256300" y="1549614"/>
-              <a:ext cx="1440000" cy="540000"/>
+              <a:off x="649767" y="1322793"/>
+              <a:ext cx="1080000" cy="1080000"/>
             </a:xfrm>
-            <a:prstGeom prst="roundRect">
+            <a:prstGeom prst="ellipse">
               <a:avLst/>
             </a:prstGeom>
             <a:solidFill>
-              <a:schemeClr val="bg1">
-                <a:lumMod val="75000"/>
-              </a:schemeClr>
+              <a:schemeClr val="accent2"/>
             </a:solidFill>
-            <a:ln>
-              <a:noFill/>
+            <a:ln w="28575">
+              <a:solidFill>
+                <a:schemeClr val="tx1"/>
+              </a:solidFill>
             </a:ln>
           </p:spPr>
           <p:style>
@@ -3260,20 +3698,76 @@
             <a:lstStyle/>
             <a:p>
               <a:pPr algn="ctr"/>
+              <a:endParaRPr lang="ko-KR" altLang="en-US"/>
+            </a:p>
+          </p:txBody>
+        </p:sp>
+        <p:cxnSp>
+          <p:nvCxnSpPr>
+            <p:cNvPr id="48" name="직선 화살표 연결선 47"/>
+            <p:cNvCxnSpPr/>
+            <p:nvPr/>
+          </p:nvCxnSpPr>
+          <p:spPr>
+            <a:xfrm>
+              <a:off x="1729767" y="1862793"/>
+              <a:ext cx="3420000" cy="0"/>
+            </a:xfrm>
+            <a:prstGeom prst="straightConnector1">
+              <a:avLst/>
+            </a:prstGeom>
+            <a:ln w="57150">
+              <a:solidFill>
+                <a:schemeClr val="tx1"/>
+              </a:solidFill>
+              <a:tailEnd type="triangle"/>
+            </a:ln>
+          </p:spPr>
+          <p:style>
+            <a:lnRef idx="1">
+              <a:schemeClr val="accent1"/>
+            </a:lnRef>
+            <a:fillRef idx="0">
+              <a:schemeClr val="accent1"/>
+            </a:fillRef>
+            <a:effectRef idx="0">
+              <a:schemeClr val="accent1"/>
+            </a:effectRef>
+            <a:fontRef idx="minor">
+              <a:schemeClr val="tx1"/>
+            </a:fontRef>
+          </p:style>
+        </p:cxnSp>
+        <p:sp>
+          <p:nvSpPr>
+            <p:cNvPr id="49" name="TextBox 48"/>
+            <p:cNvSpPr txBox="1"/>
+            <p:nvPr/>
+          </p:nvSpPr>
+          <p:spPr>
+            <a:xfrm>
+              <a:off x="2427073" y="1459559"/>
+              <a:ext cx="1770036" cy="369332"/>
+            </a:xfrm>
+            <a:prstGeom prst="rect">
+              <a:avLst/>
+            </a:prstGeom>
+            <a:noFill/>
+          </p:spPr>
+          <p:txBody>
+            <a:bodyPr wrap="none" rtlCol="0">
+              <a:spAutoFit/>
+            </a:bodyPr>
+            <a:lstStyle/>
+            <a:p>
               <a:r>
-                <a:rPr lang="en-US" altLang="ko-KR" sz="2000" dirty="0">
-                  <a:solidFill>
-                    <a:schemeClr val="tx1"/>
-                  </a:solidFill>
+                <a:rPr lang="ko-KR" altLang="en-US" dirty="0" smtClean="0">
                   <a:latin typeface="나눔스퀘어 Bold" panose="020B0600000101010101" pitchFamily="50" charset="-127"/>
                   <a:ea typeface="나눔스퀘어 Bold" panose="020B0600000101010101" pitchFamily="50" charset="-127"/>
                 </a:rPr>
-                <a:t>public</a:t>
+                <a:t>외부 접근 불가능</a:t>
               </a:r>
-              <a:endParaRPr lang="ko-KR" altLang="en-US" sz="2000" dirty="0">
-                <a:solidFill>
-                  <a:schemeClr val="tx1"/>
-                </a:solidFill>
+              <a:endParaRPr lang="ko-KR" altLang="en-US" dirty="0">
                 <a:latin typeface="나눔스퀘어 Bold" panose="020B0600000101010101" pitchFamily="50" charset="-127"/>
                 <a:ea typeface="나눔스퀘어 Bold" panose="020B0600000101010101" pitchFamily="50" charset="-127"/>
               </a:endParaRPr>
@@ -3282,39 +3776,36 @@
         </p:sp>
         <p:sp>
           <p:nvSpPr>
-            <p:cNvPr id="56" name="아래쪽 화살표 55"/>
+            <p:cNvPr id="70" name="오른쪽 중괄호 69"/>
             <p:cNvSpPr/>
             <p:nvPr/>
           </p:nvSpPr>
           <p:spPr>
             <a:xfrm>
-              <a:off x="2227600" y="2089614"/>
-              <a:ext cx="540000" cy="540000"/>
+              <a:off x="11796000" y="3897156"/>
+              <a:ext cx="396000" cy="1584000"/>
             </a:xfrm>
-            <a:prstGeom prst="downArrow">
+            <a:prstGeom prst="rightBrace">
               <a:avLst/>
             </a:prstGeom>
-            <a:solidFill>
-              <a:schemeClr val="accent5"/>
-            </a:solidFill>
-            <a:ln>
-              <a:noFill/>
+            <a:ln w="57150">
+              <a:solidFill>
+                <a:schemeClr val="tx1"/>
+              </a:solidFill>
             </a:ln>
           </p:spPr>
           <p:style>
-            <a:lnRef idx="2">
-              <a:schemeClr val="accent1">
-                <a:shade val="50000"/>
-              </a:schemeClr>
+            <a:lnRef idx="1">
+              <a:schemeClr val="accent1"/>
             </a:lnRef>
-            <a:fillRef idx="1">
+            <a:fillRef idx="0">
               <a:schemeClr val="accent1"/>
             </a:fillRef>
             <a:effectRef idx="0">
               <a:schemeClr val="accent1"/>
             </a:effectRef>
             <a:fontRef idx="minor">
-              <a:schemeClr val="lt1"/>
+              <a:schemeClr val="tx1"/>
             </a:fontRef>
           </p:style>
           <p:txBody>
@@ -3322,312 +3813,47 @@
             <a:lstStyle/>
             <a:p>
               <a:pPr algn="ctr"/>
-              <a:endParaRPr lang="ko-KR" altLang="en-US">
-                <a:latin typeface="나눔스퀘어 Bold" panose="020B0600000101010101" pitchFamily="50" charset="-127"/>
-                <a:ea typeface="나눔스퀘어 Bold" panose="020B0600000101010101" pitchFamily="50" charset="-127"/>
-              </a:endParaRPr>
+              <a:endParaRPr lang="ko-KR" altLang="en-US"/>
             </a:p>
           </p:txBody>
         </p:sp>
         <p:sp>
           <p:nvSpPr>
-            <p:cNvPr id="57" name="아래쪽 화살표 56"/>
-            <p:cNvSpPr/>
+            <p:cNvPr id="72" name="TextBox 71"/>
+            <p:cNvSpPr txBox="1"/>
             <p:nvPr/>
           </p:nvSpPr>
           <p:spPr>
             <a:xfrm>
-              <a:off x="4401113" y="2086314"/>
-              <a:ext cx="540000" cy="540000"/>
+              <a:off x="12496261" y="4504490"/>
+              <a:ext cx="2667718" cy="369332"/>
             </a:xfrm>
-            <a:prstGeom prst="downArrow">
+            <a:prstGeom prst="rect">
               <a:avLst/>
             </a:prstGeom>
-            <a:solidFill>
-              <a:schemeClr val="accent5"/>
-            </a:solidFill>
-            <a:ln>
-              <a:noFill/>
-            </a:ln>
+            <a:noFill/>
           </p:spPr>
-          <p:style>
-            <a:lnRef idx="2">
-              <a:schemeClr val="accent1">
-                <a:shade val="50000"/>
-              </a:schemeClr>
-            </a:lnRef>
-            <a:fillRef idx="1">
-              <a:schemeClr val="accent1"/>
-            </a:fillRef>
-            <a:effectRef idx="0">
-              <a:schemeClr val="accent1"/>
-            </a:effectRef>
-            <a:fontRef idx="minor">
-              <a:schemeClr val="lt1"/>
-            </a:fontRef>
-          </p:style>
           <p:txBody>
-            <a:bodyPr rtlCol="0" anchor="ctr"/>
+            <a:bodyPr wrap="none" rtlCol="0">
+              <a:spAutoFit/>
+            </a:bodyPr>
             <a:lstStyle/>
             <a:p>
-              <a:pPr algn="ctr"/>
-              <a:endParaRPr lang="ko-KR" altLang="en-US">
-                <a:latin typeface="나눔스퀘어 Bold" panose="020B0600000101010101" pitchFamily="50" charset="-127"/>
-                <a:ea typeface="나눔스퀘어 Bold" panose="020B0600000101010101" pitchFamily="50" charset="-127"/>
-              </a:endParaRPr>
-            </a:p>
-          </p:txBody>
-        </p:sp>
-        <p:sp>
-          <p:nvSpPr>
-            <p:cNvPr id="58" name="아래쪽 화살표 57"/>
-            <p:cNvSpPr/>
-            <p:nvPr/>
-          </p:nvSpPr>
-          <p:spPr>
-            <a:xfrm>
-              <a:off x="6560112" y="2086314"/>
-              <a:ext cx="540000" cy="540000"/>
-            </a:xfrm>
-            <a:prstGeom prst="downArrow">
-              <a:avLst/>
-            </a:prstGeom>
-            <a:solidFill>
-              <a:schemeClr val="accent5"/>
-            </a:solidFill>
-            <a:ln>
-              <a:noFill/>
-            </a:ln>
-          </p:spPr>
-          <p:style>
-            <a:lnRef idx="2">
-              <a:schemeClr val="accent1">
-                <a:shade val="50000"/>
-              </a:schemeClr>
-            </a:lnRef>
-            <a:fillRef idx="1">
-              <a:schemeClr val="accent1"/>
-            </a:fillRef>
-            <a:effectRef idx="0">
-              <a:schemeClr val="accent1"/>
-            </a:effectRef>
-            <a:fontRef idx="minor">
-              <a:schemeClr val="lt1"/>
-            </a:fontRef>
-          </p:style>
-          <p:txBody>
-            <a:bodyPr rtlCol="0" anchor="ctr"/>
-            <a:lstStyle/>
-            <a:p>
-              <a:pPr algn="ctr"/>
-              <a:endParaRPr lang="ko-KR" altLang="en-US">
-                <a:latin typeface="나눔스퀘어 Bold" panose="020B0600000101010101" pitchFamily="50" charset="-127"/>
-                <a:ea typeface="나눔스퀘어 Bold" panose="020B0600000101010101" pitchFamily="50" charset="-127"/>
-              </a:endParaRPr>
-            </a:p>
-          </p:txBody>
-        </p:sp>
-        <p:sp>
-          <p:nvSpPr>
-            <p:cNvPr id="59" name="아래쪽 화살표 58"/>
-            <p:cNvSpPr/>
-            <p:nvPr/>
-          </p:nvSpPr>
-          <p:spPr>
-            <a:xfrm>
-              <a:off x="8704600" y="2086314"/>
-              <a:ext cx="540000" cy="540000"/>
-            </a:xfrm>
-            <a:prstGeom prst="downArrow">
-              <a:avLst/>
-            </a:prstGeom>
-            <a:solidFill>
-              <a:schemeClr val="accent5"/>
-            </a:solidFill>
-            <a:ln>
-              <a:noFill/>
-            </a:ln>
-          </p:spPr>
-          <p:style>
-            <a:lnRef idx="2">
-              <a:schemeClr val="accent1">
-                <a:shade val="50000"/>
-              </a:schemeClr>
-            </a:lnRef>
-            <a:fillRef idx="1">
-              <a:schemeClr val="accent1"/>
-            </a:fillRef>
-            <a:effectRef idx="0">
-              <a:schemeClr val="accent1"/>
-            </a:effectRef>
-            <a:fontRef idx="minor">
-              <a:schemeClr val="lt1"/>
-            </a:fontRef>
-          </p:style>
-          <p:txBody>
-            <a:bodyPr rtlCol="0" anchor="ctr"/>
-            <a:lstStyle/>
-            <a:p>
-              <a:pPr algn="ctr"/>
-              <a:endParaRPr lang="ko-KR" altLang="en-US">
-                <a:latin typeface="나눔스퀘어 Bold" panose="020B0600000101010101" pitchFamily="50" charset="-127"/>
-                <a:ea typeface="나눔스퀘어 Bold" panose="020B0600000101010101" pitchFamily="50" charset="-127"/>
-              </a:endParaRPr>
-            </a:p>
-          </p:txBody>
-        </p:sp>
-        <p:sp>
-          <p:nvSpPr>
-            <p:cNvPr id="61" name="모서리가 둥근 직사각형 60"/>
-            <p:cNvSpPr/>
-            <p:nvPr/>
-          </p:nvSpPr>
-          <p:spPr>
-            <a:xfrm>
-              <a:off x="9859088" y="2435100"/>
-              <a:ext cx="1980000" cy="540000"/>
-            </a:xfrm>
-            <a:prstGeom prst="roundRect">
-              <a:avLst/>
-            </a:prstGeom>
-            <a:solidFill>
-              <a:schemeClr val="bg1">
-                <a:lumMod val="85000"/>
-              </a:schemeClr>
-            </a:solidFill>
-            <a:ln>
-              <a:noFill/>
-            </a:ln>
-          </p:spPr>
-          <p:style>
-            <a:lnRef idx="2">
-              <a:schemeClr val="accent1">
-                <a:shade val="50000"/>
-              </a:schemeClr>
-            </a:lnRef>
-            <a:fillRef idx="1">
-              <a:schemeClr val="accent1"/>
-            </a:fillRef>
-            <a:effectRef idx="0">
-              <a:schemeClr val="accent1"/>
-            </a:effectRef>
-            <a:fontRef idx="minor">
-              <a:schemeClr val="lt1"/>
-            </a:fontRef>
-          </p:style>
-          <p:txBody>
-            <a:bodyPr rtlCol="0" anchor="ctr"/>
-            <a:lstStyle/>
-            <a:p>
-              <a:pPr algn="ctr"/>
               <a:r>
-                <a:rPr lang="ko-KR" altLang="en-US" sz="2000" dirty="0" err="1" smtClean="0">
-                  <a:solidFill>
-                    <a:schemeClr val="tx1"/>
-                  </a:solidFill>
+                <a:rPr lang="ko-KR" altLang="en-US" dirty="0" err="1" smtClean="0">
                   <a:latin typeface="나눔스퀘어 Bold" panose="020B0600000101010101" pitchFamily="50" charset="-127"/>
                   <a:ea typeface="나눔스퀘어 Bold" panose="020B0600000101010101" pitchFamily="50" charset="-127"/>
                 </a:rPr>
-                <a:t>넓은접근</a:t>
+                <a:t>생성자를</a:t>
               </a:r>
               <a:r>
-                <a:rPr lang="ko-KR" altLang="en-US" sz="2000" dirty="0" smtClean="0">
-                  <a:solidFill>
-                    <a:schemeClr val="tx1"/>
-                  </a:solidFill>
+                <a:rPr lang="ko-KR" altLang="en-US" dirty="0" smtClean="0">
                   <a:latin typeface="나눔스퀘어 Bold" panose="020B0600000101010101" pitchFamily="50" charset="-127"/>
                   <a:ea typeface="나눔스퀘어 Bold" panose="020B0600000101010101" pitchFamily="50" charset="-127"/>
                 </a:rPr>
-                <a:t> 범위</a:t>
+                <a:t> 통한 속성 초기화</a:t>
               </a:r>
-              <a:endParaRPr lang="ko-KR" altLang="en-US" sz="2000" dirty="0">
-                <a:solidFill>
-                  <a:schemeClr val="tx1"/>
-                </a:solidFill>
-                <a:latin typeface="나눔스퀘어 Bold" panose="020B0600000101010101" pitchFamily="50" charset="-127"/>
-                <a:ea typeface="나눔스퀘어 Bold" panose="020B0600000101010101" pitchFamily="50" charset="-127"/>
-              </a:endParaRPr>
-            </a:p>
-          </p:txBody>
-        </p:sp>
-        <p:sp>
-          <p:nvSpPr>
-            <p:cNvPr id="62" name="모서리가 둥근 직사각형 61"/>
-            <p:cNvSpPr/>
-            <p:nvPr/>
-          </p:nvSpPr>
-          <p:spPr>
-            <a:xfrm>
-              <a:off x="-366888" y="2435100"/>
-              <a:ext cx="1980000" cy="540000"/>
-            </a:xfrm>
-            <a:prstGeom prst="roundRect">
-              <a:avLst/>
-            </a:prstGeom>
-            <a:solidFill>
-              <a:schemeClr val="bg1">
-                <a:lumMod val="85000"/>
-              </a:schemeClr>
-            </a:solidFill>
-            <a:ln>
-              <a:noFill/>
-            </a:ln>
-          </p:spPr>
-          <p:style>
-            <a:lnRef idx="2">
-              <a:schemeClr val="accent1">
-                <a:shade val="50000"/>
-              </a:schemeClr>
-            </a:lnRef>
-            <a:fillRef idx="1">
-              <a:schemeClr val="accent1"/>
-            </a:fillRef>
-            <a:effectRef idx="0">
-              <a:schemeClr val="accent1"/>
-            </a:effectRef>
-            <a:fontRef idx="minor">
-              <a:schemeClr val="lt1"/>
-            </a:fontRef>
-          </p:style>
-          <p:txBody>
-            <a:bodyPr rtlCol="0" anchor="ctr"/>
-            <a:lstStyle/>
-            <a:p>
-              <a:pPr algn="ctr"/>
-              <a:r>
-                <a:rPr lang="ko-KR" altLang="en-US" sz="2000" dirty="0" err="1">
-                  <a:solidFill>
-                    <a:schemeClr val="tx1"/>
-                  </a:solidFill>
-                  <a:latin typeface="나눔스퀘어 Bold" panose="020B0600000101010101" pitchFamily="50" charset="-127"/>
-                  <a:ea typeface="나눔스퀘어 Bold" panose="020B0600000101010101" pitchFamily="50" charset="-127"/>
-                </a:rPr>
-                <a:t>좁</a:t>
-              </a:r>
-              <a:r>
-                <a:rPr lang="ko-KR" altLang="en-US" sz="2000" dirty="0" err="1" smtClean="0">
-                  <a:solidFill>
-                    <a:schemeClr val="tx1"/>
-                  </a:solidFill>
-                  <a:latin typeface="나눔스퀘어 Bold" panose="020B0600000101010101" pitchFamily="50" charset="-127"/>
-                  <a:ea typeface="나눔스퀘어 Bold" panose="020B0600000101010101" pitchFamily="50" charset="-127"/>
-                </a:rPr>
-                <a:t>은접근</a:t>
-              </a:r>
-              <a:r>
-                <a:rPr lang="ko-KR" altLang="en-US" sz="2000" dirty="0" smtClean="0">
-                  <a:solidFill>
-                    <a:schemeClr val="tx1"/>
-                  </a:solidFill>
-                  <a:latin typeface="나눔스퀘어 Bold" panose="020B0600000101010101" pitchFamily="50" charset="-127"/>
-                  <a:ea typeface="나눔스퀘어 Bold" panose="020B0600000101010101" pitchFamily="50" charset="-127"/>
-                </a:rPr>
-                <a:t> 범위</a:t>
-              </a:r>
-              <a:endParaRPr lang="ko-KR" altLang="en-US" sz="2000" dirty="0">
-                <a:solidFill>
-                  <a:schemeClr val="tx1"/>
-                </a:solidFill>
+              <a:endParaRPr lang="ko-KR" altLang="en-US" dirty="0">
                 <a:latin typeface="나눔스퀘어 Bold" panose="020B0600000101010101" pitchFamily="50" charset="-127"/>
                 <a:ea typeface="나눔스퀘어 Bold" panose="020B0600000101010101" pitchFamily="50" charset="-127"/>
               </a:endParaRPr>

</xml_diff>

<commit_message>
20260813 commit : See You Later, Notion
</commit_message>
<xml_diff>
--- a/create_notion_img.pptx
+++ b/create_notion_img.pptx
@@ -247,7 +247,7 @@
           <a:p>
             <a:fld id="{7237CE1A-8831-48B5-BA93-72483C6E34E8}" type="datetimeFigureOut">
               <a:rPr lang="ko-KR" altLang="en-US" smtClean="0"/>
-              <a:t>2026-08-12</a:t>
+              <a:t>2026-08-13</a:t>
             </a:fld>
             <a:endParaRPr lang="ko-KR" altLang="en-US"/>
           </a:p>
@@ -417,7 +417,7 @@
           <a:p>
             <a:fld id="{7237CE1A-8831-48B5-BA93-72483C6E34E8}" type="datetimeFigureOut">
               <a:rPr lang="ko-KR" altLang="en-US" smtClean="0"/>
-              <a:t>2026-08-12</a:t>
+              <a:t>2026-08-13</a:t>
             </a:fld>
             <a:endParaRPr lang="ko-KR" altLang="en-US"/>
           </a:p>
@@ -597,7 +597,7 @@
           <a:p>
             <a:fld id="{7237CE1A-8831-48B5-BA93-72483C6E34E8}" type="datetimeFigureOut">
               <a:rPr lang="ko-KR" altLang="en-US" smtClean="0"/>
-              <a:t>2026-08-12</a:t>
+              <a:t>2026-08-13</a:t>
             </a:fld>
             <a:endParaRPr lang="ko-KR" altLang="en-US"/>
           </a:p>
@@ -767,7 +767,7 @@
           <a:p>
             <a:fld id="{7237CE1A-8831-48B5-BA93-72483C6E34E8}" type="datetimeFigureOut">
               <a:rPr lang="ko-KR" altLang="en-US" smtClean="0"/>
-              <a:t>2026-08-12</a:t>
+              <a:t>2026-08-13</a:t>
             </a:fld>
             <a:endParaRPr lang="ko-KR" altLang="en-US"/>
           </a:p>
@@ -1013,7 +1013,7 @@
           <a:p>
             <a:fld id="{7237CE1A-8831-48B5-BA93-72483C6E34E8}" type="datetimeFigureOut">
               <a:rPr lang="ko-KR" altLang="en-US" smtClean="0"/>
-              <a:t>2026-08-12</a:t>
+              <a:t>2026-08-13</a:t>
             </a:fld>
             <a:endParaRPr lang="ko-KR" altLang="en-US"/>
           </a:p>
@@ -1245,7 +1245,7 @@
           <a:p>
             <a:fld id="{7237CE1A-8831-48B5-BA93-72483C6E34E8}" type="datetimeFigureOut">
               <a:rPr lang="ko-KR" altLang="en-US" smtClean="0"/>
-              <a:t>2026-08-12</a:t>
+              <a:t>2026-08-13</a:t>
             </a:fld>
             <a:endParaRPr lang="ko-KR" altLang="en-US"/>
           </a:p>
@@ -1612,7 +1612,7 @@
           <a:p>
             <a:fld id="{7237CE1A-8831-48B5-BA93-72483C6E34E8}" type="datetimeFigureOut">
               <a:rPr lang="ko-KR" altLang="en-US" smtClean="0"/>
-              <a:t>2026-08-12</a:t>
+              <a:t>2026-08-13</a:t>
             </a:fld>
             <a:endParaRPr lang="ko-KR" altLang="en-US"/>
           </a:p>
@@ -1730,7 +1730,7 @@
           <a:p>
             <a:fld id="{7237CE1A-8831-48B5-BA93-72483C6E34E8}" type="datetimeFigureOut">
               <a:rPr lang="ko-KR" altLang="en-US" smtClean="0"/>
-              <a:t>2026-08-12</a:t>
+              <a:t>2026-08-13</a:t>
             </a:fld>
             <a:endParaRPr lang="ko-KR" altLang="en-US"/>
           </a:p>
@@ -1825,7 +1825,7 @@
           <a:p>
             <a:fld id="{7237CE1A-8831-48B5-BA93-72483C6E34E8}" type="datetimeFigureOut">
               <a:rPr lang="ko-KR" altLang="en-US" smtClean="0"/>
-              <a:t>2026-08-12</a:t>
+              <a:t>2026-08-13</a:t>
             </a:fld>
             <a:endParaRPr lang="ko-KR" altLang="en-US"/>
           </a:p>
@@ -2102,7 +2102,7 @@
           <a:p>
             <a:fld id="{7237CE1A-8831-48B5-BA93-72483C6E34E8}" type="datetimeFigureOut">
               <a:rPr lang="ko-KR" altLang="en-US" smtClean="0"/>
-              <a:t>2026-08-12</a:t>
+              <a:t>2026-08-13</a:t>
             </a:fld>
             <a:endParaRPr lang="ko-KR" altLang="en-US"/>
           </a:p>
@@ -2355,7 +2355,7 @@
           <a:p>
             <a:fld id="{7237CE1A-8831-48B5-BA93-72483C6E34E8}" type="datetimeFigureOut">
               <a:rPr lang="ko-KR" altLang="en-US" smtClean="0"/>
-              <a:t>2026-08-12</a:t>
+              <a:t>2026-08-13</a:t>
             </a:fld>
             <a:endParaRPr lang="ko-KR" altLang="en-US"/>
           </a:p>
@@ -2568,7 +2568,7 @@
           <a:p>
             <a:fld id="{7237CE1A-8831-48B5-BA93-72483C6E34E8}" type="datetimeFigureOut">
               <a:rPr lang="ko-KR" altLang="en-US" smtClean="0"/>
-              <a:t>2026-08-12</a:t>
+              <a:t>2026-08-13</a:t>
             </a:fld>
             <a:endParaRPr lang="ko-KR" altLang="en-US"/>
           </a:p>
@@ -3893,39 +3893,39 @@
       </p:grpSpPr>
       <p:grpSp>
         <p:nvGrpSpPr>
-          <p:cNvPr id="46" name="그룹 45"/>
+          <p:cNvPr id="11" name="그룹 10"/>
           <p:cNvGrpSpPr/>
           <p:nvPr/>
         </p:nvGrpSpPr>
         <p:grpSpPr>
           <a:xfrm>
-            <a:off x="4373457" y="942360"/>
-            <a:ext cx="6966223" cy="3455564"/>
-            <a:chOff x="4373457" y="942360"/>
-            <a:chExt cx="6966223" cy="3455564"/>
+            <a:off x="1857829" y="769257"/>
+            <a:ext cx="5962748" cy="5013372"/>
+            <a:chOff x="1857829" y="769257"/>
+            <a:chExt cx="5962748" cy="5013372"/>
           </a:xfrm>
         </p:grpSpPr>
         <p:sp>
           <p:nvSpPr>
-            <p:cNvPr id="254" name="직사각형 253"/>
-            <p:cNvSpPr>
-              <a:spLocks noChangeAspect="1"/>
-            </p:cNvSpPr>
+            <p:cNvPr id="2" name="모서리가 둥근 직사각형 1"/>
+            <p:cNvSpPr/>
             <p:nvPr/>
           </p:nvSpPr>
           <p:spPr>
             <a:xfrm>
-              <a:off x="4373457" y="942372"/>
-              <a:ext cx="864000" cy="863891"/>
+              <a:off x="1857829" y="769257"/>
+              <a:ext cx="3600000" cy="1080000"/>
             </a:xfrm>
-            <a:prstGeom prst="rect">
+            <a:prstGeom prst="roundRect">
               <a:avLst/>
             </a:prstGeom>
-            <a:noFill/>
-            <a:ln w="19050">
-              <a:solidFill>
-                <a:schemeClr val="tx1"/>
-              </a:solidFill>
+            <a:solidFill>
+              <a:schemeClr val="bg2">
+                <a:lumMod val="90000"/>
+              </a:schemeClr>
+            </a:solidFill>
+            <a:ln>
+              <a:noFill/>
             </a:ln>
           </p:spPr>
           <p:style>
@@ -3949,31 +3949,47 @@
             <a:lstStyle/>
             <a:p>
               <a:pPr algn="ctr"/>
-              <a:endParaRPr lang="ko-KR" altLang="en-US"/>
+              <a:r>
+                <a:rPr lang="en-US" altLang="ko-KR" sz="2600" dirty="0" err="1" smtClean="0">
+                  <a:solidFill>
+                    <a:schemeClr val="tx1"/>
+                  </a:solidFill>
+                  <a:latin typeface="나눔스퀘어 Bold" panose="020B0600000101010101" pitchFamily="50" charset="-127"/>
+                  <a:ea typeface="나눔스퀘어 Bold" panose="020B0600000101010101" pitchFamily="50" charset="-127"/>
+                </a:rPr>
+                <a:t>GrandParentsClass</a:t>
+              </a:r>
+              <a:endParaRPr lang="ko-KR" altLang="en-US" sz="2600" dirty="0">
+                <a:solidFill>
+                  <a:schemeClr val="tx1"/>
+                </a:solidFill>
+                <a:latin typeface="나눔스퀘어 Bold" panose="020B0600000101010101" pitchFamily="50" charset="-127"/>
+                <a:ea typeface="나눔스퀘어 Bold" panose="020B0600000101010101" pitchFamily="50" charset="-127"/>
+              </a:endParaRPr>
             </a:p>
           </p:txBody>
         </p:sp>
         <p:sp>
           <p:nvSpPr>
-            <p:cNvPr id="256" name="직사각형 255"/>
-            <p:cNvSpPr>
-              <a:spLocks noChangeAspect="1"/>
-            </p:cNvSpPr>
+            <p:cNvPr id="57" name="모서리가 둥근 직사각형 56"/>
+            <p:cNvSpPr/>
             <p:nvPr/>
           </p:nvSpPr>
           <p:spPr>
             <a:xfrm>
-              <a:off x="5237457" y="942372"/>
-              <a:ext cx="864000" cy="863891"/>
+              <a:off x="1857829" y="2735943"/>
+              <a:ext cx="3600000" cy="1080000"/>
             </a:xfrm>
-            <a:prstGeom prst="rect">
+            <a:prstGeom prst="roundRect">
               <a:avLst/>
             </a:prstGeom>
-            <a:noFill/>
-            <a:ln w="19050">
-              <a:solidFill>
-                <a:schemeClr val="tx1"/>
-              </a:solidFill>
+            <a:solidFill>
+              <a:schemeClr val="bg2">
+                <a:lumMod val="90000"/>
+              </a:schemeClr>
+            </a:solidFill>
+            <a:ln>
+              <a:noFill/>
             </a:ln>
           </p:spPr>
           <p:style>
@@ -3997,31 +4013,47 @@
             <a:lstStyle/>
             <a:p>
               <a:pPr algn="ctr"/>
-              <a:endParaRPr lang="ko-KR" altLang="en-US"/>
+              <a:r>
+                <a:rPr lang="en-US" altLang="ko-KR" sz="2600" dirty="0" err="1" smtClean="0">
+                  <a:solidFill>
+                    <a:schemeClr val="tx1"/>
+                  </a:solidFill>
+                  <a:latin typeface="나눔스퀘어 Bold" panose="020B0600000101010101" pitchFamily="50" charset="-127"/>
+                  <a:ea typeface="나눔스퀘어 Bold" panose="020B0600000101010101" pitchFamily="50" charset="-127"/>
+                </a:rPr>
+                <a:t>ParentsClass</a:t>
+              </a:r>
+              <a:endParaRPr lang="ko-KR" altLang="en-US" sz="2600" dirty="0">
+                <a:solidFill>
+                  <a:schemeClr val="tx1"/>
+                </a:solidFill>
+                <a:latin typeface="나눔스퀘어 Bold" panose="020B0600000101010101" pitchFamily="50" charset="-127"/>
+                <a:ea typeface="나눔스퀘어 Bold" panose="020B0600000101010101" pitchFamily="50" charset="-127"/>
+              </a:endParaRPr>
             </a:p>
           </p:txBody>
         </p:sp>
         <p:sp>
           <p:nvSpPr>
-            <p:cNvPr id="258" name="직사각형 257"/>
-            <p:cNvSpPr>
-              <a:spLocks noChangeAspect="1"/>
-            </p:cNvSpPr>
+            <p:cNvPr id="58" name="모서리가 둥근 직사각형 57"/>
+            <p:cNvSpPr/>
             <p:nvPr/>
           </p:nvSpPr>
           <p:spPr>
             <a:xfrm>
-              <a:off x="6101456" y="942372"/>
-              <a:ext cx="864000" cy="863891"/>
+              <a:off x="1857829" y="4702629"/>
+              <a:ext cx="3600000" cy="1080000"/>
             </a:xfrm>
-            <a:prstGeom prst="rect">
+            <a:prstGeom prst="roundRect">
               <a:avLst/>
             </a:prstGeom>
-            <a:noFill/>
-            <a:ln w="19050">
-              <a:solidFill>
-                <a:schemeClr val="tx1"/>
-              </a:solidFill>
+            <a:solidFill>
+              <a:schemeClr val="bg2">
+                <a:lumMod val="90000"/>
+              </a:schemeClr>
+            </a:solidFill>
+            <a:ln>
+              <a:noFill/>
             </a:ln>
           </p:spPr>
           <p:style>
@@ -4045,1682 +4077,120 @@
             <a:lstStyle/>
             <a:p>
               <a:pPr algn="ctr"/>
-              <a:endParaRPr lang="ko-KR" altLang="en-US"/>
+              <a:r>
+                <a:rPr lang="en-US" altLang="ko-KR" sz="2600" dirty="0" err="1" smtClean="0">
+                  <a:solidFill>
+                    <a:schemeClr val="tx1"/>
+                  </a:solidFill>
+                  <a:latin typeface="나눔스퀘어 Bold" panose="020B0600000101010101" pitchFamily="50" charset="-127"/>
+                  <a:ea typeface="나눔스퀘어 Bold" panose="020B0600000101010101" pitchFamily="50" charset="-127"/>
+                </a:rPr>
+                <a:t>ChindClass</a:t>
+              </a:r>
+              <a:endParaRPr lang="ko-KR" altLang="en-US" sz="2600" dirty="0">
+                <a:solidFill>
+                  <a:schemeClr val="tx1"/>
+                </a:solidFill>
+                <a:latin typeface="나눔스퀘어 Bold" panose="020B0600000101010101" pitchFamily="50" charset="-127"/>
+                <a:ea typeface="나눔스퀘어 Bold" panose="020B0600000101010101" pitchFamily="50" charset="-127"/>
+              </a:endParaRPr>
             </a:p>
           </p:txBody>
         </p:sp>
-        <p:sp>
-          <p:nvSpPr>
-            <p:cNvPr id="260" name="직사각형 259"/>
-            <p:cNvSpPr>
-              <a:spLocks noChangeAspect="1"/>
-            </p:cNvSpPr>
+        <p:cxnSp>
+          <p:nvCxnSpPr>
+            <p:cNvPr id="4" name="직선 화살표 연결선 3"/>
+            <p:cNvCxnSpPr>
+              <a:stCxn id="58" idx="0"/>
+              <a:endCxn id="57" idx="2"/>
+            </p:cNvCxnSpPr>
             <p:nvPr/>
-          </p:nvSpPr>
+          </p:nvCxnSpPr>
           <p:spPr>
-            <a:xfrm>
-              <a:off x="6965456" y="942372"/>
-              <a:ext cx="864000" cy="863891"/>
+            <a:xfrm flipV="1">
+              <a:off x="3657829" y="3815943"/>
+              <a:ext cx="0" cy="886686"/>
             </a:xfrm>
-            <a:prstGeom prst="rect">
+            <a:prstGeom prst="straightConnector1">
               <a:avLst/>
             </a:prstGeom>
-            <a:noFill/>
-            <a:ln w="19050">
+            <a:ln w="76200">
               <a:solidFill>
-                <a:schemeClr val="tx1"/>
+                <a:schemeClr val="accent2"/>
               </a:solidFill>
+              <a:tailEnd type="triangle"/>
             </a:ln>
           </p:spPr>
           <p:style>
-            <a:lnRef idx="2">
-              <a:schemeClr val="accent1">
-                <a:shade val="50000"/>
-              </a:schemeClr>
+            <a:lnRef idx="1">
+              <a:schemeClr val="accent1"/>
             </a:lnRef>
-            <a:fillRef idx="1">
+            <a:fillRef idx="0">
               <a:schemeClr val="accent1"/>
             </a:fillRef>
             <a:effectRef idx="0">
               <a:schemeClr val="accent1"/>
             </a:effectRef>
             <a:fontRef idx="minor">
-              <a:schemeClr val="lt1"/>
+              <a:schemeClr val="tx1"/>
             </a:fontRef>
           </p:style>
-          <p:txBody>
-            <a:bodyPr rtlCol="0" anchor="ctr"/>
-            <a:lstStyle/>
-            <a:p>
-              <a:pPr algn="ctr"/>
-              <a:endParaRPr lang="ko-KR" altLang="en-US"/>
-            </a:p>
-          </p:txBody>
-        </p:sp>
-        <p:sp>
-          <p:nvSpPr>
-            <p:cNvPr id="262" name="직사각형 261"/>
-            <p:cNvSpPr>
-              <a:spLocks noChangeAspect="1"/>
-            </p:cNvSpPr>
+        </p:cxnSp>
+        <p:cxnSp>
+          <p:nvCxnSpPr>
+            <p:cNvPr id="61" name="직선 화살표 연결선 60"/>
+            <p:cNvCxnSpPr>
+              <a:stCxn id="57" idx="0"/>
+              <a:endCxn id="2" idx="2"/>
+            </p:cNvCxnSpPr>
             <p:nvPr/>
-          </p:nvSpPr>
+          </p:nvCxnSpPr>
           <p:spPr>
-            <a:xfrm>
-              <a:off x="7829455" y="942372"/>
-              <a:ext cx="864000" cy="863891"/>
+            <a:xfrm flipV="1">
+              <a:off x="3657829" y="1849257"/>
+              <a:ext cx="0" cy="886686"/>
             </a:xfrm>
-            <a:prstGeom prst="rect">
+            <a:prstGeom prst="straightConnector1">
               <a:avLst/>
             </a:prstGeom>
-            <a:noFill/>
-            <a:ln w="19050">
+            <a:ln w="76200">
               <a:solidFill>
-                <a:schemeClr val="tx1"/>
+                <a:schemeClr val="accent2"/>
               </a:solidFill>
+              <a:tailEnd type="triangle"/>
             </a:ln>
           </p:spPr>
           <p:style>
-            <a:lnRef idx="2">
-              <a:schemeClr val="accent1">
-                <a:shade val="50000"/>
-              </a:schemeClr>
+            <a:lnRef idx="1">
+              <a:schemeClr val="accent1"/>
             </a:lnRef>
-            <a:fillRef idx="1">
+            <a:fillRef idx="0">
               <a:schemeClr val="accent1"/>
             </a:fillRef>
             <a:effectRef idx="0">
               <a:schemeClr val="accent1"/>
             </a:effectRef>
             <a:fontRef idx="minor">
-              <a:schemeClr val="lt1"/>
+              <a:schemeClr val="tx1"/>
             </a:fontRef>
           </p:style>
-          <p:txBody>
-            <a:bodyPr rtlCol="0" anchor="ctr"/>
-            <a:lstStyle/>
-            <a:p>
-              <a:pPr algn="ctr"/>
-              <a:endParaRPr lang="ko-KR" altLang="en-US"/>
-            </a:p>
-          </p:txBody>
-        </p:sp>
+        </p:cxnSp>
         <p:sp>
           <p:nvSpPr>
-            <p:cNvPr id="264" name="직사각형 263"/>
-            <p:cNvSpPr>
-              <a:spLocks noChangeAspect="1"/>
-            </p:cNvSpPr>
-            <p:nvPr/>
-          </p:nvSpPr>
-          <p:spPr>
-            <a:xfrm>
-              <a:off x="4373457" y="1806263"/>
-              <a:ext cx="864000" cy="863891"/>
-            </a:xfrm>
-            <a:prstGeom prst="rect">
-              <a:avLst/>
-            </a:prstGeom>
-            <a:noFill/>
-            <a:ln w="19050">
-              <a:solidFill>
-                <a:schemeClr val="tx1"/>
-              </a:solidFill>
-            </a:ln>
-          </p:spPr>
-          <p:style>
-            <a:lnRef idx="2">
-              <a:schemeClr val="accent1">
-                <a:shade val="50000"/>
-              </a:schemeClr>
-            </a:lnRef>
-            <a:fillRef idx="1">
-              <a:schemeClr val="accent1"/>
-            </a:fillRef>
-            <a:effectRef idx="0">
-              <a:schemeClr val="accent1"/>
-            </a:effectRef>
-            <a:fontRef idx="minor">
-              <a:schemeClr val="lt1"/>
-            </a:fontRef>
-          </p:style>
-          <p:txBody>
-            <a:bodyPr rtlCol="0" anchor="ctr"/>
-            <a:lstStyle/>
-            <a:p>
-              <a:pPr algn="ctr"/>
-              <a:endParaRPr lang="ko-KR" altLang="en-US"/>
-            </a:p>
-          </p:txBody>
-        </p:sp>
-        <p:sp>
-          <p:nvSpPr>
-            <p:cNvPr id="266" name="직사각형 265"/>
-            <p:cNvSpPr>
-              <a:spLocks noChangeAspect="1"/>
-            </p:cNvSpPr>
-            <p:nvPr/>
-          </p:nvSpPr>
-          <p:spPr>
-            <a:xfrm>
-              <a:off x="5237457" y="1806263"/>
-              <a:ext cx="864000" cy="863891"/>
-            </a:xfrm>
-            <a:prstGeom prst="rect">
-              <a:avLst/>
-            </a:prstGeom>
-            <a:noFill/>
-            <a:ln w="19050">
-              <a:solidFill>
-                <a:schemeClr val="tx1"/>
-              </a:solidFill>
-            </a:ln>
-          </p:spPr>
-          <p:style>
-            <a:lnRef idx="2">
-              <a:schemeClr val="accent1">
-                <a:shade val="50000"/>
-              </a:schemeClr>
-            </a:lnRef>
-            <a:fillRef idx="1">
-              <a:schemeClr val="accent1"/>
-            </a:fillRef>
-            <a:effectRef idx="0">
-              <a:schemeClr val="accent1"/>
-            </a:effectRef>
-            <a:fontRef idx="minor">
-              <a:schemeClr val="lt1"/>
-            </a:fontRef>
-          </p:style>
-          <p:txBody>
-            <a:bodyPr rtlCol="0" anchor="ctr"/>
-            <a:lstStyle/>
-            <a:p>
-              <a:pPr algn="ctr"/>
-              <a:endParaRPr lang="ko-KR" altLang="en-US"/>
-            </a:p>
-          </p:txBody>
-        </p:sp>
-        <p:sp>
-          <p:nvSpPr>
-            <p:cNvPr id="267" name="TextBox 266"/>
-            <p:cNvSpPr txBox="1"/>
-            <p:nvPr/>
-          </p:nvSpPr>
-          <p:spPr>
-            <a:xfrm>
-              <a:off x="5183228" y="1806259"/>
-              <a:ext cx="972457" cy="338554"/>
-            </a:xfrm>
-            <a:prstGeom prst="rect">
-              <a:avLst/>
-            </a:prstGeom>
-            <a:noFill/>
-          </p:spPr>
-          <p:txBody>
-            <a:bodyPr wrap="square" rtlCol="0">
-              <a:spAutoFit/>
-            </a:bodyPr>
-            <a:lstStyle/>
-            <a:p>
-              <a:pPr algn="ctr"/>
-              <a:r>
-                <a:rPr lang="en-US" altLang="ko-KR" sz="1600" dirty="0" smtClean="0">
-                  <a:latin typeface="나눔스퀘어 Bold" panose="020B0600000101010101" pitchFamily="50" charset="-127"/>
-                  <a:ea typeface="나눔스퀘어 Bold" panose="020B0600000101010101" pitchFamily="50" charset="-127"/>
-                </a:rPr>
-                <a:t>12s1</a:t>
-              </a:r>
-              <a:endParaRPr lang="ko-KR" altLang="en-US" sz="1600" dirty="0">
-                <a:latin typeface="나눔스퀘어 Bold" panose="020B0600000101010101" pitchFamily="50" charset="-127"/>
-                <a:ea typeface="나눔스퀘어 Bold" panose="020B0600000101010101" pitchFamily="50" charset="-127"/>
-              </a:endParaRPr>
-            </a:p>
-          </p:txBody>
-        </p:sp>
-        <p:sp>
-          <p:nvSpPr>
-            <p:cNvPr id="268" name="직사각형 267"/>
-            <p:cNvSpPr>
-              <a:spLocks noChangeAspect="1"/>
-            </p:cNvSpPr>
-            <p:nvPr/>
-          </p:nvSpPr>
-          <p:spPr>
-            <a:xfrm>
-              <a:off x="6101456" y="1806263"/>
-              <a:ext cx="864000" cy="863891"/>
-            </a:xfrm>
-            <a:prstGeom prst="rect">
-              <a:avLst/>
-            </a:prstGeom>
-            <a:noFill/>
-            <a:ln w="19050">
-              <a:solidFill>
-                <a:schemeClr val="tx1"/>
-              </a:solidFill>
-            </a:ln>
-          </p:spPr>
-          <p:style>
-            <a:lnRef idx="2">
-              <a:schemeClr val="accent1">
-                <a:shade val="50000"/>
-              </a:schemeClr>
-            </a:lnRef>
-            <a:fillRef idx="1">
-              <a:schemeClr val="accent1"/>
-            </a:fillRef>
-            <a:effectRef idx="0">
-              <a:schemeClr val="accent1"/>
-            </a:effectRef>
-            <a:fontRef idx="minor">
-              <a:schemeClr val="lt1"/>
-            </a:fontRef>
-          </p:style>
-          <p:txBody>
-            <a:bodyPr rtlCol="0" anchor="ctr"/>
-            <a:lstStyle/>
-            <a:p>
-              <a:pPr algn="ctr"/>
-              <a:endParaRPr lang="ko-KR" altLang="en-US"/>
-            </a:p>
-          </p:txBody>
-        </p:sp>
-        <p:sp>
-          <p:nvSpPr>
-            <p:cNvPr id="269" name="TextBox 268"/>
-            <p:cNvSpPr txBox="1"/>
-            <p:nvPr/>
-          </p:nvSpPr>
-          <p:spPr>
-            <a:xfrm>
-              <a:off x="6047227" y="1806259"/>
-              <a:ext cx="972457" cy="338554"/>
-            </a:xfrm>
-            <a:prstGeom prst="rect">
-              <a:avLst/>
-            </a:prstGeom>
-            <a:noFill/>
-          </p:spPr>
-          <p:txBody>
-            <a:bodyPr wrap="square" rtlCol="0">
-              <a:spAutoFit/>
-            </a:bodyPr>
-            <a:lstStyle/>
-            <a:p>
-              <a:pPr algn="ctr"/>
-              <a:r>
-                <a:rPr lang="en-US" altLang="ko-KR" sz="1600" dirty="0" smtClean="0">
-                  <a:latin typeface="나눔스퀘어 Bold" panose="020B0600000101010101" pitchFamily="50" charset="-127"/>
-                  <a:ea typeface="나눔스퀘어 Bold" panose="020B0600000101010101" pitchFamily="50" charset="-127"/>
-                </a:rPr>
-                <a:t>12s2</a:t>
-              </a:r>
-              <a:endParaRPr lang="ko-KR" altLang="en-US" sz="1600" dirty="0">
-                <a:latin typeface="나눔스퀘어 Bold" panose="020B0600000101010101" pitchFamily="50" charset="-127"/>
-                <a:ea typeface="나눔스퀘어 Bold" panose="020B0600000101010101" pitchFamily="50" charset="-127"/>
-              </a:endParaRPr>
-            </a:p>
-          </p:txBody>
-        </p:sp>
-        <p:sp>
-          <p:nvSpPr>
-            <p:cNvPr id="270" name="직사각형 269"/>
-            <p:cNvSpPr>
-              <a:spLocks noChangeAspect="1"/>
-            </p:cNvSpPr>
-            <p:nvPr/>
-          </p:nvSpPr>
-          <p:spPr>
-            <a:xfrm>
-              <a:off x="6965456" y="1806263"/>
-              <a:ext cx="864000" cy="863891"/>
-            </a:xfrm>
-            <a:prstGeom prst="rect">
-              <a:avLst/>
-            </a:prstGeom>
-            <a:noFill/>
-            <a:ln w="19050">
-              <a:solidFill>
-                <a:schemeClr val="tx1"/>
-              </a:solidFill>
-            </a:ln>
-          </p:spPr>
-          <p:style>
-            <a:lnRef idx="2">
-              <a:schemeClr val="accent1">
-                <a:shade val="50000"/>
-              </a:schemeClr>
-            </a:lnRef>
-            <a:fillRef idx="1">
-              <a:schemeClr val="accent1"/>
-            </a:fillRef>
-            <a:effectRef idx="0">
-              <a:schemeClr val="accent1"/>
-            </a:effectRef>
-            <a:fontRef idx="minor">
-              <a:schemeClr val="lt1"/>
-            </a:fontRef>
-          </p:style>
-          <p:txBody>
-            <a:bodyPr rtlCol="0" anchor="ctr"/>
-            <a:lstStyle/>
-            <a:p>
-              <a:pPr algn="ctr"/>
-              <a:endParaRPr lang="ko-KR" altLang="en-US"/>
-            </a:p>
-          </p:txBody>
-        </p:sp>
-        <p:sp>
-          <p:nvSpPr>
-            <p:cNvPr id="272" name="직사각형 271"/>
-            <p:cNvSpPr>
-              <a:spLocks noChangeAspect="1"/>
-            </p:cNvSpPr>
-            <p:nvPr/>
-          </p:nvSpPr>
-          <p:spPr>
-            <a:xfrm>
-              <a:off x="7829455" y="1806263"/>
-              <a:ext cx="864000" cy="863891"/>
-            </a:xfrm>
-            <a:prstGeom prst="rect">
-              <a:avLst/>
-            </a:prstGeom>
-            <a:noFill/>
-            <a:ln w="19050">
-              <a:solidFill>
-                <a:schemeClr val="tx1"/>
-              </a:solidFill>
-            </a:ln>
-          </p:spPr>
-          <p:style>
-            <a:lnRef idx="2">
-              <a:schemeClr val="accent1">
-                <a:shade val="50000"/>
-              </a:schemeClr>
-            </a:lnRef>
-            <a:fillRef idx="1">
-              <a:schemeClr val="accent1"/>
-            </a:fillRef>
-            <a:effectRef idx="0">
-              <a:schemeClr val="accent1"/>
-            </a:effectRef>
-            <a:fontRef idx="minor">
-              <a:schemeClr val="lt1"/>
-            </a:fontRef>
-          </p:style>
-          <p:txBody>
-            <a:bodyPr rtlCol="0" anchor="ctr"/>
-            <a:lstStyle/>
-            <a:p>
-              <a:pPr algn="ctr"/>
-              <a:endParaRPr lang="ko-KR" altLang="en-US"/>
-            </a:p>
-          </p:txBody>
-        </p:sp>
-        <p:sp>
-          <p:nvSpPr>
-            <p:cNvPr id="274" name="직사각형 273"/>
-            <p:cNvSpPr>
-              <a:spLocks noChangeAspect="1"/>
-            </p:cNvSpPr>
-            <p:nvPr/>
-          </p:nvSpPr>
-          <p:spPr>
-            <a:xfrm>
-              <a:off x="4373457" y="2670150"/>
-              <a:ext cx="864000" cy="863891"/>
-            </a:xfrm>
-            <a:prstGeom prst="rect">
-              <a:avLst/>
-            </a:prstGeom>
-            <a:noFill/>
-            <a:ln w="19050">
-              <a:solidFill>
-                <a:schemeClr val="tx1"/>
-              </a:solidFill>
-            </a:ln>
-          </p:spPr>
-          <p:style>
-            <a:lnRef idx="2">
-              <a:schemeClr val="accent1">
-                <a:shade val="50000"/>
-              </a:schemeClr>
-            </a:lnRef>
-            <a:fillRef idx="1">
-              <a:schemeClr val="accent1"/>
-            </a:fillRef>
-            <a:effectRef idx="0">
-              <a:schemeClr val="accent1"/>
-            </a:effectRef>
-            <a:fontRef idx="minor">
-              <a:schemeClr val="lt1"/>
-            </a:fontRef>
-          </p:style>
-          <p:txBody>
-            <a:bodyPr rtlCol="0" anchor="ctr"/>
-            <a:lstStyle/>
-            <a:p>
-              <a:pPr algn="ctr"/>
-              <a:endParaRPr lang="ko-KR" altLang="en-US"/>
-            </a:p>
-          </p:txBody>
-        </p:sp>
-        <p:sp>
-          <p:nvSpPr>
-            <p:cNvPr id="276" name="직사각형 275"/>
-            <p:cNvSpPr>
-              <a:spLocks noChangeAspect="1"/>
-            </p:cNvSpPr>
-            <p:nvPr/>
-          </p:nvSpPr>
-          <p:spPr>
-            <a:xfrm>
-              <a:off x="5237457" y="2670150"/>
-              <a:ext cx="864000" cy="863891"/>
-            </a:xfrm>
-            <a:prstGeom prst="rect">
-              <a:avLst/>
-            </a:prstGeom>
-            <a:noFill/>
-            <a:ln w="19050">
-              <a:solidFill>
-                <a:schemeClr val="tx1"/>
-              </a:solidFill>
-            </a:ln>
-          </p:spPr>
-          <p:style>
-            <a:lnRef idx="2">
-              <a:schemeClr val="accent1">
-                <a:shade val="50000"/>
-              </a:schemeClr>
-            </a:lnRef>
-            <a:fillRef idx="1">
-              <a:schemeClr val="accent1"/>
-            </a:fillRef>
-            <a:effectRef idx="0">
-              <a:schemeClr val="accent1"/>
-            </a:effectRef>
-            <a:fontRef idx="minor">
-              <a:schemeClr val="lt1"/>
-            </a:fontRef>
-          </p:style>
-          <p:txBody>
-            <a:bodyPr rtlCol="0" anchor="ctr"/>
-            <a:lstStyle/>
-            <a:p>
-              <a:pPr algn="ctr"/>
-              <a:endParaRPr lang="ko-KR" altLang="en-US"/>
-            </a:p>
-          </p:txBody>
-        </p:sp>
-        <p:sp>
-          <p:nvSpPr>
-            <p:cNvPr id="278" name="직사각형 277"/>
-            <p:cNvSpPr>
-              <a:spLocks noChangeAspect="1"/>
-            </p:cNvSpPr>
-            <p:nvPr/>
-          </p:nvSpPr>
-          <p:spPr>
-            <a:xfrm>
-              <a:off x="6101456" y="2670150"/>
-              <a:ext cx="864000" cy="863891"/>
-            </a:xfrm>
-            <a:prstGeom prst="rect">
-              <a:avLst/>
-            </a:prstGeom>
-            <a:noFill/>
-            <a:ln w="19050">
-              <a:solidFill>
-                <a:schemeClr val="tx1"/>
-              </a:solidFill>
-            </a:ln>
-          </p:spPr>
-          <p:style>
-            <a:lnRef idx="2">
-              <a:schemeClr val="accent1">
-                <a:shade val="50000"/>
-              </a:schemeClr>
-            </a:lnRef>
-            <a:fillRef idx="1">
-              <a:schemeClr val="accent1"/>
-            </a:fillRef>
-            <a:effectRef idx="0">
-              <a:schemeClr val="accent1"/>
-            </a:effectRef>
-            <a:fontRef idx="minor">
-              <a:schemeClr val="lt1"/>
-            </a:fontRef>
-          </p:style>
-          <p:txBody>
-            <a:bodyPr rtlCol="0" anchor="ctr"/>
-            <a:lstStyle/>
-            <a:p>
-              <a:pPr algn="ctr"/>
-              <a:endParaRPr lang="ko-KR" altLang="en-US"/>
-            </a:p>
-          </p:txBody>
-        </p:sp>
-        <p:sp>
-          <p:nvSpPr>
-            <p:cNvPr id="280" name="직사각형 279"/>
-            <p:cNvSpPr>
-              <a:spLocks noChangeAspect="1"/>
-            </p:cNvSpPr>
-            <p:nvPr/>
-          </p:nvSpPr>
-          <p:spPr>
-            <a:xfrm>
-              <a:off x="6965456" y="2670150"/>
-              <a:ext cx="864000" cy="863891"/>
-            </a:xfrm>
-            <a:prstGeom prst="rect">
-              <a:avLst/>
-            </a:prstGeom>
-            <a:noFill/>
-            <a:ln w="19050">
-              <a:solidFill>
-                <a:schemeClr val="tx1"/>
-              </a:solidFill>
-            </a:ln>
-          </p:spPr>
-          <p:style>
-            <a:lnRef idx="2">
-              <a:schemeClr val="accent1">
-                <a:shade val="50000"/>
-              </a:schemeClr>
-            </a:lnRef>
-            <a:fillRef idx="1">
-              <a:schemeClr val="accent1"/>
-            </a:fillRef>
-            <a:effectRef idx="0">
-              <a:schemeClr val="accent1"/>
-            </a:effectRef>
-            <a:fontRef idx="minor">
-              <a:schemeClr val="lt1"/>
-            </a:fontRef>
-          </p:style>
-          <p:txBody>
-            <a:bodyPr rtlCol="0" anchor="ctr"/>
-            <a:lstStyle/>
-            <a:p>
-              <a:pPr algn="ctr"/>
-              <a:endParaRPr lang="ko-KR" altLang="en-US"/>
-            </a:p>
-          </p:txBody>
-        </p:sp>
-        <p:sp>
-          <p:nvSpPr>
-            <p:cNvPr id="282" name="직사각형 281"/>
-            <p:cNvSpPr>
-              <a:spLocks noChangeAspect="1"/>
-            </p:cNvSpPr>
-            <p:nvPr/>
-          </p:nvSpPr>
-          <p:spPr>
-            <a:xfrm>
-              <a:off x="7829455" y="2670150"/>
-              <a:ext cx="864000" cy="863891"/>
-            </a:xfrm>
-            <a:prstGeom prst="rect">
-              <a:avLst/>
-            </a:prstGeom>
-            <a:noFill/>
-            <a:ln w="19050">
-              <a:solidFill>
-                <a:schemeClr val="tx1"/>
-              </a:solidFill>
-            </a:ln>
-          </p:spPr>
-          <p:style>
-            <a:lnRef idx="2">
-              <a:schemeClr val="accent1">
-                <a:shade val="50000"/>
-              </a:schemeClr>
-            </a:lnRef>
-            <a:fillRef idx="1">
-              <a:schemeClr val="accent1"/>
-            </a:fillRef>
-            <a:effectRef idx="0">
-              <a:schemeClr val="accent1"/>
-            </a:effectRef>
-            <a:fontRef idx="minor">
-              <a:schemeClr val="lt1"/>
-            </a:fontRef>
-          </p:style>
-          <p:txBody>
-            <a:bodyPr rtlCol="0" anchor="ctr"/>
-            <a:lstStyle/>
-            <a:p>
-              <a:pPr algn="ctr"/>
-              <a:endParaRPr lang="ko-KR" altLang="en-US"/>
-            </a:p>
-          </p:txBody>
-        </p:sp>
-        <p:sp>
-          <p:nvSpPr>
-            <p:cNvPr id="285" name="직사각형 284"/>
-            <p:cNvSpPr>
-              <a:spLocks noChangeAspect="1"/>
-            </p:cNvSpPr>
-            <p:nvPr/>
-          </p:nvSpPr>
-          <p:spPr>
-            <a:xfrm>
-              <a:off x="8693455" y="942368"/>
-              <a:ext cx="864000" cy="863891"/>
-            </a:xfrm>
-            <a:prstGeom prst="rect">
-              <a:avLst/>
-            </a:prstGeom>
-            <a:noFill/>
-            <a:ln w="19050">
-              <a:solidFill>
-                <a:schemeClr val="tx1"/>
-              </a:solidFill>
-            </a:ln>
-          </p:spPr>
-          <p:style>
-            <a:lnRef idx="2">
-              <a:schemeClr val="accent1">
-                <a:shade val="50000"/>
-              </a:schemeClr>
-            </a:lnRef>
-            <a:fillRef idx="1">
-              <a:schemeClr val="accent1"/>
-            </a:fillRef>
-            <a:effectRef idx="0">
-              <a:schemeClr val="accent1"/>
-            </a:effectRef>
-            <a:fontRef idx="minor">
-              <a:schemeClr val="lt1"/>
-            </a:fontRef>
-          </p:style>
-          <p:txBody>
-            <a:bodyPr rtlCol="0" anchor="ctr"/>
-            <a:lstStyle/>
-            <a:p>
-              <a:pPr algn="ctr"/>
-              <a:endParaRPr lang="ko-KR" altLang="en-US"/>
-            </a:p>
-          </p:txBody>
-        </p:sp>
-        <p:sp>
-          <p:nvSpPr>
-            <p:cNvPr id="287" name="직사각형 286"/>
-            <p:cNvSpPr>
-              <a:spLocks noChangeAspect="1"/>
-            </p:cNvSpPr>
-            <p:nvPr/>
-          </p:nvSpPr>
-          <p:spPr>
-            <a:xfrm>
-              <a:off x="9557454" y="942368"/>
-              <a:ext cx="864000" cy="863891"/>
-            </a:xfrm>
-            <a:prstGeom prst="rect">
-              <a:avLst/>
-            </a:prstGeom>
-            <a:noFill/>
-            <a:ln w="19050">
-              <a:solidFill>
-                <a:schemeClr val="tx1"/>
-              </a:solidFill>
-            </a:ln>
-          </p:spPr>
-          <p:style>
-            <a:lnRef idx="2">
-              <a:schemeClr val="accent1">
-                <a:shade val="50000"/>
-              </a:schemeClr>
-            </a:lnRef>
-            <a:fillRef idx="1">
-              <a:schemeClr val="accent1"/>
-            </a:fillRef>
-            <a:effectRef idx="0">
-              <a:schemeClr val="accent1"/>
-            </a:effectRef>
-            <a:fontRef idx="minor">
-              <a:schemeClr val="lt1"/>
-            </a:fontRef>
-          </p:style>
-          <p:txBody>
-            <a:bodyPr rtlCol="0" anchor="ctr"/>
-            <a:lstStyle/>
-            <a:p>
-              <a:pPr algn="ctr"/>
-              <a:endParaRPr lang="ko-KR" altLang="en-US"/>
-            </a:p>
-          </p:txBody>
-        </p:sp>
-        <p:sp>
-          <p:nvSpPr>
-            <p:cNvPr id="289" name="직사각형 288"/>
-            <p:cNvSpPr>
-              <a:spLocks noChangeAspect="1"/>
-            </p:cNvSpPr>
-            <p:nvPr/>
-          </p:nvSpPr>
-          <p:spPr>
-            <a:xfrm>
-              <a:off x="8693455" y="1806259"/>
-              <a:ext cx="864000" cy="863891"/>
-            </a:xfrm>
-            <a:prstGeom prst="rect">
-              <a:avLst/>
-            </a:prstGeom>
-            <a:noFill/>
-            <a:ln w="19050">
-              <a:solidFill>
-                <a:schemeClr val="tx1"/>
-              </a:solidFill>
-            </a:ln>
-          </p:spPr>
-          <p:style>
-            <a:lnRef idx="2">
-              <a:schemeClr val="accent1">
-                <a:shade val="50000"/>
-              </a:schemeClr>
-            </a:lnRef>
-            <a:fillRef idx="1">
-              <a:schemeClr val="accent1"/>
-            </a:fillRef>
-            <a:effectRef idx="0">
-              <a:schemeClr val="accent1"/>
-            </a:effectRef>
-            <a:fontRef idx="minor">
-              <a:schemeClr val="lt1"/>
-            </a:fontRef>
-          </p:style>
-          <p:txBody>
-            <a:bodyPr rtlCol="0" anchor="ctr"/>
-            <a:lstStyle/>
-            <a:p>
-              <a:pPr algn="ctr"/>
-              <a:endParaRPr lang="ko-KR" altLang="en-US"/>
-            </a:p>
-          </p:txBody>
-        </p:sp>
-        <p:sp>
-          <p:nvSpPr>
-            <p:cNvPr id="291" name="직사각형 290"/>
-            <p:cNvSpPr>
-              <a:spLocks noChangeAspect="1"/>
-            </p:cNvSpPr>
-            <p:nvPr/>
-          </p:nvSpPr>
-          <p:spPr>
-            <a:xfrm>
-              <a:off x="9557454" y="1806259"/>
-              <a:ext cx="864000" cy="863891"/>
-            </a:xfrm>
-            <a:prstGeom prst="rect">
-              <a:avLst/>
-            </a:prstGeom>
-            <a:noFill/>
-            <a:ln w="19050">
-              <a:solidFill>
-                <a:schemeClr val="tx1"/>
-              </a:solidFill>
-            </a:ln>
-          </p:spPr>
-          <p:style>
-            <a:lnRef idx="2">
-              <a:schemeClr val="accent1">
-                <a:shade val="50000"/>
-              </a:schemeClr>
-            </a:lnRef>
-            <a:fillRef idx="1">
-              <a:schemeClr val="accent1"/>
-            </a:fillRef>
-            <a:effectRef idx="0">
-              <a:schemeClr val="accent1"/>
-            </a:effectRef>
-            <a:fontRef idx="minor">
-              <a:schemeClr val="lt1"/>
-            </a:fontRef>
-          </p:style>
-          <p:txBody>
-            <a:bodyPr rtlCol="0" anchor="ctr"/>
-            <a:lstStyle/>
-            <a:p>
-              <a:pPr algn="ctr"/>
-              <a:endParaRPr lang="ko-KR" altLang="en-US"/>
-            </a:p>
-          </p:txBody>
-        </p:sp>
-        <p:sp>
-          <p:nvSpPr>
-            <p:cNvPr id="293" name="직사각형 292"/>
-            <p:cNvSpPr>
-              <a:spLocks noChangeAspect="1"/>
-            </p:cNvSpPr>
-            <p:nvPr/>
-          </p:nvSpPr>
-          <p:spPr>
-            <a:xfrm>
-              <a:off x="8693455" y="2670146"/>
-              <a:ext cx="864000" cy="863891"/>
-            </a:xfrm>
-            <a:prstGeom prst="rect">
-              <a:avLst/>
-            </a:prstGeom>
-            <a:noFill/>
-            <a:ln w="19050">
-              <a:solidFill>
-                <a:schemeClr val="tx1"/>
-              </a:solidFill>
-            </a:ln>
-          </p:spPr>
-          <p:style>
-            <a:lnRef idx="2">
-              <a:schemeClr val="accent1">
-                <a:shade val="50000"/>
-              </a:schemeClr>
-            </a:lnRef>
-            <a:fillRef idx="1">
-              <a:schemeClr val="accent1"/>
-            </a:fillRef>
-            <a:effectRef idx="0">
-              <a:schemeClr val="accent1"/>
-            </a:effectRef>
-            <a:fontRef idx="minor">
-              <a:schemeClr val="lt1"/>
-            </a:fontRef>
-          </p:style>
-          <p:txBody>
-            <a:bodyPr rtlCol="0" anchor="ctr"/>
-            <a:lstStyle/>
-            <a:p>
-              <a:pPr algn="ctr"/>
-              <a:endParaRPr lang="ko-KR" altLang="en-US"/>
-            </a:p>
-          </p:txBody>
-        </p:sp>
-        <p:sp>
-          <p:nvSpPr>
-            <p:cNvPr id="295" name="직사각형 294"/>
-            <p:cNvSpPr>
-              <a:spLocks noChangeAspect="1"/>
-            </p:cNvSpPr>
-            <p:nvPr/>
-          </p:nvSpPr>
-          <p:spPr>
-            <a:xfrm>
-              <a:off x="9557454" y="2670146"/>
-              <a:ext cx="864000" cy="863891"/>
-            </a:xfrm>
-            <a:prstGeom prst="rect">
-              <a:avLst/>
-            </a:prstGeom>
-            <a:noFill/>
-            <a:ln w="19050">
-              <a:solidFill>
-                <a:schemeClr val="tx1"/>
-              </a:solidFill>
-            </a:ln>
-          </p:spPr>
-          <p:style>
-            <a:lnRef idx="2">
-              <a:schemeClr val="accent1">
-                <a:shade val="50000"/>
-              </a:schemeClr>
-            </a:lnRef>
-            <a:fillRef idx="1">
-              <a:schemeClr val="accent1"/>
-            </a:fillRef>
-            <a:effectRef idx="0">
-              <a:schemeClr val="accent1"/>
-            </a:effectRef>
-            <a:fontRef idx="minor">
-              <a:schemeClr val="lt1"/>
-            </a:fontRef>
-          </p:style>
-          <p:txBody>
-            <a:bodyPr rtlCol="0" anchor="ctr"/>
-            <a:lstStyle/>
-            <a:p>
-              <a:pPr algn="ctr"/>
-              <a:endParaRPr lang="ko-KR" altLang="en-US"/>
-            </a:p>
-          </p:txBody>
-        </p:sp>
-        <p:sp>
-          <p:nvSpPr>
-            <p:cNvPr id="296" name="TextBox 295"/>
-            <p:cNvSpPr txBox="1"/>
-            <p:nvPr/>
-          </p:nvSpPr>
-          <p:spPr>
-            <a:xfrm>
-              <a:off x="9503225" y="2670142"/>
-              <a:ext cx="972457" cy="338554"/>
-            </a:xfrm>
-            <a:prstGeom prst="rect">
-              <a:avLst/>
-            </a:prstGeom>
-            <a:noFill/>
-          </p:spPr>
-          <p:txBody>
-            <a:bodyPr wrap="square" rtlCol="0">
-              <a:spAutoFit/>
-            </a:bodyPr>
-            <a:lstStyle/>
-            <a:p>
-              <a:pPr algn="ctr"/>
-              <a:r>
-                <a:rPr lang="en-US" altLang="ko-KR" sz="1600" dirty="0" smtClean="0">
-                  <a:latin typeface="나눔스퀘어 Bold" panose="020B0600000101010101" pitchFamily="50" charset="-127"/>
-                  <a:ea typeface="나눔스퀘어 Bold" panose="020B0600000101010101" pitchFamily="50" charset="-127"/>
-                </a:rPr>
-                <a:t>90h8</a:t>
-              </a:r>
-              <a:endParaRPr lang="ko-KR" altLang="en-US" sz="1600" dirty="0">
-                <a:latin typeface="나눔스퀘어 Bold" panose="020B0600000101010101" pitchFamily="50" charset="-127"/>
-                <a:ea typeface="나눔스퀘어 Bold" panose="020B0600000101010101" pitchFamily="50" charset="-127"/>
-              </a:endParaRPr>
-            </a:p>
-          </p:txBody>
-        </p:sp>
-        <p:sp>
-          <p:nvSpPr>
-            <p:cNvPr id="298" name="직사각형 297"/>
-            <p:cNvSpPr>
-              <a:spLocks noChangeAspect="1"/>
-            </p:cNvSpPr>
-            <p:nvPr/>
-          </p:nvSpPr>
-          <p:spPr>
-            <a:xfrm>
-              <a:off x="4373457" y="3534033"/>
-              <a:ext cx="864000" cy="863891"/>
-            </a:xfrm>
-            <a:prstGeom prst="rect">
-              <a:avLst/>
-            </a:prstGeom>
-            <a:noFill/>
-            <a:ln w="19050">
-              <a:solidFill>
-                <a:schemeClr val="tx1"/>
-              </a:solidFill>
-            </a:ln>
-          </p:spPr>
-          <p:style>
-            <a:lnRef idx="2">
-              <a:schemeClr val="accent1">
-                <a:shade val="50000"/>
-              </a:schemeClr>
-            </a:lnRef>
-            <a:fillRef idx="1">
-              <a:schemeClr val="accent1"/>
-            </a:fillRef>
-            <a:effectRef idx="0">
-              <a:schemeClr val="accent1"/>
-            </a:effectRef>
-            <a:fontRef idx="minor">
-              <a:schemeClr val="lt1"/>
-            </a:fontRef>
-          </p:style>
-          <p:txBody>
-            <a:bodyPr rtlCol="0" anchor="ctr"/>
-            <a:lstStyle/>
-            <a:p>
-              <a:pPr algn="ctr"/>
-              <a:endParaRPr lang="ko-KR" altLang="en-US"/>
-            </a:p>
-          </p:txBody>
-        </p:sp>
-        <p:sp>
-          <p:nvSpPr>
-            <p:cNvPr id="300" name="직사각형 299"/>
-            <p:cNvSpPr>
-              <a:spLocks noChangeAspect="1"/>
-            </p:cNvSpPr>
-            <p:nvPr/>
-          </p:nvSpPr>
-          <p:spPr>
-            <a:xfrm>
-              <a:off x="5237457" y="3534033"/>
-              <a:ext cx="864000" cy="863891"/>
-            </a:xfrm>
-            <a:prstGeom prst="rect">
-              <a:avLst/>
-            </a:prstGeom>
-            <a:noFill/>
-            <a:ln w="19050">
-              <a:solidFill>
-                <a:schemeClr val="tx1"/>
-              </a:solidFill>
-            </a:ln>
-          </p:spPr>
-          <p:style>
-            <a:lnRef idx="2">
-              <a:schemeClr val="accent1">
-                <a:shade val="50000"/>
-              </a:schemeClr>
-            </a:lnRef>
-            <a:fillRef idx="1">
-              <a:schemeClr val="accent1"/>
-            </a:fillRef>
-            <a:effectRef idx="0">
-              <a:schemeClr val="accent1"/>
-            </a:effectRef>
-            <a:fontRef idx="minor">
-              <a:schemeClr val="lt1"/>
-            </a:fontRef>
-          </p:style>
-          <p:txBody>
-            <a:bodyPr rtlCol="0" anchor="ctr"/>
-            <a:lstStyle/>
-            <a:p>
-              <a:pPr algn="ctr"/>
-              <a:endParaRPr lang="ko-KR" altLang="en-US"/>
-            </a:p>
-          </p:txBody>
-        </p:sp>
-        <p:sp>
-          <p:nvSpPr>
-            <p:cNvPr id="302" name="직사각형 301"/>
-            <p:cNvSpPr>
-              <a:spLocks noChangeAspect="1"/>
-            </p:cNvSpPr>
-            <p:nvPr/>
-          </p:nvSpPr>
-          <p:spPr>
-            <a:xfrm>
-              <a:off x="6101456" y="3534033"/>
-              <a:ext cx="864000" cy="863891"/>
-            </a:xfrm>
-            <a:prstGeom prst="rect">
-              <a:avLst/>
-            </a:prstGeom>
-            <a:noFill/>
-            <a:ln w="19050">
-              <a:solidFill>
-                <a:schemeClr val="tx1"/>
-              </a:solidFill>
-            </a:ln>
-          </p:spPr>
-          <p:style>
-            <a:lnRef idx="2">
-              <a:schemeClr val="accent1">
-                <a:shade val="50000"/>
-              </a:schemeClr>
-            </a:lnRef>
-            <a:fillRef idx="1">
-              <a:schemeClr val="accent1"/>
-            </a:fillRef>
-            <a:effectRef idx="0">
-              <a:schemeClr val="accent1"/>
-            </a:effectRef>
-            <a:fontRef idx="minor">
-              <a:schemeClr val="lt1"/>
-            </a:fontRef>
-          </p:style>
-          <p:txBody>
-            <a:bodyPr rtlCol="0" anchor="ctr"/>
-            <a:lstStyle/>
-            <a:p>
-              <a:pPr algn="ctr"/>
-              <a:endParaRPr lang="ko-KR" altLang="en-US"/>
-            </a:p>
-          </p:txBody>
-        </p:sp>
-        <p:sp>
-          <p:nvSpPr>
-            <p:cNvPr id="303" name="TextBox 302"/>
-            <p:cNvSpPr txBox="1"/>
-            <p:nvPr/>
-          </p:nvSpPr>
-          <p:spPr>
-            <a:xfrm>
-              <a:off x="6047227" y="3534029"/>
-              <a:ext cx="972457" cy="338554"/>
-            </a:xfrm>
-            <a:prstGeom prst="rect">
-              <a:avLst/>
-            </a:prstGeom>
-            <a:noFill/>
-          </p:spPr>
-          <p:txBody>
-            <a:bodyPr wrap="square" rtlCol="0">
-              <a:spAutoFit/>
-            </a:bodyPr>
-            <a:lstStyle/>
-            <a:p>
-              <a:pPr algn="ctr"/>
-              <a:r>
-                <a:rPr lang="en-US" altLang="ko-KR" sz="1600" dirty="0" smtClean="0">
-                  <a:latin typeface="나눔스퀘어 Bold" panose="020B0600000101010101" pitchFamily="50" charset="-127"/>
-                  <a:ea typeface="나눔스퀘어 Bold" panose="020B0600000101010101" pitchFamily="50" charset="-127"/>
-                </a:rPr>
-                <a:t>55cv2</a:t>
-              </a:r>
-              <a:endParaRPr lang="ko-KR" altLang="en-US" sz="1600" dirty="0">
-                <a:latin typeface="나눔스퀘어 Bold" panose="020B0600000101010101" pitchFamily="50" charset="-127"/>
-                <a:ea typeface="나눔스퀘어 Bold" panose="020B0600000101010101" pitchFamily="50" charset="-127"/>
-              </a:endParaRPr>
-            </a:p>
-          </p:txBody>
-        </p:sp>
-        <p:sp>
-          <p:nvSpPr>
-            <p:cNvPr id="304" name="직사각형 303"/>
-            <p:cNvSpPr>
-              <a:spLocks noChangeAspect="1"/>
-            </p:cNvSpPr>
-            <p:nvPr/>
-          </p:nvSpPr>
-          <p:spPr>
-            <a:xfrm>
-              <a:off x="6965456" y="3534033"/>
-              <a:ext cx="864000" cy="863891"/>
-            </a:xfrm>
-            <a:prstGeom prst="rect">
-              <a:avLst/>
-            </a:prstGeom>
-            <a:noFill/>
-            <a:ln w="19050">
-              <a:solidFill>
-                <a:schemeClr val="tx1"/>
-              </a:solidFill>
-            </a:ln>
-          </p:spPr>
-          <p:style>
-            <a:lnRef idx="2">
-              <a:schemeClr val="accent1">
-                <a:shade val="50000"/>
-              </a:schemeClr>
-            </a:lnRef>
-            <a:fillRef idx="1">
-              <a:schemeClr val="accent1"/>
-            </a:fillRef>
-            <a:effectRef idx="0">
-              <a:schemeClr val="accent1"/>
-            </a:effectRef>
-            <a:fontRef idx="minor">
-              <a:schemeClr val="lt1"/>
-            </a:fontRef>
-          </p:style>
-          <p:txBody>
-            <a:bodyPr rtlCol="0" anchor="ctr"/>
-            <a:lstStyle/>
-            <a:p>
-              <a:pPr algn="ctr"/>
-              <a:endParaRPr lang="ko-KR" altLang="en-US"/>
-            </a:p>
-          </p:txBody>
-        </p:sp>
-        <p:sp>
-          <p:nvSpPr>
-            <p:cNvPr id="305" name="TextBox 304"/>
-            <p:cNvSpPr txBox="1"/>
-            <p:nvPr/>
-          </p:nvSpPr>
-          <p:spPr>
-            <a:xfrm>
-              <a:off x="6911227" y="3534029"/>
-              <a:ext cx="972457" cy="338554"/>
-            </a:xfrm>
-            <a:prstGeom prst="rect">
-              <a:avLst/>
-            </a:prstGeom>
-            <a:noFill/>
-          </p:spPr>
-          <p:txBody>
-            <a:bodyPr wrap="square" rtlCol="0">
-              <a:spAutoFit/>
-            </a:bodyPr>
-            <a:lstStyle/>
-            <a:p>
-              <a:pPr algn="ctr"/>
-              <a:r>
-                <a:rPr lang="en-US" altLang="ko-KR" sz="1600" dirty="0" smtClean="0">
-                  <a:latin typeface="나눔스퀘어 Bold" panose="020B0600000101010101" pitchFamily="50" charset="-127"/>
-                  <a:ea typeface="나눔스퀘어 Bold" panose="020B0600000101010101" pitchFamily="50" charset="-127"/>
-                </a:rPr>
-                <a:t>55cv3</a:t>
-              </a:r>
-              <a:endParaRPr lang="ko-KR" altLang="en-US" sz="1600" dirty="0">
-                <a:latin typeface="나눔스퀘어 Bold" panose="020B0600000101010101" pitchFamily="50" charset="-127"/>
-                <a:ea typeface="나눔스퀘어 Bold" panose="020B0600000101010101" pitchFamily="50" charset="-127"/>
-              </a:endParaRPr>
-            </a:p>
-          </p:txBody>
-        </p:sp>
-        <p:sp>
-          <p:nvSpPr>
-            <p:cNvPr id="306" name="직사각형 305"/>
-            <p:cNvSpPr>
-              <a:spLocks noChangeAspect="1"/>
-            </p:cNvSpPr>
-            <p:nvPr/>
-          </p:nvSpPr>
-          <p:spPr>
-            <a:xfrm>
-              <a:off x="7829455" y="3534033"/>
-              <a:ext cx="864000" cy="863891"/>
-            </a:xfrm>
-            <a:prstGeom prst="rect">
-              <a:avLst/>
-            </a:prstGeom>
-            <a:noFill/>
-            <a:ln w="19050">
-              <a:solidFill>
-                <a:schemeClr val="tx1"/>
-              </a:solidFill>
-            </a:ln>
-          </p:spPr>
-          <p:style>
-            <a:lnRef idx="2">
-              <a:schemeClr val="accent1">
-                <a:shade val="50000"/>
-              </a:schemeClr>
-            </a:lnRef>
-            <a:fillRef idx="1">
-              <a:schemeClr val="accent1"/>
-            </a:fillRef>
-            <a:effectRef idx="0">
-              <a:schemeClr val="accent1"/>
-            </a:effectRef>
-            <a:fontRef idx="minor">
-              <a:schemeClr val="lt1"/>
-            </a:fontRef>
-          </p:style>
-          <p:txBody>
-            <a:bodyPr rtlCol="0" anchor="ctr"/>
-            <a:lstStyle/>
-            <a:p>
-              <a:pPr algn="ctr"/>
-              <a:endParaRPr lang="ko-KR" altLang="en-US"/>
-            </a:p>
-          </p:txBody>
-        </p:sp>
-        <p:sp>
-          <p:nvSpPr>
-            <p:cNvPr id="307" name="TextBox 306"/>
-            <p:cNvSpPr txBox="1"/>
-            <p:nvPr/>
-          </p:nvSpPr>
-          <p:spPr>
-            <a:xfrm>
-              <a:off x="7775226" y="3534029"/>
-              <a:ext cx="972457" cy="338554"/>
-            </a:xfrm>
-            <a:prstGeom prst="rect">
-              <a:avLst/>
-            </a:prstGeom>
-            <a:noFill/>
-          </p:spPr>
-          <p:txBody>
-            <a:bodyPr wrap="square" rtlCol="0">
-              <a:spAutoFit/>
-            </a:bodyPr>
-            <a:lstStyle/>
-            <a:p>
-              <a:pPr algn="ctr"/>
-              <a:r>
-                <a:rPr lang="en-US" altLang="ko-KR" sz="1600" dirty="0" smtClean="0">
-                  <a:latin typeface="나눔스퀘어 Bold" panose="020B0600000101010101" pitchFamily="50" charset="-127"/>
-                  <a:ea typeface="나눔스퀘어 Bold" panose="020B0600000101010101" pitchFamily="50" charset="-127"/>
-                </a:rPr>
-                <a:t>55cv4</a:t>
-              </a:r>
-              <a:endParaRPr lang="ko-KR" altLang="en-US" sz="1600" dirty="0">
-                <a:latin typeface="나눔스퀘어 Bold" panose="020B0600000101010101" pitchFamily="50" charset="-127"/>
-                <a:ea typeface="나눔스퀘어 Bold" panose="020B0600000101010101" pitchFamily="50" charset="-127"/>
-              </a:endParaRPr>
-            </a:p>
-          </p:txBody>
-        </p:sp>
-        <p:sp>
-          <p:nvSpPr>
-            <p:cNvPr id="318" name="직사각형 317"/>
-            <p:cNvSpPr>
-              <a:spLocks noChangeAspect="1"/>
-            </p:cNvSpPr>
-            <p:nvPr/>
-          </p:nvSpPr>
-          <p:spPr>
-            <a:xfrm>
-              <a:off x="8693455" y="3534029"/>
-              <a:ext cx="864000" cy="863891"/>
-            </a:xfrm>
-            <a:prstGeom prst="rect">
-              <a:avLst/>
-            </a:prstGeom>
-            <a:noFill/>
-            <a:ln w="19050">
-              <a:solidFill>
-                <a:schemeClr val="tx1"/>
-              </a:solidFill>
-            </a:ln>
-          </p:spPr>
-          <p:style>
-            <a:lnRef idx="2">
-              <a:schemeClr val="accent1">
-                <a:shade val="50000"/>
-              </a:schemeClr>
-            </a:lnRef>
-            <a:fillRef idx="1">
-              <a:schemeClr val="accent1"/>
-            </a:fillRef>
-            <a:effectRef idx="0">
-              <a:schemeClr val="accent1"/>
-            </a:effectRef>
-            <a:fontRef idx="minor">
-              <a:schemeClr val="lt1"/>
-            </a:fontRef>
-          </p:style>
-          <p:txBody>
-            <a:bodyPr rtlCol="0" anchor="ctr"/>
-            <a:lstStyle/>
-            <a:p>
-              <a:pPr algn="ctr"/>
-              <a:endParaRPr lang="ko-KR" altLang="en-US"/>
-            </a:p>
-          </p:txBody>
-        </p:sp>
-        <p:sp>
-          <p:nvSpPr>
-            <p:cNvPr id="320" name="직사각형 319"/>
-            <p:cNvSpPr>
-              <a:spLocks noChangeAspect="1"/>
-            </p:cNvSpPr>
-            <p:nvPr/>
-          </p:nvSpPr>
-          <p:spPr>
-            <a:xfrm>
-              <a:off x="9557454" y="3534029"/>
-              <a:ext cx="864000" cy="863891"/>
-            </a:xfrm>
-            <a:prstGeom prst="rect">
-              <a:avLst/>
-            </a:prstGeom>
-            <a:noFill/>
-            <a:ln w="19050">
-              <a:solidFill>
-                <a:schemeClr val="tx1"/>
-              </a:solidFill>
-            </a:ln>
-          </p:spPr>
-          <p:style>
-            <a:lnRef idx="2">
-              <a:schemeClr val="accent1">
-                <a:shade val="50000"/>
-              </a:schemeClr>
-            </a:lnRef>
-            <a:fillRef idx="1">
-              <a:schemeClr val="accent1"/>
-            </a:fillRef>
-            <a:effectRef idx="0">
-              <a:schemeClr val="accent1"/>
-            </a:effectRef>
-            <a:fontRef idx="minor">
-              <a:schemeClr val="lt1"/>
-            </a:fontRef>
-          </p:style>
-          <p:txBody>
-            <a:bodyPr rtlCol="0" anchor="ctr"/>
-            <a:lstStyle/>
-            <a:p>
-              <a:pPr algn="ctr"/>
-              <a:endParaRPr lang="ko-KR" altLang="en-US"/>
-            </a:p>
-          </p:txBody>
-        </p:sp>
-        <p:sp>
-          <p:nvSpPr>
-            <p:cNvPr id="326" name="직사각형 325"/>
-            <p:cNvSpPr>
-              <a:spLocks noChangeAspect="1"/>
-            </p:cNvSpPr>
-            <p:nvPr/>
-          </p:nvSpPr>
-          <p:spPr>
-            <a:xfrm>
-              <a:off x="10421452" y="942368"/>
-              <a:ext cx="864000" cy="863891"/>
-            </a:xfrm>
-            <a:prstGeom prst="rect">
-              <a:avLst/>
-            </a:prstGeom>
-            <a:noFill/>
-            <a:ln w="19050">
-              <a:solidFill>
-                <a:schemeClr val="tx1"/>
-              </a:solidFill>
-            </a:ln>
-          </p:spPr>
-          <p:style>
-            <a:lnRef idx="2">
-              <a:schemeClr val="accent1">
-                <a:shade val="50000"/>
-              </a:schemeClr>
-            </a:lnRef>
-            <a:fillRef idx="1">
-              <a:schemeClr val="accent1"/>
-            </a:fillRef>
-            <a:effectRef idx="0">
-              <a:schemeClr val="accent1"/>
-            </a:effectRef>
-            <a:fontRef idx="minor">
-              <a:schemeClr val="lt1"/>
-            </a:fontRef>
-          </p:style>
-          <p:txBody>
-            <a:bodyPr rtlCol="0" anchor="ctr"/>
-            <a:lstStyle/>
-            <a:p>
-              <a:pPr algn="ctr"/>
-              <a:endParaRPr lang="ko-KR" altLang="en-US"/>
-            </a:p>
-          </p:txBody>
-        </p:sp>
-        <p:sp>
-          <p:nvSpPr>
-            <p:cNvPr id="328" name="직사각형 327"/>
-            <p:cNvSpPr>
-              <a:spLocks noChangeAspect="1"/>
-            </p:cNvSpPr>
-            <p:nvPr/>
-          </p:nvSpPr>
-          <p:spPr>
-            <a:xfrm>
-              <a:off x="10421452" y="1806259"/>
-              <a:ext cx="864000" cy="863891"/>
-            </a:xfrm>
-            <a:prstGeom prst="rect">
-              <a:avLst/>
-            </a:prstGeom>
-            <a:noFill/>
-            <a:ln w="19050">
-              <a:solidFill>
-                <a:schemeClr val="tx1"/>
-              </a:solidFill>
-            </a:ln>
-          </p:spPr>
-          <p:style>
-            <a:lnRef idx="2">
-              <a:schemeClr val="accent1">
-                <a:shade val="50000"/>
-              </a:schemeClr>
-            </a:lnRef>
-            <a:fillRef idx="1">
-              <a:schemeClr val="accent1"/>
-            </a:fillRef>
-            <a:effectRef idx="0">
-              <a:schemeClr val="accent1"/>
-            </a:effectRef>
-            <a:fontRef idx="minor">
-              <a:schemeClr val="lt1"/>
-            </a:fontRef>
-          </p:style>
-          <p:txBody>
-            <a:bodyPr rtlCol="0" anchor="ctr"/>
-            <a:lstStyle/>
-            <a:p>
-              <a:pPr algn="ctr"/>
-              <a:endParaRPr lang="ko-KR" altLang="en-US"/>
-            </a:p>
-          </p:txBody>
-        </p:sp>
-        <p:sp>
-          <p:nvSpPr>
-            <p:cNvPr id="330" name="직사각형 329"/>
-            <p:cNvSpPr>
-              <a:spLocks noChangeAspect="1"/>
-            </p:cNvSpPr>
-            <p:nvPr/>
-          </p:nvSpPr>
-          <p:spPr>
-            <a:xfrm>
-              <a:off x="10421452" y="2670146"/>
-              <a:ext cx="864000" cy="863891"/>
-            </a:xfrm>
-            <a:prstGeom prst="rect">
-              <a:avLst/>
-            </a:prstGeom>
-            <a:noFill/>
-            <a:ln w="19050">
-              <a:solidFill>
-                <a:schemeClr val="tx1"/>
-              </a:solidFill>
-            </a:ln>
-          </p:spPr>
-          <p:style>
-            <a:lnRef idx="2">
-              <a:schemeClr val="accent1">
-                <a:shade val="50000"/>
-              </a:schemeClr>
-            </a:lnRef>
-            <a:fillRef idx="1">
-              <a:schemeClr val="accent1"/>
-            </a:fillRef>
-            <a:effectRef idx="0">
-              <a:schemeClr val="accent1"/>
-            </a:effectRef>
-            <a:fontRef idx="minor">
-              <a:schemeClr val="lt1"/>
-            </a:fontRef>
-          </p:style>
-          <p:txBody>
-            <a:bodyPr rtlCol="0" anchor="ctr"/>
-            <a:lstStyle/>
-            <a:p>
-              <a:pPr algn="ctr"/>
-              <a:endParaRPr lang="ko-KR" altLang="en-US"/>
-            </a:p>
-          </p:txBody>
-        </p:sp>
-        <p:sp>
-          <p:nvSpPr>
-            <p:cNvPr id="331" name="TextBox 330"/>
-            <p:cNvSpPr txBox="1"/>
-            <p:nvPr/>
-          </p:nvSpPr>
-          <p:spPr>
-            <a:xfrm>
-              <a:off x="10367223" y="2670142"/>
-              <a:ext cx="972457" cy="338554"/>
-            </a:xfrm>
-            <a:prstGeom prst="rect">
-              <a:avLst/>
-            </a:prstGeom>
-            <a:noFill/>
-          </p:spPr>
-          <p:txBody>
-            <a:bodyPr wrap="square" rtlCol="0">
-              <a:spAutoFit/>
-            </a:bodyPr>
-            <a:lstStyle/>
-            <a:p>
-              <a:pPr algn="ctr"/>
-              <a:r>
-                <a:rPr lang="en-US" altLang="ko-KR" sz="1600" dirty="0" smtClean="0">
-                  <a:latin typeface="나눔스퀘어 Bold" panose="020B0600000101010101" pitchFamily="50" charset="-127"/>
-                  <a:ea typeface="나눔스퀘어 Bold" panose="020B0600000101010101" pitchFamily="50" charset="-127"/>
-                </a:rPr>
-                <a:t>90h9</a:t>
-              </a:r>
-              <a:endParaRPr lang="ko-KR" altLang="en-US" sz="1600" dirty="0">
-                <a:latin typeface="나눔스퀘어 Bold" panose="020B0600000101010101" pitchFamily="50" charset="-127"/>
-                <a:ea typeface="나눔스퀘어 Bold" panose="020B0600000101010101" pitchFamily="50" charset="-127"/>
-              </a:endParaRPr>
-            </a:p>
-          </p:txBody>
-        </p:sp>
-        <p:sp>
-          <p:nvSpPr>
-            <p:cNvPr id="332" name="직사각형 331"/>
-            <p:cNvSpPr>
-              <a:spLocks noChangeAspect="1"/>
-            </p:cNvSpPr>
-            <p:nvPr/>
-          </p:nvSpPr>
-          <p:spPr>
-            <a:xfrm>
-              <a:off x="10421452" y="3534029"/>
-              <a:ext cx="864000" cy="863891"/>
-            </a:xfrm>
-            <a:prstGeom prst="rect">
-              <a:avLst/>
-            </a:prstGeom>
-            <a:noFill/>
-            <a:ln w="19050">
-              <a:solidFill>
-                <a:schemeClr val="tx1"/>
-              </a:solidFill>
-            </a:ln>
-          </p:spPr>
-          <p:style>
-            <a:lnRef idx="2">
-              <a:schemeClr val="accent1">
-                <a:shade val="50000"/>
-              </a:schemeClr>
-            </a:lnRef>
-            <a:fillRef idx="1">
-              <a:schemeClr val="accent1"/>
-            </a:fillRef>
-            <a:effectRef idx="0">
-              <a:schemeClr val="accent1"/>
-            </a:effectRef>
-            <a:fontRef idx="minor">
-              <a:schemeClr val="lt1"/>
-            </a:fontRef>
-          </p:style>
-          <p:txBody>
-            <a:bodyPr rtlCol="0" anchor="ctr"/>
-            <a:lstStyle/>
-            <a:p>
-              <a:pPr algn="ctr"/>
-              <a:endParaRPr lang="ko-KR" altLang="en-US"/>
-            </a:p>
-          </p:txBody>
-        </p:sp>
-        <p:sp>
-          <p:nvSpPr>
-            <p:cNvPr id="352" name="직사각형 351"/>
+            <p:cNvPr id="10" name="모서리가 둥근 직사각형 9"/>
             <p:cNvSpPr/>
             <p:nvPr/>
           </p:nvSpPr>
           <p:spPr>
             <a:xfrm>
-              <a:off x="5381455" y="2144805"/>
-              <a:ext cx="576000" cy="432000"/>
+              <a:off x="5660577" y="769257"/>
+              <a:ext cx="2160000" cy="1080000"/>
             </a:xfrm>
-            <a:prstGeom prst="rect">
+            <a:prstGeom prst="roundRect">
               <a:avLst/>
             </a:prstGeom>
-            <a:solidFill>
-              <a:schemeClr val="accent6">
-                <a:lumMod val="40000"/>
-                <a:lumOff val="60000"/>
-              </a:schemeClr>
-            </a:solidFill>
-            <a:ln>
+            <a:noFill/>
+            <a:ln w="28575">
               <a:solidFill>
                 <a:schemeClr val="tx1"/>
               </a:solidFill>
@@ -5748,42 +4218,71 @@
             <a:p>
               <a:pPr algn="ctr"/>
               <a:r>
-                <a:rPr lang="en-US" altLang="ko-KR" dirty="0" smtClean="0">
+                <a:rPr lang="ko-KR" altLang="en-US" sz="2000" dirty="0" smtClean="0">
                   <a:solidFill>
                     <a:schemeClr val="tx1"/>
                   </a:solidFill>
+                  <a:latin typeface="나눔스퀘어 Bold" panose="020B0600000101010101" pitchFamily="50" charset="-127"/>
+                  <a:ea typeface="나눔스퀘어 Bold" panose="020B0600000101010101" pitchFamily="50" charset="-127"/>
                 </a:rPr>
-                <a:t>10</a:t>
+                <a:t>속성</a:t>
               </a:r>
-              <a:endParaRPr lang="ko-KR" altLang="en-US" dirty="0">
+              <a:r>
+                <a:rPr lang="en-US" altLang="ko-KR" sz="2000" dirty="0" smtClean="0">
+                  <a:solidFill>
+                    <a:schemeClr val="tx1"/>
+                  </a:solidFill>
+                  <a:latin typeface="나눔스퀘어 Bold" panose="020B0600000101010101" pitchFamily="50" charset="-127"/>
+                  <a:ea typeface="나눔스퀘어 Bold" panose="020B0600000101010101" pitchFamily="50" charset="-127"/>
+                </a:rPr>
+                <a:t>1 &amp; </a:t>
+              </a:r>
+              <a:r>
+                <a:rPr lang="ko-KR" altLang="en-US" sz="2000" dirty="0" smtClean="0">
+                  <a:solidFill>
+                    <a:schemeClr val="tx1"/>
+                  </a:solidFill>
+                  <a:latin typeface="나눔스퀘어 Bold" panose="020B0600000101010101" pitchFamily="50" charset="-127"/>
+                  <a:ea typeface="나눔스퀘어 Bold" panose="020B0600000101010101" pitchFamily="50" charset="-127"/>
+                </a:rPr>
+                <a:t>기능</a:t>
+              </a:r>
+              <a:r>
+                <a:rPr lang="en-US" altLang="ko-KR" sz="2000" dirty="0" smtClean="0">
+                  <a:solidFill>
+                    <a:schemeClr val="tx1"/>
+                  </a:solidFill>
+                  <a:latin typeface="나눔스퀘어 Bold" panose="020B0600000101010101" pitchFamily="50" charset="-127"/>
+                  <a:ea typeface="나눔스퀘어 Bold" panose="020B0600000101010101" pitchFamily="50" charset="-127"/>
+                </a:rPr>
+                <a:t>1</a:t>
+              </a:r>
+              <a:endParaRPr lang="ko-KR" altLang="en-US" sz="2000" dirty="0">
                 <a:solidFill>
                   <a:schemeClr val="tx1"/>
                 </a:solidFill>
+                <a:latin typeface="나눔스퀘어 Bold" panose="020B0600000101010101" pitchFamily="50" charset="-127"/>
+                <a:ea typeface="나눔스퀘어 Bold" panose="020B0600000101010101" pitchFamily="50" charset="-127"/>
               </a:endParaRPr>
             </a:p>
           </p:txBody>
         </p:sp>
         <p:sp>
           <p:nvSpPr>
-            <p:cNvPr id="353" name="직사각형 352"/>
+            <p:cNvPr id="68" name="모서리가 둥근 직사각형 67"/>
             <p:cNvSpPr/>
             <p:nvPr/>
           </p:nvSpPr>
           <p:spPr>
             <a:xfrm>
-              <a:off x="6245452" y="2139326"/>
-              <a:ext cx="576000" cy="432000"/>
+              <a:off x="5660577" y="2735943"/>
+              <a:ext cx="2160000" cy="1080000"/>
             </a:xfrm>
-            <a:prstGeom prst="rect">
+            <a:prstGeom prst="roundRect">
               <a:avLst/>
             </a:prstGeom>
-            <a:solidFill>
-              <a:schemeClr val="accent6">
-                <a:lumMod val="40000"/>
-                <a:lumOff val="60000"/>
-              </a:schemeClr>
-            </a:solidFill>
-            <a:ln>
+            <a:noFill/>
+            <a:ln w="28575">
               <a:solidFill>
                 <a:schemeClr val="tx1"/>
               </a:solidFill>
@@ -5811,42 +4310,131 @@
             <a:p>
               <a:pPr algn="ctr"/>
               <a:r>
-                <a:rPr lang="en-US" altLang="ko-KR" dirty="0" smtClean="0">
+                <a:rPr lang="ko-KR" altLang="en-US" sz="2000" dirty="0">
                   <a:solidFill>
                     <a:schemeClr val="tx1"/>
                   </a:solidFill>
+                  <a:latin typeface="나눔스퀘어 Bold" panose="020B0600000101010101" pitchFamily="50" charset="-127"/>
+                  <a:ea typeface="나눔스퀘어 Bold" panose="020B0600000101010101" pitchFamily="50" charset="-127"/>
                 </a:rPr>
-                <a:t>10</a:t>
+                <a:t>속성</a:t>
               </a:r>
-              <a:endParaRPr lang="ko-KR" altLang="en-US" dirty="0">
+              <a:r>
+                <a:rPr lang="en-US" altLang="ko-KR" sz="2000" dirty="0">
+                  <a:solidFill>
+                    <a:schemeClr val="tx1"/>
+                  </a:solidFill>
+                  <a:latin typeface="나눔스퀘어 Bold" panose="020B0600000101010101" pitchFamily="50" charset="-127"/>
+                  <a:ea typeface="나눔스퀘어 Bold" panose="020B0600000101010101" pitchFamily="50" charset="-127"/>
+                </a:rPr>
+                <a:t>1 &amp; </a:t>
+              </a:r>
+              <a:r>
+                <a:rPr lang="ko-KR" altLang="en-US" sz="2000" dirty="0">
+                  <a:solidFill>
+                    <a:schemeClr val="tx1"/>
+                  </a:solidFill>
+                  <a:latin typeface="나눔스퀘어 Bold" panose="020B0600000101010101" pitchFamily="50" charset="-127"/>
+                  <a:ea typeface="나눔스퀘어 Bold" panose="020B0600000101010101" pitchFamily="50" charset="-127"/>
+                </a:rPr>
+                <a:t>기능</a:t>
+              </a:r>
+              <a:r>
+                <a:rPr lang="en-US" altLang="ko-KR" sz="2000" dirty="0">
+                  <a:solidFill>
+                    <a:schemeClr val="tx1"/>
+                  </a:solidFill>
+                  <a:latin typeface="나눔스퀘어 Bold" panose="020B0600000101010101" pitchFamily="50" charset="-127"/>
+                  <a:ea typeface="나눔스퀘어 Bold" panose="020B0600000101010101" pitchFamily="50" charset="-127"/>
+                </a:rPr>
+                <a:t>1</a:t>
+              </a:r>
+              <a:endParaRPr lang="ko-KR" altLang="en-US" sz="2000" dirty="0">
                 <a:solidFill>
                   <a:schemeClr val="tx1"/>
                 </a:solidFill>
+                <a:latin typeface="나눔스퀘어 Bold" panose="020B0600000101010101" pitchFamily="50" charset="-127"/>
+                <a:ea typeface="나눔스퀘어 Bold" panose="020B0600000101010101" pitchFamily="50" charset="-127"/>
+              </a:endParaRPr>
+            </a:p>
+            <a:p>
+              <a:pPr algn="ctr"/>
+              <a:r>
+                <a:rPr lang="ko-KR" altLang="en-US" sz="2000" dirty="0" smtClean="0">
+                  <a:solidFill>
+                    <a:schemeClr val="tx1"/>
+                  </a:solidFill>
+                  <a:latin typeface="나눔스퀘어 Bold" panose="020B0600000101010101" pitchFamily="50" charset="-127"/>
+                  <a:ea typeface="나눔스퀘어 Bold" panose="020B0600000101010101" pitchFamily="50" charset="-127"/>
+                </a:rPr>
+                <a:t>속성</a:t>
+              </a:r>
+              <a:r>
+                <a:rPr lang="en-US" altLang="ko-KR" sz="2000" dirty="0" smtClean="0">
+                  <a:solidFill>
+                    <a:schemeClr val="tx1"/>
+                  </a:solidFill>
+                  <a:latin typeface="나눔스퀘어 Bold" panose="020B0600000101010101" pitchFamily="50" charset="-127"/>
+                  <a:ea typeface="나눔스퀘어 Bold" panose="020B0600000101010101" pitchFamily="50" charset="-127"/>
+                </a:rPr>
+                <a:t>2 </a:t>
+              </a:r>
+              <a:r>
+                <a:rPr lang="en-US" altLang="ko-KR" sz="2000" dirty="0">
+                  <a:solidFill>
+                    <a:schemeClr val="tx1"/>
+                  </a:solidFill>
+                  <a:latin typeface="나눔스퀘어 Bold" panose="020B0600000101010101" pitchFamily="50" charset="-127"/>
+                  <a:ea typeface="나눔스퀘어 Bold" panose="020B0600000101010101" pitchFamily="50" charset="-127"/>
+                </a:rPr>
+                <a:t>&amp; </a:t>
+              </a:r>
+              <a:r>
+                <a:rPr lang="ko-KR" altLang="en-US" sz="2000" dirty="0" smtClean="0">
+                  <a:solidFill>
+                    <a:schemeClr val="tx1"/>
+                  </a:solidFill>
+                  <a:latin typeface="나눔스퀘어 Bold" panose="020B0600000101010101" pitchFamily="50" charset="-127"/>
+                  <a:ea typeface="나눔스퀘어 Bold" panose="020B0600000101010101" pitchFamily="50" charset="-127"/>
+                </a:rPr>
+                <a:t>기능</a:t>
+              </a:r>
+              <a:r>
+                <a:rPr lang="en-US" altLang="ko-KR" sz="2000" dirty="0">
+                  <a:solidFill>
+                    <a:schemeClr val="tx1"/>
+                  </a:solidFill>
+                  <a:latin typeface="나눔스퀘어 Bold" panose="020B0600000101010101" pitchFamily="50" charset="-127"/>
+                  <a:ea typeface="나눔스퀘어 Bold" panose="020B0600000101010101" pitchFamily="50" charset="-127"/>
+                </a:rPr>
+                <a:t>2</a:t>
+              </a:r>
+              <a:endParaRPr lang="ko-KR" altLang="en-US" sz="2000" dirty="0">
+                <a:solidFill>
+                  <a:schemeClr val="tx1"/>
+                </a:solidFill>
+                <a:latin typeface="나눔스퀘어 Bold" panose="020B0600000101010101" pitchFamily="50" charset="-127"/>
+                <a:ea typeface="나눔스퀘어 Bold" panose="020B0600000101010101" pitchFamily="50" charset="-127"/>
               </a:endParaRPr>
             </a:p>
           </p:txBody>
         </p:sp>
         <p:sp>
           <p:nvSpPr>
-            <p:cNvPr id="354" name="직사각형 353"/>
+            <p:cNvPr id="69" name="모서리가 둥근 직사각형 68"/>
             <p:cNvSpPr/>
             <p:nvPr/>
           </p:nvSpPr>
           <p:spPr>
             <a:xfrm>
-              <a:off x="9701452" y="3008684"/>
-              <a:ext cx="576000" cy="432000"/>
+              <a:off x="5660577" y="4702629"/>
+              <a:ext cx="2160000" cy="1080000"/>
             </a:xfrm>
-            <a:prstGeom prst="rect">
+            <a:prstGeom prst="roundRect">
               <a:avLst/>
             </a:prstGeom>
-            <a:solidFill>
-              <a:schemeClr val="accent5">
-                <a:lumMod val="40000"/>
-                <a:lumOff val="60000"/>
-              </a:schemeClr>
-            </a:solidFill>
-            <a:ln>
+            <a:noFill/>
+            <a:ln w="28575">
               <a:solidFill>
                 <a:schemeClr val="tx1"/>
               </a:solidFill>
@@ -5874,514 +4462,146 @@
             <a:p>
               <a:pPr algn="ctr"/>
               <a:r>
-                <a:rPr lang="en-US" altLang="ko-KR" dirty="0" smtClean="0">
-                  <a:solidFill>
-                    <a:schemeClr val="tx1"/>
-                  </a:solidFill>
-                </a:rPr>
-                <a:t>10</a:t>
-              </a:r>
-              <a:endParaRPr lang="ko-KR" altLang="en-US" dirty="0">
-                <a:solidFill>
-                  <a:schemeClr val="tx1"/>
-                </a:solidFill>
-              </a:endParaRPr>
-            </a:p>
-          </p:txBody>
-        </p:sp>
-        <p:sp>
-          <p:nvSpPr>
-            <p:cNvPr id="355" name="직사각형 354"/>
-            <p:cNvSpPr/>
-            <p:nvPr/>
-          </p:nvSpPr>
-          <p:spPr>
-            <a:xfrm>
-              <a:off x="10565449" y="3008684"/>
-              <a:ext cx="576000" cy="432000"/>
-            </a:xfrm>
-            <a:prstGeom prst="rect">
-              <a:avLst/>
-            </a:prstGeom>
-            <a:solidFill>
-              <a:schemeClr val="accent5">
-                <a:lumMod val="40000"/>
-                <a:lumOff val="60000"/>
-              </a:schemeClr>
-            </a:solidFill>
-            <a:ln>
-              <a:solidFill>
-                <a:schemeClr val="tx1"/>
-              </a:solidFill>
-            </a:ln>
-          </p:spPr>
-          <p:style>
-            <a:lnRef idx="2">
-              <a:schemeClr val="accent1">
-                <a:shade val="50000"/>
-              </a:schemeClr>
-            </a:lnRef>
-            <a:fillRef idx="1">
-              <a:schemeClr val="accent1"/>
-            </a:fillRef>
-            <a:effectRef idx="0">
-              <a:schemeClr val="accent1"/>
-            </a:effectRef>
-            <a:fontRef idx="minor">
-              <a:schemeClr val="lt1"/>
-            </a:fontRef>
-          </p:style>
-          <p:txBody>
-            <a:bodyPr rtlCol="0" anchor="ctr"/>
-            <a:lstStyle/>
-            <a:p>
-              <a:pPr algn="ctr"/>
-              <a:r>
-                <a:rPr lang="en-US" altLang="ko-KR" dirty="0" smtClean="0">
-                  <a:solidFill>
-                    <a:schemeClr val="tx1"/>
-                  </a:solidFill>
-                </a:rPr>
-                <a:t>10</a:t>
-              </a:r>
-              <a:endParaRPr lang="ko-KR" altLang="en-US" dirty="0">
-                <a:solidFill>
-                  <a:schemeClr val="tx1"/>
-                </a:solidFill>
-              </a:endParaRPr>
-            </a:p>
-          </p:txBody>
-        </p:sp>
-        <p:sp>
-          <p:nvSpPr>
-            <p:cNvPr id="356" name="직사각형 355"/>
-            <p:cNvSpPr/>
-            <p:nvPr/>
-          </p:nvSpPr>
-          <p:spPr>
-            <a:xfrm>
-              <a:off x="6155685" y="3872583"/>
-              <a:ext cx="720000" cy="432000"/>
-            </a:xfrm>
-            <a:prstGeom prst="rect">
-              <a:avLst/>
-            </a:prstGeom>
-            <a:solidFill>
-              <a:schemeClr val="bg2">
-                <a:lumMod val="90000"/>
-              </a:schemeClr>
-            </a:solidFill>
-            <a:ln>
-              <a:solidFill>
-                <a:schemeClr val="tx1"/>
-              </a:solidFill>
-            </a:ln>
-          </p:spPr>
-          <p:style>
-            <a:lnRef idx="2">
-              <a:schemeClr val="accent1">
-                <a:shade val="50000"/>
-              </a:schemeClr>
-            </a:lnRef>
-            <a:fillRef idx="1">
-              <a:schemeClr val="accent1"/>
-            </a:fillRef>
-            <a:effectRef idx="0">
-              <a:schemeClr val="accent1"/>
-            </a:effectRef>
-            <a:fontRef idx="minor">
-              <a:schemeClr val="lt1"/>
-            </a:fontRef>
-          </p:style>
-          <p:txBody>
-            <a:bodyPr rtlCol="0" anchor="ctr"/>
-            <a:lstStyle/>
-            <a:p>
-              <a:pPr algn="ctr"/>
-              <a:r>
-                <a:rPr lang="en-US" altLang="ko-KR" sz="1600" dirty="0">
+                <a:rPr lang="ko-KR" altLang="en-US" sz="2000" dirty="0">
                   <a:solidFill>
                     <a:schemeClr val="tx1"/>
                   </a:solidFill>
                   <a:latin typeface="나눔스퀘어 Bold" panose="020B0600000101010101" pitchFamily="50" charset="-127"/>
                   <a:ea typeface="나눔스퀘어 Bold" panose="020B0600000101010101" pitchFamily="50" charset="-127"/>
                 </a:rPr>
-                <a:t>12s1</a:t>
+                <a:t>속성</a:t>
               </a:r>
-              <a:endParaRPr lang="ko-KR" altLang="en-US" sz="1600" dirty="0">
-                <a:solidFill>
-                  <a:schemeClr val="tx1"/>
-                </a:solidFill>
-                <a:latin typeface="나눔스퀘어 Bold" panose="020B0600000101010101" pitchFamily="50" charset="-127"/>
-                <a:ea typeface="나눔스퀘어 Bold" panose="020B0600000101010101" pitchFamily="50" charset="-127"/>
-              </a:endParaRPr>
-            </a:p>
-          </p:txBody>
-        </p:sp>
-        <p:sp>
-          <p:nvSpPr>
-            <p:cNvPr id="360" name="TextBox 359"/>
-            <p:cNvSpPr txBox="1"/>
-            <p:nvPr/>
-          </p:nvSpPr>
-          <p:spPr>
-            <a:xfrm>
-              <a:off x="7775225" y="942360"/>
-              <a:ext cx="972457" cy="338554"/>
-            </a:xfrm>
-            <a:prstGeom prst="rect">
-              <a:avLst/>
-            </a:prstGeom>
-            <a:noFill/>
-          </p:spPr>
-          <p:txBody>
-            <a:bodyPr wrap="square" rtlCol="0">
-              <a:spAutoFit/>
-            </a:bodyPr>
-            <a:lstStyle/>
-            <a:p>
-              <a:pPr algn="ctr"/>
               <a:r>
-                <a:rPr lang="en-US" altLang="ko-KR" sz="1600" dirty="0" smtClean="0">
-                  <a:latin typeface="나눔스퀘어 Bold" panose="020B0600000101010101" pitchFamily="50" charset="-127"/>
-                  <a:ea typeface="나눔스퀘어 Bold" panose="020B0600000101010101" pitchFamily="50" charset="-127"/>
-                </a:rPr>
-                <a:t>29e5</a:t>
-              </a:r>
-              <a:endParaRPr lang="ko-KR" altLang="en-US" sz="1600" dirty="0">
-                <a:latin typeface="나눔스퀘어 Bold" panose="020B0600000101010101" pitchFamily="50" charset="-127"/>
-                <a:ea typeface="나눔스퀘어 Bold" panose="020B0600000101010101" pitchFamily="50" charset="-127"/>
-              </a:endParaRPr>
-            </a:p>
-          </p:txBody>
-        </p:sp>
-        <p:sp>
-          <p:nvSpPr>
-            <p:cNvPr id="362" name="TextBox 361"/>
-            <p:cNvSpPr txBox="1"/>
-            <p:nvPr/>
-          </p:nvSpPr>
-          <p:spPr>
-            <a:xfrm>
-              <a:off x="8639224" y="942360"/>
-              <a:ext cx="972457" cy="338554"/>
-            </a:xfrm>
-            <a:prstGeom prst="rect">
-              <a:avLst/>
-            </a:prstGeom>
-            <a:noFill/>
-          </p:spPr>
-          <p:txBody>
-            <a:bodyPr wrap="square" rtlCol="0">
-              <a:spAutoFit/>
-            </a:bodyPr>
-            <a:lstStyle/>
-            <a:p>
-              <a:pPr algn="ctr"/>
-              <a:r>
-                <a:rPr lang="en-US" altLang="ko-KR" sz="1600" dirty="0" smtClean="0">
-                  <a:latin typeface="나눔스퀘어 Bold" panose="020B0600000101010101" pitchFamily="50" charset="-127"/>
-                  <a:ea typeface="나눔스퀘어 Bold" panose="020B0600000101010101" pitchFamily="50" charset="-127"/>
-                </a:rPr>
-                <a:t>29e6</a:t>
-              </a:r>
-              <a:endParaRPr lang="ko-KR" altLang="en-US" sz="1600" dirty="0">
-                <a:latin typeface="나눔스퀘어 Bold" panose="020B0600000101010101" pitchFamily="50" charset="-127"/>
-                <a:ea typeface="나눔스퀘어 Bold" panose="020B0600000101010101" pitchFamily="50" charset="-127"/>
-              </a:endParaRPr>
-            </a:p>
-          </p:txBody>
-        </p:sp>
-        <p:sp>
-          <p:nvSpPr>
-            <p:cNvPr id="363" name="직사각형 362"/>
-            <p:cNvSpPr/>
-            <p:nvPr/>
-          </p:nvSpPr>
-          <p:spPr>
-            <a:xfrm>
-              <a:off x="7973453" y="1280910"/>
-              <a:ext cx="576000" cy="432000"/>
-            </a:xfrm>
-            <a:prstGeom prst="rect">
-              <a:avLst/>
-            </a:prstGeom>
-            <a:solidFill>
-              <a:schemeClr val="accent4">
-                <a:lumMod val="20000"/>
-                <a:lumOff val="80000"/>
-              </a:schemeClr>
-            </a:solidFill>
-            <a:ln>
-              <a:solidFill>
-                <a:schemeClr val="tx1"/>
-              </a:solidFill>
-            </a:ln>
-          </p:spPr>
-          <p:style>
-            <a:lnRef idx="2">
-              <a:schemeClr val="accent1">
-                <a:shade val="50000"/>
-              </a:schemeClr>
-            </a:lnRef>
-            <a:fillRef idx="1">
-              <a:schemeClr val="accent1"/>
-            </a:fillRef>
-            <a:effectRef idx="0">
-              <a:schemeClr val="accent1"/>
-            </a:effectRef>
-            <a:fontRef idx="minor">
-              <a:schemeClr val="lt1"/>
-            </a:fontRef>
-          </p:style>
-          <p:txBody>
-            <a:bodyPr rtlCol="0" anchor="ctr"/>
-            <a:lstStyle/>
-            <a:p>
-              <a:pPr algn="ctr"/>
-              <a:r>
-                <a:rPr lang="en-US" altLang="ko-KR" dirty="0" smtClean="0">
-                  <a:solidFill>
-                    <a:schemeClr val="tx1"/>
-                  </a:solidFill>
-                </a:rPr>
-                <a:t>10</a:t>
-              </a:r>
-              <a:endParaRPr lang="ko-KR" altLang="en-US" dirty="0">
-                <a:solidFill>
-                  <a:schemeClr val="tx1"/>
-                </a:solidFill>
-              </a:endParaRPr>
-            </a:p>
-          </p:txBody>
-        </p:sp>
-        <p:sp>
-          <p:nvSpPr>
-            <p:cNvPr id="364" name="직사각형 363"/>
-            <p:cNvSpPr/>
-            <p:nvPr/>
-          </p:nvSpPr>
-          <p:spPr>
-            <a:xfrm>
-              <a:off x="8837452" y="1280910"/>
-              <a:ext cx="576000" cy="432000"/>
-            </a:xfrm>
-            <a:prstGeom prst="rect">
-              <a:avLst/>
-            </a:prstGeom>
-            <a:solidFill>
-              <a:schemeClr val="accent4">
-                <a:lumMod val="20000"/>
-                <a:lumOff val="80000"/>
-              </a:schemeClr>
-            </a:solidFill>
-            <a:ln>
-              <a:solidFill>
-                <a:schemeClr val="tx1"/>
-              </a:solidFill>
-            </a:ln>
-          </p:spPr>
-          <p:style>
-            <a:lnRef idx="2">
-              <a:schemeClr val="accent1">
-                <a:shade val="50000"/>
-              </a:schemeClr>
-            </a:lnRef>
-            <a:fillRef idx="1">
-              <a:schemeClr val="accent1"/>
-            </a:fillRef>
-            <a:effectRef idx="0">
-              <a:schemeClr val="accent1"/>
-            </a:effectRef>
-            <a:fontRef idx="minor">
-              <a:schemeClr val="lt1"/>
-            </a:fontRef>
-          </p:style>
-          <p:txBody>
-            <a:bodyPr rtlCol="0" anchor="ctr"/>
-            <a:lstStyle/>
-            <a:p>
-              <a:pPr algn="ctr"/>
-              <a:r>
-                <a:rPr lang="en-US" altLang="ko-KR" dirty="0" smtClean="0">
-                  <a:solidFill>
-                    <a:schemeClr val="tx1"/>
-                  </a:solidFill>
-                </a:rPr>
-                <a:t>10</a:t>
-              </a:r>
-              <a:endParaRPr lang="ko-KR" altLang="en-US" dirty="0">
-                <a:solidFill>
-                  <a:schemeClr val="tx1"/>
-                </a:solidFill>
-              </a:endParaRPr>
-            </a:p>
-          </p:txBody>
-        </p:sp>
-        <p:cxnSp>
-          <p:nvCxnSpPr>
-            <p:cNvPr id="30" name="꺾인 연결선 29"/>
-            <p:cNvCxnSpPr>
-              <a:stCxn id="302" idx="1"/>
-              <a:endCxn id="267" idx="1"/>
-            </p:cNvCxnSpPr>
-            <p:nvPr/>
-          </p:nvCxnSpPr>
-          <p:spPr>
-            <a:xfrm rot="10800000">
-              <a:off x="5183228" y="1975537"/>
-              <a:ext cx="918228" cy="1990443"/>
-            </a:xfrm>
-            <a:prstGeom prst="bentConnector3">
-              <a:avLst>
-                <a:gd name="adj1" fmla="val 142876"/>
-              </a:avLst>
-            </a:prstGeom>
-            <a:ln w="76200">
-              <a:solidFill>
-                <a:schemeClr val="accent2"/>
-              </a:solidFill>
-              <a:tailEnd type="triangle"/>
-            </a:ln>
-          </p:spPr>
-          <p:style>
-            <a:lnRef idx="1">
-              <a:schemeClr val="accent1"/>
-            </a:lnRef>
-            <a:fillRef idx="0">
-              <a:schemeClr val="accent1"/>
-            </a:fillRef>
-            <a:effectRef idx="0">
-              <a:schemeClr val="accent1"/>
-            </a:effectRef>
-            <a:fontRef idx="minor">
-              <a:schemeClr val="tx1"/>
-            </a:fontRef>
-          </p:style>
-        </p:cxnSp>
-        <p:sp>
-          <p:nvSpPr>
-            <p:cNvPr id="365" name="직사각형 364"/>
-            <p:cNvSpPr/>
-            <p:nvPr/>
-          </p:nvSpPr>
-          <p:spPr>
-            <a:xfrm>
-              <a:off x="7033934" y="3872583"/>
-              <a:ext cx="720000" cy="432000"/>
-            </a:xfrm>
-            <a:prstGeom prst="rect">
-              <a:avLst/>
-            </a:prstGeom>
-            <a:solidFill>
-              <a:schemeClr val="bg2">
-                <a:lumMod val="90000"/>
-              </a:schemeClr>
-            </a:solidFill>
-            <a:ln>
-              <a:solidFill>
-                <a:schemeClr val="tx1"/>
-              </a:solidFill>
-            </a:ln>
-          </p:spPr>
-          <p:style>
-            <a:lnRef idx="2">
-              <a:schemeClr val="accent1">
-                <a:shade val="50000"/>
-              </a:schemeClr>
-            </a:lnRef>
-            <a:fillRef idx="1">
-              <a:schemeClr val="accent1"/>
-            </a:fillRef>
-            <a:effectRef idx="0">
-              <a:schemeClr val="accent1"/>
-            </a:effectRef>
-            <a:fontRef idx="minor">
-              <a:schemeClr val="lt1"/>
-            </a:fontRef>
-          </p:style>
-          <p:txBody>
-            <a:bodyPr rtlCol="0" anchor="ctr"/>
-            <a:lstStyle/>
-            <a:p>
-              <a:pPr algn="ctr"/>
-              <a:r>
-                <a:rPr lang="en-US" altLang="ko-KR" sz="1600" dirty="0">
+                <a:rPr lang="en-US" altLang="ko-KR" sz="2000" dirty="0">
                   <a:solidFill>
                     <a:schemeClr val="tx1"/>
                   </a:solidFill>
                   <a:latin typeface="나눔스퀘어 Bold" panose="020B0600000101010101" pitchFamily="50" charset="-127"/>
                   <a:ea typeface="나눔스퀘어 Bold" panose="020B0600000101010101" pitchFamily="50" charset="-127"/>
                 </a:rPr>
-                <a:t>29e5</a:t>
+                <a:t>1 &amp; </a:t>
               </a:r>
-              <a:endParaRPr lang="ko-KR" altLang="en-US" sz="1600" dirty="0">
-                <a:solidFill>
-                  <a:schemeClr val="tx1"/>
-                </a:solidFill>
-                <a:latin typeface="나눔스퀘어 Bold" panose="020B0600000101010101" pitchFamily="50" charset="-127"/>
-                <a:ea typeface="나눔스퀘어 Bold" panose="020B0600000101010101" pitchFamily="50" charset="-127"/>
-              </a:endParaRPr>
-            </a:p>
-          </p:txBody>
-        </p:sp>
-        <p:sp>
-          <p:nvSpPr>
-            <p:cNvPr id="366" name="직사각형 365"/>
-            <p:cNvSpPr/>
-            <p:nvPr/>
-          </p:nvSpPr>
-          <p:spPr>
-            <a:xfrm>
-              <a:off x="7897931" y="3872583"/>
-              <a:ext cx="720000" cy="432000"/>
-            </a:xfrm>
-            <a:prstGeom prst="rect">
-              <a:avLst/>
-            </a:prstGeom>
-            <a:solidFill>
-              <a:schemeClr val="bg2">
-                <a:lumMod val="90000"/>
-              </a:schemeClr>
-            </a:solidFill>
-            <a:ln>
-              <a:solidFill>
-                <a:schemeClr val="tx1"/>
-              </a:solidFill>
-            </a:ln>
-          </p:spPr>
-          <p:style>
-            <a:lnRef idx="2">
-              <a:schemeClr val="accent1">
-                <a:shade val="50000"/>
-              </a:schemeClr>
-            </a:lnRef>
-            <a:fillRef idx="1">
-              <a:schemeClr val="accent1"/>
-            </a:fillRef>
-            <a:effectRef idx="0">
-              <a:schemeClr val="accent1"/>
-            </a:effectRef>
-            <a:fontRef idx="minor">
-              <a:schemeClr val="lt1"/>
-            </a:fontRef>
-          </p:style>
-          <p:txBody>
-            <a:bodyPr rtlCol="0" anchor="ctr"/>
-            <a:lstStyle/>
-            <a:p>
-              <a:pPr algn="ctr"/>
               <a:r>
-                <a:rPr lang="en-US" altLang="ko-KR" sz="1600" dirty="0">
+                <a:rPr lang="ko-KR" altLang="en-US" sz="2000" dirty="0">
                   <a:solidFill>
                     <a:schemeClr val="tx1"/>
                   </a:solidFill>
                   <a:latin typeface="나눔스퀘어 Bold" panose="020B0600000101010101" pitchFamily="50" charset="-127"/>
                   <a:ea typeface="나눔스퀘어 Bold" panose="020B0600000101010101" pitchFamily="50" charset="-127"/>
                 </a:rPr>
-                <a:t>90h8</a:t>
+                <a:t>기능</a:t>
               </a:r>
-              <a:endParaRPr lang="ko-KR" altLang="en-US" sz="1600" dirty="0">
+              <a:r>
+                <a:rPr lang="en-US" altLang="ko-KR" sz="2000" dirty="0">
+                  <a:solidFill>
+                    <a:schemeClr val="tx1"/>
+                  </a:solidFill>
+                  <a:latin typeface="나눔스퀘어 Bold" panose="020B0600000101010101" pitchFamily="50" charset="-127"/>
+                  <a:ea typeface="나눔스퀘어 Bold" panose="020B0600000101010101" pitchFamily="50" charset="-127"/>
+                </a:rPr>
+                <a:t>1</a:t>
+              </a:r>
+              <a:endParaRPr lang="ko-KR" altLang="en-US" sz="2000" dirty="0">
+                <a:solidFill>
+                  <a:schemeClr val="tx1"/>
+                </a:solidFill>
+                <a:latin typeface="나눔스퀘어 Bold" panose="020B0600000101010101" pitchFamily="50" charset="-127"/>
+                <a:ea typeface="나눔스퀘어 Bold" panose="020B0600000101010101" pitchFamily="50" charset="-127"/>
+              </a:endParaRPr>
+            </a:p>
+            <a:p>
+              <a:pPr algn="ctr"/>
+              <a:r>
+                <a:rPr lang="ko-KR" altLang="en-US" sz="2000" dirty="0">
+                  <a:solidFill>
+                    <a:schemeClr val="tx1"/>
+                  </a:solidFill>
+                  <a:latin typeface="나눔스퀘어 Bold" panose="020B0600000101010101" pitchFamily="50" charset="-127"/>
+                  <a:ea typeface="나눔스퀘어 Bold" panose="020B0600000101010101" pitchFamily="50" charset="-127"/>
+                </a:rPr>
+                <a:t>속성</a:t>
+              </a:r>
+              <a:r>
+                <a:rPr lang="en-US" altLang="ko-KR" sz="2000" dirty="0">
+                  <a:solidFill>
+                    <a:schemeClr val="tx1"/>
+                  </a:solidFill>
+                  <a:latin typeface="나눔스퀘어 Bold" panose="020B0600000101010101" pitchFamily="50" charset="-127"/>
+                  <a:ea typeface="나눔스퀘어 Bold" panose="020B0600000101010101" pitchFamily="50" charset="-127"/>
+                </a:rPr>
+                <a:t>2 &amp; </a:t>
+              </a:r>
+              <a:r>
+                <a:rPr lang="ko-KR" altLang="en-US" sz="2000" dirty="0">
+                  <a:solidFill>
+                    <a:schemeClr val="tx1"/>
+                  </a:solidFill>
+                  <a:latin typeface="나눔스퀘어 Bold" panose="020B0600000101010101" pitchFamily="50" charset="-127"/>
+                  <a:ea typeface="나눔스퀘어 Bold" panose="020B0600000101010101" pitchFamily="50" charset="-127"/>
+                </a:rPr>
+                <a:t>기능</a:t>
+              </a:r>
+              <a:r>
+                <a:rPr lang="en-US" altLang="ko-KR" sz="2000" dirty="0">
+                  <a:solidFill>
+                    <a:schemeClr val="tx1"/>
+                  </a:solidFill>
+                  <a:latin typeface="나눔스퀘어 Bold" panose="020B0600000101010101" pitchFamily="50" charset="-127"/>
+                  <a:ea typeface="나눔스퀘어 Bold" panose="020B0600000101010101" pitchFamily="50" charset="-127"/>
+                </a:rPr>
+                <a:t>2</a:t>
+              </a:r>
+              <a:endParaRPr lang="ko-KR" altLang="en-US" sz="2000" dirty="0">
+                <a:solidFill>
+                  <a:schemeClr val="tx1"/>
+                </a:solidFill>
+                <a:latin typeface="나눔스퀘어 Bold" panose="020B0600000101010101" pitchFamily="50" charset="-127"/>
+                <a:ea typeface="나눔스퀘어 Bold" panose="020B0600000101010101" pitchFamily="50" charset="-127"/>
+              </a:endParaRPr>
+            </a:p>
+            <a:p>
+              <a:pPr algn="ctr"/>
+              <a:r>
+                <a:rPr lang="ko-KR" altLang="en-US" sz="2000" dirty="0" smtClean="0">
+                  <a:solidFill>
+                    <a:schemeClr val="tx1"/>
+                  </a:solidFill>
+                  <a:latin typeface="나눔스퀘어 Bold" panose="020B0600000101010101" pitchFamily="50" charset="-127"/>
+                  <a:ea typeface="나눔스퀘어 Bold" panose="020B0600000101010101" pitchFamily="50" charset="-127"/>
+                </a:rPr>
+                <a:t>속성</a:t>
+              </a:r>
+              <a:r>
+                <a:rPr lang="en-US" altLang="ko-KR" sz="2000" dirty="0" smtClean="0">
+                  <a:solidFill>
+                    <a:schemeClr val="tx1"/>
+                  </a:solidFill>
+                  <a:latin typeface="나눔스퀘어 Bold" panose="020B0600000101010101" pitchFamily="50" charset="-127"/>
+                  <a:ea typeface="나눔스퀘어 Bold" panose="020B0600000101010101" pitchFamily="50" charset="-127"/>
+                </a:rPr>
+                <a:t>3 &amp; </a:t>
+              </a:r>
+              <a:r>
+                <a:rPr lang="ko-KR" altLang="en-US" sz="2000" dirty="0" smtClean="0">
+                  <a:solidFill>
+                    <a:schemeClr val="tx1"/>
+                  </a:solidFill>
+                  <a:latin typeface="나눔스퀘어 Bold" panose="020B0600000101010101" pitchFamily="50" charset="-127"/>
+                  <a:ea typeface="나눔스퀘어 Bold" panose="020B0600000101010101" pitchFamily="50" charset="-127"/>
+                </a:rPr>
+                <a:t>속성</a:t>
+              </a:r>
+              <a:r>
+                <a:rPr lang="en-US" altLang="ko-KR" sz="2000" dirty="0" smtClean="0">
+                  <a:solidFill>
+                    <a:schemeClr val="tx1"/>
+                  </a:solidFill>
+                  <a:latin typeface="나눔스퀘어 Bold" panose="020B0600000101010101" pitchFamily="50" charset="-127"/>
+                  <a:ea typeface="나눔스퀘어 Bold" panose="020B0600000101010101" pitchFamily="50" charset="-127"/>
+                </a:rPr>
+                <a:t>3</a:t>
+              </a:r>
+              <a:endParaRPr lang="ko-KR" altLang="en-US" sz="2000" dirty="0">
                 <a:solidFill>
                   <a:schemeClr val="tx1"/>
                 </a:solidFill>
@@ -6391,86 +4611,6 @@
             </a:p>
           </p:txBody>
         </p:sp>
-        <p:cxnSp>
-          <p:nvCxnSpPr>
-            <p:cNvPr id="367" name="꺾인 연결선 366"/>
-            <p:cNvCxnSpPr>
-              <a:stCxn id="305" idx="0"/>
-              <a:endCxn id="360" idx="1"/>
-            </p:cNvCxnSpPr>
-            <p:nvPr/>
-          </p:nvCxnSpPr>
-          <p:spPr>
-            <a:xfrm rot="5400000" flipH="1" flipV="1">
-              <a:off x="6375144" y="2133949"/>
-              <a:ext cx="2422392" cy="377769"/>
-            </a:xfrm>
-            <a:prstGeom prst="bentConnector2">
-              <a:avLst/>
-            </a:prstGeom>
-            <a:ln w="76200">
-              <a:solidFill>
-                <a:schemeClr val="accent2"/>
-              </a:solidFill>
-              <a:tailEnd type="triangle"/>
-            </a:ln>
-          </p:spPr>
-          <p:style>
-            <a:lnRef idx="1">
-              <a:schemeClr val="accent1"/>
-            </a:lnRef>
-            <a:fillRef idx="0">
-              <a:schemeClr val="accent1"/>
-            </a:fillRef>
-            <a:effectRef idx="0">
-              <a:schemeClr val="accent1"/>
-            </a:effectRef>
-            <a:fontRef idx="minor">
-              <a:schemeClr val="tx1"/>
-            </a:fontRef>
-          </p:style>
-        </p:cxnSp>
-        <p:cxnSp>
-          <p:nvCxnSpPr>
-            <p:cNvPr id="368" name="꺾인 연결선 367"/>
-            <p:cNvCxnSpPr>
-              <a:stCxn id="318" idx="1"/>
-              <a:endCxn id="296" idx="1"/>
-            </p:cNvCxnSpPr>
-            <p:nvPr/>
-          </p:nvCxnSpPr>
-          <p:spPr>
-            <a:xfrm rot="10800000" flipH="1">
-              <a:off x="8693455" y="2839419"/>
-              <a:ext cx="809770" cy="1126556"/>
-            </a:xfrm>
-            <a:prstGeom prst="bentConnector3">
-              <a:avLst>
-                <a:gd name="adj1" fmla="val 39209"/>
-              </a:avLst>
-            </a:prstGeom>
-            <a:ln w="76200">
-              <a:solidFill>
-                <a:schemeClr val="accent2"/>
-              </a:solidFill>
-              <a:tailEnd type="triangle"/>
-            </a:ln>
-          </p:spPr>
-          <p:style>
-            <a:lnRef idx="1">
-              <a:schemeClr val="accent1"/>
-            </a:lnRef>
-            <a:fillRef idx="0">
-              <a:schemeClr val="accent1"/>
-            </a:fillRef>
-            <a:effectRef idx="0">
-              <a:schemeClr val="accent1"/>
-            </a:effectRef>
-            <a:fontRef idx="minor">
-              <a:schemeClr val="tx1"/>
-            </a:fontRef>
-          </p:style>
-        </p:cxnSp>
       </p:grpSp>
     </p:spTree>
     <p:extLst>
@@ -12898,112 +11038,36 @@
       </p:grpSpPr>
       <p:grpSp>
         <p:nvGrpSpPr>
-          <p:cNvPr id="7" name="그룹 6"/>
+          <p:cNvPr id="51" name="그룹 50"/>
           <p:cNvGrpSpPr/>
           <p:nvPr/>
         </p:nvGrpSpPr>
         <p:grpSpPr>
           <a:xfrm>
-            <a:off x="-1792239" y="516447"/>
-            <a:ext cx="17346415" cy="4091166"/>
-            <a:chOff x="-1792239" y="516447"/>
-            <a:chExt cx="17346415" cy="4091166"/>
+            <a:off x="-1729200" y="4366350"/>
+            <a:ext cx="10530300" cy="4731750"/>
+            <a:chOff x="-1729200" y="4366350"/>
+            <a:chExt cx="10530300" cy="4731750"/>
           </a:xfrm>
         </p:grpSpPr>
         <p:sp>
           <p:nvSpPr>
-            <p:cNvPr id="6" name="TextBox 5"/>
-            <p:cNvSpPr txBox="1"/>
+            <p:cNvPr id="23" name="모서리가 둥근 직사각형 22"/>
+            <p:cNvSpPr/>
             <p:nvPr/>
           </p:nvSpPr>
           <p:spPr>
             <a:xfrm>
-              <a:off x="-1792239" y="2028273"/>
-              <a:ext cx="15446857" cy="1323439"/>
+              <a:off x="2095950" y="7658100"/>
+              <a:ext cx="2880000" cy="1440000"/>
             </a:xfrm>
-            <a:prstGeom prst="rect">
-              <a:avLst/>
-            </a:prstGeom>
-            <a:noFill/>
-          </p:spPr>
-          <p:txBody>
-            <a:bodyPr wrap="none" rtlCol="0">
-              <a:spAutoFit/>
-            </a:bodyPr>
-            <a:lstStyle/>
-            <a:p>
-              <a:r>
-                <a:rPr lang="en-US" altLang="ko-KR" sz="8000" dirty="0" err="1">
-                  <a:latin typeface="나눔스퀘어 Bold" panose="020B0600000101010101" pitchFamily="50" charset="-127"/>
-                  <a:ea typeface="나눔스퀘어 Bold" panose="020B0600000101010101" pitchFamily="50" charset="-127"/>
-                </a:rPr>
-                <a:t>i</a:t>
-              </a:r>
-              <a:r>
-                <a:rPr lang="en-US" altLang="ko-KR" sz="8000" dirty="0" err="1" smtClean="0">
-                  <a:latin typeface="나눔스퀘어 Bold" panose="020B0600000101010101" pitchFamily="50" charset="-127"/>
-                  <a:ea typeface="나눔스퀘어 Bold" panose="020B0600000101010101" pitchFamily="50" charset="-127"/>
-                </a:rPr>
-                <a:t>nt</a:t>
-              </a:r>
-              <a:r>
-                <a:rPr lang="en-US" altLang="ko-KR" sz="8000" dirty="0" smtClean="0">
-                  <a:latin typeface="나눔스퀘어 Bold" panose="020B0600000101010101" pitchFamily="50" charset="-127"/>
-                  <a:ea typeface="나눔스퀘어 Bold" panose="020B0600000101010101" pitchFamily="50" charset="-127"/>
-                </a:rPr>
-                <a:t>[][][] </a:t>
-              </a:r>
-              <a:r>
-                <a:rPr lang="en-US" altLang="ko-KR" sz="8000" dirty="0" err="1" smtClean="0">
-                  <a:latin typeface="나눔스퀘어 Bold" panose="020B0600000101010101" pitchFamily="50" charset="-127"/>
-                  <a:ea typeface="나눔스퀘어 Bold" panose="020B0600000101010101" pitchFamily="50" charset="-127"/>
-                </a:rPr>
-                <a:t>mns</a:t>
-              </a:r>
-              <a:r>
-                <a:rPr lang="en-US" altLang="ko-KR" sz="8000" dirty="0" smtClean="0">
-                  <a:latin typeface="나눔스퀘어 Bold" panose="020B0600000101010101" pitchFamily="50" charset="-127"/>
-                  <a:ea typeface="나눔스퀘어 Bold" panose="020B0600000101010101" pitchFamily="50" charset="-127"/>
-                </a:rPr>
-                <a:t> = new </a:t>
-              </a:r>
-              <a:r>
-                <a:rPr lang="en-US" altLang="ko-KR" sz="8000" dirty="0" err="1" smtClean="0">
-                  <a:latin typeface="나눔스퀘어 Bold" panose="020B0600000101010101" pitchFamily="50" charset="-127"/>
-                  <a:ea typeface="나눔스퀘어 Bold" panose="020B0600000101010101" pitchFamily="50" charset="-127"/>
-                </a:rPr>
-                <a:t>int</a:t>
-              </a:r>
-              <a:r>
-                <a:rPr lang="en-US" altLang="ko-KR" sz="8000" dirty="0" smtClean="0">
-                  <a:latin typeface="나눔스퀘어 Bold" panose="020B0600000101010101" pitchFamily="50" charset="-127"/>
-                  <a:ea typeface="나눔스퀘어 Bold" panose="020B0600000101010101" pitchFamily="50" charset="-127"/>
-                </a:rPr>
-                <a:t>[3][2][2];</a:t>
-              </a:r>
-              <a:endParaRPr lang="ko-KR" altLang="en-US" sz="8000" dirty="0">
-                <a:latin typeface="나눔스퀘어 Bold" panose="020B0600000101010101" pitchFamily="50" charset="-127"/>
-                <a:ea typeface="나눔스퀘어 Bold" panose="020B0600000101010101" pitchFamily="50" charset="-127"/>
-              </a:endParaRPr>
-            </a:p>
-          </p:txBody>
-        </p:sp>
-        <p:sp>
-          <p:nvSpPr>
-            <p:cNvPr id="10" name="아래쪽 화살표 9"/>
-            <p:cNvSpPr/>
-            <p:nvPr/>
-          </p:nvSpPr>
-          <p:spPr>
-            <a:xfrm rot="10800000">
-              <a:off x="9316197" y="3171142"/>
-              <a:ext cx="432000" cy="720000"/>
-            </a:xfrm>
-            <a:prstGeom prst="downArrow">
+            <a:prstGeom prst="roundRect">
               <a:avLst/>
             </a:prstGeom>
             <a:solidFill>
-              <a:schemeClr val="accent2"/>
+              <a:schemeClr val="bg2">
+                <a:lumMod val="90000"/>
+              </a:schemeClr>
             </a:solidFill>
             <a:ln>
               <a:noFill/>
@@ -13030,69 +11094,60 @@
             <a:lstStyle/>
             <a:p>
               <a:pPr algn="ctr"/>
-              <a:endParaRPr lang="ko-KR" altLang="en-US" sz="3600"/>
+              <a:r>
+                <a:rPr lang="en-US" altLang="ko-KR" sz="2800" dirty="0">
+                  <a:solidFill>
+                    <a:schemeClr val="tx1"/>
+                  </a:solidFill>
+                  <a:latin typeface="나눔스퀘어 Bold" panose="020B0600000101010101" pitchFamily="50" charset="-127"/>
+                  <a:ea typeface="나눔스퀘어 Bold" panose="020B0600000101010101" pitchFamily="50" charset="-127"/>
+                </a:rPr>
+                <a:t>Strategy </a:t>
+              </a:r>
+              <a:r>
+                <a:rPr lang="en-US" altLang="ko-KR" sz="2800" dirty="0" smtClean="0">
+                  <a:solidFill>
+                    <a:schemeClr val="tx1"/>
+                  </a:solidFill>
+                  <a:latin typeface="나눔스퀘어 Bold" panose="020B0600000101010101" pitchFamily="50" charset="-127"/>
+                  <a:ea typeface="나눔스퀘어 Bold" panose="020B0600000101010101" pitchFamily="50" charset="-127"/>
+                </a:rPr>
+                <a:t>B</a:t>
+              </a:r>
+              <a:endParaRPr lang="en-US" altLang="ko-KR" sz="2800" dirty="0">
+                <a:solidFill>
+                  <a:schemeClr val="tx1"/>
+                </a:solidFill>
+                <a:latin typeface="나눔스퀘어 Bold" panose="020B0600000101010101" pitchFamily="50" charset="-127"/>
+                <a:ea typeface="나눔스퀘어 Bold" panose="020B0600000101010101" pitchFamily="50" charset="-127"/>
+              </a:endParaRPr>
             </a:p>
-          </p:txBody>
-        </p:sp>
-        <p:sp>
-          <p:nvSpPr>
-            <p:cNvPr id="18" name="TextBox 17"/>
-            <p:cNvSpPr txBox="1"/>
-            <p:nvPr/>
-          </p:nvSpPr>
-          <p:spPr>
-            <a:xfrm>
-              <a:off x="8852863" y="772372"/>
-              <a:ext cx="4198585" cy="646331"/>
-            </a:xfrm>
-            <a:prstGeom prst="rect">
-              <a:avLst/>
-            </a:prstGeom>
-            <a:noFill/>
-          </p:spPr>
-          <p:txBody>
-            <a:bodyPr wrap="none" rtlCol="0">
-              <a:spAutoFit/>
-            </a:bodyPr>
-            <a:lstStyle/>
             <a:p>
               <a:pPr algn="ctr"/>
               <a:r>
-                <a:rPr lang="en-US" altLang="ko-KR" sz="3600" dirty="0" smtClean="0">
+                <a:rPr lang="ko-KR" altLang="en-US" sz="2800" dirty="0">
+                  <a:solidFill>
+                    <a:schemeClr val="tx1"/>
+                  </a:solidFill>
                   <a:latin typeface="나눔스퀘어 Bold" panose="020B0600000101010101" pitchFamily="50" charset="-127"/>
                   <a:ea typeface="나눔스퀘어 Bold" panose="020B0600000101010101" pitchFamily="50" charset="-127"/>
                 </a:rPr>
-                <a:t>2</a:t>
+                <a:t>전략 </a:t>
               </a:r>
               <a:r>
-                <a:rPr lang="ko-KR" altLang="en-US" sz="3600" dirty="0" smtClean="0">
+                <a:rPr lang="en-US" altLang="ko-KR" sz="2800" dirty="0">
+                  <a:solidFill>
+                    <a:schemeClr val="tx1"/>
+                  </a:solidFill>
                   <a:latin typeface="나눔스퀘어 Bold" panose="020B0600000101010101" pitchFamily="50" charset="-127"/>
                   <a:ea typeface="나눔스퀘어 Bold" panose="020B0600000101010101" pitchFamily="50" charset="-127"/>
                 </a:rPr>
-                <a:t>차원 </a:t>
+                <a:t>B</a:t>
               </a:r>
-              <a:r>
-                <a:rPr lang="ko-KR" altLang="en-US" sz="3600" dirty="0">
-                  <a:latin typeface="나눔스퀘어 Bold" panose="020B0600000101010101" pitchFamily="50" charset="-127"/>
-                  <a:ea typeface="나눔스퀘어 Bold" panose="020B0600000101010101" pitchFamily="50" charset="-127"/>
-                </a:rPr>
-                <a:t>배열의 길이</a:t>
-              </a:r>
-              <a:r>
-                <a:rPr lang="en-US" altLang="ko-KR" sz="3600" dirty="0">
-                  <a:latin typeface="나눔스퀘어 Bold" panose="020B0600000101010101" pitchFamily="50" charset="-127"/>
-                  <a:ea typeface="나눔스퀘어 Bold" panose="020B0600000101010101" pitchFamily="50" charset="-127"/>
-                </a:rPr>
-                <a:t>: </a:t>
-              </a:r>
-              <a:r>
-                <a:rPr lang="en-US" altLang="ko-KR" sz="3600" dirty="0" smtClean="0">
-                  <a:latin typeface="나눔스퀘어 Bold" panose="020B0600000101010101" pitchFamily="50" charset="-127"/>
-                  <a:ea typeface="나눔스퀘어 Bold" panose="020B0600000101010101" pitchFamily="50" charset="-127"/>
-                </a:rPr>
-                <a:t>2</a:t>
-              </a:r>
-              <a:endParaRPr lang="ko-KR" altLang="en-US" sz="3600" dirty="0">
+              <a:endParaRPr lang="ko-KR" altLang="en-US" sz="2800" dirty="0">
+                <a:solidFill>
+                  <a:schemeClr val="tx1"/>
+                </a:solidFill>
                 <a:latin typeface="나눔스퀘어 Bold" panose="020B0600000101010101" pitchFamily="50" charset="-127"/>
                 <a:ea typeface="나눔스퀘어 Bold" panose="020B0600000101010101" pitchFamily="50" charset="-127"/>
               </a:endParaRPr>
@@ -13101,20 +11156,22 @@
         </p:sp>
         <p:sp>
           <p:nvSpPr>
-            <p:cNvPr id="19" name="아래쪽 화살표 18"/>
+            <p:cNvPr id="24" name="모서리가 둥근 직사각형 23"/>
             <p:cNvSpPr/>
             <p:nvPr/>
           </p:nvSpPr>
           <p:spPr>
             <a:xfrm>
-              <a:off x="10736154" y="1418703"/>
-              <a:ext cx="432000" cy="720000"/>
+              <a:off x="5921100" y="7658100"/>
+              <a:ext cx="2880000" cy="1440000"/>
             </a:xfrm>
-            <a:prstGeom prst="downArrow">
+            <a:prstGeom prst="roundRect">
               <a:avLst/>
             </a:prstGeom>
             <a:solidFill>
-              <a:schemeClr val="accent2"/>
+              <a:schemeClr val="bg2">
+                <a:lumMod val="90000"/>
+              </a:schemeClr>
             </a:solidFill>
             <a:ln>
               <a:noFill/>
@@ -13141,48 +11198,60 @@
             <a:lstStyle/>
             <a:p>
               <a:pPr algn="ctr"/>
-              <a:endParaRPr lang="ko-KR" altLang="en-US" sz="3600"/>
+              <a:r>
+                <a:rPr lang="en-US" altLang="ko-KR" sz="2800" dirty="0">
+                  <a:solidFill>
+                    <a:schemeClr val="tx1"/>
+                  </a:solidFill>
+                  <a:latin typeface="나눔스퀘어 Bold" panose="020B0600000101010101" pitchFamily="50" charset="-127"/>
+                  <a:ea typeface="나눔스퀘어 Bold" panose="020B0600000101010101" pitchFamily="50" charset="-127"/>
+                </a:rPr>
+                <a:t>Strategy </a:t>
+              </a:r>
+              <a:r>
+                <a:rPr lang="en-US" altLang="ko-KR" sz="2800" dirty="0" smtClean="0">
+                  <a:solidFill>
+                    <a:schemeClr val="tx1"/>
+                  </a:solidFill>
+                  <a:latin typeface="나눔스퀘어 Bold" panose="020B0600000101010101" pitchFamily="50" charset="-127"/>
+                  <a:ea typeface="나눔스퀘어 Bold" panose="020B0600000101010101" pitchFamily="50" charset="-127"/>
+                </a:rPr>
+                <a:t>C</a:t>
+              </a:r>
+              <a:endParaRPr lang="en-US" altLang="ko-KR" sz="2800" dirty="0">
+                <a:solidFill>
+                  <a:schemeClr val="tx1"/>
+                </a:solidFill>
+                <a:latin typeface="나눔스퀘어 Bold" panose="020B0600000101010101" pitchFamily="50" charset="-127"/>
+                <a:ea typeface="나눔스퀘어 Bold" panose="020B0600000101010101" pitchFamily="50" charset="-127"/>
+              </a:endParaRPr>
             </a:p>
-          </p:txBody>
-        </p:sp>
-        <p:sp>
-          <p:nvSpPr>
-            <p:cNvPr id="26" name="TextBox 25"/>
-            <p:cNvSpPr txBox="1"/>
-            <p:nvPr/>
-          </p:nvSpPr>
-          <p:spPr>
-            <a:xfrm>
-              <a:off x="-376688" y="516447"/>
-              <a:ext cx="2262158" cy="646331"/>
-            </a:xfrm>
-            <a:prstGeom prst="rect">
-              <a:avLst/>
-            </a:prstGeom>
-            <a:noFill/>
-          </p:spPr>
-          <p:txBody>
-            <a:bodyPr wrap="none" rtlCol="0">
-              <a:spAutoFit/>
-            </a:bodyPr>
-            <a:lstStyle/>
             <a:p>
               <a:pPr algn="ctr"/>
               <a:r>
-                <a:rPr lang="en-US" altLang="ko-KR" sz="3600" dirty="0">
+                <a:rPr lang="ko-KR" altLang="en-US" sz="2800" dirty="0">
+                  <a:solidFill>
+                    <a:schemeClr val="tx1"/>
+                  </a:solidFill>
                   <a:latin typeface="나눔스퀘어 Bold" panose="020B0600000101010101" pitchFamily="50" charset="-127"/>
                   <a:ea typeface="나눔스퀘어 Bold" panose="020B0600000101010101" pitchFamily="50" charset="-127"/>
                 </a:rPr>
-                <a:t>3</a:t>
+                <a:t>전략 </a:t>
               </a:r>
               <a:r>
-                <a:rPr lang="ko-KR" altLang="en-US" sz="3600" dirty="0" smtClean="0">
+                <a:rPr lang="en-US" altLang="ko-KR" sz="2800" dirty="0">
+                  <a:solidFill>
+                    <a:schemeClr val="tx1"/>
+                  </a:solidFill>
                   <a:latin typeface="나눔스퀘어 Bold" panose="020B0600000101010101" pitchFamily="50" charset="-127"/>
                   <a:ea typeface="나눔스퀘어 Bold" panose="020B0600000101010101" pitchFamily="50" charset="-127"/>
                 </a:rPr>
-                <a:t>차원 배열</a:t>
+                <a:t>C</a:t>
               </a:r>
-              <a:endParaRPr lang="ko-KR" altLang="en-US" sz="3600" dirty="0">
+              <a:endParaRPr lang="ko-KR" altLang="en-US" sz="2800" dirty="0">
+                <a:solidFill>
+                  <a:schemeClr val="tx1"/>
+                </a:solidFill>
                 <a:latin typeface="나눔스퀘어 Bold" panose="020B0600000101010101" pitchFamily="50" charset="-127"/>
                 <a:ea typeface="나눔스퀘어 Bold" panose="020B0600000101010101" pitchFamily="50" charset="-127"/>
               </a:endParaRPr>
@@ -13191,20 +11260,22 @@
         </p:sp>
         <p:sp>
           <p:nvSpPr>
-            <p:cNvPr id="35" name="아래쪽 화살표 34"/>
+            <p:cNvPr id="25" name="모서리가 둥근 직사각형 24"/>
             <p:cNvSpPr/>
             <p:nvPr/>
           </p:nvSpPr>
           <p:spPr>
             <a:xfrm>
-              <a:off x="538386" y="1162778"/>
-              <a:ext cx="432000" cy="720000"/>
+              <a:off x="1375950" y="4366350"/>
+              <a:ext cx="4320000" cy="1440000"/>
             </a:xfrm>
-            <a:prstGeom prst="downArrow">
+            <a:prstGeom prst="roundRect">
               <a:avLst/>
             </a:prstGeom>
             <a:solidFill>
-              <a:schemeClr val="accent2"/>
+              <a:schemeClr val="bg2">
+                <a:lumMod val="90000"/>
+              </a:schemeClr>
             </a:solidFill>
             <a:ln>
               <a:noFill/>
@@ -13231,55 +11302,33 @@
             <a:lstStyle/>
             <a:p>
               <a:pPr algn="ctr"/>
-              <a:endParaRPr lang="ko-KR" altLang="en-US" sz="3600" dirty="0"/>
+              <a:r>
+                <a:rPr lang="en-US" altLang="ko-KR" sz="2800" dirty="0" smtClean="0">
+                  <a:solidFill>
+                    <a:schemeClr val="tx1"/>
+                  </a:solidFill>
+                  <a:latin typeface="나눔스퀘어 Bold" panose="020B0600000101010101" pitchFamily="50" charset="-127"/>
+                  <a:ea typeface="나눔스퀘어 Bold" panose="020B0600000101010101" pitchFamily="50" charset="-127"/>
+                </a:rPr>
+                <a:t>Strategy</a:t>
+              </a:r>
             </a:p>
-          </p:txBody>
-        </p:sp>
-        <p:sp>
-          <p:nvSpPr>
-            <p:cNvPr id="37" name="TextBox 36"/>
-            <p:cNvSpPr txBox="1"/>
-            <p:nvPr/>
-          </p:nvSpPr>
-          <p:spPr>
-            <a:xfrm>
-              <a:off x="6164545" y="3894041"/>
-              <a:ext cx="4198585" cy="646331"/>
-            </a:xfrm>
-            <a:prstGeom prst="rect">
-              <a:avLst/>
-            </a:prstGeom>
-            <a:noFill/>
-          </p:spPr>
-          <p:txBody>
-            <a:bodyPr wrap="none" rtlCol="0">
-              <a:spAutoFit/>
-            </a:bodyPr>
-            <a:lstStyle/>
             <a:p>
               <a:pPr algn="ctr"/>
               <a:r>
-                <a:rPr lang="en-US" altLang="ko-KR" sz="3600" dirty="0" smtClean="0">
+                <a:rPr lang="ko-KR" altLang="en-US" sz="2800" dirty="0" smtClean="0">
+                  <a:solidFill>
+                    <a:schemeClr val="tx1"/>
+                  </a:solidFill>
                   <a:latin typeface="나눔스퀘어 Bold" panose="020B0600000101010101" pitchFamily="50" charset="-127"/>
                   <a:ea typeface="나눔스퀘어 Bold" panose="020B0600000101010101" pitchFamily="50" charset="-127"/>
                 </a:rPr>
-                <a:t>1</a:t>
+                <a:t>인터페이스</a:t>
               </a:r>
-              <a:r>
-                <a:rPr lang="ko-KR" altLang="en-US" sz="3600" dirty="0" smtClean="0">
-                  <a:latin typeface="나눔스퀘어 Bold" panose="020B0600000101010101" pitchFamily="50" charset="-127"/>
-                  <a:ea typeface="나눔스퀘어 Bold" panose="020B0600000101010101" pitchFamily="50" charset="-127"/>
-                </a:rPr>
-                <a:t>차원 배열의 길이</a:t>
-              </a:r>
-              <a:r>
-                <a:rPr lang="en-US" altLang="ko-KR" sz="3600" dirty="0" smtClean="0">
-                  <a:latin typeface="나눔스퀘어 Bold" panose="020B0600000101010101" pitchFamily="50" charset="-127"/>
-                  <a:ea typeface="나눔스퀘어 Bold" panose="020B0600000101010101" pitchFamily="50" charset="-127"/>
-                </a:rPr>
-                <a:t>: 3</a:t>
-              </a:r>
-              <a:endParaRPr lang="ko-KR" altLang="en-US" sz="3600" dirty="0">
+              <a:endParaRPr lang="ko-KR" altLang="en-US" sz="2800" dirty="0">
+                <a:solidFill>
+                  <a:schemeClr val="tx1"/>
+                </a:solidFill>
                 <a:latin typeface="나눔스퀘어 Bold" panose="020B0600000101010101" pitchFamily="50" charset="-127"/>
                 <a:ea typeface="나눔스퀘어 Bold" panose="020B0600000101010101" pitchFamily="50" charset="-127"/>
               </a:endParaRPr>
@@ -13288,65 +11337,22 @@
         </p:sp>
         <p:sp>
           <p:nvSpPr>
-            <p:cNvPr id="4" name="오른쪽 대괄호 3"/>
+            <p:cNvPr id="27" name="모서리가 둥근 직사각형 26"/>
             <p:cNvSpPr/>
             <p:nvPr/>
           </p:nvSpPr>
           <p:spPr>
-            <a:xfrm rot="16200000">
-              <a:off x="661469" y="909374"/>
-              <a:ext cx="216000" cy="2232000"/>
+            <a:xfrm>
+              <a:off x="-1729200" y="7658100"/>
+              <a:ext cx="2880000" cy="1440000"/>
             </a:xfrm>
-            <a:prstGeom prst="rightBracket">
-              <a:avLst>
-                <a:gd name="adj" fmla="val 78604"/>
-              </a:avLst>
-            </a:prstGeom>
-            <a:ln w="38100">
-              <a:solidFill>
-                <a:schemeClr val="tx1"/>
-              </a:solidFill>
-            </a:ln>
-          </p:spPr>
-          <p:style>
-            <a:lnRef idx="1">
-              <a:schemeClr val="accent1"/>
-            </a:lnRef>
-            <a:fillRef idx="0">
-              <a:schemeClr val="accent1"/>
-            </a:fillRef>
-            <a:effectRef idx="0">
-              <a:schemeClr val="accent1"/>
-            </a:effectRef>
-            <a:fontRef idx="minor">
-              <a:schemeClr val="tx1"/>
-            </a:fontRef>
-          </p:style>
-          <p:txBody>
-            <a:bodyPr rtlCol="0" anchor="ctr"/>
-            <a:lstStyle/>
-            <a:p>
-              <a:pPr algn="ctr"/>
-              <a:endParaRPr lang="ko-KR" altLang="en-US" dirty="0"/>
-            </a:p>
-          </p:txBody>
-        </p:sp>
-        <p:sp>
-          <p:nvSpPr>
-            <p:cNvPr id="17" name="아래쪽 화살표 16"/>
-            <p:cNvSpPr/>
-            <p:nvPr/>
-          </p:nvSpPr>
-          <p:spPr>
-            <a:xfrm rot="10800000">
-              <a:off x="12160114" y="3171142"/>
-              <a:ext cx="432000" cy="720000"/>
-            </a:xfrm>
-            <a:prstGeom prst="downArrow">
+            <a:prstGeom prst="roundRect">
               <a:avLst/>
             </a:prstGeom>
             <a:solidFill>
-              <a:schemeClr val="accent2"/>
+              <a:schemeClr val="bg2">
+                <a:lumMod val="90000"/>
+              </a:schemeClr>
             </a:solidFill>
             <a:ln>
               <a:noFill/>
@@ -13373,61 +11379,565 @@
             <a:lstStyle/>
             <a:p>
               <a:pPr algn="ctr"/>
-              <a:endParaRPr lang="ko-KR" altLang="en-US" sz="3600"/>
+              <a:r>
+                <a:rPr lang="en-US" altLang="ko-KR" sz="2800" dirty="0" smtClean="0">
+                  <a:solidFill>
+                    <a:schemeClr val="tx1"/>
+                  </a:solidFill>
+                  <a:latin typeface="나눔스퀘어 Bold" panose="020B0600000101010101" pitchFamily="50" charset="-127"/>
+                  <a:ea typeface="나눔스퀘어 Bold" panose="020B0600000101010101" pitchFamily="50" charset="-127"/>
+                </a:rPr>
+                <a:t>Strategy A</a:t>
+              </a:r>
+            </a:p>
+            <a:p>
+              <a:pPr algn="ctr"/>
+              <a:r>
+                <a:rPr lang="ko-KR" altLang="en-US" sz="2800" dirty="0" smtClean="0">
+                  <a:solidFill>
+                    <a:schemeClr val="tx1"/>
+                  </a:solidFill>
+                  <a:latin typeface="나눔스퀘어 Bold" panose="020B0600000101010101" pitchFamily="50" charset="-127"/>
+                  <a:ea typeface="나눔스퀘어 Bold" panose="020B0600000101010101" pitchFamily="50" charset="-127"/>
+                </a:rPr>
+                <a:t>전략 </a:t>
+              </a:r>
+              <a:r>
+                <a:rPr lang="en-US" altLang="ko-KR" sz="2800" dirty="0">
+                  <a:solidFill>
+                    <a:schemeClr val="tx1"/>
+                  </a:solidFill>
+                  <a:latin typeface="나눔스퀘어 Bold" panose="020B0600000101010101" pitchFamily="50" charset="-127"/>
+                  <a:ea typeface="나눔스퀘어 Bold" panose="020B0600000101010101" pitchFamily="50" charset="-127"/>
+                </a:rPr>
+                <a:t>A</a:t>
+              </a:r>
+              <a:endParaRPr lang="ko-KR" altLang="en-US" sz="2800" dirty="0">
+                <a:solidFill>
+                  <a:schemeClr val="tx1"/>
+                </a:solidFill>
+                <a:latin typeface="나눔스퀘어 Bold" panose="020B0600000101010101" pitchFamily="50" charset="-127"/>
+                <a:ea typeface="나눔스퀘어 Bold" panose="020B0600000101010101" pitchFamily="50" charset="-127"/>
+              </a:endParaRPr>
+            </a:p>
+          </p:txBody>
+        </p:sp>
+        <p:cxnSp>
+          <p:nvCxnSpPr>
+            <p:cNvPr id="16" name="꺾인 연결선 15"/>
+            <p:cNvCxnSpPr>
+              <a:stCxn id="25" idx="2"/>
+            </p:cNvCxnSpPr>
+            <p:nvPr/>
+          </p:nvCxnSpPr>
+          <p:spPr>
+            <a:xfrm rot="5400000">
+              <a:off x="2610075" y="6732225"/>
+              <a:ext cx="1851750" cy="12700"/>
+            </a:xfrm>
+            <a:prstGeom prst="bentConnector3">
+              <a:avLst/>
+            </a:prstGeom>
+            <a:ln w="76200">
+              <a:solidFill>
+                <a:schemeClr val="accent2"/>
+              </a:solidFill>
+              <a:tailEnd type="triangle"/>
+            </a:ln>
+          </p:spPr>
+          <p:style>
+            <a:lnRef idx="1">
+              <a:schemeClr val="accent1"/>
+            </a:lnRef>
+            <a:fillRef idx="0">
+              <a:schemeClr val="accent1"/>
+            </a:fillRef>
+            <a:effectRef idx="0">
+              <a:schemeClr val="accent1"/>
+            </a:effectRef>
+            <a:fontRef idx="minor">
+              <a:schemeClr val="tx1"/>
+            </a:fontRef>
+          </p:style>
+        </p:cxnSp>
+        <p:cxnSp>
+          <p:nvCxnSpPr>
+            <p:cNvPr id="30" name="꺾인 연결선 29"/>
+            <p:cNvCxnSpPr>
+              <a:stCxn id="25" idx="2"/>
+              <a:endCxn id="24" idx="0"/>
+            </p:cNvCxnSpPr>
+            <p:nvPr/>
+          </p:nvCxnSpPr>
+          <p:spPr>
+            <a:xfrm rot="16200000" flipH="1">
+              <a:off x="4522650" y="4819650"/>
+              <a:ext cx="1851750" cy="3825150"/>
+            </a:xfrm>
+            <a:prstGeom prst="bentConnector3">
+              <a:avLst/>
+            </a:prstGeom>
+            <a:ln w="76200">
+              <a:solidFill>
+                <a:schemeClr val="accent2"/>
+              </a:solidFill>
+              <a:tailEnd type="triangle"/>
+            </a:ln>
+          </p:spPr>
+          <p:style>
+            <a:lnRef idx="1">
+              <a:schemeClr val="accent1"/>
+            </a:lnRef>
+            <a:fillRef idx="0">
+              <a:schemeClr val="accent1"/>
+            </a:fillRef>
+            <a:effectRef idx="0">
+              <a:schemeClr val="accent1"/>
+            </a:effectRef>
+            <a:fontRef idx="minor">
+              <a:schemeClr val="tx1"/>
+            </a:fontRef>
+          </p:style>
+        </p:cxnSp>
+        <p:cxnSp>
+          <p:nvCxnSpPr>
+            <p:cNvPr id="33" name="꺾인 연결선 32"/>
+            <p:cNvCxnSpPr>
+              <a:stCxn id="25" idx="2"/>
+              <a:endCxn id="27" idx="0"/>
+            </p:cNvCxnSpPr>
+            <p:nvPr/>
+          </p:nvCxnSpPr>
+          <p:spPr>
+            <a:xfrm rot="5400000">
+              <a:off x="697500" y="4819650"/>
+              <a:ext cx="1851750" cy="3825150"/>
+            </a:xfrm>
+            <a:prstGeom prst="bentConnector3">
+              <a:avLst/>
+            </a:prstGeom>
+            <a:ln w="76200">
+              <a:solidFill>
+                <a:schemeClr val="accent2"/>
+              </a:solidFill>
+              <a:tailEnd type="triangle"/>
+            </a:ln>
+          </p:spPr>
+          <p:style>
+            <a:lnRef idx="1">
+              <a:schemeClr val="accent1"/>
+            </a:lnRef>
+            <a:fillRef idx="0">
+              <a:schemeClr val="accent1"/>
+            </a:fillRef>
+            <a:effectRef idx="0">
+              <a:schemeClr val="accent1"/>
+            </a:effectRef>
+            <a:fontRef idx="minor">
+              <a:schemeClr val="tx1"/>
+            </a:fontRef>
+          </p:style>
+        </p:cxnSp>
+      </p:grpSp>
+      <p:grpSp>
+        <p:nvGrpSpPr>
+          <p:cNvPr id="34" name="그룹 33"/>
+          <p:cNvGrpSpPr/>
+          <p:nvPr/>
+        </p:nvGrpSpPr>
+        <p:grpSpPr>
+          <a:xfrm>
+            <a:off x="1150800" y="-1772200"/>
+            <a:ext cx="10530300" cy="4731750"/>
+            <a:chOff x="1150800" y="-1772200"/>
+            <a:chExt cx="10530300" cy="4731750"/>
+          </a:xfrm>
+        </p:grpSpPr>
+        <p:sp>
+          <p:nvSpPr>
+            <p:cNvPr id="36" name="모서리가 둥근 직사각형 35"/>
+            <p:cNvSpPr/>
+            <p:nvPr/>
+          </p:nvSpPr>
+          <p:spPr>
+            <a:xfrm>
+              <a:off x="4975950" y="1519550"/>
+              <a:ext cx="2880000" cy="1440000"/>
+            </a:xfrm>
+            <a:prstGeom prst="roundRect">
+              <a:avLst/>
+            </a:prstGeom>
+            <a:solidFill>
+              <a:schemeClr val="bg2">
+                <a:lumMod val="90000"/>
+              </a:schemeClr>
+            </a:solidFill>
+            <a:ln>
+              <a:noFill/>
+            </a:ln>
+          </p:spPr>
+          <p:style>
+            <a:lnRef idx="2">
+              <a:schemeClr val="accent1">
+                <a:shade val="50000"/>
+              </a:schemeClr>
+            </a:lnRef>
+            <a:fillRef idx="1">
+              <a:schemeClr val="accent1"/>
+            </a:fillRef>
+            <a:effectRef idx="0">
+              <a:schemeClr val="accent1"/>
+            </a:effectRef>
+            <a:fontRef idx="minor">
+              <a:schemeClr val="lt1"/>
+            </a:fontRef>
+          </p:style>
+          <p:txBody>
+            <a:bodyPr rtlCol="0" anchor="ctr"/>
+            <a:lstStyle/>
+            <a:p>
+              <a:pPr algn="ctr"/>
+              <a:r>
+                <a:rPr lang="ko-KR" altLang="en-US" sz="2800" dirty="0" smtClean="0">
+                  <a:solidFill>
+                    <a:schemeClr val="tx1"/>
+                  </a:solidFill>
+                  <a:latin typeface="나눔스퀘어 Bold" panose="020B0600000101010101" pitchFamily="50" charset="-127"/>
+                  <a:ea typeface="나눔스퀘어 Bold" panose="020B0600000101010101" pitchFamily="50" charset="-127"/>
+                </a:rPr>
+                <a:t>현금</a:t>
+              </a:r>
+              <a:endParaRPr lang="ko-KR" altLang="en-US" sz="2800" dirty="0">
+                <a:solidFill>
+                  <a:schemeClr val="tx1"/>
+                </a:solidFill>
+                <a:latin typeface="나눔스퀘어 Bold" panose="020B0600000101010101" pitchFamily="50" charset="-127"/>
+                <a:ea typeface="나눔스퀘어 Bold" panose="020B0600000101010101" pitchFamily="50" charset="-127"/>
+              </a:endParaRPr>
             </a:p>
           </p:txBody>
         </p:sp>
         <p:sp>
           <p:nvSpPr>
-            <p:cNvPr id="20" name="TextBox 19"/>
-            <p:cNvSpPr txBox="1"/>
+            <p:cNvPr id="38" name="모서리가 둥근 직사각형 37"/>
+            <p:cNvSpPr/>
             <p:nvPr/>
           </p:nvSpPr>
           <p:spPr>
             <a:xfrm>
-              <a:off x="11355591" y="3961282"/>
-              <a:ext cx="4198585" cy="646331"/>
+              <a:off x="8801100" y="1519550"/>
+              <a:ext cx="2880000" cy="1440000"/>
             </a:xfrm>
-            <a:prstGeom prst="rect">
+            <a:prstGeom prst="roundRect">
               <a:avLst/>
             </a:prstGeom>
-            <a:noFill/>
+            <a:solidFill>
+              <a:schemeClr val="bg2">
+                <a:lumMod val="90000"/>
+              </a:schemeClr>
+            </a:solidFill>
+            <a:ln>
+              <a:noFill/>
+            </a:ln>
           </p:spPr>
+          <p:style>
+            <a:lnRef idx="2">
+              <a:schemeClr val="accent1">
+                <a:shade val="50000"/>
+              </a:schemeClr>
+            </a:lnRef>
+            <a:fillRef idx="1">
+              <a:schemeClr val="accent1"/>
+            </a:fillRef>
+            <a:effectRef idx="0">
+              <a:schemeClr val="accent1"/>
+            </a:effectRef>
+            <a:fontRef idx="minor">
+              <a:schemeClr val="lt1"/>
+            </a:fontRef>
+          </p:style>
           <p:txBody>
-            <a:bodyPr wrap="none" rtlCol="0">
-              <a:spAutoFit/>
-            </a:bodyPr>
+            <a:bodyPr rtlCol="0" anchor="ctr"/>
             <a:lstStyle/>
             <a:p>
               <a:pPr algn="ctr"/>
               <a:r>
-                <a:rPr lang="en-US" altLang="ko-KR" sz="3600" dirty="0">
+                <a:rPr lang="ko-KR" altLang="en-US" sz="2800" dirty="0" err="1" smtClean="0">
+                  <a:solidFill>
+                    <a:schemeClr val="tx1"/>
+                  </a:solidFill>
                   <a:latin typeface="나눔스퀘어 Bold" panose="020B0600000101010101" pitchFamily="50" charset="-127"/>
                   <a:ea typeface="나눔스퀘어 Bold" panose="020B0600000101010101" pitchFamily="50" charset="-127"/>
                 </a:rPr>
-                <a:t>3</a:t>
+                <a:t>삼성페이</a:t>
               </a:r>
-              <a:r>
-                <a:rPr lang="ko-KR" altLang="en-US" sz="3600" dirty="0" smtClean="0">
-                  <a:latin typeface="나눔스퀘어 Bold" panose="020B0600000101010101" pitchFamily="50" charset="-127"/>
-                  <a:ea typeface="나눔스퀘어 Bold" panose="020B0600000101010101" pitchFamily="50" charset="-127"/>
-                </a:rPr>
-                <a:t>차원 배열의 길이</a:t>
-              </a:r>
-              <a:r>
-                <a:rPr lang="en-US" altLang="ko-KR" sz="3600" dirty="0" smtClean="0">
-                  <a:latin typeface="나눔스퀘어 Bold" panose="020B0600000101010101" pitchFamily="50" charset="-127"/>
-                  <a:ea typeface="나눔스퀘어 Bold" panose="020B0600000101010101" pitchFamily="50" charset="-127"/>
-                </a:rPr>
-                <a:t>: 2</a:t>
-              </a:r>
-              <a:endParaRPr lang="ko-KR" altLang="en-US" sz="3600" dirty="0">
+              <a:endParaRPr lang="ko-KR" altLang="en-US" sz="2800" dirty="0">
+                <a:solidFill>
+                  <a:schemeClr val="tx1"/>
+                </a:solidFill>
                 <a:latin typeface="나눔스퀘어 Bold" panose="020B0600000101010101" pitchFamily="50" charset="-127"/>
                 <a:ea typeface="나눔스퀘어 Bold" panose="020B0600000101010101" pitchFamily="50" charset="-127"/>
               </a:endParaRPr>
             </a:p>
           </p:txBody>
         </p:sp>
+        <p:sp>
+          <p:nvSpPr>
+            <p:cNvPr id="39" name="모서리가 둥근 직사각형 38"/>
+            <p:cNvSpPr/>
+            <p:nvPr/>
+          </p:nvSpPr>
+          <p:spPr>
+            <a:xfrm>
+              <a:off x="4255950" y="-1772200"/>
+              <a:ext cx="4320000" cy="1440000"/>
+            </a:xfrm>
+            <a:prstGeom prst="roundRect">
+              <a:avLst/>
+            </a:prstGeom>
+            <a:solidFill>
+              <a:schemeClr val="bg2">
+                <a:lumMod val="90000"/>
+              </a:schemeClr>
+            </a:solidFill>
+            <a:ln>
+              <a:noFill/>
+            </a:ln>
+          </p:spPr>
+          <p:style>
+            <a:lnRef idx="2">
+              <a:schemeClr val="accent1">
+                <a:shade val="50000"/>
+              </a:schemeClr>
+            </a:lnRef>
+            <a:fillRef idx="1">
+              <a:schemeClr val="accent1"/>
+            </a:fillRef>
+            <a:effectRef idx="0">
+              <a:schemeClr val="accent1"/>
+            </a:effectRef>
+            <a:fontRef idx="minor">
+              <a:schemeClr val="lt1"/>
+            </a:fontRef>
+          </p:style>
+          <p:txBody>
+            <a:bodyPr rtlCol="0" anchor="ctr"/>
+            <a:lstStyle/>
+            <a:p>
+              <a:pPr algn="ctr"/>
+              <a:r>
+                <a:rPr lang="en-US" altLang="ko-KR" sz="2800" dirty="0" smtClean="0">
+                  <a:solidFill>
+                    <a:schemeClr val="tx1"/>
+                  </a:solidFill>
+                  <a:latin typeface="나눔스퀘어 Bold" panose="020B0600000101010101" pitchFamily="50" charset="-127"/>
+                  <a:ea typeface="나눔스퀘어 Bold" panose="020B0600000101010101" pitchFamily="50" charset="-127"/>
+                </a:rPr>
+                <a:t>Payment Strategy</a:t>
+              </a:r>
+            </a:p>
+            <a:p>
+              <a:pPr algn="ctr"/>
+              <a:r>
+                <a:rPr lang="ko-KR" altLang="en-US" sz="2800" dirty="0" smtClean="0">
+                  <a:solidFill>
+                    <a:schemeClr val="tx1"/>
+                  </a:solidFill>
+                  <a:latin typeface="나눔스퀘어 Bold" panose="020B0600000101010101" pitchFamily="50" charset="-127"/>
+                  <a:ea typeface="나눔스퀘어 Bold" panose="020B0600000101010101" pitchFamily="50" charset="-127"/>
+                </a:rPr>
+                <a:t>인터페이스 예시</a:t>
+              </a:r>
+              <a:endParaRPr lang="ko-KR" altLang="en-US" sz="2800" dirty="0">
+                <a:solidFill>
+                  <a:schemeClr val="tx1"/>
+                </a:solidFill>
+                <a:latin typeface="나눔스퀘어 Bold" panose="020B0600000101010101" pitchFamily="50" charset="-127"/>
+                <a:ea typeface="나눔스퀘어 Bold" panose="020B0600000101010101" pitchFamily="50" charset="-127"/>
+              </a:endParaRPr>
+            </a:p>
+          </p:txBody>
+        </p:sp>
+        <p:sp>
+          <p:nvSpPr>
+            <p:cNvPr id="40" name="모서리가 둥근 직사각형 39"/>
+            <p:cNvSpPr/>
+            <p:nvPr/>
+          </p:nvSpPr>
+          <p:spPr>
+            <a:xfrm>
+              <a:off x="1150800" y="1519550"/>
+              <a:ext cx="2880000" cy="1440000"/>
+            </a:xfrm>
+            <a:prstGeom prst="roundRect">
+              <a:avLst/>
+            </a:prstGeom>
+            <a:solidFill>
+              <a:schemeClr val="bg2">
+                <a:lumMod val="90000"/>
+              </a:schemeClr>
+            </a:solidFill>
+            <a:ln>
+              <a:noFill/>
+            </a:ln>
+          </p:spPr>
+          <p:style>
+            <a:lnRef idx="2">
+              <a:schemeClr val="accent1">
+                <a:shade val="50000"/>
+              </a:schemeClr>
+            </a:lnRef>
+            <a:fillRef idx="1">
+              <a:schemeClr val="accent1"/>
+            </a:fillRef>
+            <a:effectRef idx="0">
+              <a:schemeClr val="accent1"/>
+            </a:effectRef>
+            <a:fontRef idx="minor">
+              <a:schemeClr val="lt1"/>
+            </a:fontRef>
+          </p:style>
+          <p:txBody>
+            <a:bodyPr rtlCol="0" anchor="ctr"/>
+            <a:lstStyle/>
+            <a:p>
+              <a:pPr algn="ctr"/>
+              <a:r>
+                <a:rPr lang="ko-KR" altLang="en-US" sz="2800" dirty="0" smtClean="0">
+                  <a:solidFill>
+                    <a:schemeClr val="tx1"/>
+                  </a:solidFill>
+                  <a:latin typeface="나눔스퀘어 Bold" panose="020B0600000101010101" pitchFamily="50" charset="-127"/>
+                  <a:ea typeface="나눔스퀘어 Bold" panose="020B0600000101010101" pitchFamily="50" charset="-127"/>
+                </a:rPr>
+                <a:t>카드</a:t>
+              </a:r>
+              <a:endParaRPr lang="ko-KR" altLang="en-US" sz="2800" dirty="0">
+                <a:solidFill>
+                  <a:schemeClr val="tx1"/>
+                </a:solidFill>
+                <a:latin typeface="나눔스퀘어 Bold" panose="020B0600000101010101" pitchFamily="50" charset="-127"/>
+                <a:ea typeface="나눔스퀘어 Bold" panose="020B0600000101010101" pitchFamily="50" charset="-127"/>
+              </a:endParaRPr>
+            </a:p>
+          </p:txBody>
+        </p:sp>
+        <p:cxnSp>
+          <p:nvCxnSpPr>
+            <p:cNvPr id="41" name="꺾인 연결선 40"/>
+            <p:cNvCxnSpPr>
+              <a:stCxn id="39" idx="2"/>
+            </p:cNvCxnSpPr>
+            <p:nvPr/>
+          </p:nvCxnSpPr>
+          <p:spPr>
+            <a:xfrm rot="5400000">
+              <a:off x="5490075" y="593675"/>
+              <a:ext cx="1851750" cy="12700"/>
+            </a:xfrm>
+            <a:prstGeom prst="bentConnector3">
+              <a:avLst/>
+            </a:prstGeom>
+            <a:ln w="76200">
+              <a:solidFill>
+                <a:schemeClr val="accent2"/>
+              </a:solidFill>
+              <a:tailEnd type="triangle"/>
+            </a:ln>
+          </p:spPr>
+          <p:style>
+            <a:lnRef idx="1">
+              <a:schemeClr val="accent1"/>
+            </a:lnRef>
+            <a:fillRef idx="0">
+              <a:schemeClr val="accent1"/>
+            </a:fillRef>
+            <a:effectRef idx="0">
+              <a:schemeClr val="accent1"/>
+            </a:effectRef>
+            <a:fontRef idx="minor">
+              <a:schemeClr val="tx1"/>
+            </a:fontRef>
+          </p:style>
+        </p:cxnSp>
+        <p:cxnSp>
+          <p:nvCxnSpPr>
+            <p:cNvPr id="42" name="꺾인 연결선 41"/>
+            <p:cNvCxnSpPr>
+              <a:stCxn id="39" idx="2"/>
+              <a:endCxn id="38" idx="0"/>
+            </p:cNvCxnSpPr>
+            <p:nvPr/>
+          </p:nvCxnSpPr>
+          <p:spPr>
+            <a:xfrm rot="16200000" flipH="1">
+              <a:off x="7402650" y="-1318900"/>
+              <a:ext cx="1851750" cy="3825150"/>
+            </a:xfrm>
+            <a:prstGeom prst="bentConnector3">
+              <a:avLst/>
+            </a:prstGeom>
+            <a:ln w="76200">
+              <a:solidFill>
+                <a:schemeClr val="accent2"/>
+              </a:solidFill>
+              <a:tailEnd type="triangle"/>
+            </a:ln>
+          </p:spPr>
+          <p:style>
+            <a:lnRef idx="1">
+              <a:schemeClr val="accent1"/>
+            </a:lnRef>
+            <a:fillRef idx="0">
+              <a:schemeClr val="accent1"/>
+            </a:fillRef>
+            <a:effectRef idx="0">
+              <a:schemeClr val="accent1"/>
+            </a:effectRef>
+            <a:fontRef idx="minor">
+              <a:schemeClr val="tx1"/>
+            </a:fontRef>
+          </p:style>
+        </p:cxnSp>
+        <p:cxnSp>
+          <p:nvCxnSpPr>
+            <p:cNvPr id="43" name="꺾인 연결선 42"/>
+            <p:cNvCxnSpPr>
+              <a:stCxn id="39" idx="2"/>
+              <a:endCxn id="40" idx="0"/>
+            </p:cNvCxnSpPr>
+            <p:nvPr/>
+          </p:nvCxnSpPr>
+          <p:spPr>
+            <a:xfrm rot="5400000">
+              <a:off x="3577500" y="-1318900"/>
+              <a:ext cx="1851750" cy="3825150"/>
+            </a:xfrm>
+            <a:prstGeom prst="bentConnector3">
+              <a:avLst/>
+            </a:prstGeom>
+            <a:ln w="76200">
+              <a:solidFill>
+                <a:schemeClr val="accent2"/>
+              </a:solidFill>
+              <a:tailEnd type="triangle"/>
+            </a:ln>
+          </p:spPr>
+          <p:style>
+            <a:lnRef idx="1">
+              <a:schemeClr val="accent1"/>
+            </a:lnRef>
+            <a:fillRef idx="0">
+              <a:schemeClr val="accent1"/>
+            </a:fillRef>
+            <a:effectRef idx="0">
+              <a:schemeClr val="accent1"/>
+            </a:effectRef>
+            <a:fontRef idx="minor">
+              <a:schemeClr val="tx1"/>
+            </a:fontRef>
+          </p:style>
+        </p:cxnSp>
       </p:grpSp>
     </p:spTree>
     <p:extLst>

</xml_diff>

<commit_message>
20260813 commit : finish
</commit_message>
<xml_diff>
--- a/create_notion_img.pptx
+++ b/create_notion_img.pptx
@@ -10,6 +10,7 @@
     <p:sldId id="259" r:id="rId4"/>
     <p:sldId id="257" r:id="rId5"/>
     <p:sldId id="258" r:id="rId6"/>
+    <p:sldId id="263" r:id="rId7"/>
   </p:sldIdLst>
   <p:sldSz cx="12192000" cy="6858000"/>
   <p:notesSz cx="6858000" cy="9144000"/>
@@ -247,7 +248,7 @@
           <a:p>
             <a:fld id="{7237CE1A-8831-48B5-BA93-72483C6E34E8}" type="datetimeFigureOut">
               <a:rPr lang="ko-KR" altLang="en-US" smtClean="0"/>
-              <a:t>2026-08-13</a:t>
+              <a:t>26-08-13(Thu)</a:t>
             </a:fld>
             <a:endParaRPr lang="ko-KR" altLang="en-US"/>
           </a:p>
@@ -417,7 +418,7 @@
           <a:p>
             <a:fld id="{7237CE1A-8831-48B5-BA93-72483C6E34E8}" type="datetimeFigureOut">
               <a:rPr lang="ko-KR" altLang="en-US" smtClean="0"/>
-              <a:t>2026-08-13</a:t>
+              <a:t>26-08-13(Thu)</a:t>
             </a:fld>
             <a:endParaRPr lang="ko-KR" altLang="en-US"/>
           </a:p>
@@ -597,7 +598,7 @@
           <a:p>
             <a:fld id="{7237CE1A-8831-48B5-BA93-72483C6E34E8}" type="datetimeFigureOut">
               <a:rPr lang="ko-KR" altLang="en-US" smtClean="0"/>
-              <a:t>2026-08-13</a:t>
+              <a:t>26-08-13(Thu)</a:t>
             </a:fld>
             <a:endParaRPr lang="ko-KR" altLang="en-US"/>
           </a:p>
@@ -767,7 +768,7 @@
           <a:p>
             <a:fld id="{7237CE1A-8831-48B5-BA93-72483C6E34E8}" type="datetimeFigureOut">
               <a:rPr lang="ko-KR" altLang="en-US" smtClean="0"/>
-              <a:t>2026-08-13</a:t>
+              <a:t>26-08-13(Thu)</a:t>
             </a:fld>
             <a:endParaRPr lang="ko-KR" altLang="en-US"/>
           </a:p>
@@ -1013,7 +1014,7 @@
           <a:p>
             <a:fld id="{7237CE1A-8831-48B5-BA93-72483C6E34E8}" type="datetimeFigureOut">
               <a:rPr lang="ko-KR" altLang="en-US" smtClean="0"/>
-              <a:t>2026-08-13</a:t>
+              <a:t>26-08-13(Thu)</a:t>
             </a:fld>
             <a:endParaRPr lang="ko-KR" altLang="en-US"/>
           </a:p>
@@ -1245,7 +1246,7 @@
           <a:p>
             <a:fld id="{7237CE1A-8831-48B5-BA93-72483C6E34E8}" type="datetimeFigureOut">
               <a:rPr lang="ko-KR" altLang="en-US" smtClean="0"/>
-              <a:t>2026-08-13</a:t>
+              <a:t>26-08-13(Thu)</a:t>
             </a:fld>
             <a:endParaRPr lang="ko-KR" altLang="en-US"/>
           </a:p>
@@ -1612,7 +1613,7 @@
           <a:p>
             <a:fld id="{7237CE1A-8831-48B5-BA93-72483C6E34E8}" type="datetimeFigureOut">
               <a:rPr lang="ko-KR" altLang="en-US" smtClean="0"/>
-              <a:t>2026-08-13</a:t>
+              <a:t>26-08-13(Thu)</a:t>
             </a:fld>
             <a:endParaRPr lang="ko-KR" altLang="en-US"/>
           </a:p>
@@ -1730,7 +1731,7 @@
           <a:p>
             <a:fld id="{7237CE1A-8831-48B5-BA93-72483C6E34E8}" type="datetimeFigureOut">
               <a:rPr lang="ko-KR" altLang="en-US" smtClean="0"/>
-              <a:t>2026-08-13</a:t>
+              <a:t>26-08-13(Thu)</a:t>
             </a:fld>
             <a:endParaRPr lang="ko-KR" altLang="en-US"/>
           </a:p>
@@ -1825,7 +1826,7 @@
           <a:p>
             <a:fld id="{7237CE1A-8831-48B5-BA93-72483C6E34E8}" type="datetimeFigureOut">
               <a:rPr lang="ko-KR" altLang="en-US" smtClean="0"/>
-              <a:t>2026-08-13</a:t>
+              <a:t>26-08-13(Thu)</a:t>
             </a:fld>
             <a:endParaRPr lang="ko-KR" altLang="en-US"/>
           </a:p>
@@ -2102,7 +2103,7 @@
           <a:p>
             <a:fld id="{7237CE1A-8831-48B5-BA93-72483C6E34E8}" type="datetimeFigureOut">
               <a:rPr lang="ko-KR" altLang="en-US" smtClean="0"/>
-              <a:t>2026-08-13</a:t>
+              <a:t>26-08-13(Thu)</a:t>
             </a:fld>
             <a:endParaRPr lang="ko-KR" altLang="en-US"/>
           </a:p>
@@ -2355,7 +2356,7 @@
           <a:p>
             <a:fld id="{7237CE1A-8831-48B5-BA93-72483C6E34E8}" type="datetimeFigureOut">
               <a:rPr lang="ko-KR" altLang="en-US" smtClean="0"/>
-              <a:t>2026-08-13</a:t>
+              <a:t>26-08-13(Thu)</a:t>
             </a:fld>
             <a:endParaRPr lang="ko-KR" altLang="en-US"/>
           </a:p>
@@ -2568,7 +2569,7 @@
           <a:p>
             <a:fld id="{7237CE1A-8831-48B5-BA93-72483C6E34E8}" type="datetimeFigureOut">
               <a:rPr lang="ko-KR" altLang="en-US" smtClean="0"/>
-              <a:t>2026-08-13</a:t>
+              <a:t>26-08-13(Thu)</a:t>
             </a:fld>
             <a:endParaRPr lang="ko-KR" altLang="en-US"/>
           </a:p>
@@ -11038,35 +11039,122 @@
       </p:grpSpPr>
       <p:grpSp>
         <p:nvGrpSpPr>
-          <p:cNvPr id="51" name="그룹 50"/>
+          <p:cNvPr id="82" name="그룹 81"/>
           <p:cNvGrpSpPr/>
           <p:nvPr/>
         </p:nvGrpSpPr>
         <p:grpSpPr>
           <a:xfrm>
-            <a:off x="-1729200" y="4366350"/>
-            <a:ext cx="10530300" cy="4731750"/>
-            <a:chOff x="-1729200" y="4366350"/>
-            <a:chExt cx="10530300" cy="4731750"/>
+            <a:off x="1447800" y="1473200"/>
+            <a:ext cx="8721500" cy="2160000"/>
+            <a:chOff x="1447800" y="1473200"/>
+            <a:chExt cx="8721500" cy="2160000"/>
           </a:xfrm>
         </p:grpSpPr>
         <p:sp>
           <p:nvSpPr>
-            <p:cNvPr id="23" name="모서리가 둥근 직사각형 22"/>
+            <p:cNvPr id="69" name="직사각형 68"/>
             <p:cNvSpPr/>
             <p:nvPr/>
           </p:nvSpPr>
           <p:spPr>
             <a:xfrm>
-              <a:off x="2095950" y="7658100"/>
-              <a:ext cx="2880000" cy="1440000"/>
+              <a:off x="4368550" y="1473200"/>
+              <a:ext cx="3600000" cy="2160000"/>
+            </a:xfrm>
+            <a:prstGeom prst="rect">
+              <a:avLst/>
+            </a:prstGeom>
+            <a:solidFill>
+              <a:schemeClr val="bg1">
+                <a:lumMod val="95000"/>
+              </a:schemeClr>
+            </a:solidFill>
+            <a:ln w="28575">
+              <a:solidFill>
+                <a:schemeClr val="tx1"/>
+              </a:solidFill>
+            </a:ln>
+          </p:spPr>
+          <p:style>
+            <a:lnRef idx="2">
+              <a:schemeClr val="accent1">
+                <a:shade val="50000"/>
+              </a:schemeClr>
+            </a:lnRef>
+            <a:fillRef idx="1">
+              <a:schemeClr val="accent1"/>
+            </a:fillRef>
+            <a:effectRef idx="0">
+              <a:schemeClr val="accent1"/>
+            </a:effectRef>
+            <a:fontRef idx="minor">
+              <a:schemeClr val="lt1"/>
+            </a:fontRef>
+          </p:style>
+          <p:txBody>
+            <a:bodyPr rtlCol="0" anchor="ctr"/>
+            <a:lstStyle/>
+            <a:p>
+              <a:pPr algn="ctr"/>
+              <a:r>
+                <a:rPr lang="ko-KR" altLang="en-US" sz="2800" dirty="0" smtClean="0">
+                  <a:solidFill>
+                    <a:schemeClr val="tx1"/>
+                  </a:solidFill>
+                  <a:latin typeface="나눔스퀘어 Bold" panose="020B0600000101010101" pitchFamily="50" charset="-127"/>
+                  <a:ea typeface="나눔스퀘어 Bold" panose="020B0600000101010101" pitchFamily="50" charset="-127"/>
+                </a:rPr>
+                <a:t>객체 </a:t>
+              </a:r>
+              <a:r>
+                <a:rPr lang="en-US" altLang="ko-KR" sz="2800" dirty="0" smtClean="0">
+                  <a:solidFill>
+                    <a:schemeClr val="tx1"/>
+                  </a:solidFill>
+                  <a:latin typeface="나눔스퀘어 Bold" panose="020B0600000101010101" pitchFamily="50" charset="-127"/>
+                  <a:ea typeface="나눔스퀘어 Bold" panose="020B0600000101010101" pitchFamily="50" charset="-127"/>
+                </a:rPr>
+                <a:t>1</a:t>
+              </a:r>
+              <a:r>
+                <a:rPr lang="ko-KR" altLang="en-US" sz="2800" dirty="0" smtClean="0">
+                  <a:solidFill>
+                    <a:schemeClr val="tx1"/>
+                  </a:solidFill>
+                  <a:latin typeface="나눔스퀘어 Bold" panose="020B0600000101010101" pitchFamily="50" charset="-127"/>
+                  <a:ea typeface="나눔스퀘어 Bold" panose="020B0600000101010101" pitchFamily="50" charset="-127"/>
+                </a:rPr>
+                <a:t>개</a:t>
+              </a:r>
+              <a:endParaRPr lang="ko-KR" altLang="en-US" sz="2800" dirty="0">
+                <a:solidFill>
+                  <a:schemeClr val="tx1"/>
+                </a:solidFill>
+                <a:latin typeface="나눔스퀘어 Bold" panose="020B0600000101010101" pitchFamily="50" charset="-127"/>
+                <a:ea typeface="나눔스퀘어 Bold" panose="020B0600000101010101" pitchFamily="50" charset="-127"/>
+              </a:endParaRPr>
+            </a:p>
+          </p:txBody>
+        </p:sp>
+        <p:sp>
+          <p:nvSpPr>
+            <p:cNvPr id="70" name="모서리가 둥근 직사각형 69"/>
+            <p:cNvSpPr/>
+            <p:nvPr/>
+          </p:nvSpPr>
+          <p:spPr>
+            <a:xfrm>
+              <a:off x="1447800" y="2193200"/>
+              <a:ext cx="2160000" cy="720000"/>
             </a:xfrm>
             <a:prstGeom prst="roundRect">
               <a:avLst/>
             </a:prstGeom>
             <a:solidFill>
-              <a:schemeClr val="bg2">
-                <a:lumMod val="90000"/>
+              <a:schemeClr val="accent4">
+                <a:lumMod val="40000"/>
+                <a:lumOff val="60000"/>
               </a:schemeClr>
             </a:solidFill>
             <a:ln>
@@ -11095,56 +11183,16 @@
             <a:p>
               <a:pPr algn="ctr"/>
               <a:r>
-                <a:rPr lang="en-US" altLang="ko-KR" sz="2800" dirty="0">
+                <a:rPr lang="en-US" altLang="ko-KR" sz="2400" dirty="0">
                   <a:solidFill>
                     <a:schemeClr val="tx1"/>
                   </a:solidFill>
                   <a:latin typeface="나눔스퀘어 Bold" panose="020B0600000101010101" pitchFamily="50" charset="-127"/>
                   <a:ea typeface="나눔스퀘어 Bold" panose="020B0600000101010101" pitchFamily="50" charset="-127"/>
                 </a:rPr>
-                <a:t>Strategy </a:t>
-              </a:r>
-              <a:r>
-                <a:rPr lang="en-US" altLang="ko-KR" sz="2800" dirty="0" smtClean="0">
-                  <a:solidFill>
-                    <a:schemeClr val="tx1"/>
-                  </a:solidFill>
-                  <a:latin typeface="나눔스퀘어 Bold" panose="020B0600000101010101" pitchFamily="50" charset="-127"/>
-                  <a:ea typeface="나눔스퀘어 Bold" panose="020B0600000101010101" pitchFamily="50" charset="-127"/>
-                </a:rPr>
-                <a:t>B</a:t>
-              </a:r>
-              <a:endParaRPr lang="en-US" altLang="ko-KR" sz="2800" dirty="0">
-                <a:solidFill>
-                  <a:schemeClr val="tx1"/>
-                </a:solidFill>
-                <a:latin typeface="나눔스퀘어 Bold" panose="020B0600000101010101" pitchFamily="50" charset="-127"/>
-                <a:ea typeface="나눔스퀘어 Bold" panose="020B0600000101010101" pitchFamily="50" charset="-127"/>
-              </a:endParaRPr>
-            </a:p>
-            <a:p>
-              <a:pPr algn="ctr"/>
-              <a:r>
-                <a:rPr lang="ko-KR" altLang="en-US" sz="2800" dirty="0">
-                  <a:solidFill>
-                    <a:schemeClr val="tx1"/>
-                  </a:solidFill>
-                  <a:latin typeface="나눔스퀘어 Bold" panose="020B0600000101010101" pitchFamily="50" charset="-127"/>
-                  <a:ea typeface="나눔스퀘어 Bold" panose="020B0600000101010101" pitchFamily="50" charset="-127"/>
-                </a:rPr>
-                <a:t>전략 </a:t>
-              </a:r>
-              <a:r>
-                <a:rPr lang="en-US" altLang="ko-KR" sz="2800" dirty="0">
-                  <a:solidFill>
-                    <a:schemeClr val="tx1"/>
-                  </a:solidFill>
-                  <a:latin typeface="나눔스퀘어 Bold" panose="020B0600000101010101" pitchFamily="50" charset="-127"/>
-                  <a:ea typeface="나눔스퀘어 Bold" panose="020B0600000101010101" pitchFamily="50" charset="-127"/>
-                </a:rPr>
-                <a:t>B</a:t>
-              </a:r>
-              <a:endParaRPr lang="ko-KR" altLang="en-US" sz="2800" dirty="0">
+                <a:t>Singleton</a:t>
+              </a:r>
+              <a:endParaRPr lang="ko-KR" altLang="en-US" sz="2400" dirty="0">
                 <a:solidFill>
                   <a:schemeClr val="tx1"/>
                 </a:solidFill>
@@ -11156,21 +11204,22 @@
         </p:sp>
         <p:sp>
           <p:nvSpPr>
-            <p:cNvPr id="24" name="모서리가 둥근 직사각형 23"/>
+            <p:cNvPr id="71" name="모서리가 둥근 직사각형 70"/>
             <p:cNvSpPr/>
             <p:nvPr/>
           </p:nvSpPr>
           <p:spPr>
             <a:xfrm>
-              <a:off x="5921100" y="7658100"/>
-              <a:ext cx="2880000" cy="1440000"/>
+              <a:off x="8729300" y="1663700"/>
+              <a:ext cx="1440000" cy="720000"/>
             </a:xfrm>
             <a:prstGeom prst="roundRect">
               <a:avLst/>
             </a:prstGeom>
             <a:solidFill>
-              <a:schemeClr val="bg2">
-                <a:lumMod val="90000"/>
+              <a:schemeClr val="accent4">
+                <a:lumMod val="40000"/>
+                <a:lumOff val="60000"/>
               </a:schemeClr>
             </a:solidFill>
             <a:ln>
@@ -11199,56 +11248,16 @@
             <a:p>
               <a:pPr algn="ctr"/>
               <a:r>
-                <a:rPr lang="en-US" altLang="ko-KR" sz="2800" dirty="0">
+                <a:rPr lang="en-US" altLang="ko-KR" sz="2000" dirty="0" smtClean="0">
                   <a:solidFill>
                     <a:schemeClr val="tx1"/>
                   </a:solidFill>
                   <a:latin typeface="나눔스퀘어 Bold" panose="020B0600000101010101" pitchFamily="50" charset="-127"/>
                   <a:ea typeface="나눔스퀘어 Bold" panose="020B0600000101010101" pitchFamily="50" charset="-127"/>
                 </a:rPr>
-                <a:t>Strategy </a:t>
-              </a:r>
-              <a:r>
-                <a:rPr lang="en-US" altLang="ko-KR" sz="2800" dirty="0" smtClean="0">
-                  <a:solidFill>
-                    <a:schemeClr val="tx1"/>
-                  </a:solidFill>
-                  <a:latin typeface="나눔스퀘어 Bold" panose="020B0600000101010101" pitchFamily="50" charset="-127"/>
-                  <a:ea typeface="나눔스퀘어 Bold" panose="020B0600000101010101" pitchFamily="50" charset="-127"/>
-                </a:rPr>
-                <a:t>C</a:t>
-              </a:r>
-              <a:endParaRPr lang="en-US" altLang="ko-KR" sz="2800" dirty="0">
-                <a:solidFill>
-                  <a:schemeClr val="tx1"/>
-                </a:solidFill>
-                <a:latin typeface="나눔스퀘어 Bold" panose="020B0600000101010101" pitchFamily="50" charset="-127"/>
-                <a:ea typeface="나눔스퀘어 Bold" panose="020B0600000101010101" pitchFamily="50" charset="-127"/>
-              </a:endParaRPr>
-            </a:p>
-            <a:p>
-              <a:pPr algn="ctr"/>
-              <a:r>
-                <a:rPr lang="ko-KR" altLang="en-US" sz="2800" dirty="0">
-                  <a:solidFill>
-                    <a:schemeClr val="tx1"/>
-                  </a:solidFill>
-                  <a:latin typeface="나눔스퀘어 Bold" panose="020B0600000101010101" pitchFamily="50" charset="-127"/>
-                  <a:ea typeface="나눔스퀘어 Bold" panose="020B0600000101010101" pitchFamily="50" charset="-127"/>
-                </a:rPr>
-                <a:t>전략 </a:t>
-              </a:r>
-              <a:r>
-                <a:rPr lang="en-US" altLang="ko-KR" sz="2800" dirty="0">
-                  <a:solidFill>
-                    <a:schemeClr val="tx1"/>
-                  </a:solidFill>
-                  <a:latin typeface="나눔스퀘어 Bold" panose="020B0600000101010101" pitchFamily="50" charset="-127"/>
-                  <a:ea typeface="나눔스퀘어 Bold" panose="020B0600000101010101" pitchFamily="50" charset="-127"/>
-                </a:rPr>
-                <a:t>C</a:t>
-              </a:r>
-              <a:endParaRPr lang="ko-KR" altLang="en-US" sz="2800" dirty="0">
+                <a:t>Object 1</a:t>
+              </a:r>
+              <a:endParaRPr lang="ko-KR" altLang="en-US" sz="2000" dirty="0">
                 <a:solidFill>
                   <a:schemeClr val="tx1"/>
                 </a:solidFill>
@@ -11260,21 +11269,22 @@
         </p:sp>
         <p:sp>
           <p:nvSpPr>
-            <p:cNvPr id="25" name="모서리가 둥근 직사각형 24"/>
+            <p:cNvPr id="72" name="모서리가 둥근 직사각형 71"/>
             <p:cNvSpPr/>
             <p:nvPr/>
           </p:nvSpPr>
           <p:spPr>
             <a:xfrm>
-              <a:off x="1375950" y="4366350"/>
-              <a:ext cx="4320000" cy="1440000"/>
+              <a:off x="8729300" y="2722700"/>
+              <a:ext cx="1440000" cy="720000"/>
             </a:xfrm>
             <a:prstGeom prst="roundRect">
               <a:avLst/>
             </a:prstGeom>
             <a:solidFill>
-              <a:schemeClr val="bg2">
-                <a:lumMod val="90000"/>
+              <a:schemeClr val="accent4">
+                <a:lumMod val="40000"/>
+                <a:lumOff val="60000"/>
               </a:schemeClr>
             </a:solidFill>
             <a:ln>
@@ -11303,29 +11313,16 @@
             <a:p>
               <a:pPr algn="ctr"/>
               <a:r>
-                <a:rPr lang="en-US" altLang="ko-KR" sz="2800" dirty="0" smtClean="0">
+                <a:rPr lang="en-US" altLang="ko-KR" sz="2000" dirty="0" smtClean="0">
                   <a:solidFill>
                     <a:schemeClr val="tx1"/>
                   </a:solidFill>
                   <a:latin typeface="나눔스퀘어 Bold" panose="020B0600000101010101" pitchFamily="50" charset="-127"/>
                   <a:ea typeface="나눔스퀘어 Bold" panose="020B0600000101010101" pitchFamily="50" charset="-127"/>
                 </a:rPr>
-                <a:t>Strategy</a:t>
-              </a:r>
-            </a:p>
-            <a:p>
-              <a:pPr algn="ctr"/>
-              <a:r>
-                <a:rPr lang="ko-KR" altLang="en-US" sz="2800" dirty="0" smtClean="0">
-                  <a:solidFill>
-                    <a:schemeClr val="tx1"/>
-                  </a:solidFill>
-                  <a:latin typeface="나눔스퀘어 Bold" panose="020B0600000101010101" pitchFamily="50" charset="-127"/>
-                  <a:ea typeface="나눔스퀘어 Bold" panose="020B0600000101010101" pitchFamily="50" charset="-127"/>
-                </a:rPr>
-                <a:t>인터페이스</a:t>
-              </a:r>
-              <a:endParaRPr lang="ko-KR" altLang="en-US" sz="2800" dirty="0">
+                <a:t>Object 2</a:t>
+              </a:r>
+              <a:endParaRPr lang="ko-KR" altLang="en-US" sz="2000" dirty="0">
                 <a:solidFill>
                   <a:schemeClr val="tx1"/>
                 </a:solidFill>
@@ -11337,21 +11334,389 @@
         </p:sp>
         <p:sp>
           <p:nvSpPr>
-            <p:cNvPr id="27" name="모서리가 둥근 직사각형 26"/>
+            <p:cNvPr id="79" name="오른쪽 화살표 78"/>
             <p:cNvSpPr/>
             <p:nvPr/>
           </p:nvSpPr>
           <p:spPr>
             <a:xfrm>
-              <a:off x="-1729200" y="7658100"/>
+              <a:off x="3700175" y="2337300"/>
+              <a:ext cx="576000" cy="431800"/>
+            </a:xfrm>
+            <a:prstGeom prst="rightArrow">
+              <a:avLst/>
+            </a:prstGeom>
+            <a:solidFill>
+              <a:schemeClr val="accent2"/>
+            </a:solidFill>
+            <a:ln>
+              <a:noFill/>
+            </a:ln>
+          </p:spPr>
+          <p:style>
+            <a:lnRef idx="2">
+              <a:schemeClr val="accent1">
+                <a:shade val="50000"/>
+              </a:schemeClr>
+            </a:lnRef>
+            <a:fillRef idx="1">
+              <a:schemeClr val="accent1"/>
+            </a:fillRef>
+            <a:effectRef idx="0">
+              <a:schemeClr val="accent1"/>
+            </a:effectRef>
+            <a:fontRef idx="minor">
+              <a:schemeClr val="lt1"/>
+            </a:fontRef>
+          </p:style>
+          <p:txBody>
+            <a:bodyPr rtlCol="0" anchor="ctr"/>
+            <a:lstStyle/>
+            <a:p>
+              <a:pPr algn="ctr"/>
+              <a:endParaRPr lang="ko-KR" altLang="en-US"/>
+            </a:p>
+          </p:txBody>
+        </p:sp>
+        <p:sp>
+          <p:nvSpPr>
+            <p:cNvPr id="80" name="오른쪽 화살표 79"/>
+            <p:cNvSpPr/>
+            <p:nvPr/>
+          </p:nvSpPr>
+          <p:spPr>
+            <a:xfrm flipH="1">
+              <a:off x="8060925" y="1807800"/>
+              <a:ext cx="576000" cy="431800"/>
+            </a:xfrm>
+            <a:prstGeom prst="rightArrow">
+              <a:avLst/>
+            </a:prstGeom>
+            <a:solidFill>
+              <a:schemeClr val="accent2"/>
+            </a:solidFill>
+            <a:ln>
+              <a:noFill/>
+            </a:ln>
+          </p:spPr>
+          <p:style>
+            <a:lnRef idx="2">
+              <a:schemeClr val="accent1">
+                <a:shade val="50000"/>
+              </a:schemeClr>
+            </a:lnRef>
+            <a:fillRef idx="1">
+              <a:schemeClr val="accent1"/>
+            </a:fillRef>
+            <a:effectRef idx="0">
+              <a:schemeClr val="accent1"/>
+            </a:effectRef>
+            <a:fontRef idx="minor">
+              <a:schemeClr val="lt1"/>
+            </a:fontRef>
+          </p:style>
+          <p:txBody>
+            <a:bodyPr rtlCol="0" anchor="ctr"/>
+            <a:lstStyle/>
+            <a:p>
+              <a:pPr algn="ctr"/>
+              <a:endParaRPr lang="ko-KR" altLang="en-US"/>
+            </a:p>
+          </p:txBody>
+        </p:sp>
+        <p:sp>
+          <p:nvSpPr>
+            <p:cNvPr id="81" name="오른쪽 화살표 80"/>
+            <p:cNvSpPr/>
+            <p:nvPr/>
+          </p:nvSpPr>
+          <p:spPr>
+            <a:xfrm flipH="1">
+              <a:off x="8060925" y="2866800"/>
+              <a:ext cx="576000" cy="431800"/>
+            </a:xfrm>
+            <a:prstGeom prst="rightArrow">
+              <a:avLst/>
+            </a:prstGeom>
+            <a:solidFill>
+              <a:schemeClr val="accent2"/>
+            </a:solidFill>
+            <a:ln>
+              <a:noFill/>
+            </a:ln>
+          </p:spPr>
+          <p:style>
+            <a:lnRef idx="2">
+              <a:schemeClr val="accent1">
+                <a:shade val="50000"/>
+              </a:schemeClr>
+            </a:lnRef>
+            <a:fillRef idx="1">
+              <a:schemeClr val="accent1"/>
+            </a:fillRef>
+            <a:effectRef idx="0">
+              <a:schemeClr val="accent1"/>
+            </a:effectRef>
+            <a:fontRef idx="minor">
+              <a:schemeClr val="lt1"/>
+            </a:fontRef>
+          </p:style>
+          <p:txBody>
+            <a:bodyPr rtlCol="0" anchor="ctr"/>
+            <a:lstStyle/>
+            <a:p>
+              <a:pPr algn="ctr"/>
+              <a:endParaRPr lang="ko-KR" altLang="en-US"/>
+            </a:p>
+          </p:txBody>
+        </p:sp>
+      </p:grpSp>
+    </p:spTree>
+    <p:extLst>
+      <p:ext uri="{BB962C8B-B14F-4D97-AF65-F5344CB8AC3E}">
+        <p14:creationId xmlns:p14="http://schemas.microsoft.com/office/powerpoint/2010/main" val="1679211822"/>
+      </p:ext>
+    </p:extLst>
+  </p:cSld>
+  <p:clrMapOvr>
+    <a:masterClrMapping/>
+  </p:clrMapOvr>
+</p:sld>
+</file>
+
+<file path=ppt/slides/slide6.xml><?xml version="1.0" encoding="utf-8"?>
+<p:sld xmlns:a="http://schemas.openxmlformats.org/drawingml/2006/main" xmlns:r="http://schemas.openxmlformats.org/officeDocument/2006/relationships" xmlns:p="http://schemas.openxmlformats.org/presentationml/2006/main">
+  <p:cSld>
+    <p:spTree>
+      <p:nvGrpSpPr>
+        <p:cNvPr id="1" name=""/>
+        <p:cNvGrpSpPr/>
+        <p:nvPr/>
+      </p:nvGrpSpPr>
+      <p:grpSpPr>
+        <a:xfrm>
+          <a:off x="0" y="0"/>
+          <a:ext cx="0" cy="0"/>
+          <a:chOff x="0" y="0"/>
+          <a:chExt cx="0" cy="0"/>
+        </a:xfrm>
+      </p:grpSpPr>
+      <p:grpSp>
+        <p:nvGrpSpPr>
+          <p:cNvPr id="24" name="그룹 23"/>
+          <p:cNvGrpSpPr/>
+          <p:nvPr/>
+        </p:nvGrpSpPr>
+        <p:grpSpPr>
+          <a:xfrm>
+            <a:off x="-38912" y="-243270"/>
+            <a:ext cx="10790912" cy="4526219"/>
+            <a:chOff x="-38912" y="-243270"/>
+            <a:chExt cx="10790912" cy="4526219"/>
+          </a:xfrm>
+        </p:grpSpPr>
+        <p:sp>
+          <p:nvSpPr>
+            <p:cNvPr id="19" name="모서리가 둥근 직사각형 18"/>
+            <p:cNvSpPr/>
+            <p:nvPr/>
+          </p:nvSpPr>
+          <p:spPr>
+            <a:xfrm>
+              <a:off x="3916544" y="360000"/>
               <a:ext cx="2880000" cy="1440000"/>
             </a:xfrm>
             <a:prstGeom prst="roundRect">
-              <a:avLst/>
+              <a:avLst>
+                <a:gd name="adj" fmla="val 7210"/>
+              </a:avLst>
             </a:prstGeom>
             <a:solidFill>
-              <a:schemeClr val="bg2">
-                <a:lumMod val="90000"/>
+              <a:schemeClr val="accent5"/>
+            </a:solidFill>
+            <a:ln>
+              <a:noFill/>
+            </a:ln>
+          </p:spPr>
+          <p:style>
+            <a:lnRef idx="2">
+              <a:schemeClr val="accent1">
+                <a:shade val="50000"/>
+              </a:schemeClr>
+            </a:lnRef>
+            <a:fillRef idx="1">
+              <a:schemeClr val="accent1"/>
+            </a:fillRef>
+            <a:effectRef idx="0">
+              <a:schemeClr val="accent1"/>
+            </a:effectRef>
+            <a:fontRef idx="minor">
+              <a:schemeClr val="lt1"/>
+            </a:fontRef>
+          </p:style>
+          <p:txBody>
+            <a:bodyPr rtlCol="0" anchor="ctr"/>
+            <a:lstStyle/>
+            <a:p>
+              <a:pPr algn="ctr"/>
+              <a:r>
+                <a:rPr lang="en-US" altLang="ko-KR" sz="3600" dirty="0" smtClean="0">
+                  <a:solidFill>
+                    <a:schemeClr val="bg1"/>
+                  </a:solidFill>
+                  <a:latin typeface="나눔스퀘어 Bold" panose="020B0600000101010101" pitchFamily="50" charset="-127"/>
+                  <a:ea typeface="나눔스퀘어 Bold" panose="020B0600000101010101" pitchFamily="50" charset="-127"/>
+                </a:rPr>
+                <a:t>Controller</a:t>
+              </a:r>
+              <a:endParaRPr lang="ko-KR" altLang="en-US" sz="3600" dirty="0">
+                <a:solidFill>
+                  <a:schemeClr val="bg1"/>
+                </a:solidFill>
+                <a:latin typeface="나눔스퀘어 Bold" panose="020B0600000101010101" pitchFamily="50" charset="-127"/>
+                <a:ea typeface="나눔스퀘어 Bold" panose="020B0600000101010101" pitchFamily="50" charset="-127"/>
+              </a:endParaRPr>
+            </a:p>
+          </p:txBody>
+        </p:sp>
+        <p:sp>
+          <p:nvSpPr>
+            <p:cNvPr id="20" name="모서리가 둥근 직사각형 19"/>
+            <p:cNvSpPr/>
+            <p:nvPr/>
+          </p:nvSpPr>
+          <p:spPr>
+            <a:xfrm>
+              <a:off x="7872000" y="0"/>
+              <a:ext cx="2880000" cy="3600000"/>
+            </a:xfrm>
+            <a:prstGeom prst="roundRect">
+              <a:avLst>
+                <a:gd name="adj" fmla="val 7210"/>
+              </a:avLst>
+            </a:prstGeom>
+            <a:solidFill>
+              <a:schemeClr val="accent5"/>
+            </a:solidFill>
+            <a:ln>
+              <a:noFill/>
+            </a:ln>
+          </p:spPr>
+          <p:style>
+            <a:lnRef idx="2">
+              <a:schemeClr val="accent1">
+                <a:shade val="50000"/>
+              </a:schemeClr>
+            </a:lnRef>
+            <a:fillRef idx="1">
+              <a:schemeClr val="accent1"/>
+            </a:fillRef>
+            <a:effectRef idx="0">
+              <a:schemeClr val="accent1"/>
+            </a:effectRef>
+            <a:fontRef idx="minor">
+              <a:schemeClr val="lt1"/>
+            </a:fontRef>
+          </p:style>
+          <p:txBody>
+            <a:bodyPr rtlCol="0" anchor="ctr"/>
+            <a:lstStyle/>
+            <a:p>
+              <a:pPr algn="ctr"/>
+              <a:endParaRPr lang="ko-KR" altLang="en-US" sz="2400" dirty="0">
+                <a:solidFill>
+                  <a:schemeClr val="tx1"/>
+                </a:solidFill>
+                <a:latin typeface="나눔스퀘어 Bold" panose="020B0600000101010101" pitchFamily="50" charset="-127"/>
+                <a:ea typeface="나눔스퀘어 Bold" panose="020B0600000101010101" pitchFamily="50" charset="-127"/>
+              </a:endParaRPr>
+            </a:p>
+          </p:txBody>
+        </p:sp>
+        <p:sp>
+          <p:nvSpPr>
+            <p:cNvPr id="21" name="모서리가 둥근 직사각형 20"/>
+            <p:cNvSpPr/>
+            <p:nvPr/>
+          </p:nvSpPr>
+          <p:spPr>
+            <a:xfrm>
+              <a:off x="-38912" y="360000"/>
+              <a:ext cx="2880000" cy="1440000"/>
+            </a:xfrm>
+            <a:prstGeom prst="roundRect">
+              <a:avLst>
+                <a:gd name="adj" fmla="val 7210"/>
+              </a:avLst>
+            </a:prstGeom>
+            <a:solidFill>
+              <a:schemeClr val="accent5"/>
+            </a:solidFill>
+            <a:ln>
+              <a:noFill/>
+            </a:ln>
+          </p:spPr>
+          <p:style>
+            <a:lnRef idx="2">
+              <a:schemeClr val="accent1">
+                <a:shade val="50000"/>
+              </a:schemeClr>
+            </a:lnRef>
+            <a:fillRef idx="1">
+              <a:schemeClr val="accent1"/>
+            </a:fillRef>
+            <a:effectRef idx="0">
+              <a:schemeClr val="accent1"/>
+            </a:effectRef>
+            <a:fontRef idx="minor">
+              <a:schemeClr val="lt1"/>
+            </a:fontRef>
+          </p:style>
+          <p:txBody>
+            <a:bodyPr rtlCol="0" anchor="ctr"/>
+            <a:lstStyle/>
+            <a:p>
+              <a:pPr algn="ctr"/>
+              <a:r>
+                <a:rPr lang="en-US" altLang="ko-KR" sz="3600" dirty="0" err="1" smtClean="0">
+                  <a:solidFill>
+                    <a:schemeClr val="bg1"/>
+                  </a:solidFill>
+                  <a:latin typeface="나눔스퀘어 Bold" panose="020B0600000101010101" pitchFamily="50" charset="-127"/>
+                  <a:ea typeface="나눔스퀘어 Bold" panose="020B0600000101010101" pitchFamily="50" charset="-127"/>
+                </a:rPr>
+                <a:t>MainClass</a:t>
+              </a:r>
+              <a:endParaRPr lang="ko-KR" altLang="en-US" sz="3600" dirty="0">
+                <a:solidFill>
+                  <a:schemeClr val="bg1"/>
+                </a:solidFill>
+                <a:latin typeface="나눔스퀘어 Bold" panose="020B0600000101010101" pitchFamily="50" charset="-127"/>
+                <a:ea typeface="나눔스퀘어 Bold" panose="020B0600000101010101" pitchFamily="50" charset="-127"/>
+              </a:endParaRPr>
+            </a:p>
+          </p:txBody>
+        </p:sp>
+        <p:sp>
+          <p:nvSpPr>
+            <p:cNvPr id="22" name="모서리가 둥근 직사각형 21"/>
+            <p:cNvSpPr/>
+            <p:nvPr/>
+          </p:nvSpPr>
+          <p:spPr>
+            <a:xfrm>
+              <a:off x="4276544" y="1932209"/>
+              <a:ext cx="2160000" cy="720000"/>
+            </a:xfrm>
+            <a:prstGeom prst="roundRect">
+              <a:avLst>
+                <a:gd name="adj" fmla="val 7210"/>
+              </a:avLst>
+            </a:prstGeom>
+            <a:solidFill>
+              <a:schemeClr val="accent5">
+                <a:lumMod val="60000"/>
+                <a:lumOff val="40000"/>
               </a:schemeClr>
             </a:solidFill>
             <a:ln>
@@ -11380,39 +11745,36 @@
             <a:p>
               <a:pPr algn="ctr"/>
               <a:r>
-                <a:rPr lang="en-US" altLang="ko-KR" sz="2800" dirty="0" smtClean="0">
+                <a:rPr lang="en-US" altLang="ko-KR" sz="2400" dirty="0" smtClean="0">
                   <a:solidFill>
                     <a:schemeClr val="tx1"/>
                   </a:solidFill>
                   <a:latin typeface="나눔스퀘어 Bold" panose="020B0600000101010101" pitchFamily="50" charset="-127"/>
                   <a:ea typeface="나눔스퀘어 Bold" panose="020B0600000101010101" pitchFamily="50" charset="-127"/>
                 </a:rPr>
-                <a:t>Strategy A</a:t>
-              </a:r>
-            </a:p>
-            <a:p>
-              <a:pPr algn="ctr"/>
-              <a:r>
-                <a:rPr lang="ko-KR" altLang="en-US" sz="2800" dirty="0" smtClean="0">
+                <a:t>New </a:t>
+              </a:r>
+              <a:r>
+                <a:rPr lang="ko-KR" altLang="en-US" sz="2400" dirty="0" smtClean="0">
                   <a:solidFill>
                     <a:schemeClr val="tx1"/>
                   </a:solidFill>
                   <a:latin typeface="나눔스퀘어 Bold" panose="020B0600000101010101" pitchFamily="50" charset="-127"/>
                   <a:ea typeface="나눔스퀘어 Bold" panose="020B0600000101010101" pitchFamily="50" charset="-127"/>
                 </a:rPr>
-                <a:t>전략 </a:t>
-              </a:r>
-              <a:r>
-                <a:rPr lang="en-US" altLang="ko-KR" sz="2800" dirty="0">
+                <a:t>부품 </a:t>
+              </a:r>
+              <a:r>
+                <a:rPr lang="en-US" altLang="ko-KR" sz="2400" dirty="0" smtClean="0">
                   <a:solidFill>
                     <a:schemeClr val="tx1"/>
                   </a:solidFill>
                   <a:latin typeface="나눔스퀘어 Bold" panose="020B0600000101010101" pitchFamily="50" charset="-127"/>
                   <a:ea typeface="나눔스퀘어 Bold" panose="020B0600000101010101" pitchFamily="50" charset="-127"/>
                 </a:rPr>
-                <a:t>A</a:t>
-              </a:r>
-              <a:endParaRPr lang="ko-KR" altLang="en-US" sz="2800" dirty="0">
+                <a:t>1</a:t>
+              </a:r>
+              <a:endParaRPr lang="ko-KR" altLang="en-US" sz="2400" dirty="0">
                 <a:solidFill>
                   <a:schemeClr val="tx1"/>
                 </a:solidFill>
@@ -11422,154 +11784,26 @@
             </a:p>
           </p:txBody>
         </p:sp>
-        <p:cxnSp>
-          <p:nvCxnSpPr>
-            <p:cNvPr id="16" name="꺾인 연결선 15"/>
-            <p:cNvCxnSpPr>
-              <a:stCxn id="25" idx="2"/>
-            </p:cNvCxnSpPr>
-            <p:nvPr/>
-          </p:nvCxnSpPr>
-          <p:spPr>
-            <a:xfrm rot="5400000">
-              <a:off x="2610075" y="6732225"/>
-              <a:ext cx="1851750" cy="12700"/>
-            </a:xfrm>
-            <a:prstGeom prst="bentConnector3">
-              <a:avLst/>
-            </a:prstGeom>
-            <a:ln w="76200">
-              <a:solidFill>
-                <a:schemeClr val="accent2"/>
-              </a:solidFill>
-              <a:tailEnd type="triangle"/>
-            </a:ln>
-          </p:spPr>
-          <p:style>
-            <a:lnRef idx="1">
-              <a:schemeClr val="accent1"/>
-            </a:lnRef>
-            <a:fillRef idx="0">
-              <a:schemeClr val="accent1"/>
-            </a:fillRef>
-            <a:effectRef idx="0">
-              <a:schemeClr val="accent1"/>
-            </a:effectRef>
-            <a:fontRef idx="minor">
-              <a:schemeClr val="tx1"/>
-            </a:fontRef>
-          </p:style>
-        </p:cxnSp>
-        <p:cxnSp>
-          <p:nvCxnSpPr>
-            <p:cNvPr id="30" name="꺾인 연결선 29"/>
-            <p:cNvCxnSpPr>
-              <a:stCxn id="25" idx="2"/>
-              <a:endCxn id="24" idx="0"/>
-            </p:cNvCxnSpPr>
-            <p:nvPr/>
-          </p:nvCxnSpPr>
-          <p:spPr>
-            <a:xfrm rot="16200000" flipH="1">
-              <a:off x="4522650" y="4819650"/>
-              <a:ext cx="1851750" cy="3825150"/>
-            </a:xfrm>
-            <a:prstGeom prst="bentConnector3">
-              <a:avLst/>
-            </a:prstGeom>
-            <a:ln w="76200">
-              <a:solidFill>
-                <a:schemeClr val="accent2"/>
-              </a:solidFill>
-              <a:tailEnd type="triangle"/>
-            </a:ln>
-          </p:spPr>
-          <p:style>
-            <a:lnRef idx="1">
-              <a:schemeClr val="accent1"/>
-            </a:lnRef>
-            <a:fillRef idx="0">
-              <a:schemeClr val="accent1"/>
-            </a:fillRef>
-            <a:effectRef idx="0">
-              <a:schemeClr val="accent1"/>
-            </a:effectRef>
-            <a:fontRef idx="minor">
-              <a:schemeClr val="tx1"/>
-            </a:fontRef>
-          </p:style>
-        </p:cxnSp>
-        <p:cxnSp>
-          <p:nvCxnSpPr>
-            <p:cNvPr id="33" name="꺾인 연결선 32"/>
-            <p:cNvCxnSpPr>
-              <a:stCxn id="25" idx="2"/>
-              <a:endCxn id="27" idx="0"/>
-            </p:cNvCxnSpPr>
-            <p:nvPr/>
-          </p:nvCxnSpPr>
-          <p:spPr>
-            <a:xfrm rot="5400000">
-              <a:off x="697500" y="4819650"/>
-              <a:ext cx="1851750" cy="3825150"/>
-            </a:xfrm>
-            <a:prstGeom prst="bentConnector3">
-              <a:avLst/>
-            </a:prstGeom>
-            <a:ln w="76200">
-              <a:solidFill>
-                <a:schemeClr val="accent2"/>
-              </a:solidFill>
-              <a:tailEnd type="triangle"/>
-            </a:ln>
-          </p:spPr>
-          <p:style>
-            <a:lnRef idx="1">
-              <a:schemeClr val="accent1"/>
-            </a:lnRef>
-            <a:fillRef idx="0">
-              <a:schemeClr val="accent1"/>
-            </a:fillRef>
-            <a:effectRef idx="0">
-              <a:schemeClr val="accent1"/>
-            </a:effectRef>
-            <a:fontRef idx="minor">
-              <a:schemeClr val="tx1"/>
-            </a:fontRef>
-          </p:style>
-        </p:cxnSp>
-      </p:grpSp>
-      <p:grpSp>
-        <p:nvGrpSpPr>
-          <p:cNvPr id="34" name="그룹 33"/>
-          <p:cNvGrpSpPr/>
-          <p:nvPr/>
-        </p:nvGrpSpPr>
-        <p:grpSpPr>
-          <a:xfrm>
-            <a:off x="1150800" y="-1772200"/>
-            <a:ext cx="10530300" cy="4731750"/>
-            <a:chOff x="1150800" y="-1772200"/>
-            <a:chExt cx="10530300" cy="4731750"/>
-          </a:xfrm>
-        </p:grpSpPr>
         <p:sp>
           <p:nvSpPr>
-            <p:cNvPr id="36" name="모서리가 둥근 직사각형 35"/>
+            <p:cNvPr id="26" name="모서리가 둥근 직사각형 25"/>
             <p:cNvSpPr/>
             <p:nvPr/>
           </p:nvSpPr>
           <p:spPr>
             <a:xfrm>
-              <a:off x="4975950" y="1519550"/>
-              <a:ext cx="2880000" cy="1440000"/>
+              <a:off x="4276544" y="2746886"/>
+              <a:ext cx="2160000" cy="720000"/>
             </a:xfrm>
             <a:prstGeom prst="roundRect">
-              <a:avLst/>
+              <a:avLst>
+                <a:gd name="adj" fmla="val 7210"/>
+              </a:avLst>
             </a:prstGeom>
             <a:solidFill>
-              <a:schemeClr val="bg2">
-                <a:lumMod val="90000"/>
+              <a:schemeClr val="accent5">
+                <a:lumMod val="60000"/>
+                <a:lumOff val="40000"/>
               </a:schemeClr>
             </a:solidFill>
             <a:ln>
@@ -11598,42 +11832,58 @@
             <a:p>
               <a:pPr algn="ctr"/>
               <a:r>
-                <a:rPr lang="ko-KR" altLang="en-US" sz="2800" dirty="0" smtClean="0">
+                <a:rPr lang="en-US" altLang="ko-KR" sz="2400" dirty="0">
                   <a:solidFill>
                     <a:schemeClr val="tx1"/>
                   </a:solidFill>
                   <a:latin typeface="나눔스퀘어 Bold" panose="020B0600000101010101" pitchFamily="50" charset="-127"/>
                   <a:ea typeface="나눔스퀘어 Bold" panose="020B0600000101010101" pitchFamily="50" charset="-127"/>
                 </a:rPr>
-                <a:t>현금</a:t>
-              </a:r>
-              <a:endParaRPr lang="ko-KR" altLang="en-US" sz="2800" dirty="0">
-                <a:solidFill>
-                  <a:schemeClr val="tx1"/>
-                </a:solidFill>
-                <a:latin typeface="나눔스퀘어 Bold" panose="020B0600000101010101" pitchFamily="50" charset="-127"/>
-                <a:ea typeface="나눔스퀘어 Bold" panose="020B0600000101010101" pitchFamily="50" charset="-127"/>
-              </a:endParaRPr>
+                <a:t>New </a:t>
+              </a:r>
+              <a:r>
+                <a:rPr lang="ko-KR" altLang="en-US" sz="2400" dirty="0">
+                  <a:solidFill>
+                    <a:schemeClr val="tx1"/>
+                  </a:solidFill>
+                  <a:latin typeface="나눔스퀘어 Bold" panose="020B0600000101010101" pitchFamily="50" charset="-127"/>
+                  <a:ea typeface="나눔스퀘어 Bold" panose="020B0600000101010101" pitchFamily="50" charset="-127"/>
+                </a:rPr>
+                <a:t>부품 </a:t>
+              </a:r>
+              <a:r>
+                <a:rPr lang="en-US" altLang="ko-KR" sz="2400" dirty="0" smtClean="0">
+                  <a:solidFill>
+                    <a:schemeClr val="tx1"/>
+                  </a:solidFill>
+                  <a:latin typeface="나눔스퀘어 Bold" panose="020B0600000101010101" pitchFamily="50" charset="-127"/>
+                  <a:ea typeface="나눔스퀘어 Bold" panose="020B0600000101010101" pitchFamily="50" charset="-127"/>
+                </a:rPr>
+                <a:t>2</a:t>
+              </a:r>
             </a:p>
           </p:txBody>
         </p:sp>
         <p:sp>
           <p:nvSpPr>
-            <p:cNvPr id="38" name="모서리가 둥근 직사각형 37"/>
+            <p:cNvPr id="28" name="모서리가 둥근 직사각형 27"/>
             <p:cNvSpPr/>
             <p:nvPr/>
           </p:nvSpPr>
           <p:spPr>
             <a:xfrm>
-              <a:off x="8801100" y="1519550"/>
-              <a:ext cx="2880000" cy="1440000"/>
+              <a:off x="4276544" y="3562949"/>
+              <a:ext cx="2160000" cy="720000"/>
             </a:xfrm>
             <a:prstGeom prst="roundRect">
-              <a:avLst/>
+              <a:avLst>
+                <a:gd name="adj" fmla="val 7210"/>
+              </a:avLst>
             </a:prstGeom>
             <a:solidFill>
-              <a:schemeClr val="bg2">
-                <a:lumMod val="90000"/>
+              <a:schemeClr val="accent5">
+                <a:lumMod val="60000"/>
+                <a:lumOff val="40000"/>
               </a:schemeClr>
             </a:solidFill>
             <a:ln>
@@ -11662,16 +11912,36 @@
             <a:p>
               <a:pPr algn="ctr"/>
               <a:r>
-                <a:rPr lang="ko-KR" altLang="en-US" sz="2800" dirty="0" err="1" smtClean="0">
+                <a:rPr lang="en-US" altLang="ko-KR" sz="2400" dirty="0">
                   <a:solidFill>
                     <a:schemeClr val="tx1"/>
                   </a:solidFill>
                   <a:latin typeface="나눔스퀘어 Bold" panose="020B0600000101010101" pitchFamily="50" charset="-127"/>
                   <a:ea typeface="나눔스퀘어 Bold" panose="020B0600000101010101" pitchFamily="50" charset="-127"/>
                 </a:rPr>
-                <a:t>삼성페이</a:t>
-              </a:r>
-              <a:endParaRPr lang="ko-KR" altLang="en-US" sz="2800" dirty="0">
+                <a:t>New </a:t>
+              </a:r>
+              <a:r>
+                <a:rPr lang="ko-KR" altLang="en-US" sz="2400" dirty="0">
+                  <a:solidFill>
+                    <a:schemeClr val="tx1"/>
+                  </a:solidFill>
+                  <a:latin typeface="나눔스퀘어 Bold" panose="020B0600000101010101" pitchFamily="50" charset="-127"/>
+                  <a:ea typeface="나눔스퀘어 Bold" panose="020B0600000101010101" pitchFamily="50" charset="-127"/>
+                </a:rPr>
+                <a:t>부품 </a:t>
+              </a:r>
+              <a:r>
+                <a:rPr lang="en-US" altLang="ko-KR" sz="2400" dirty="0" smtClean="0">
+                  <a:solidFill>
+                    <a:schemeClr val="tx1"/>
+                  </a:solidFill>
+                  <a:latin typeface="나눔스퀘어 Bold" panose="020B0600000101010101" pitchFamily="50" charset="-127"/>
+                  <a:ea typeface="나눔스퀘어 Bold" panose="020B0600000101010101" pitchFamily="50" charset="-127"/>
+                </a:rPr>
+                <a:t>3</a:t>
+              </a:r>
+              <a:endParaRPr lang="ko-KR" altLang="en-US" sz="2400" dirty="0">
                 <a:solidFill>
                   <a:schemeClr val="tx1"/>
                 </a:solidFill>
@@ -11683,21 +11953,179 @@
         </p:sp>
         <p:sp>
           <p:nvSpPr>
-            <p:cNvPr id="39" name="모서리가 둥근 직사각형 38"/>
+            <p:cNvPr id="3" name="모서리가 둥근 직사각형 2"/>
             <p:cNvSpPr/>
             <p:nvPr/>
           </p:nvSpPr>
           <p:spPr>
             <a:xfrm>
-              <a:off x="4255950" y="-1772200"/>
-              <a:ext cx="4320000" cy="1440000"/>
+              <a:off x="8232000" y="-243270"/>
+              <a:ext cx="2160000" cy="720000"/>
             </a:xfrm>
             <a:prstGeom prst="roundRect">
+              <a:avLst>
+                <a:gd name="adj" fmla="val 12500"/>
+              </a:avLst>
+            </a:prstGeom>
+            <a:solidFill>
+              <a:schemeClr val="accent5">
+                <a:lumMod val="75000"/>
+              </a:schemeClr>
+            </a:solidFill>
+          </p:spPr>
+          <p:style>
+            <a:lnRef idx="2">
+              <a:schemeClr val="accent1">
+                <a:shade val="50000"/>
+              </a:schemeClr>
+            </a:lnRef>
+            <a:fillRef idx="1">
+              <a:schemeClr val="accent1"/>
+            </a:fillRef>
+            <a:effectRef idx="0">
+              <a:schemeClr val="accent1"/>
+            </a:effectRef>
+            <a:fontRef idx="minor">
+              <a:schemeClr val="lt1"/>
+            </a:fontRef>
+          </p:style>
+          <p:txBody>
+            <a:bodyPr rtlCol="0" anchor="ctr"/>
+            <a:lstStyle/>
+            <a:p>
+              <a:pPr algn="ctr"/>
+              <a:r>
+                <a:rPr lang="en-US" altLang="ko-KR" sz="3600" dirty="0" smtClean="0">
+                  <a:solidFill>
+                    <a:schemeClr val="bg1"/>
+                  </a:solidFill>
+                  <a:latin typeface="나눔스퀘어 Bold" panose="020B0600000101010101" pitchFamily="50" charset="-127"/>
+                  <a:ea typeface="나눔스퀘어 Bold" panose="020B0600000101010101" pitchFamily="50" charset="-127"/>
+                </a:rPr>
+                <a:t>Service</a:t>
+              </a:r>
+              <a:endParaRPr lang="ko-KR" altLang="en-US" sz="3600" dirty="0">
+                <a:solidFill>
+                  <a:schemeClr val="bg1"/>
+                </a:solidFill>
+                <a:latin typeface="나눔스퀘어 Bold" panose="020B0600000101010101" pitchFamily="50" charset="-127"/>
+                <a:ea typeface="나눔스퀘어 Bold" panose="020B0600000101010101" pitchFamily="50" charset="-127"/>
+              </a:endParaRPr>
+            </a:p>
+          </p:txBody>
+        </p:sp>
+        <p:sp>
+          <p:nvSpPr>
+            <p:cNvPr id="4" name="오른쪽 화살표 3"/>
+            <p:cNvSpPr/>
+            <p:nvPr/>
+          </p:nvSpPr>
+          <p:spPr>
+            <a:xfrm>
+              <a:off x="6884272" y="630000"/>
+              <a:ext cx="900000" cy="900000"/>
+            </a:xfrm>
+            <a:prstGeom prst="rightArrow">
               <a:avLst/>
             </a:prstGeom>
             <a:solidFill>
-              <a:schemeClr val="bg2">
-                <a:lumMod val="90000"/>
+              <a:schemeClr val="accent2"/>
+            </a:solidFill>
+            <a:ln>
+              <a:noFill/>
+            </a:ln>
+          </p:spPr>
+          <p:style>
+            <a:lnRef idx="2">
+              <a:schemeClr val="accent1">
+                <a:shade val="50000"/>
+              </a:schemeClr>
+            </a:lnRef>
+            <a:fillRef idx="1">
+              <a:schemeClr val="accent1"/>
+            </a:fillRef>
+            <a:effectRef idx="0">
+              <a:schemeClr val="accent1"/>
+            </a:effectRef>
+            <a:fontRef idx="minor">
+              <a:schemeClr val="lt1"/>
+            </a:fontRef>
+          </p:style>
+          <p:txBody>
+            <a:bodyPr rtlCol="0" anchor="ctr"/>
+            <a:lstStyle/>
+            <a:p>
+              <a:pPr algn="ctr"/>
+              <a:endParaRPr lang="ko-KR" altLang="en-US"/>
+            </a:p>
+          </p:txBody>
+        </p:sp>
+        <p:sp>
+          <p:nvSpPr>
+            <p:cNvPr id="29" name="오른쪽 화살표 28"/>
+            <p:cNvSpPr/>
+            <p:nvPr/>
+          </p:nvSpPr>
+          <p:spPr>
+            <a:xfrm>
+              <a:off x="2928816" y="630000"/>
+              <a:ext cx="900000" cy="900000"/>
+            </a:xfrm>
+            <a:prstGeom prst="rightArrow">
+              <a:avLst/>
+            </a:prstGeom>
+            <a:solidFill>
+              <a:schemeClr val="accent2"/>
+            </a:solidFill>
+            <a:ln>
+              <a:noFill/>
+            </a:ln>
+          </p:spPr>
+          <p:style>
+            <a:lnRef idx="2">
+              <a:schemeClr val="accent1">
+                <a:shade val="50000"/>
+              </a:schemeClr>
+            </a:lnRef>
+            <a:fillRef idx="1">
+              <a:schemeClr val="accent1"/>
+            </a:fillRef>
+            <a:effectRef idx="0">
+              <a:schemeClr val="accent1"/>
+            </a:effectRef>
+            <a:fontRef idx="minor">
+              <a:schemeClr val="lt1"/>
+            </a:fontRef>
+          </p:style>
+          <p:txBody>
+            <a:bodyPr rtlCol="0" anchor="ctr"/>
+            <a:lstStyle/>
+            <a:p>
+              <a:pPr algn="ctr"/>
+              <a:endParaRPr lang="ko-KR" altLang="en-US"/>
+            </a:p>
+          </p:txBody>
+        </p:sp>
+        <p:sp>
+          <p:nvSpPr>
+            <p:cNvPr id="12" name="모서리가 둥근 직사각형 11"/>
+            <p:cNvSpPr/>
+            <p:nvPr/>
+          </p:nvSpPr>
+          <p:spPr>
+            <a:xfrm>
+              <a:off x="8232000" y="810000"/>
+              <a:ext cx="2160000" cy="720000"/>
+            </a:xfrm>
+            <a:prstGeom prst="roundRect">
+              <a:avLst>
+                <a:gd name="adj" fmla="val 7210"/>
+              </a:avLst>
+            </a:prstGeom>
+            <a:solidFill>
+              <a:schemeClr val="accent5">
+                <a:lumMod val="60000"/>
+                <a:lumOff val="40000"/>
               </a:schemeClr>
             </a:solidFill>
             <a:ln>
@@ -11726,29 +12154,36 @@
             <a:p>
               <a:pPr algn="ctr"/>
               <a:r>
-                <a:rPr lang="en-US" altLang="ko-KR" sz="2800" dirty="0" smtClean="0">
+                <a:rPr lang="ko-KR" altLang="en-US" sz="2400" dirty="0" smtClean="0">
                   <a:solidFill>
                     <a:schemeClr val="tx1"/>
                   </a:solidFill>
                   <a:latin typeface="나눔스퀘어 Bold" panose="020B0600000101010101" pitchFamily="50" charset="-127"/>
                   <a:ea typeface="나눔스퀘어 Bold" panose="020B0600000101010101" pitchFamily="50" charset="-127"/>
                 </a:rPr>
-                <a:t>Payment Strategy</a:t>
-              </a:r>
-            </a:p>
-            <a:p>
-              <a:pPr algn="ctr"/>
-              <a:r>
-                <a:rPr lang="ko-KR" altLang="en-US" sz="2800" dirty="0" smtClean="0">
+                <a:t>부품 </a:t>
+              </a:r>
+              <a:r>
+                <a:rPr lang="en-US" altLang="ko-KR" sz="2400" dirty="0" smtClean="0">
                   <a:solidFill>
                     <a:schemeClr val="tx1"/>
                   </a:solidFill>
                   <a:latin typeface="나눔스퀘어 Bold" panose="020B0600000101010101" pitchFamily="50" charset="-127"/>
                   <a:ea typeface="나눔스퀘어 Bold" panose="020B0600000101010101" pitchFamily="50" charset="-127"/>
                 </a:rPr>
-                <a:t>인터페이스 예시</a:t>
-              </a:r>
-              <a:endParaRPr lang="ko-KR" altLang="en-US" sz="2800" dirty="0">
+                <a:t>1 </a:t>
+              </a:r>
+              <a:r>
+                <a:rPr lang="ko-KR" altLang="en-US" sz="2400" dirty="0" smtClean="0">
+                  <a:solidFill>
+                    <a:schemeClr val="tx1"/>
+                  </a:solidFill>
+                  <a:latin typeface="나눔스퀘어 Bold" panose="020B0600000101010101" pitchFamily="50" charset="-127"/>
+                  <a:ea typeface="나눔스퀘어 Bold" panose="020B0600000101010101" pitchFamily="50" charset="-127"/>
+                </a:rPr>
+                <a:t>객체</a:t>
+              </a:r>
+              <a:endParaRPr lang="ko-KR" altLang="en-US" sz="2400" dirty="0">
                 <a:solidFill>
                   <a:schemeClr val="tx1"/>
                 </a:solidFill>
@@ -11760,21 +12195,24 @@
         </p:sp>
         <p:sp>
           <p:nvSpPr>
-            <p:cNvPr id="40" name="모서리가 둥근 직사각형 39"/>
+            <p:cNvPr id="13" name="모서리가 둥근 직사각형 12"/>
             <p:cNvSpPr/>
             <p:nvPr/>
           </p:nvSpPr>
           <p:spPr>
             <a:xfrm>
-              <a:off x="1150800" y="1519550"/>
-              <a:ext cx="2880000" cy="1440000"/>
+              <a:off x="8232000" y="1624677"/>
+              <a:ext cx="2160000" cy="720000"/>
             </a:xfrm>
             <a:prstGeom prst="roundRect">
-              <a:avLst/>
+              <a:avLst>
+                <a:gd name="adj" fmla="val 7210"/>
+              </a:avLst>
             </a:prstGeom>
             <a:solidFill>
-              <a:schemeClr val="bg2">
-                <a:lumMod val="90000"/>
+              <a:schemeClr val="accent5">
+                <a:lumMod val="60000"/>
+                <a:lumOff val="40000"/>
               </a:schemeClr>
             </a:solidFill>
             <a:ln>
@@ -11803,16 +12241,123 @@
             <a:p>
               <a:pPr algn="ctr"/>
               <a:r>
-                <a:rPr lang="ko-KR" altLang="en-US" sz="2800" dirty="0" smtClean="0">
+                <a:rPr lang="ko-KR" altLang="en-US" sz="2400" dirty="0" smtClean="0">
                   <a:solidFill>
                     <a:schemeClr val="tx1"/>
                   </a:solidFill>
                   <a:latin typeface="나눔스퀘어 Bold" panose="020B0600000101010101" pitchFamily="50" charset="-127"/>
                   <a:ea typeface="나눔스퀘어 Bold" panose="020B0600000101010101" pitchFamily="50" charset="-127"/>
                 </a:rPr>
-                <a:t>카드</a:t>
-              </a:r>
-              <a:endParaRPr lang="ko-KR" altLang="en-US" sz="2800" dirty="0">
+                <a:t>부품 </a:t>
+              </a:r>
+              <a:r>
+                <a:rPr lang="en-US" altLang="ko-KR" sz="2400" dirty="0" smtClean="0">
+                  <a:solidFill>
+                    <a:schemeClr val="tx1"/>
+                  </a:solidFill>
+                  <a:latin typeface="나눔스퀘어 Bold" panose="020B0600000101010101" pitchFamily="50" charset="-127"/>
+                  <a:ea typeface="나눔스퀘어 Bold" panose="020B0600000101010101" pitchFamily="50" charset="-127"/>
+                </a:rPr>
+                <a:t>2 </a:t>
+              </a:r>
+              <a:r>
+                <a:rPr lang="ko-KR" altLang="en-US" sz="2400" dirty="0">
+                  <a:solidFill>
+                    <a:schemeClr val="tx1"/>
+                  </a:solidFill>
+                  <a:latin typeface="나눔스퀘어 Bold" panose="020B0600000101010101" pitchFamily="50" charset="-127"/>
+                  <a:ea typeface="나눔스퀘어 Bold" panose="020B0600000101010101" pitchFamily="50" charset="-127"/>
+                </a:rPr>
+                <a:t>객체</a:t>
+              </a:r>
+              <a:endParaRPr lang="en-US" altLang="ko-KR" sz="2400" dirty="0" smtClean="0">
+                <a:solidFill>
+                  <a:schemeClr val="tx1"/>
+                </a:solidFill>
+                <a:latin typeface="나눔스퀘어 Bold" panose="020B0600000101010101" pitchFamily="50" charset="-127"/>
+                <a:ea typeface="나눔스퀘어 Bold" panose="020B0600000101010101" pitchFamily="50" charset="-127"/>
+              </a:endParaRPr>
+            </a:p>
+          </p:txBody>
+        </p:sp>
+        <p:sp>
+          <p:nvSpPr>
+            <p:cNvPr id="14" name="모서리가 둥근 직사각형 13"/>
+            <p:cNvSpPr/>
+            <p:nvPr/>
+          </p:nvSpPr>
+          <p:spPr>
+            <a:xfrm>
+              <a:off x="8232000" y="2440740"/>
+              <a:ext cx="2160000" cy="720000"/>
+            </a:xfrm>
+            <a:prstGeom prst="roundRect">
+              <a:avLst>
+                <a:gd name="adj" fmla="val 7210"/>
+              </a:avLst>
+            </a:prstGeom>
+            <a:solidFill>
+              <a:schemeClr val="accent5">
+                <a:lumMod val="60000"/>
+                <a:lumOff val="40000"/>
+              </a:schemeClr>
+            </a:solidFill>
+            <a:ln>
+              <a:noFill/>
+            </a:ln>
+          </p:spPr>
+          <p:style>
+            <a:lnRef idx="2">
+              <a:schemeClr val="accent1">
+                <a:shade val="50000"/>
+              </a:schemeClr>
+            </a:lnRef>
+            <a:fillRef idx="1">
+              <a:schemeClr val="accent1"/>
+            </a:fillRef>
+            <a:effectRef idx="0">
+              <a:schemeClr val="accent1"/>
+            </a:effectRef>
+            <a:fontRef idx="minor">
+              <a:schemeClr val="lt1"/>
+            </a:fontRef>
+          </p:style>
+          <p:txBody>
+            <a:bodyPr rtlCol="0" anchor="ctr"/>
+            <a:lstStyle/>
+            <a:p>
+              <a:pPr algn="ctr"/>
+              <a:r>
+                <a:rPr lang="ko-KR" altLang="en-US" sz="2400" dirty="0" smtClean="0">
+                  <a:solidFill>
+                    <a:schemeClr val="tx1"/>
+                  </a:solidFill>
+                  <a:latin typeface="나눔스퀘어 Bold" panose="020B0600000101010101" pitchFamily="50" charset="-127"/>
+                  <a:ea typeface="나눔스퀘어 Bold" panose="020B0600000101010101" pitchFamily="50" charset="-127"/>
+                </a:rPr>
+                <a:t>부품 </a:t>
+              </a:r>
+              <a:r>
+                <a:rPr lang="en-US" altLang="ko-KR" sz="2400" dirty="0" smtClean="0">
+                  <a:solidFill>
+                    <a:schemeClr val="tx1"/>
+                  </a:solidFill>
+                  <a:latin typeface="나눔스퀘어 Bold" panose="020B0600000101010101" pitchFamily="50" charset="-127"/>
+                  <a:ea typeface="나눔스퀘어 Bold" panose="020B0600000101010101" pitchFamily="50" charset="-127"/>
+                </a:rPr>
+                <a:t>3 </a:t>
+              </a:r>
+              <a:r>
+                <a:rPr lang="ko-KR" altLang="en-US" sz="2400" dirty="0">
+                  <a:solidFill>
+                    <a:schemeClr val="tx1"/>
+                  </a:solidFill>
+                  <a:latin typeface="나눔스퀘어 Bold" panose="020B0600000101010101" pitchFamily="50" charset="-127"/>
+                  <a:ea typeface="나눔스퀘어 Bold" panose="020B0600000101010101" pitchFamily="50" charset="-127"/>
+                </a:rPr>
+                <a:t>객체</a:t>
+              </a:r>
+              <a:endParaRPr lang="ko-KR" altLang="en-US" sz="2400" dirty="0">
                 <a:solidFill>
                   <a:schemeClr val="tx1"/>
                 </a:solidFill>
@@ -11824,23 +12369,26 @@
         </p:sp>
         <p:cxnSp>
           <p:nvCxnSpPr>
-            <p:cNvPr id="41" name="꺾인 연결선 40"/>
+            <p:cNvPr id="5" name="꺾인 연결선 4"/>
             <p:cNvCxnSpPr>
-              <a:stCxn id="39" idx="2"/>
+              <a:stCxn id="22" idx="3"/>
+              <a:endCxn id="12" idx="1"/>
             </p:cNvCxnSpPr>
             <p:nvPr/>
           </p:nvCxnSpPr>
           <p:spPr>
-            <a:xfrm rot="5400000">
-              <a:off x="5490075" y="593675"/>
-              <a:ext cx="1851750" cy="12700"/>
+            <a:xfrm flipV="1">
+              <a:off x="6436544" y="1170000"/>
+              <a:ext cx="1795456" cy="1122209"/>
             </a:xfrm>
             <a:prstGeom prst="bentConnector3">
-              <a:avLst/>
+              <a:avLst>
+                <a:gd name="adj1" fmla="val 38081"/>
+              </a:avLst>
             </a:prstGeom>
             <a:ln w="76200">
               <a:solidFill>
-                <a:schemeClr val="accent2"/>
+                <a:srgbClr val="FF0000"/>
               </a:solidFill>
               <a:tailEnd type="triangle"/>
             </a:ln>
@@ -11862,24 +12410,24 @@
         </p:cxnSp>
         <p:cxnSp>
           <p:nvCxnSpPr>
-            <p:cNvPr id="42" name="꺾인 연결선 41"/>
+            <p:cNvPr id="18" name="꺾인 연결선 17"/>
             <p:cNvCxnSpPr>
-              <a:stCxn id="39" idx="2"/>
-              <a:endCxn id="38" idx="0"/>
+              <a:stCxn id="26" idx="3"/>
+              <a:endCxn id="13" idx="1"/>
             </p:cNvCxnSpPr>
             <p:nvPr/>
           </p:nvCxnSpPr>
           <p:spPr>
-            <a:xfrm rot="16200000" flipH="1">
-              <a:off x="7402650" y="-1318900"/>
-              <a:ext cx="1851750" cy="3825150"/>
+            <a:xfrm flipV="1">
+              <a:off x="6436544" y="1984677"/>
+              <a:ext cx="1795456" cy="1122209"/>
             </a:xfrm>
             <a:prstGeom prst="bentConnector3">
               <a:avLst/>
             </a:prstGeom>
             <a:ln w="76200">
               <a:solidFill>
-                <a:schemeClr val="accent2"/>
+                <a:srgbClr val="FF0000"/>
               </a:solidFill>
               <a:tailEnd type="triangle"/>
             </a:ln>
@@ -11901,24 +12449,26 @@
         </p:cxnSp>
         <p:cxnSp>
           <p:nvCxnSpPr>
-            <p:cNvPr id="43" name="꺾인 연결선 42"/>
+            <p:cNvPr id="23" name="꺾인 연결선 22"/>
             <p:cNvCxnSpPr>
-              <a:stCxn id="39" idx="2"/>
-              <a:endCxn id="40" idx="0"/>
+              <a:stCxn id="28" idx="3"/>
+              <a:endCxn id="14" idx="1"/>
             </p:cNvCxnSpPr>
             <p:nvPr/>
           </p:nvCxnSpPr>
           <p:spPr>
-            <a:xfrm rot="5400000">
-              <a:off x="3577500" y="-1318900"/>
-              <a:ext cx="1851750" cy="3825150"/>
+            <a:xfrm flipV="1">
+              <a:off x="6436544" y="2800740"/>
+              <a:ext cx="1795456" cy="1122209"/>
             </a:xfrm>
             <a:prstGeom prst="bentConnector3">
-              <a:avLst/>
+              <a:avLst>
+                <a:gd name="adj1" fmla="val 61919"/>
+              </a:avLst>
             </a:prstGeom>
             <a:ln w="76200">
               <a:solidFill>
-                <a:schemeClr val="accent2"/>
+                <a:srgbClr val="FF0000"/>
               </a:solidFill>
               <a:tailEnd type="triangle"/>
             </a:ln>
@@ -11942,7 +12492,7 @@
     </p:spTree>
     <p:extLst>
       <p:ext uri="{BB962C8B-B14F-4D97-AF65-F5344CB8AC3E}">
-        <p14:creationId xmlns:p14="http://schemas.microsoft.com/office/powerpoint/2010/main" val="1679211822"/>
+        <p14:creationId xmlns:p14="http://schemas.microsoft.com/office/powerpoint/2010/main" val="315607415"/>
       </p:ext>
     </p:extLst>
   </p:cSld>

</xml_diff>

<commit_message>
20260814 commit : remp, finish
</commit_message>
<xml_diff>
--- a/create_notion_img.pptx
+++ b/create_notion_img.pptx
@@ -248,7 +248,7 @@
           <a:p>
             <a:fld id="{7237CE1A-8831-48B5-BA93-72483C6E34E8}" type="datetimeFigureOut">
               <a:rPr lang="ko-KR" altLang="en-US" smtClean="0"/>
-              <a:t>26-08-13(Thu)</a:t>
+              <a:t>2026-08-14</a:t>
             </a:fld>
             <a:endParaRPr lang="ko-KR" altLang="en-US"/>
           </a:p>
@@ -418,7 +418,7 @@
           <a:p>
             <a:fld id="{7237CE1A-8831-48B5-BA93-72483C6E34E8}" type="datetimeFigureOut">
               <a:rPr lang="ko-KR" altLang="en-US" smtClean="0"/>
-              <a:t>26-08-13(Thu)</a:t>
+              <a:t>2026-08-14</a:t>
             </a:fld>
             <a:endParaRPr lang="ko-KR" altLang="en-US"/>
           </a:p>
@@ -598,7 +598,7 @@
           <a:p>
             <a:fld id="{7237CE1A-8831-48B5-BA93-72483C6E34E8}" type="datetimeFigureOut">
               <a:rPr lang="ko-KR" altLang="en-US" smtClean="0"/>
-              <a:t>26-08-13(Thu)</a:t>
+              <a:t>2026-08-14</a:t>
             </a:fld>
             <a:endParaRPr lang="ko-KR" altLang="en-US"/>
           </a:p>
@@ -768,7 +768,7 @@
           <a:p>
             <a:fld id="{7237CE1A-8831-48B5-BA93-72483C6E34E8}" type="datetimeFigureOut">
               <a:rPr lang="ko-KR" altLang="en-US" smtClean="0"/>
-              <a:t>26-08-13(Thu)</a:t>
+              <a:t>2026-08-14</a:t>
             </a:fld>
             <a:endParaRPr lang="ko-KR" altLang="en-US"/>
           </a:p>
@@ -1014,7 +1014,7 @@
           <a:p>
             <a:fld id="{7237CE1A-8831-48B5-BA93-72483C6E34E8}" type="datetimeFigureOut">
               <a:rPr lang="ko-KR" altLang="en-US" smtClean="0"/>
-              <a:t>26-08-13(Thu)</a:t>
+              <a:t>2026-08-14</a:t>
             </a:fld>
             <a:endParaRPr lang="ko-KR" altLang="en-US"/>
           </a:p>
@@ -1246,7 +1246,7 @@
           <a:p>
             <a:fld id="{7237CE1A-8831-48B5-BA93-72483C6E34E8}" type="datetimeFigureOut">
               <a:rPr lang="ko-KR" altLang="en-US" smtClean="0"/>
-              <a:t>26-08-13(Thu)</a:t>
+              <a:t>2026-08-14</a:t>
             </a:fld>
             <a:endParaRPr lang="ko-KR" altLang="en-US"/>
           </a:p>
@@ -1613,7 +1613,7 @@
           <a:p>
             <a:fld id="{7237CE1A-8831-48B5-BA93-72483C6E34E8}" type="datetimeFigureOut">
               <a:rPr lang="ko-KR" altLang="en-US" smtClean="0"/>
-              <a:t>26-08-13(Thu)</a:t>
+              <a:t>2026-08-14</a:t>
             </a:fld>
             <a:endParaRPr lang="ko-KR" altLang="en-US"/>
           </a:p>
@@ -1731,7 +1731,7 @@
           <a:p>
             <a:fld id="{7237CE1A-8831-48B5-BA93-72483C6E34E8}" type="datetimeFigureOut">
               <a:rPr lang="ko-KR" altLang="en-US" smtClean="0"/>
-              <a:t>26-08-13(Thu)</a:t>
+              <a:t>2026-08-14</a:t>
             </a:fld>
             <a:endParaRPr lang="ko-KR" altLang="en-US"/>
           </a:p>
@@ -1826,7 +1826,7 @@
           <a:p>
             <a:fld id="{7237CE1A-8831-48B5-BA93-72483C6E34E8}" type="datetimeFigureOut">
               <a:rPr lang="ko-KR" altLang="en-US" smtClean="0"/>
-              <a:t>26-08-13(Thu)</a:t>
+              <a:t>2026-08-14</a:t>
             </a:fld>
             <a:endParaRPr lang="ko-KR" altLang="en-US"/>
           </a:p>
@@ -2103,7 +2103,7 @@
           <a:p>
             <a:fld id="{7237CE1A-8831-48B5-BA93-72483C6E34E8}" type="datetimeFigureOut">
               <a:rPr lang="ko-KR" altLang="en-US" smtClean="0"/>
-              <a:t>26-08-13(Thu)</a:t>
+              <a:t>2026-08-14</a:t>
             </a:fld>
             <a:endParaRPr lang="ko-KR" altLang="en-US"/>
           </a:p>
@@ -2356,7 +2356,7 @@
           <a:p>
             <a:fld id="{7237CE1A-8831-48B5-BA93-72483C6E34E8}" type="datetimeFigureOut">
               <a:rPr lang="ko-KR" altLang="en-US" smtClean="0"/>
-              <a:t>26-08-13(Thu)</a:t>
+              <a:t>2026-08-14</a:t>
             </a:fld>
             <a:endParaRPr lang="ko-KR" altLang="en-US"/>
           </a:p>
@@ -2569,7 +2569,7 @@
           <a:p>
             <a:fld id="{7237CE1A-8831-48B5-BA93-72483C6E34E8}" type="datetimeFigureOut">
               <a:rPr lang="ko-KR" altLang="en-US" smtClean="0"/>
-              <a:t>26-08-13(Thu)</a:t>
+              <a:t>2026-08-14</a:t>
             </a:fld>
             <a:endParaRPr lang="ko-KR" altLang="en-US"/>
           </a:p>
@@ -3894,28 +3894,1587 @@
       </p:grpSpPr>
       <p:grpSp>
         <p:nvGrpSpPr>
-          <p:cNvPr id="11" name="그룹 10"/>
+          <p:cNvPr id="114" name="그룹 113"/>
           <p:cNvGrpSpPr/>
           <p:nvPr/>
         </p:nvGrpSpPr>
         <p:grpSpPr>
           <a:xfrm>
-            <a:off x="1857829" y="769257"/>
-            <a:ext cx="5962748" cy="5013372"/>
-            <a:chOff x="1857829" y="769257"/>
-            <a:chExt cx="5962748" cy="5013372"/>
+            <a:off x="2120900" y="138525"/>
+            <a:ext cx="6691142" cy="5087448"/>
+            <a:chOff x="2120900" y="138525"/>
+            <a:chExt cx="6691142" cy="5087448"/>
           </a:xfrm>
         </p:grpSpPr>
         <p:sp>
           <p:nvSpPr>
-            <p:cNvPr id="2" name="모서리가 둥근 직사각형 1"/>
+            <p:cNvPr id="15" name="직사각형 14"/>
             <p:cNvSpPr/>
             <p:nvPr/>
           </p:nvSpPr>
           <p:spPr>
             <a:xfrm>
-              <a:off x="1857829" y="769257"/>
-              <a:ext cx="3600000" cy="1080000"/>
+              <a:off x="2120900" y="1078637"/>
+              <a:ext cx="6691142" cy="1015663"/>
+            </a:xfrm>
+            <a:prstGeom prst="rect">
+              <a:avLst/>
+            </a:prstGeom>
+          </p:spPr>
+          <p:txBody>
+            <a:bodyPr wrap="square">
+              <a:spAutoFit/>
+            </a:bodyPr>
+            <a:lstStyle/>
+            <a:p>
+              <a:r>
+                <a:rPr lang="en-US" altLang="ko-KR" sz="6000" dirty="0" smtClean="0">
+                  <a:latin typeface="나눔스퀘어 Bold" panose="020B0600000101010101" pitchFamily="50" charset="-127"/>
+                  <a:ea typeface="나눔스퀘어 Bold" panose="020B0600000101010101" pitchFamily="50" charset="-127"/>
+                </a:rPr>
+                <a:t>String </a:t>
+              </a:r>
+              <a:r>
+                <a:rPr lang="en-US" altLang="ko-KR" sz="6000" dirty="0" err="1" smtClean="0">
+                  <a:latin typeface="나눔스퀘어 Bold" panose="020B0600000101010101" pitchFamily="50" charset="-127"/>
+                  <a:ea typeface="나눔스퀘어 Bold" panose="020B0600000101010101" pitchFamily="50" charset="-127"/>
+                </a:rPr>
+                <a:t>str</a:t>
+              </a:r>
+              <a:r>
+                <a:rPr lang="en-US" altLang="ko-KR" sz="6000" dirty="0" smtClean="0">
+                  <a:latin typeface="나눔스퀘어 Bold" panose="020B0600000101010101" pitchFamily="50" charset="-127"/>
+                  <a:ea typeface="나눔스퀘어 Bold" panose="020B0600000101010101" pitchFamily="50" charset="-127"/>
+                </a:rPr>
+                <a:t> = “Hello”</a:t>
+              </a:r>
+              <a:endParaRPr lang="en-US" altLang="ko-KR" sz="6000" dirty="0">
+                <a:latin typeface="나눔스퀘어 Bold" panose="020B0600000101010101" pitchFamily="50" charset="-127"/>
+                <a:ea typeface="나눔스퀘어 Bold" panose="020B0600000101010101" pitchFamily="50" charset="-127"/>
+              </a:endParaRPr>
+            </a:p>
+          </p:txBody>
+        </p:sp>
+        <p:sp>
+          <p:nvSpPr>
+            <p:cNvPr id="24" name="TextBox 23"/>
+            <p:cNvSpPr txBox="1"/>
+            <p:nvPr/>
+          </p:nvSpPr>
+          <p:spPr>
+            <a:xfrm>
+              <a:off x="2465069" y="138526"/>
+              <a:ext cx="1688284" cy="400110"/>
+            </a:xfrm>
+            <a:prstGeom prst="rect">
+              <a:avLst/>
+            </a:prstGeom>
+            <a:noFill/>
+          </p:spPr>
+          <p:txBody>
+            <a:bodyPr wrap="none" rtlCol="0">
+              <a:spAutoFit/>
+            </a:bodyPr>
+            <a:lstStyle/>
+            <a:p>
+              <a:pPr algn="ctr"/>
+              <a:r>
+                <a:rPr lang="en-US" altLang="ko-KR" sz="2000" dirty="0" smtClean="0">
+                  <a:latin typeface="나눔스퀘어 Bold" panose="020B0600000101010101" pitchFamily="50" charset="-127"/>
+                  <a:ea typeface="나눔스퀘어 Bold" panose="020B0600000101010101" pitchFamily="50" charset="-127"/>
+                </a:rPr>
+                <a:t>String </a:t>
+              </a:r>
+              <a:r>
+                <a:rPr lang="ko-KR" altLang="en-US" sz="2000" dirty="0" smtClean="0">
+                  <a:latin typeface="나눔스퀘어 Bold" panose="020B0600000101010101" pitchFamily="50" charset="-127"/>
+                  <a:ea typeface="나눔스퀘어 Bold" panose="020B0600000101010101" pitchFamily="50" charset="-127"/>
+                </a:rPr>
+                <a:t>키워드</a:t>
+              </a:r>
+              <a:endParaRPr lang="ko-KR" altLang="en-US" sz="2000" dirty="0">
+                <a:latin typeface="나눔스퀘어 Bold" panose="020B0600000101010101" pitchFamily="50" charset="-127"/>
+                <a:ea typeface="나눔스퀘어 Bold" panose="020B0600000101010101" pitchFamily="50" charset="-127"/>
+              </a:endParaRPr>
+            </a:p>
+          </p:txBody>
+        </p:sp>
+        <p:sp>
+          <p:nvSpPr>
+            <p:cNvPr id="30" name="TextBox 29"/>
+            <p:cNvSpPr txBox="1"/>
+            <p:nvPr/>
+          </p:nvSpPr>
+          <p:spPr>
+            <a:xfrm>
+              <a:off x="4794036" y="138526"/>
+              <a:ext cx="652743" cy="400110"/>
+            </a:xfrm>
+            <a:prstGeom prst="rect">
+              <a:avLst/>
+            </a:prstGeom>
+            <a:noFill/>
+          </p:spPr>
+          <p:txBody>
+            <a:bodyPr wrap="none" rtlCol="0">
+              <a:spAutoFit/>
+            </a:bodyPr>
+            <a:lstStyle/>
+            <a:p>
+              <a:pPr algn="ctr"/>
+              <a:r>
+                <a:rPr lang="ko-KR" altLang="en-US" sz="2000" smtClean="0">
+                  <a:latin typeface="나눔스퀘어 Bold" panose="020B0600000101010101" pitchFamily="50" charset="-127"/>
+                  <a:ea typeface="나눔스퀘어 Bold" panose="020B0600000101010101" pitchFamily="50" charset="-127"/>
+                </a:rPr>
+                <a:t>변수</a:t>
+              </a:r>
+              <a:endParaRPr lang="ko-KR" altLang="en-US" sz="2000" dirty="0">
+                <a:latin typeface="나눔스퀘어 Bold" panose="020B0600000101010101" pitchFamily="50" charset="-127"/>
+                <a:ea typeface="나눔스퀘어 Bold" panose="020B0600000101010101" pitchFamily="50" charset="-127"/>
+              </a:endParaRPr>
+            </a:p>
+          </p:txBody>
+        </p:sp>
+        <p:sp>
+          <p:nvSpPr>
+            <p:cNvPr id="31" name="아래쪽 화살표 30"/>
+            <p:cNvSpPr/>
+            <p:nvPr/>
+          </p:nvSpPr>
+          <p:spPr>
+            <a:xfrm rot="10800000" flipH="1" flipV="1">
+              <a:off x="3129211" y="538637"/>
+              <a:ext cx="360000" cy="540000"/>
+            </a:xfrm>
+            <a:prstGeom prst="downArrow">
+              <a:avLst/>
+            </a:prstGeom>
+            <a:solidFill>
+              <a:schemeClr val="accent2"/>
+            </a:solidFill>
+            <a:ln>
+              <a:noFill/>
+            </a:ln>
+          </p:spPr>
+          <p:style>
+            <a:lnRef idx="2">
+              <a:schemeClr val="accent1">
+                <a:shade val="50000"/>
+              </a:schemeClr>
+            </a:lnRef>
+            <a:fillRef idx="1">
+              <a:schemeClr val="accent1"/>
+            </a:fillRef>
+            <a:effectRef idx="0">
+              <a:schemeClr val="accent1"/>
+            </a:effectRef>
+            <a:fontRef idx="minor">
+              <a:schemeClr val="lt1"/>
+            </a:fontRef>
+          </p:style>
+          <p:txBody>
+            <a:bodyPr rtlCol="0" anchor="ctr"/>
+            <a:lstStyle/>
+            <a:p>
+              <a:pPr algn="ctr"/>
+              <a:endParaRPr lang="ko-KR" altLang="en-US">
+                <a:latin typeface="나눔스퀘어 Bold" panose="020B0600000101010101" pitchFamily="50" charset="-127"/>
+                <a:ea typeface="나눔스퀘어 Bold" panose="020B0600000101010101" pitchFamily="50" charset="-127"/>
+              </a:endParaRPr>
+            </a:p>
+          </p:txBody>
+        </p:sp>
+        <p:sp>
+          <p:nvSpPr>
+            <p:cNvPr id="32" name="TextBox 31"/>
+            <p:cNvSpPr txBox="1"/>
+            <p:nvPr/>
+          </p:nvSpPr>
+          <p:spPr>
+            <a:xfrm>
+              <a:off x="6561569" y="138525"/>
+              <a:ext cx="2185215" cy="400110"/>
+            </a:xfrm>
+            <a:prstGeom prst="rect">
+              <a:avLst/>
+            </a:prstGeom>
+            <a:noFill/>
+          </p:spPr>
+          <p:txBody>
+            <a:bodyPr wrap="none" rtlCol="0">
+              <a:spAutoFit/>
+            </a:bodyPr>
+            <a:lstStyle/>
+            <a:p>
+              <a:pPr algn="ctr"/>
+              <a:r>
+                <a:rPr lang="ko-KR" altLang="en-US" sz="2000" dirty="0" smtClean="0">
+                  <a:latin typeface="나눔스퀘어 Bold" panose="020B0600000101010101" pitchFamily="50" charset="-127"/>
+                  <a:ea typeface="나눔스퀘어 Bold" panose="020B0600000101010101" pitchFamily="50" charset="-127"/>
+                </a:rPr>
+                <a:t>담은 문자열 데이터</a:t>
+              </a:r>
+              <a:endParaRPr lang="ko-KR" altLang="en-US" sz="2000" dirty="0">
+                <a:latin typeface="나눔스퀘어 Bold" panose="020B0600000101010101" pitchFamily="50" charset="-127"/>
+                <a:ea typeface="나눔스퀘어 Bold" panose="020B0600000101010101" pitchFamily="50" charset="-127"/>
+              </a:endParaRPr>
+            </a:p>
+          </p:txBody>
+        </p:sp>
+        <p:sp>
+          <p:nvSpPr>
+            <p:cNvPr id="33" name="아래쪽 화살표 32"/>
+            <p:cNvSpPr/>
+            <p:nvPr/>
+          </p:nvSpPr>
+          <p:spPr>
+            <a:xfrm rot="10800000" flipH="1" flipV="1">
+              <a:off x="7474177" y="538636"/>
+              <a:ext cx="360000" cy="540000"/>
+            </a:xfrm>
+            <a:prstGeom prst="downArrow">
+              <a:avLst/>
+            </a:prstGeom>
+            <a:solidFill>
+              <a:schemeClr val="accent2"/>
+            </a:solidFill>
+            <a:ln>
+              <a:noFill/>
+            </a:ln>
+          </p:spPr>
+          <p:style>
+            <a:lnRef idx="2">
+              <a:schemeClr val="accent1">
+                <a:shade val="50000"/>
+              </a:schemeClr>
+            </a:lnRef>
+            <a:fillRef idx="1">
+              <a:schemeClr val="accent1"/>
+            </a:fillRef>
+            <a:effectRef idx="0">
+              <a:schemeClr val="accent1"/>
+            </a:effectRef>
+            <a:fontRef idx="minor">
+              <a:schemeClr val="lt1"/>
+            </a:fontRef>
+          </p:style>
+          <p:txBody>
+            <a:bodyPr rtlCol="0" anchor="ctr"/>
+            <a:lstStyle/>
+            <a:p>
+              <a:pPr algn="ctr"/>
+              <a:endParaRPr lang="ko-KR" altLang="en-US">
+                <a:latin typeface="나눔스퀘어 Bold" panose="020B0600000101010101" pitchFamily="50" charset="-127"/>
+                <a:ea typeface="나눔스퀘어 Bold" panose="020B0600000101010101" pitchFamily="50" charset="-127"/>
+              </a:endParaRPr>
+            </a:p>
+          </p:txBody>
+        </p:sp>
+        <p:sp>
+          <p:nvSpPr>
+            <p:cNvPr id="43" name="아래쪽 화살표 42"/>
+            <p:cNvSpPr/>
+            <p:nvPr/>
+          </p:nvSpPr>
+          <p:spPr>
+            <a:xfrm rot="10800000" flipH="1" flipV="1">
+              <a:off x="4940408" y="538637"/>
+              <a:ext cx="360000" cy="540000"/>
+            </a:xfrm>
+            <a:prstGeom prst="downArrow">
+              <a:avLst/>
+            </a:prstGeom>
+            <a:solidFill>
+              <a:schemeClr val="accent2"/>
+            </a:solidFill>
+            <a:ln>
+              <a:noFill/>
+            </a:ln>
+          </p:spPr>
+          <p:style>
+            <a:lnRef idx="2">
+              <a:schemeClr val="accent1">
+                <a:shade val="50000"/>
+              </a:schemeClr>
+            </a:lnRef>
+            <a:fillRef idx="1">
+              <a:schemeClr val="accent1"/>
+            </a:fillRef>
+            <a:effectRef idx="0">
+              <a:schemeClr val="accent1"/>
+            </a:effectRef>
+            <a:fontRef idx="minor">
+              <a:schemeClr val="lt1"/>
+            </a:fontRef>
+          </p:style>
+          <p:txBody>
+            <a:bodyPr rtlCol="0" anchor="ctr"/>
+            <a:lstStyle/>
+            <a:p>
+              <a:pPr algn="ctr"/>
+              <a:endParaRPr lang="ko-KR" altLang="en-US">
+                <a:latin typeface="나눔스퀘어 Bold" panose="020B0600000101010101" pitchFamily="50" charset="-127"/>
+                <a:ea typeface="나눔스퀘어 Bold" panose="020B0600000101010101" pitchFamily="50" charset="-127"/>
+              </a:endParaRPr>
+            </a:p>
+          </p:txBody>
+        </p:sp>
+        <p:grpSp>
+          <p:nvGrpSpPr>
+            <p:cNvPr id="34" name="그룹 33"/>
+            <p:cNvGrpSpPr/>
+            <p:nvPr/>
+          </p:nvGrpSpPr>
+          <p:grpSpPr>
+            <a:xfrm>
+              <a:off x="2442472" y="2634300"/>
+              <a:ext cx="6047998" cy="2591673"/>
+              <a:chOff x="5498280" y="2634304"/>
+              <a:chExt cx="6047998" cy="2591673"/>
+            </a:xfrm>
+          </p:grpSpPr>
+          <p:sp>
+            <p:nvSpPr>
+              <p:cNvPr id="44" name="직사각형 43"/>
+              <p:cNvSpPr>
+                <a:spLocks noChangeAspect="1"/>
+              </p:cNvSpPr>
+              <p:nvPr/>
+            </p:nvSpPr>
+            <p:spPr>
+              <a:xfrm>
+                <a:off x="7226280" y="2634308"/>
+                <a:ext cx="864000" cy="863891"/>
+              </a:xfrm>
+              <a:prstGeom prst="rect">
+                <a:avLst/>
+              </a:prstGeom>
+              <a:noFill/>
+              <a:ln w="19050">
+                <a:solidFill>
+                  <a:schemeClr val="tx1"/>
+                </a:solidFill>
+              </a:ln>
+            </p:spPr>
+            <p:style>
+              <a:lnRef idx="2">
+                <a:schemeClr val="accent1">
+                  <a:shade val="50000"/>
+                </a:schemeClr>
+              </a:lnRef>
+              <a:fillRef idx="1">
+                <a:schemeClr val="accent1"/>
+              </a:fillRef>
+              <a:effectRef idx="0">
+                <a:schemeClr val="accent1"/>
+              </a:effectRef>
+              <a:fontRef idx="minor">
+                <a:schemeClr val="lt1"/>
+              </a:fontRef>
+            </p:style>
+            <p:txBody>
+              <a:bodyPr rtlCol="0" anchor="ctr"/>
+              <a:lstStyle/>
+              <a:p>
+                <a:pPr algn="ctr"/>
+                <a:endParaRPr lang="ko-KR" altLang="en-US" sz="2400">
+                  <a:solidFill>
+                    <a:schemeClr val="tx1"/>
+                  </a:solidFill>
+                  <a:latin typeface="나눔스퀘어 Bold" panose="020B0600000101010101" pitchFamily="50" charset="-127"/>
+                  <a:ea typeface="나눔스퀘어 Bold" panose="020B0600000101010101" pitchFamily="50" charset="-127"/>
+                </a:endParaRPr>
+              </a:p>
+            </p:txBody>
+          </p:sp>
+          <p:sp>
+            <p:nvSpPr>
+              <p:cNvPr id="46" name="직사각형 45"/>
+              <p:cNvSpPr>
+                <a:spLocks noChangeAspect="1"/>
+              </p:cNvSpPr>
+              <p:nvPr/>
+            </p:nvSpPr>
+            <p:spPr>
+              <a:xfrm>
+                <a:off x="8090280" y="2634308"/>
+                <a:ext cx="864000" cy="863891"/>
+              </a:xfrm>
+              <a:prstGeom prst="rect">
+                <a:avLst/>
+              </a:prstGeom>
+              <a:noFill/>
+              <a:ln w="19050">
+                <a:solidFill>
+                  <a:schemeClr val="tx1"/>
+                </a:solidFill>
+              </a:ln>
+            </p:spPr>
+            <p:style>
+              <a:lnRef idx="2">
+                <a:schemeClr val="accent1">
+                  <a:shade val="50000"/>
+                </a:schemeClr>
+              </a:lnRef>
+              <a:fillRef idx="1">
+                <a:schemeClr val="accent1"/>
+              </a:fillRef>
+              <a:effectRef idx="0">
+                <a:schemeClr val="accent1"/>
+              </a:effectRef>
+              <a:fontRef idx="minor">
+                <a:schemeClr val="lt1"/>
+              </a:fontRef>
+            </p:style>
+            <p:txBody>
+              <a:bodyPr rtlCol="0" anchor="ctr"/>
+              <a:lstStyle/>
+              <a:p>
+                <a:pPr algn="ctr"/>
+                <a:endParaRPr lang="ko-KR" altLang="en-US" sz="2400">
+                  <a:solidFill>
+                    <a:schemeClr val="tx1"/>
+                  </a:solidFill>
+                  <a:latin typeface="나눔스퀘어 Bold" panose="020B0600000101010101" pitchFamily="50" charset="-127"/>
+                  <a:ea typeface="나눔스퀘어 Bold" panose="020B0600000101010101" pitchFamily="50" charset="-127"/>
+                </a:endParaRPr>
+              </a:p>
+            </p:txBody>
+          </p:sp>
+          <p:sp>
+            <p:nvSpPr>
+              <p:cNvPr id="48" name="직사각형 47"/>
+              <p:cNvSpPr>
+                <a:spLocks noChangeAspect="1"/>
+              </p:cNvSpPr>
+              <p:nvPr/>
+            </p:nvSpPr>
+            <p:spPr>
+              <a:xfrm>
+                <a:off x="8954279" y="2634308"/>
+                <a:ext cx="864000" cy="863891"/>
+              </a:xfrm>
+              <a:prstGeom prst="rect">
+                <a:avLst/>
+              </a:prstGeom>
+              <a:noFill/>
+              <a:ln w="19050">
+                <a:solidFill>
+                  <a:schemeClr val="tx1"/>
+                </a:solidFill>
+              </a:ln>
+            </p:spPr>
+            <p:style>
+              <a:lnRef idx="2">
+                <a:schemeClr val="accent1">
+                  <a:shade val="50000"/>
+                </a:schemeClr>
+              </a:lnRef>
+              <a:fillRef idx="1">
+                <a:schemeClr val="accent1"/>
+              </a:fillRef>
+              <a:effectRef idx="0">
+                <a:schemeClr val="accent1"/>
+              </a:effectRef>
+              <a:fontRef idx="minor">
+                <a:schemeClr val="lt1"/>
+              </a:fontRef>
+            </p:style>
+            <p:txBody>
+              <a:bodyPr rtlCol="0" anchor="ctr"/>
+              <a:lstStyle/>
+              <a:p>
+                <a:pPr algn="ctr"/>
+                <a:endParaRPr lang="ko-KR" altLang="en-US" sz="2400">
+                  <a:solidFill>
+                    <a:schemeClr val="tx1"/>
+                  </a:solidFill>
+                  <a:latin typeface="나눔스퀘어 Bold" panose="020B0600000101010101" pitchFamily="50" charset="-127"/>
+                  <a:ea typeface="나눔스퀘어 Bold" panose="020B0600000101010101" pitchFamily="50" charset="-127"/>
+                </a:endParaRPr>
+              </a:p>
+            </p:txBody>
+          </p:sp>
+          <p:sp>
+            <p:nvSpPr>
+              <p:cNvPr id="50" name="직사각형 49"/>
+              <p:cNvSpPr>
+                <a:spLocks noChangeAspect="1"/>
+              </p:cNvSpPr>
+              <p:nvPr/>
+            </p:nvSpPr>
+            <p:spPr>
+              <a:xfrm>
+                <a:off x="9818279" y="2634308"/>
+                <a:ext cx="864000" cy="863891"/>
+              </a:xfrm>
+              <a:prstGeom prst="rect">
+                <a:avLst/>
+              </a:prstGeom>
+              <a:noFill/>
+              <a:ln w="19050">
+                <a:solidFill>
+                  <a:schemeClr val="tx1"/>
+                </a:solidFill>
+              </a:ln>
+            </p:spPr>
+            <p:style>
+              <a:lnRef idx="2">
+                <a:schemeClr val="accent1">
+                  <a:shade val="50000"/>
+                </a:schemeClr>
+              </a:lnRef>
+              <a:fillRef idx="1">
+                <a:schemeClr val="accent1"/>
+              </a:fillRef>
+              <a:effectRef idx="0">
+                <a:schemeClr val="accent1"/>
+              </a:effectRef>
+              <a:fontRef idx="minor">
+                <a:schemeClr val="lt1"/>
+              </a:fontRef>
+            </p:style>
+            <p:txBody>
+              <a:bodyPr rtlCol="0" anchor="ctr"/>
+              <a:lstStyle/>
+              <a:p>
+                <a:pPr algn="ctr"/>
+                <a:endParaRPr lang="ko-KR" altLang="en-US" sz="2400">
+                  <a:solidFill>
+                    <a:schemeClr val="tx1"/>
+                  </a:solidFill>
+                  <a:latin typeface="나눔스퀘어 Bold" panose="020B0600000101010101" pitchFamily="50" charset="-127"/>
+                  <a:ea typeface="나눔스퀘어 Bold" panose="020B0600000101010101" pitchFamily="50" charset="-127"/>
+                </a:endParaRPr>
+              </a:p>
+            </p:txBody>
+          </p:sp>
+          <p:sp>
+            <p:nvSpPr>
+              <p:cNvPr id="52" name="직사각형 51"/>
+              <p:cNvSpPr>
+                <a:spLocks noChangeAspect="1"/>
+              </p:cNvSpPr>
+              <p:nvPr/>
+            </p:nvSpPr>
+            <p:spPr>
+              <a:xfrm>
+                <a:off x="10682278" y="2634308"/>
+                <a:ext cx="864000" cy="863891"/>
+              </a:xfrm>
+              <a:prstGeom prst="rect">
+                <a:avLst/>
+              </a:prstGeom>
+              <a:noFill/>
+              <a:ln w="19050">
+                <a:solidFill>
+                  <a:schemeClr val="tx1"/>
+                </a:solidFill>
+              </a:ln>
+            </p:spPr>
+            <p:style>
+              <a:lnRef idx="2">
+                <a:schemeClr val="accent1">
+                  <a:shade val="50000"/>
+                </a:schemeClr>
+              </a:lnRef>
+              <a:fillRef idx="1">
+                <a:schemeClr val="accent1"/>
+              </a:fillRef>
+              <a:effectRef idx="0">
+                <a:schemeClr val="accent1"/>
+              </a:effectRef>
+              <a:fontRef idx="minor">
+                <a:schemeClr val="lt1"/>
+              </a:fontRef>
+            </p:style>
+            <p:txBody>
+              <a:bodyPr rtlCol="0" anchor="ctr"/>
+              <a:lstStyle/>
+              <a:p>
+                <a:pPr algn="ctr"/>
+                <a:endParaRPr lang="ko-KR" altLang="en-US" sz="2400">
+                  <a:solidFill>
+                    <a:schemeClr val="tx1"/>
+                  </a:solidFill>
+                  <a:latin typeface="나눔스퀘어 Bold" panose="020B0600000101010101" pitchFamily="50" charset="-127"/>
+                  <a:ea typeface="나눔스퀘어 Bold" panose="020B0600000101010101" pitchFamily="50" charset="-127"/>
+                </a:endParaRPr>
+              </a:p>
+            </p:txBody>
+          </p:sp>
+          <p:sp>
+            <p:nvSpPr>
+              <p:cNvPr id="54" name="직사각형 53"/>
+              <p:cNvSpPr>
+                <a:spLocks noChangeAspect="1"/>
+              </p:cNvSpPr>
+              <p:nvPr/>
+            </p:nvSpPr>
+            <p:spPr>
+              <a:xfrm>
+                <a:off x="7226280" y="3498199"/>
+                <a:ext cx="864000" cy="863891"/>
+              </a:xfrm>
+              <a:prstGeom prst="rect">
+                <a:avLst/>
+              </a:prstGeom>
+              <a:noFill/>
+              <a:ln w="19050">
+                <a:solidFill>
+                  <a:schemeClr val="tx1"/>
+                </a:solidFill>
+              </a:ln>
+            </p:spPr>
+            <p:style>
+              <a:lnRef idx="2">
+                <a:schemeClr val="accent1">
+                  <a:shade val="50000"/>
+                </a:schemeClr>
+              </a:lnRef>
+              <a:fillRef idx="1">
+                <a:schemeClr val="accent1"/>
+              </a:fillRef>
+              <a:effectRef idx="0">
+                <a:schemeClr val="accent1"/>
+              </a:effectRef>
+              <a:fontRef idx="minor">
+                <a:schemeClr val="lt1"/>
+              </a:fontRef>
+            </p:style>
+            <p:txBody>
+              <a:bodyPr rtlCol="0" anchor="ctr"/>
+              <a:lstStyle/>
+              <a:p>
+                <a:pPr algn="ctr"/>
+                <a:r>
+                  <a:rPr lang="en-US" altLang="ko-KR" sz="2400" dirty="0" err="1">
+                    <a:solidFill>
+                      <a:schemeClr val="tx1"/>
+                    </a:solidFill>
+                    <a:latin typeface="나눔스퀘어 Bold" panose="020B0600000101010101" pitchFamily="50" charset="-127"/>
+                    <a:ea typeface="나눔스퀘어 Bold" panose="020B0600000101010101" pitchFamily="50" charset="-127"/>
+                  </a:rPr>
+                  <a:t>e</a:t>
+                </a:r>
+                <a:endParaRPr lang="ko-KR" altLang="en-US" sz="2400" dirty="0">
+                  <a:solidFill>
+                    <a:schemeClr val="tx1"/>
+                  </a:solidFill>
+                  <a:latin typeface="나눔스퀘어 Bold" panose="020B0600000101010101" pitchFamily="50" charset="-127"/>
+                  <a:ea typeface="나눔스퀘어 Bold" panose="020B0600000101010101" pitchFamily="50" charset="-127"/>
+                </a:endParaRPr>
+              </a:p>
+            </p:txBody>
+          </p:sp>
+          <p:sp>
+            <p:nvSpPr>
+              <p:cNvPr id="56" name="직사각형 55"/>
+              <p:cNvSpPr>
+                <a:spLocks noChangeAspect="1"/>
+              </p:cNvSpPr>
+              <p:nvPr/>
+            </p:nvSpPr>
+            <p:spPr>
+              <a:xfrm>
+                <a:off x="8090280" y="3498199"/>
+                <a:ext cx="864000" cy="863891"/>
+              </a:xfrm>
+              <a:prstGeom prst="rect">
+                <a:avLst/>
+              </a:prstGeom>
+              <a:noFill/>
+              <a:ln w="19050">
+                <a:solidFill>
+                  <a:schemeClr val="tx1"/>
+                </a:solidFill>
+              </a:ln>
+            </p:spPr>
+            <p:style>
+              <a:lnRef idx="2">
+                <a:schemeClr val="accent1">
+                  <a:shade val="50000"/>
+                </a:schemeClr>
+              </a:lnRef>
+              <a:fillRef idx="1">
+                <a:schemeClr val="accent1"/>
+              </a:fillRef>
+              <a:effectRef idx="0">
+                <a:schemeClr val="accent1"/>
+              </a:effectRef>
+              <a:fontRef idx="minor">
+                <a:schemeClr val="lt1"/>
+              </a:fontRef>
+            </p:style>
+            <p:txBody>
+              <a:bodyPr rtlCol="0" anchor="ctr"/>
+              <a:lstStyle/>
+              <a:p>
+                <a:pPr algn="ctr"/>
+                <a:r>
+                  <a:rPr lang="en-US" altLang="ko-KR" sz="2400" dirty="0" err="1">
+                    <a:solidFill>
+                      <a:schemeClr val="tx1"/>
+                    </a:solidFill>
+                    <a:latin typeface="나눔스퀘어 Bold" panose="020B0600000101010101" pitchFamily="50" charset="-127"/>
+                    <a:ea typeface="나눔스퀘어 Bold" panose="020B0600000101010101" pitchFamily="50" charset="-127"/>
+                  </a:rPr>
+                  <a:t>l</a:t>
+                </a:r>
+                <a:endParaRPr lang="ko-KR" altLang="en-US" sz="2400" dirty="0">
+                  <a:solidFill>
+                    <a:schemeClr val="tx1"/>
+                  </a:solidFill>
+                  <a:latin typeface="나눔스퀘어 Bold" panose="020B0600000101010101" pitchFamily="50" charset="-127"/>
+                  <a:ea typeface="나눔스퀘어 Bold" panose="020B0600000101010101" pitchFamily="50" charset="-127"/>
+                </a:endParaRPr>
+              </a:p>
+            </p:txBody>
+          </p:sp>
+          <p:sp>
+            <p:nvSpPr>
+              <p:cNvPr id="60" name="직사각형 59"/>
+              <p:cNvSpPr>
+                <a:spLocks noChangeAspect="1"/>
+              </p:cNvSpPr>
+              <p:nvPr/>
+            </p:nvSpPr>
+            <p:spPr>
+              <a:xfrm>
+                <a:off x="8954279" y="3498199"/>
+                <a:ext cx="864000" cy="863891"/>
+              </a:xfrm>
+              <a:prstGeom prst="rect">
+                <a:avLst/>
+              </a:prstGeom>
+              <a:noFill/>
+              <a:ln w="19050">
+                <a:solidFill>
+                  <a:schemeClr val="tx1"/>
+                </a:solidFill>
+              </a:ln>
+            </p:spPr>
+            <p:style>
+              <a:lnRef idx="2">
+                <a:schemeClr val="accent1">
+                  <a:shade val="50000"/>
+                </a:schemeClr>
+              </a:lnRef>
+              <a:fillRef idx="1">
+                <a:schemeClr val="accent1"/>
+              </a:fillRef>
+              <a:effectRef idx="0">
+                <a:schemeClr val="accent1"/>
+              </a:effectRef>
+              <a:fontRef idx="minor">
+                <a:schemeClr val="lt1"/>
+              </a:fontRef>
+            </p:style>
+            <p:txBody>
+              <a:bodyPr rtlCol="0" anchor="ctr"/>
+              <a:lstStyle/>
+              <a:p>
+                <a:pPr algn="ctr"/>
+                <a:r>
+                  <a:rPr lang="en-US" altLang="ko-KR" sz="2400" dirty="0" err="1">
+                    <a:solidFill>
+                      <a:schemeClr val="tx1"/>
+                    </a:solidFill>
+                    <a:latin typeface="나눔스퀘어 Bold" panose="020B0600000101010101" pitchFamily="50" charset="-127"/>
+                    <a:ea typeface="나눔스퀘어 Bold" panose="020B0600000101010101" pitchFamily="50" charset="-127"/>
+                  </a:rPr>
+                  <a:t>l</a:t>
+                </a:r>
+                <a:endParaRPr lang="ko-KR" altLang="en-US" sz="2400" dirty="0">
+                  <a:solidFill>
+                    <a:schemeClr val="tx1"/>
+                  </a:solidFill>
+                  <a:latin typeface="나눔스퀘어 Bold" panose="020B0600000101010101" pitchFamily="50" charset="-127"/>
+                  <a:ea typeface="나눔스퀘어 Bold" panose="020B0600000101010101" pitchFamily="50" charset="-127"/>
+                </a:endParaRPr>
+              </a:p>
+            </p:txBody>
+          </p:sp>
+          <p:sp>
+            <p:nvSpPr>
+              <p:cNvPr id="63" name="직사각형 62"/>
+              <p:cNvSpPr>
+                <a:spLocks noChangeAspect="1"/>
+              </p:cNvSpPr>
+              <p:nvPr/>
+            </p:nvSpPr>
+            <p:spPr>
+              <a:xfrm>
+                <a:off x="9818279" y="3498199"/>
+                <a:ext cx="864000" cy="863891"/>
+              </a:xfrm>
+              <a:prstGeom prst="rect">
+                <a:avLst/>
+              </a:prstGeom>
+              <a:noFill/>
+              <a:ln w="19050">
+                <a:solidFill>
+                  <a:schemeClr val="tx1"/>
+                </a:solidFill>
+              </a:ln>
+            </p:spPr>
+            <p:style>
+              <a:lnRef idx="2">
+                <a:schemeClr val="accent1">
+                  <a:shade val="50000"/>
+                </a:schemeClr>
+              </a:lnRef>
+              <a:fillRef idx="1">
+                <a:schemeClr val="accent1"/>
+              </a:fillRef>
+              <a:effectRef idx="0">
+                <a:schemeClr val="accent1"/>
+              </a:effectRef>
+              <a:fontRef idx="minor">
+                <a:schemeClr val="lt1"/>
+              </a:fontRef>
+            </p:style>
+            <p:txBody>
+              <a:bodyPr rtlCol="0" anchor="ctr"/>
+              <a:lstStyle/>
+              <a:p>
+                <a:pPr algn="ctr"/>
+                <a:r>
+                  <a:rPr lang="en-US" altLang="ko-KR" sz="2400" dirty="0" err="1">
+                    <a:solidFill>
+                      <a:schemeClr val="tx1"/>
+                    </a:solidFill>
+                    <a:latin typeface="나눔스퀘어 Bold" panose="020B0600000101010101" pitchFamily="50" charset="-127"/>
+                    <a:ea typeface="나눔스퀘어 Bold" panose="020B0600000101010101" pitchFamily="50" charset="-127"/>
+                  </a:rPr>
+                  <a:t>o</a:t>
+                </a:r>
+                <a:endParaRPr lang="ko-KR" altLang="en-US" sz="2400" dirty="0">
+                  <a:solidFill>
+                    <a:schemeClr val="tx1"/>
+                  </a:solidFill>
+                  <a:latin typeface="나눔스퀘어 Bold" panose="020B0600000101010101" pitchFamily="50" charset="-127"/>
+                  <a:ea typeface="나눔스퀘어 Bold" panose="020B0600000101010101" pitchFamily="50" charset="-127"/>
+                </a:endParaRPr>
+              </a:p>
+            </p:txBody>
+          </p:sp>
+          <p:sp>
+            <p:nvSpPr>
+              <p:cNvPr id="65" name="직사각형 64"/>
+              <p:cNvSpPr>
+                <a:spLocks noChangeAspect="1"/>
+              </p:cNvSpPr>
+              <p:nvPr/>
+            </p:nvSpPr>
+            <p:spPr>
+              <a:xfrm>
+                <a:off x="10682278" y="3498199"/>
+                <a:ext cx="864000" cy="863891"/>
+              </a:xfrm>
+              <a:prstGeom prst="rect">
+                <a:avLst/>
+              </a:prstGeom>
+              <a:noFill/>
+              <a:ln w="19050">
+                <a:solidFill>
+                  <a:schemeClr val="tx1"/>
+                </a:solidFill>
+              </a:ln>
+            </p:spPr>
+            <p:style>
+              <a:lnRef idx="2">
+                <a:schemeClr val="accent1">
+                  <a:shade val="50000"/>
+                </a:schemeClr>
+              </a:lnRef>
+              <a:fillRef idx="1">
+                <a:schemeClr val="accent1"/>
+              </a:fillRef>
+              <a:effectRef idx="0">
+                <a:schemeClr val="accent1"/>
+              </a:effectRef>
+              <a:fontRef idx="minor">
+                <a:schemeClr val="lt1"/>
+              </a:fontRef>
+            </p:style>
+            <p:txBody>
+              <a:bodyPr rtlCol="0" anchor="ctr"/>
+              <a:lstStyle/>
+              <a:p>
+                <a:pPr algn="ctr"/>
+                <a:endParaRPr lang="ko-KR" altLang="en-US" sz="2400">
+                  <a:solidFill>
+                    <a:schemeClr val="tx1"/>
+                  </a:solidFill>
+                  <a:latin typeface="나눔스퀘어 Bold" panose="020B0600000101010101" pitchFamily="50" charset="-127"/>
+                  <a:ea typeface="나눔스퀘어 Bold" panose="020B0600000101010101" pitchFamily="50" charset="-127"/>
+                </a:endParaRPr>
+              </a:p>
+            </p:txBody>
+          </p:sp>
+          <p:sp>
+            <p:nvSpPr>
+              <p:cNvPr id="67" name="직사각형 66"/>
+              <p:cNvSpPr>
+                <a:spLocks noChangeAspect="1"/>
+              </p:cNvSpPr>
+              <p:nvPr/>
+            </p:nvSpPr>
+            <p:spPr>
+              <a:xfrm>
+                <a:off x="7226280" y="4362086"/>
+                <a:ext cx="864000" cy="863891"/>
+              </a:xfrm>
+              <a:prstGeom prst="rect">
+                <a:avLst/>
+              </a:prstGeom>
+              <a:noFill/>
+              <a:ln w="19050">
+                <a:solidFill>
+                  <a:schemeClr val="tx1"/>
+                </a:solidFill>
+              </a:ln>
+            </p:spPr>
+            <p:style>
+              <a:lnRef idx="2">
+                <a:schemeClr val="accent1">
+                  <a:shade val="50000"/>
+                </a:schemeClr>
+              </a:lnRef>
+              <a:fillRef idx="1">
+                <a:schemeClr val="accent1"/>
+              </a:fillRef>
+              <a:effectRef idx="0">
+                <a:schemeClr val="accent1"/>
+              </a:effectRef>
+              <a:fontRef idx="minor">
+                <a:schemeClr val="lt1"/>
+              </a:fontRef>
+            </p:style>
+            <p:txBody>
+              <a:bodyPr rtlCol="0" anchor="ctr"/>
+              <a:lstStyle/>
+              <a:p>
+                <a:pPr algn="ctr"/>
+                <a:endParaRPr lang="ko-KR" altLang="en-US" sz="2400">
+                  <a:solidFill>
+                    <a:schemeClr val="tx1"/>
+                  </a:solidFill>
+                  <a:latin typeface="나눔스퀘어 Bold" panose="020B0600000101010101" pitchFamily="50" charset="-127"/>
+                  <a:ea typeface="나눔스퀘어 Bold" panose="020B0600000101010101" pitchFamily="50" charset="-127"/>
+                </a:endParaRPr>
+              </a:p>
+            </p:txBody>
+          </p:sp>
+          <p:sp>
+            <p:nvSpPr>
+              <p:cNvPr id="71" name="직사각형 70"/>
+              <p:cNvSpPr>
+                <a:spLocks noChangeAspect="1"/>
+              </p:cNvSpPr>
+              <p:nvPr/>
+            </p:nvSpPr>
+            <p:spPr>
+              <a:xfrm>
+                <a:off x="8090280" y="4362086"/>
+                <a:ext cx="864000" cy="863891"/>
+              </a:xfrm>
+              <a:prstGeom prst="rect">
+                <a:avLst/>
+              </a:prstGeom>
+              <a:noFill/>
+              <a:ln w="19050">
+                <a:solidFill>
+                  <a:schemeClr val="tx1"/>
+                </a:solidFill>
+              </a:ln>
+            </p:spPr>
+            <p:style>
+              <a:lnRef idx="2">
+                <a:schemeClr val="accent1">
+                  <a:shade val="50000"/>
+                </a:schemeClr>
+              </a:lnRef>
+              <a:fillRef idx="1">
+                <a:schemeClr val="accent1"/>
+              </a:fillRef>
+              <a:effectRef idx="0">
+                <a:schemeClr val="accent1"/>
+              </a:effectRef>
+              <a:fontRef idx="minor">
+                <a:schemeClr val="lt1"/>
+              </a:fontRef>
+            </p:style>
+            <p:txBody>
+              <a:bodyPr rtlCol="0" anchor="ctr"/>
+              <a:lstStyle/>
+              <a:p>
+                <a:pPr algn="ctr"/>
+                <a:endParaRPr lang="ko-KR" altLang="en-US" sz="2400">
+                  <a:solidFill>
+                    <a:schemeClr val="tx1"/>
+                  </a:solidFill>
+                  <a:latin typeface="나눔스퀘어 Bold" panose="020B0600000101010101" pitchFamily="50" charset="-127"/>
+                  <a:ea typeface="나눔스퀘어 Bold" panose="020B0600000101010101" pitchFamily="50" charset="-127"/>
+                </a:endParaRPr>
+              </a:p>
+            </p:txBody>
+          </p:sp>
+          <p:sp>
+            <p:nvSpPr>
+              <p:cNvPr id="73" name="직사각형 72"/>
+              <p:cNvSpPr>
+                <a:spLocks noChangeAspect="1"/>
+              </p:cNvSpPr>
+              <p:nvPr/>
+            </p:nvSpPr>
+            <p:spPr>
+              <a:xfrm>
+                <a:off x="8954279" y="4362086"/>
+                <a:ext cx="864000" cy="863891"/>
+              </a:xfrm>
+              <a:prstGeom prst="rect">
+                <a:avLst/>
+              </a:prstGeom>
+              <a:noFill/>
+              <a:ln w="19050">
+                <a:solidFill>
+                  <a:schemeClr val="tx1"/>
+                </a:solidFill>
+              </a:ln>
+            </p:spPr>
+            <p:style>
+              <a:lnRef idx="2">
+                <a:schemeClr val="accent1">
+                  <a:shade val="50000"/>
+                </a:schemeClr>
+              </a:lnRef>
+              <a:fillRef idx="1">
+                <a:schemeClr val="accent1"/>
+              </a:fillRef>
+              <a:effectRef idx="0">
+                <a:schemeClr val="accent1"/>
+              </a:effectRef>
+              <a:fontRef idx="minor">
+                <a:schemeClr val="lt1"/>
+              </a:fontRef>
+            </p:style>
+            <p:txBody>
+              <a:bodyPr rtlCol="0" anchor="ctr"/>
+              <a:lstStyle/>
+              <a:p>
+                <a:pPr algn="ctr"/>
+                <a:endParaRPr lang="ko-KR" altLang="en-US" sz="2400">
+                  <a:solidFill>
+                    <a:schemeClr val="tx1"/>
+                  </a:solidFill>
+                  <a:latin typeface="나눔스퀘어 Bold" panose="020B0600000101010101" pitchFamily="50" charset="-127"/>
+                  <a:ea typeface="나눔스퀘어 Bold" panose="020B0600000101010101" pitchFamily="50" charset="-127"/>
+                </a:endParaRPr>
+              </a:p>
+            </p:txBody>
+          </p:sp>
+          <p:sp>
+            <p:nvSpPr>
+              <p:cNvPr id="75" name="직사각형 74"/>
+              <p:cNvSpPr>
+                <a:spLocks noChangeAspect="1"/>
+              </p:cNvSpPr>
+              <p:nvPr/>
+            </p:nvSpPr>
+            <p:spPr>
+              <a:xfrm>
+                <a:off x="9818279" y="4362086"/>
+                <a:ext cx="864000" cy="863891"/>
+              </a:xfrm>
+              <a:prstGeom prst="rect">
+                <a:avLst/>
+              </a:prstGeom>
+              <a:noFill/>
+              <a:ln w="19050">
+                <a:solidFill>
+                  <a:schemeClr val="tx1"/>
+                </a:solidFill>
+              </a:ln>
+            </p:spPr>
+            <p:style>
+              <a:lnRef idx="2">
+                <a:schemeClr val="accent1">
+                  <a:shade val="50000"/>
+                </a:schemeClr>
+              </a:lnRef>
+              <a:fillRef idx="1">
+                <a:schemeClr val="accent1"/>
+              </a:fillRef>
+              <a:effectRef idx="0">
+                <a:schemeClr val="accent1"/>
+              </a:effectRef>
+              <a:fontRef idx="minor">
+                <a:schemeClr val="lt1"/>
+              </a:fontRef>
+            </p:style>
+            <p:txBody>
+              <a:bodyPr rtlCol="0" anchor="ctr"/>
+              <a:lstStyle/>
+              <a:p>
+                <a:pPr algn="ctr"/>
+                <a:endParaRPr lang="ko-KR" altLang="en-US" sz="2400">
+                  <a:solidFill>
+                    <a:schemeClr val="tx1"/>
+                  </a:solidFill>
+                  <a:latin typeface="나눔스퀘어 Bold" panose="020B0600000101010101" pitchFamily="50" charset="-127"/>
+                  <a:ea typeface="나눔스퀘어 Bold" panose="020B0600000101010101" pitchFamily="50" charset="-127"/>
+                </a:endParaRPr>
+              </a:p>
+            </p:txBody>
+          </p:sp>
+          <p:sp>
+            <p:nvSpPr>
+              <p:cNvPr id="77" name="직사각형 76"/>
+              <p:cNvSpPr>
+                <a:spLocks noChangeAspect="1"/>
+              </p:cNvSpPr>
+              <p:nvPr/>
+            </p:nvSpPr>
+            <p:spPr>
+              <a:xfrm>
+                <a:off x="10682278" y="4362086"/>
+                <a:ext cx="864000" cy="863891"/>
+              </a:xfrm>
+              <a:prstGeom prst="rect">
+                <a:avLst/>
+              </a:prstGeom>
+              <a:noFill/>
+              <a:ln w="19050">
+                <a:solidFill>
+                  <a:schemeClr val="tx1"/>
+                </a:solidFill>
+              </a:ln>
+            </p:spPr>
+            <p:style>
+              <a:lnRef idx="2">
+                <a:schemeClr val="accent1">
+                  <a:shade val="50000"/>
+                </a:schemeClr>
+              </a:lnRef>
+              <a:fillRef idx="1">
+                <a:schemeClr val="accent1"/>
+              </a:fillRef>
+              <a:effectRef idx="0">
+                <a:schemeClr val="accent1"/>
+              </a:effectRef>
+              <a:fontRef idx="minor">
+                <a:schemeClr val="lt1"/>
+              </a:fontRef>
+            </p:style>
+            <p:txBody>
+              <a:bodyPr rtlCol="0" anchor="ctr"/>
+              <a:lstStyle/>
+              <a:p>
+                <a:pPr algn="ctr"/>
+                <a:endParaRPr lang="ko-KR" altLang="en-US" sz="2400">
+                  <a:solidFill>
+                    <a:schemeClr val="tx1"/>
+                  </a:solidFill>
+                  <a:latin typeface="나눔스퀘어 Bold" panose="020B0600000101010101" pitchFamily="50" charset="-127"/>
+                  <a:ea typeface="나눔스퀘어 Bold" panose="020B0600000101010101" pitchFamily="50" charset="-127"/>
+                </a:endParaRPr>
+              </a:p>
+            </p:txBody>
+          </p:sp>
+          <p:sp>
+            <p:nvSpPr>
+              <p:cNvPr id="79" name="직사각형 78"/>
+              <p:cNvSpPr>
+                <a:spLocks noChangeAspect="1"/>
+              </p:cNvSpPr>
+              <p:nvPr/>
+            </p:nvSpPr>
+            <p:spPr>
+              <a:xfrm>
+                <a:off x="5498280" y="2634304"/>
+                <a:ext cx="864000" cy="863891"/>
+              </a:xfrm>
+              <a:prstGeom prst="rect">
+                <a:avLst/>
+              </a:prstGeom>
+              <a:noFill/>
+              <a:ln w="19050">
+                <a:solidFill>
+                  <a:schemeClr val="tx1"/>
+                </a:solidFill>
+              </a:ln>
+            </p:spPr>
+            <p:style>
+              <a:lnRef idx="2">
+                <a:schemeClr val="accent1">
+                  <a:shade val="50000"/>
+                </a:schemeClr>
+              </a:lnRef>
+              <a:fillRef idx="1">
+                <a:schemeClr val="accent1"/>
+              </a:fillRef>
+              <a:effectRef idx="0">
+                <a:schemeClr val="accent1"/>
+              </a:effectRef>
+              <a:fontRef idx="minor">
+                <a:schemeClr val="lt1"/>
+              </a:fontRef>
+            </p:style>
+            <p:txBody>
+              <a:bodyPr rtlCol="0" anchor="ctr"/>
+              <a:lstStyle/>
+              <a:p>
+                <a:pPr algn="ctr"/>
+                <a:endParaRPr lang="ko-KR" altLang="en-US" sz="2400">
+                  <a:solidFill>
+                    <a:schemeClr val="tx1"/>
+                  </a:solidFill>
+                  <a:latin typeface="나눔스퀘어 Bold" panose="020B0600000101010101" pitchFamily="50" charset="-127"/>
+                  <a:ea typeface="나눔스퀘어 Bold" panose="020B0600000101010101" pitchFamily="50" charset="-127"/>
+                </a:endParaRPr>
+              </a:p>
+            </p:txBody>
+          </p:sp>
+          <p:sp>
+            <p:nvSpPr>
+              <p:cNvPr id="80" name="직사각형 79"/>
+              <p:cNvSpPr>
+                <a:spLocks noChangeAspect="1"/>
+              </p:cNvSpPr>
+              <p:nvPr/>
+            </p:nvSpPr>
+            <p:spPr>
+              <a:xfrm>
+                <a:off x="6362279" y="2634304"/>
+                <a:ext cx="864000" cy="863891"/>
+              </a:xfrm>
+              <a:prstGeom prst="rect">
+                <a:avLst/>
+              </a:prstGeom>
+              <a:noFill/>
+              <a:ln w="19050">
+                <a:solidFill>
+                  <a:schemeClr val="tx1"/>
+                </a:solidFill>
+              </a:ln>
+            </p:spPr>
+            <p:style>
+              <a:lnRef idx="2">
+                <a:schemeClr val="accent1">
+                  <a:shade val="50000"/>
+                </a:schemeClr>
+              </a:lnRef>
+              <a:fillRef idx="1">
+                <a:schemeClr val="accent1"/>
+              </a:fillRef>
+              <a:effectRef idx="0">
+                <a:schemeClr val="accent1"/>
+              </a:effectRef>
+              <a:fontRef idx="minor">
+                <a:schemeClr val="lt1"/>
+              </a:fontRef>
+            </p:style>
+            <p:txBody>
+              <a:bodyPr rtlCol="0" anchor="ctr"/>
+              <a:lstStyle/>
+              <a:p>
+                <a:pPr algn="ctr"/>
+                <a:endParaRPr lang="ko-KR" altLang="en-US" sz="2400">
+                  <a:solidFill>
+                    <a:schemeClr val="tx1"/>
+                  </a:solidFill>
+                  <a:latin typeface="나눔스퀘어 Bold" panose="020B0600000101010101" pitchFamily="50" charset="-127"/>
+                  <a:ea typeface="나눔스퀘어 Bold" panose="020B0600000101010101" pitchFamily="50" charset="-127"/>
+                </a:endParaRPr>
+              </a:p>
+            </p:txBody>
+          </p:sp>
+          <p:sp>
+            <p:nvSpPr>
+              <p:cNvPr id="81" name="직사각형 80"/>
+              <p:cNvSpPr>
+                <a:spLocks noChangeAspect="1"/>
+              </p:cNvSpPr>
+              <p:nvPr/>
+            </p:nvSpPr>
+            <p:spPr>
+              <a:xfrm>
+                <a:off x="5498280" y="3498195"/>
+                <a:ext cx="864000" cy="863891"/>
+              </a:xfrm>
+              <a:prstGeom prst="rect">
+                <a:avLst/>
+              </a:prstGeom>
+              <a:noFill/>
+              <a:ln w="19050">
+                <a:solidFill>
+                  <a:schemeClr val="tx1"/>
+                </a:solidFill>
+              </a:ln>
+            </p:spPr>
+            <p:style>
+              <a:lnRef idx="2">
+                <a:schemeClr val="accent1">
+                  <a:shade val="50000"/>
+                </a:schemeClr>
+              </a:lnRef>
+              <a:fillRef idx="1">
+                <a:schemeClr val="accent1"/>
+              </a:fillRef>
+              <a:effectRef idx="0">
+                <a:schemeClr val="accent1"/>
+              </a:effectRef>
+              <a:fontRef idx="minor">
+                <a:schemeClr val="lt1"/>
+              </a:fontRef>
+            </p:style>
+            <p:txBody>
+              <a:bodyPr rtlCol="0" anchor="ctr"/>
+              <a:lstStyle/>
+              <a:p>
+                <a:pPr algn="ctr"/>
+                <a:endParaRPr lang="ko-KR" altLang="en-US" sz="2400">
+                  <a:solidFill>
+                    <a:schemeClr val="tx1"/>
+                  </a:solidFill>
+                  <a:latin typeface="나눔스퀘어 Bold" panose="020B0600000101010101" pitchFamily="50" charset="-127"/>
+                  <a:ea typeface="나눔스퀘어 Bold" panose="020B0600000101010101" pitchFamily="50" charset="-127"/>
+                </a:endParaRPr>
+              </a:p>
+            </p:txBody>
+          </p:sp>
+          <p:sp>
+            <p:nvSpPr>
+              <p:cNvPr id="82" name="직사각형 81"/>
+              <p:cNvSpPr>
+                <a:spLocks noChangeAspect="1"/>
+              </p:cNvSpPr>
+              <p:nvPr/>
+            </p:nvSpPr>
+            <p:spPr>
+              <a:xfrm>
+                <a:off x="6362279" y="3498195"/>
+                <a:ext cx="864000" cy="863891"/>
+              </a:xfrm>
+              <a:prstGeom prst="rect">
+                <a:avLst/>
+              </a:prstGeom>
+              <a:noFill/>
+              <a:ln w="19050">
+                <a:solidFill>
+                  <a:schemeClr val="tx1"/>
+                </a:solidFill>
+              </a:ln>
+            </p:spPr>
+            <p:style>
+              <a:lnRef idx="2">
+                <a:schemeClr val="accent1">
+                  <a:shade val="50000"/>
+                </a:schemeClr>
+              </a:lnRef>
+              <a:fillRef idx="1">
+                <a:schemeClr val="accent1"/>
+              </a:fillRef>
+              <a:effectRef idx="0">
+                <a:schemeClr val="accent1"/>
+              </a:effectRef>
+              <a:fontRef idx="minor">
+                <a:schemeClr val="lt1"/>
+              </a:fontRef>
+            </p:style>
+            <p:txBody>
+              <a:bodyPr rtlCol="0" anchor="ctr"/>
+              <a:lstStyle/>
+              <a:p>
+                <a:pPr algn="ctr"/>
+                <a:r>
+                  <a:rPr lang="en-US" altLang="ko-KR" sz="2400" dirty="0" err="1">
+                    <a:solidFill>
+                      <a:schemeClr val="tx1"/>
+                    </a:solidFill>
+                    <a:latin typeface="나눔스퀘어 Bold" panose="020B0600000101010101" pitchFamily="50" charset="-127"/>
+                    <a:ea typeface="나눔스퀘어 Bold" panose="020B0600000101010101" pitchFamily="50" charset="-127"/>
+                  </a:rPr>
+                  <a:t>H</a:t>
+                </a:r>
+                <a:endParaRPr lang="ko-KR" altLang="en-US" sz="2400" dirty="0">
+                  <a:solidFill>
+                    <a:schemeClr val="tx1"/>
+                  </a:solidFill>
+                  <a:latin typeface="나눔스퀘어 Bold" panose="020B0600000101010101" pitchFamily="50" charset="-127"/>
+                  <a:ea typeface="나눔스퀘어 Bold" panose="020B0600000101010101" pitchFamily="50" charset="-127"/>
+                </a:endParaRPr>
+              </a:p>
+            </p:txBody>
+          </p:sp>
+          <p:sp>
+            <p:nvSpPr>
+              <p:cNvPr id="83" name="직사각형 82"/>
+              <p:cNvSpPr>
+                <a:spLocks noChangeAspect="1"/>
+              </p:cNvSpPr>
+              <p:nvPr/>
+            </p:nvSpPr>
+            <p:spPr>
+              <a:xfrm>
+                <a:off x="5498280" y="4362082"/>
+                <a:ext cx="864000" cy="863891"/>
+              </a:xfrm>
+              <a:prstGeom prst="rect">
+                <a:avLst/>
+              </a:prstGeom>
+              <a:noFill/>
+              <a:ln w="19050">
+                <a:solidFill>
+                  <a:schemeClr val="tx1"/>
+                </a:solidFill>
+              </a:ln>
+            </p:spPr>
+            <p:style>
+              <a:lnRef idx="2">
+                <a:schemeClr val="accent1">
+                  <a:shade val="50000"/>
+                </a:schemeClr>
+              </a:lnRef>
+              <a:fillRef idx="1">
+                <a:schemeClr val="accent1"/>
+              </a:fillRef>
+              <a:effectRef idx="0">
+                <a:schemeClr val="accent1"/>
+              </a:effectRef>
+              <a:fontRef idx="minor">
+                <a:schemeClr val="lt1"/>
+              </a:fontRef>
+            </p:style>
+            <p:txBody>
+              <a:bodyPr rtlCol="0" anchor="ctr"/>
+              <a:lstStyle/>
+              <a:p>
+                <a:pPr algn="ctr"/>
+                <a:endParaRPr lang="ko-KR" altLang="en-US" sz="2400">
+                  <a:solidFill>
+                    <a:schemeClr val="tx1"/>
+                  </a:solidFill>
+                  <a:latin typeface="나눔스퀘어 Bold" panose="020B0600000101010101" pitchFamily="50" charset="-127"/>
+                  <a:ea typeface="나눔스퀘어 Bold" panose="020B0600000101010101" pitchFamily="50" charset="-127"/>
+                </a:endParaRPr>
+              </a:p>
+            </p:txBody>
+          </p:sp>
+          <p:sp>
+            <p:nvSpPr>
+              <p:cNvPr id="84" name="직사각형 83"/>
+              <p:cNvSpPr>
+                <a:spLocks noChangeAspect="1"/>
+              </p:cNvSpPr>
+              <p:nvPr/>
+            </p:nvSpPr>
+            <p:spPr>
+              <a:xfrm>
+                <a:off x="6362279" y="4362082"/>
+                <a:ext cx="864000" cy="863891"/>
+              </a:xfrm>
+              <a:prstGeom prst="rect">
+                <a:avLst/>
+              </a:prstGeom>
+              <a:noFill/>
+              <a:ln w="19050">
+                <a:solidFill>
+                  <a:schemeClr val="tx1"/>
+                </a:solidFill>
+              </a:ln>
+            </p:spPr>
+            <p:style>
+              <a:lnRef idx="2">
+                <a:schemeClr val="accent1">
+                  <a:shade val="50000"/>
+                </a:schemeClr>
+              </a:lnRef>
+              <a:fillRef idx="1">
+                <a:schemeClr val="accent1"/>
+              </a:fillRef>
+              <a:effectRef idx="0">
+                <a:schemeClr val="accent1"/>
+              </a:effectRef>
+              <a:fontRef idx="minor">
+                <a:schemeClr val="lt1"/>
+              </a:fontRef>
+            </p:style>
+            <p:txBody>
+              <a:bodyPr rtlCol="0" anchor="ctr"/>
+              <a:lstStyle/>
+              <a:p>
+                <a:pPr algn="ctr"/>
+                <a:endParaRPr lang="ko-KR" altLang="en-US" sz="2400">
+                  <a:solidFill>
+                    <a:schemeClr val="tx1"/>
+                  </a:solidFill>
+                  <a:latin typeface="나눔스퀘어 Bold" panose="020B0600000101010101" pitchFamily="50" charset="-127"/>
+                  <a:ea typeface="나눔스퀘어 Bold" panose="020B0600000101010101" pitchFamily="50" charset="-127"/>
+                </a:endParaRPr>
+              </a:p>
+            </p:txBody>
+          </p:sp>
+        </p:grpSp>
+        <p:sp>
+          <p:nvSpPr>
+            <p:cNvPr id="35" name="직사각형 34"/>
+            <p:cNvSpPr/>
+            <p:nvPr/>
+          </p:nvSpPr>
+          <p:spPr>
+            <a:xfrm>
+              <a:off x="3205035" y="3422306"/>
+              <a:ext cx="4522872" cy="1015659"/>
+            </a:xfrm>
+            <a:prstGeom prst="rect">
+              <a:avLst/>
+            </a:prstGeom>
+            <a:noFill/>
+            <a:ln w="57150">
+              <a:solidFill>
+                <a:srgbClr val="FF0000"/>
+              </a:solidFill>
+            </a:ln>
+          </p:spPr>
+          <p:style>
+            <a:lnRef idx="2">
+              <a:schemeClr val="accent1">
+                <a:shade val="50000"/>
+              </a:schemeClr>
+            </a:lnRef>
+            <a:fillRef idx="1">
+              <a:schemeClr val="accent1"/>
+            </a:fillRef>
+            <a:effectRef idx="0">
+              <a:schemeClr val="accent1"/>
+            </a:effectRef>
+            <a:fontRef idx="minor">
+              <a:schemeClr val="lt1"/>
+            </a:fontRef>
+          </p:style>
+          <p:txBody>
+            <a:bodyPr rtlCol="0" anchor="ctr"/>
+            <a:lstStyle/>
+            <a:p>
+              <a:pPr algn="ctr"/>
+              <a:endParaRPr lang="ko-KR" altLang="en-US"/>
+            </a:p>
+          </p:txBody>
+        </p:sp>
+        <p:sp>
+          <p:nvSpPr>
+            <p:cNvPr id="42" name="모서리가 둥근 직사각형 41"/>
+            <p:cNvSpPr/>
+            <p:nvPr/>
+          </p:nvSpPr>
+          <p:spPr>
+            <a:xfrm>
+              <a:off x="4746471" y="3091095"/>
+              <a:ext cx="1440000" cy="540000"/>
             </a:xfrm>
             <a:prstGeom prst="roundRect">
               <a:avLst/>
@@ -3951,658 +5510,16 @@
             <a:p>
               <a:pPr algn="ctr"/>
               <a:r>
-                <a:rPr lang="en-US" altLang="ko-KR" sz="2600" dirty="0" err="1" smtClean="0">
+                <a:rPr lang="en-US" altLang="ko-KR" sz="2800" dirty="0" smtClean="0">
                   <a:solidFill>
                     <a:schemeClr val="tx1"/>
                   </a:solidFill>
                   <a:latin typeface="나눔스퀘어 Bold" panose="020B0600000101010101" pitchFamily="50" charset="-127"/>
                   <a:ea typeface="나눔스퀘어 Bold" panose="020B0600000101010101" pitchFamily="50" charset="-127"/>
                 </a:rPr>
-                <a:t>GrandParentsClass</a:t>
+                <a:t>“Hello”</a:t>
               </a:r>
-              <a:endParaRPr lang="ko-KR" altLang="en-US" sz="2600" dirty="0">
-                <a:solidFill>
-                  <a:schemeClr val="tx1"/>
-                </a:solidFill>
-                <a:latin typeface="나눔스퀘어 Bold" panose="020B0600000101010101" pitchFamily="50" charset="-127"/>
-                <a:ea typeface="나눔스퀘어 Bold" panose="020B0600000101010101" pitchFamily="50" charset="-127"/>
-              </a:endParaRPr>
-            </a:p>
-          </p:txBody>
-        </p:sp>
-        <p:sp>
-          <p:nvSpPr>
-            <p:cNvPr id="57" name="모서리가 둥근 직사각형 56"/>
-            <p:cNvSpPr/>
-            <p:nvPr/>
-          </p:nvSpPr>
-          <p:spPr>
-            <a:xfrm>
-              <a:off x="1857829" y="2735943"/>
-              <a:ext cx="3600000" cy="1080000"/>
-            </a:xfrm>
-            <a:prstGeom prst="roundRect">
-              <a:avLst/>
-            </a:prstGeom>
-            <a:solidFill>
-              <a:schemeClr val="bg2">
-                <a:lumMod val="90000"/>
-              </a:schemeClr>
-            </a:solidFill>
-            <a:ln>
-              <a:noFill/>
-            </a:ln>
-          </p:spPr>
-          <p:style>
-            <a:lnRef idx="2">
-              <a:schemeClr val="accent1">
-                <a:shade val="50000"/>
-              </a:schemeClr>
-            </a:lnRef>
-            <a:fillRef idx="1">
-              <a:schemeClr val="accent1"/>
-            </a:fillRef>
-            <a:effectRef idx="0">
-              <a:schemeClr val="accent1"/>
-            </a:effectRef>
-            <a:fontRef idx="minor">
-              <a:schemeClr val="lt1"/>
-            </a:fontRef>
-          </p:style>
-          <p:txBody>
-            <a:bodyPr rtlCol="0" anchor="ctr"/>
-            <a:lstStyle/>
-            <a:p>
-              <a:pPr algn="ctr"/>
-              <a:r>
-                <a:rPr lang="en-US" altLang="ko-KR" sz="2600" dirty="0" err="1" smtClean="0">
-                  <a:solidFill>
-                    <a:schemeClr val="tx1"/>
-                  </a:solidFill>
-                  <a:latin typeface="나눔스퀘어 Bold" panose="020B0600000101010101" pitchFamily="50" charset="-127"/>
-                  <a:ea typeface="나눔스퀘어 Bold" panose="020B0600000101010101" pitchFamily="50" charset="-127"/>
-                </a:rPr>
-                <a:t>ParentsClass</a:t>
-              </a:r>
-              <a:endParaRPr lang="ko-KR" altLang="en-US" sz="2600" dirty="0">
-                <a:solidFill>
-                  <a:schemeClr val="tx1"/>
-                </a:solidFill>
-                <a:latin typeface="나눔스퀘어 Bold" panose="020B0600000101010101" pitchFamily="50" charset="-127"/>
-                <a:ea typeface="나눔스퀘어 Bold" panose="020B0600000101010101" pitchFamily="50" charset="-127"/>
-              </a:endParaRPr>
-            </a:p>
-          </p:txBody>
-        </p:sp>
-        <p:sp>
-          <p:nvSpPr>
-            <p:cNvPr id="58" name="모서리가 둥근 직사각형 57"/>
-            <p:cNvSpPr/>
-            <p:nvPr/>
-          </p:nvSpPr>
-          <p:spPr>
-            <a:xfrm>
-              <a:off x="1857829" y="4702629"/>
-              <a:ext cx="3600000" cy="1080000"/>
-            </a:xfrm>
-            <a:prstGeom prst="roundRect">
-              <a:avLst/>
-            </a:prstGeom>
-            <a:solidFill>
-              <a:schemeClr val="bg2">
-                <a:lumMod val="90000"/>
-              </a:schemeClr>
-            </a:solidFill>
-            <a:ln>
-              <a:noFill/>
-            </a:ln>
-          </p:spPr>
-          <p:style>
-            <a:lnRef idx="2">
-              <a:schemeClr val="accent1">
-                <a:shade val="50000"/>
-              </a:schemeClr>
-            </a:lnRef>
-            <a:fillRef idx="1">
-              <a:schemeClr val="accent1"/>
-            </a:fillRef>
-            <a:effectRef idx="0">
-              <a:schemeClr val="accent1"/>
-            </a:effectRef>
-            <a:fontRef idx="minor">
-              <a:schemeClr val="lt1"/>
-            </a:fontRef>
-          </p:style>
-          <p:txBody>
-            <a:bodyPr rtlCol="0" anchor="ctr"/>
-            <a:lstStyle/>
-            <a:p>
-              <a:pPr algn="ctr"/>
-              <a:r>
-                <a:rPr lang="en-US" altLang="ko-KR" sz="2600" dirty="0" err="1" smtClean="0">
-                  <a:solidFill>
-                    <a:schemeClr val="tx1"/>
-                  </a:solidFill>
-                  <a:latin typeface="나눔스퀘어 Bold" panose="020B0600000101010101" pitchFamily="50" charset="-127"/>
-                  <a:ea typeface="나눔스퀘어 Bold" panose="020B0600000101010101" pitchFamily="50" charset="-127"/>
-                </a:rPr>
-                <a:t>ChindClass</a:t>
-              </a:r>
-              <a:endParaRPr lang="ko-KR" altLang="en-US" sz="2600" dirty="0">
-                <a:solidFill>
-                  <a:schemeClr val="tx1"/>
-                </a:solidFill>
-                <a:latin typeface="나눔스퀘어 Bold" panose="020B0600000101010101" pitchFamily="50" charset="-127"/>
-                <a:ea typeface="나눔스퀘어 Bold" panose="020B0600000101010101" pitchFamily="50" charset="-127"/>
-              </a:endParaRPr>
-            </a:p>
-          </p:txBody>
-        </p:sp>
-        <p:cxnSp>
-          <p:nvCxnSpPr>
-            <p:cNvPr id="4" name="직선 화살표 연결선 3"/>
-            <p:cNvCxnSpPr>
-              <a:stCxn id="58" idx="0"/>
-              <a:endCxn id="57" idx="2"/>
-            </p:cNvCxnSpPr>
-            <p:nvPr/>
-          </p:nvCxnSpPr>
-          <p:spPr>
-            <a:xfrm flipV="1">
-              <a:off x="3657829" y="3815943"/>
-              <a:ext cx="0" cy="886686"/>
-            </a:xfrm>
-            <a:prstGeom prst="straightConnector1">
-              <a:avLst/>
-            </a:prstGeom>
-            <a:ln w="76200">
-              <a:solidFill>
-                <a:schemeClr val="accent2"/>
-              </a:solidFill>
-              <a:tailEnd type="triangle"/>
-            </a:ln>
-          </p:spPr>
-          <p:style>
-            <a:lnRef idx="1">
-              <a:schemeClr val="accent1"/>
-            </a:lnRef>
-            <a:fillRef idx="0">
-              <a:schemeClr val="accent1"/>
-            </a:fillRef>
-            <a:effectRef idx="0">
-              <a:schemeClr val="accent1"/>
-            </a:effectRef>
-            <a:fontRef idx="minor">
-              <a:schemeClr val="tx1"/>
-            </a:fontRef>
-          </p:style>
-        </p:cxnSp>
-        <p:cxnSp>
-          <p:nvCxnSpPr>
-            <p:cNvPr id="61" name="직선 화살표 연결선 60"/>
-            <p:cNvCxnSpPr>
-              <a:stCxn id="57" idx="0"/>
-              <a:endCxn id="2" idx="2"/>
-            </p:cNvCxnSpPr>
-            <p:nvPr/>
-          </p:nvCxnSpPr>
-          <p:spPr>
-            <a:xfrm flipV="1">
-              <a:off x="3657829" y="1849257"/>
-              <a:ext cx="0" cy="886686"/>
-            </a:xfrm>
-            <a:prstGeom prst="straightConnector1">
-              <a:avLst/>
-            </a:prstGeom>
-            <a:ln w="76200">
-              <a:solidFill>
-                <a:schemeClr val="accent2"/>
-              </a:solidFill>
-              <a:tailEnd type="triangle"/>
-            </a:ln>
-          </p:spPr>
-          <p:style>
-            <a:lnRef idx="1">
-              <a:schemeClr val="accent1"/>
-            </a:lnRef>
-            <a:fillRef idx="0">
-              <a:schemeClr val="accent1"/>
-            </a:fillRef>
-            <a:effectRef idx="0">
-              <a:schemeClr val="accent1"/>
-            </a:effectRef>
-            <a:fontRef idx="minor">
-              <a:schemeClr val="tx1"/>
-            </a:fontRef>
-          </p:style>
-        </p:cxnSp>
-        <p:sp>
-          <p:nvSpPr>
-            <p:cNvPr id="10" name="모서리가 둥근 직사각형 9"/>
-            <p:cNvSpPr/>
-            <p:nvPr/>
-          </p:nvSpPr>
-          <p:spPr>
-            <a:xfrm>
-              <a:off x="5660577" y="769257"/>
-              <a:ext cx="2160000" cy="1080000"/>
-            </a:xfrm>
-            <a:prstGeom prst="roundRect">
-              <a:avLst/>
-            </a:prstGeom>
-            <a:noFill/>
-            <a:ln w="28575">
-              <a:solidFill>
-                <a:schemeClr val="tx1"/>
-              </a:solidFill>
-            </a:ln>
-          </p:spPr>
-          <p:style>
-            <a:lnRef idx="2">
-              <a:schemeClr val="accent1">
-                <a:shade val="50000"/>
-              </a:schemeClr>
-            </a:lnRef>
-            <a:fillRef idx="1">
-              <a:schemeClr val="accent1"/>
-            </a:fillRef>
-            <a:effectRef idx="0">
-              <a:schemeClr val="accent1"/>
-            </a:effectRef>
-            <a:fontRef idx="minor">
-              <a:schemeClr val="lt1"/>
-            </a:fontRef>
-          </p:style>
-          <p:txBody>
-            <a:bodyPr rtlCol="0" anchor="ctr"/>
-            <a:lstStyle/>
-            <a:p>
-              <a:pPr algn="ctr"/>
-              <a:r>
-                <a:rPr lang="ko-KR" altLang="en-US" sz="2000" dirty="0" smtClean="0">
-                  <a:solidFill>
-                    <a:schemeClr val="tx1"/>
-                  </a:solidFill>
-                  <a:latin typeface="나눔스퀘어 Bold" panose="020B0600000101010101" pitchFamily="50" charset="-127"/>
-                  <a:ea typeface="나눔스퀘어 Bold" panose="020B0600000101010101" pitchFamily="50" charset="-127"/>
-                </a:rPr>
-                <a:t>속성</a:t>
-              </a:r>
-              <a:r>
-                <a:rPr lang="en-US" altLang="ko-KR" sz="2000" dirty="0" smtClean="0">
-                  <a:solidFill>
-                    <a:schemeClr val="tx1"/>
-                  </a:solidFill>
-                  <a:latin typeface="나눔스퀘어 Bold" panose="020B0600000101010101" pitchFamily="50" charset="-127"/>
-                  <a:ea typeface="나눔스퀘어 Bold" panose="020B0600000101010101" pitchFamily="50" charset="-127"/>
-                </a:rPr>
-                <a:t>1 &amp; </a:t>
-              </a:r>
-              <a:r>
-                <a:rPr lang="ko-KR" altLang="en-US" sz="2000" dirty="0" smtClean="0">
-                  <a:solidFill>
-                    <a:schemeClr val="tx1"/>
-                  </a:solidFill>
-                  <a:latin typeface="나눔스퀘어 Bold" panose="020B0600000101010101" pitchFamily="50" charset="-127"/>
-                  <a:ea typeface="나눔스퀘어 Bold" panose="020B0600000101010101" pitchFamily="50" charset="-127"/>
-                </a:rPr>
-                <a:t>기능</a:t>
-              </a:r>
-              <a:r>
-                <a:rPr lang="en-US" altLang="ko-KR" sz="2000" dirty="0" smtClean="0">
-                  <a:solidFill>
-                    <a:schemeClr val="tx1"/>
-                  </a:solidFill>
-                  <a:latin typeface="나눔스퀘어 Bold" panose="020B0600000101010101" pitchFamily="50" charset="-127"/>
-                  <a:ea typeface="나눔스퀘어 Bold" panose="020B0600000101010101" pitchFamily="50" charset="-127"/>
-                </a:rPr>
-                <a:t>1</a:t>
-              </a:r>
-              <a:endParaRPr lang="ko-KR" altLang="en-US" sz="2000" dirty="0">
-                <a:solidFill>
-                  <a:schemeClr val="tx1"/>
-                </a:solidFill>
-                <a:latin typeface="나눔스퀘어 Bold" panose="020B0600000101010101" pitchFamily="50" charset="-127"/>
-                <a:ea typeface="나눔스퀘어 Bold" panose="020B0600000101010101" pitchFamily="50" charset="-127"/>
-              </a:endParaRPr>
-            </a:p>
-          </p:txBody>
-        </p:sp>
-        <p:sp>
-          <p:nvSpPr>
-            <p:cNvPr id="68" name="모서리가 둥근 직사각형 67"/>
-            <p:cNvSpPr/>
-            <p:nvPr/>
-          </p:nvSpPr>
-          <p:spPr>
-            <a:xfrm>
-              <a:off x="5660577" y="2735943"/>
-              <a:ext cx="2160000" cy="1080000"/>
-            </a:xfrm>
-            <a:prstGeom prst="roundRect">
-              <a:avLst/>
-            </a:prstGeom>
-            <a:noFill/>
-            <a:ln w="28575">
-              <a:solidFill>
-                <a:schemeClr val="tx1"/>
-              </a:solidFill>
-            </a:ln>
-          </p:spPr>
-          <p:style>
-            <a:lnRef idx="2">
-              <a:schemeClr val="accent1">
-                <a:shade val="50000"/>
-              </a:schemeClr>
-            </a:lnRef>
-            <a:fillRef idx="1">
-              <a:schemeClr val="accent1"/>
-            </a:fillRef>
-            <a:effectRef idx="0">
-              <a:schemeClr val="accent1"/>
-            </a:effectRef>
-            <a:fontRef idx="minor">
-              <a:schemeClr val="lt1"/>
-            </a:fontRef>
-          </p:style>
-          <p:txBody>
-            <a:bodyPr rtlCol="0" anchor="ctr"/>
-            <a:lstStyle/>
-            <a:p>
-              <a:pPr algn="ctr"/>
-              <a:r>
-                <a:rPr lang="ko-KR" altLang="en-US" sz="2000" dirty="0">
-                  <a:solidFill>
-                    <a:schemeClr val="tx1"/>
-                  </a:solidFill>
-                  <a:latin typeface="나눔스퀘어 Bold" panose="020B0600000101010101" pitchFamily="50" charset="-127"/>
-                  <a:ea typeface="나눔스퀘어 Bold" panose="020B0600000101010101" pitchFamily="50" charset="-127"/>
-                </a:rPr>
-                <a:t>속성</a:t>
-              </a:r>
-              <a:r>
-                <a:rPr lang="en-US" altLang="ko-KR" sz="2000" dirty="0">
-                  <a:solidFill>
-                    <a:schemeClr val="tx1"/>
-                  </a:solidFill>
-                  <a:latin typeface="나눔스퀘어 Bold" panose="020B0600000101010101" pitchFamily="50" charset="-127"/>
-                  <a:ea typeface="나눔스퀘어 Bold" panose="020B0600000101010101" pitchFamily="50" charset="-127"/>
-                </a:rPr>
-                <a:t>1 &amp; </a:t>
-              </a:r>
-              <a:r>
-                <a:rPr lang="ko-KR" altLang="en-US" sz="2000" dirty="0">
-                  <a:solidFill>
-                    <a:schemeClr val="tx1"/>
-                  </a:solidFill>
-                  <a:latin typeface="나눔스퀘어 Bold" panose="020B0600000101010101" pitchFamily="50" charset="-127"/>
-                  <a:ea typeface="나눔스퀘어 Bold" panose="020B0600000101010101" pitchFamily="50" charset="-127"/>
-                </a:rPr>
-                <a:t>기능</a:t>
-              </a:r>
-              <a:r>
-                <a:rPr lang="en-US" altLang="ko-KR" sz="2000" dirty="0">
-                  <a:solidFill>
-                    <a:schemeClr val="tx1"/>
-                  </a:solidFill>
-                  <a:latin typeface="나눔스퀘어 Bold" panose="020B0600000101010101" pitchFamily="50" charset="-127"/>
-                  <a:ea typeface="나눔스퀘어 Bold" panose="020B0600000101010101" pitchFamily="50" charset="-127"/>
-                </a:rPr>
-                <a:t>1</a:t>
-              </a:r>
-              <a:endParaRPr lang="ko-KR" altLang="en-US" sz="2000" dirty="0">
-                <a:solidFill>
-                  <a:schemeClr val="tx1"/>
-                </a:solidFill>
-                <a:latin typeface="나눔스퀘어 Bold" panose="020B0600000101010101" pitchFamily="50" charset="-127"/>
-                <a:ea typeface="나눔스퀘어 Bold" panose="020B0600000101010101" pitchFamily="50" charset="-127"/>
-              </a:endParaRPr>
-            </a:p>
-            <a:p>
-              <a:pPr algn="ctr"/>
-              <a:r>
-                <a:rPr lang="ko-KR" altLang="en-US" sz="2000" dirty="0" smtClean="0">
-                  <a:solidFill>
-                    <a:schemeClr val="tx1"/>
-                  </a:solidFill>
-                  <a:latin typeface="나눔스퀘어 Bold" panose="020B0600000101010101" pitchFamily="50" charset="-127"/>
-                  <a:ea typeface="나눔스퀘어 Bold" panose="020B0600000101010101" pitchFamily="50" charset="-127"/>
-                </a:rPr>
-                <a:t>속성</a:t>
-              </a:r>
-              <a:r>
-                <a:rPr lang="en-US" altLang="ko-KR" sz="2000" dirty="0" smtClean="0">
-                  <a:solidFill>
-                    <a:schemeClr val="tx1"/>
-                  </a:solidFill>
-                  <a:latin typeface="나눔스퀘어 Bold" panose="020B0600000101010101" pitchFamily="50" charset="-127"/>
-                  <a:ea typeface="나눔스퀘어 Bold" panose="020B0600000101010101" pitchFamily="50" charset="-127"/>
-                </a:rPr>
-                <a:t>2 </a:t>
-              </a:r>
-              <a:r>
-                <a:rPr lang="en-US" altLang="ko-KR" sz="2000" dirty="0">
-                  <a:solidFill>
-                    <a:schemeClr val="tx1"/>
-                  </a:solidFill>
-                  <a:latin typeface="나눔스퀘어 Bold" panose="020B0600000101010101" pitchFamily="50" charset="-127"/>
-                  <a:ea typeface="나눔스퀘어 Bold" panose="020B0600000101010101" pitchFamily="50" charset="-127"/>
-                </a:rPr>
-                <a:t>&amp; </a:t>
-              </a:r>
-              <a:r>
-                <a:rPr lang="ko-KR" altLang="en-US" sz="2000" dirty="0" smtClean="0">
-                  <a:solidFill>
-                    <a:schemeClr val="tx1"/>
-                  </a:solidFill>
-                  <a:latin typeface="나눔스퀘어 Bold" panose="020B0600000101010101" pitchFamily="50" charset="-127"/>
-                  <a:ea typeface="나눔스퀘어 Bold" panose="020B0600000101010101" pitchFamily="50" charset="-127"/>
-                </a:rPr>
-                <a:t>기능</a:t>
-              </a:r>
-              <a:r>
-                <a:rPr lang="en-US" altLang="ko-KR" sz="2000" dirty="0">
-                  <a:solidFill>
-                    <a:schemeClr val="tx1"/>
-                  </a:solidFill>
-                  <a:latin typeface="나눔스퀘어 Bold" panose="020B0600000101010101" pitchFamily="50" charset="-127"/>
-                  <a:ea typeface="나눔스퀘어 Bold" panose="020B0600000101010101" pitchFamily="50" charset="-127"/>
-                </a:rPr>
-                <a:t>2</a:t>
-              </a:r>
-              <a:endParaRPr lang="ko-KR" altLang="en-US" sz="2000" dirty="0">
-                <a:solidFill>
-                  <a:schemeClr val="tx1"/>
-                </a:solidFill>
-                <a:latin typeface="나눔스퀘어 Bold" panose="020B0600000101010101" pitchFamily="50" charset="-127"/>
-                <a:ea typeface="나눔스퀘어 Bold" panose="020B0600000101010101" pitchFamily="50" charset="-127"/>
-              </a:endParaRPr>
-            </a:p>
-          </p:txBody>
-        </p:sp>
-        <p:sp>
-          <p:nvSpPr>
-            <p:cNvPr id="69" name="모서리가 둥근 직사각형 68"/>
-            <p:cNvSpPr/>
-            <p:nvPr/>
-          </p:nvSpPr>
-          <p:spPr>
-            <a:xfrm>
-              <a:off x="5660577" y="4702629"/>
-              <a:ext cx="2160000" cy="1080000"/>
-            </a:xfrm>
-            <a:prstGeom prst="roundRect">
-              <a:avLst/>
-            </a:prstGeom>
-            <a:noFill/>
-            <a:ln w="28575">
-              <a:solidFill>
-                <a:schemeClr val="tx1"/>
-              </a:solidFill>
-            </a:ln>
-          </p:spPr>
-          <p:style>
-            <a:lnRef idx="2">
-              <a:schemeClr val="accent1">
-                <a:shade val="50000"/>
-              </a:schemeClr>
-            </a:lnRef>
-            <a:fillRef idx="1">
-              <a:schemeClr val="accent1"/>
-            </a:fillRef>
-            <a:effectRef idx="0">
-              <a:schemeClr val="accent1"/>
-            </a:effectRef>
-            <a:fontRef idx="minor">
-              <a:schemeClr val="lt1"/>
-            </a:fontRef>
-          </p:style>
-          <p:txBody>
-            <a:bodyPr rtlCol="0" anchor="ctr"/>
-            <a:lstStyle/>
-            <a:p>
-              <a:pPr algn="ctr"/>
-              <a:r>
-                <a:rPr lang="ko-KR" altLang="en-US" sz="2000" dirty="0">
-                  <a:solidFill>
-                    <a:schemeClr val="tx1"/>
-                  </a:solidFill>
-                  <a:latin typeface="나눔스퀘어 Bold" panose="020B0600000101010101" pitchFamily="50" charset="-127"/>
-                  <a:ea typeface="나눔스퀘어 Bold" panose="020B0600000101010101" pitchFamily="50" charset="-127"/>
-                </a:rPr>
-                <a:t>속성</a:t>
-              </a:r>
-              <a:r>
-                <a:rPr lang="en-US" altLang="ko-KR" sz="2000" dirty="0">
-                  <a:solidFill>
-                    <a:schemeClr val="tx1"/>
-                  </a:solidFill>
-                  <a:latin typeface="나눔스퀘어 Bold" panose="020B0600000101010101" pitchFamily="50" charset="-127"/>
-                  <a:ea typeface="나눔스퀘어 Bold" panose="020B0600000101010101" pitchFamily="50" charset="-127"/>
-                </a:rPr>
-                <a:t>1 &amp; </a:t>
-              </a:r>
-              <a:r>
-                <a:rPr lang="ko-KR" altLang="en-US" sz="2000" dirty="0">
-                  <a:solidFill>
-                    <a:schemeClr val="tx1"/>
-                  </a:solidFill>
-                  <a:latin typeface="나눔스퀘어 Bold" panose="020B0600000101010101" pitchFamily="50" charset="-127"/>
-                  <a:ea typeface="나눔스퀘어 Bold" panose="020B0600000101010101" pitchFamily="50" charset="-127"/>
-                </a:rPr>
-                <a:t>기능</a:t>
-              </a:r>
-              <a:r>
-                <a:rPr lang="en-US" altLang="ko-KR" sz="2000" dirty="0">
-                  <a:solidFill>
-                    <a:schemeClr val="tx1"/>
-                  </a:solidFill>
-                  <a:latin typeface="나눔스퀘어 Bold" panose="020B0600000101010101" pitchFamily="50" charset="-127"/>
-                  <a:ea typeface="나눔스퀘어 Bold" panose="020B0600000101010101" pitchFamily="50" charset="-127"/>
-                </a:rPr>
-                <a:t>1</a:t>
-              </a:r>
-              <a:endParaRPr lang="ko-KR" altLang="en-US" sz="2000" dirty="0">
-                <a:solidFill>
-                  <a:schemeClr val="tx1"/>
-                </a:solidFill>
-                <a:latin typeface="나눔스퀘어 Bold" panose="020B0600000101010101" pitchFamily="50" charset="-127"/>
-                <a:ea typeface="나눔스퀘어 Bold" panose="020B0600000101010101" pitchFamily="50" charset="-127"/>
-              </a:endParaRPr>
-            </a:p>
-            <a:p>
-              <a:pPr algn="ctr"/>
-              <a:r>
-                <a:rPr lang="ko-KR" altLang="en-US" sz="2000" dirty="0">
-                  <a:solidFill>
-                    <a:schemeClr val="tx1"/>
-                  </a:solidFill>
-                  <a:latin typeface="나눔스퀘어 Bold" panose="020B0600000101010101" pitchFamily="50" charset="-127"/>
-                  <a:ea typeface="나눔스퀘어 Bold" panose="020B0600000101010101" pitchFamily="50" charset="-127"/>
-                </a:rPr>
-                <a:t>속성</a:t>
-              </a:r>
-              <a:r>
-                <a:rPr lang="en-US" altLang="ko-KR" sz="2000" dirty="0">
-                  <a:solidFill>
-                    <a:schemeClr val="tx1"/>
-                  </a:solidFill>
-                  <a:latin typeface="나눔스퀘어 Bold" panose="020B0600000101010101" pitchFamily="50" charset="-127"/>
-                  <a:ea typeface="나눔스퀘어 Bold" panose="020B0600000101010101" pitchFamily="50" charset="-127"/>
-                </a:rPr>
-                <a:t>2 &amp; </a:t>
-              </a:r>
-              <a:r>
-                <a:rPr lang="ko-KR" altLang="en-US" sz="2000" dirty="0">
-                  <a:solidFill>
-                    <a:schemeClr val="tx1"/>
-                  </a:solidFill>
-                  <a:latin typeface="나눔스퀘어 Bold" panose="020B0600000101010101" pitchFamily="50" charset="-127"/>
-                  <a:ea typeface="나눔스퀘어 Bold" panose="020B0600000101010101" pitchFamily="50" charset="-127"/>
-                </a:rPr>
-                <a:t>기능</a:t>
-              </a:r>
-              <a:r>
-                <a:rPr lang="en-US" altLang="ko-KR" sz="2000" dirty="0">
-                  <a:solidFill>
-                    <a:schemeClr val="tx1"/>
-                  </a:solidFill>
-                  <a:latin typeface="나눔스퀘어 Bold" panose="020B0600000101010101" pitchFamily="50" charset="-127"/>
-                  <a:ea typeface="나눔스퀘어 Bold" panose="020B0600000101010101" pitchFamily="50" charset="-127"/>
-                </a:rPr>
-                <a:t>2</a:t>
-              </a:r>
-              <a:endParaRPr lang="ko-KR" altLang="en-US" sz="2000" dirty="0">
-                <a:solidFill>
-                  <a:schemeClr val="tx1"/>
-                </a:solidFill>
-                <a:latin typeface="나눔스퀘어 Bold" panose="020B0600000101010101" pitchFamily="50" charset="-127"/>
-                <a:ea typeface="나눔스퀘어 Bold" panose="020B0600000101010101" pitchFamily="50" charset="-127"/>
-              </a:endParaRPr>
-            </a:p>
-            <a:p>
-              <a:pPr algn="ctr"/>
-              <a:r>
-                <a:rPr lang="ko-KR" altLang="en-US" sz="2000" dirty="0" smtClean="0">
-                  <a:solidFill>
-                    <a:schemeClr val="tx1"/>
-                  </a:solidFill>
-                  <a:latin typeface="나눔스퀘어 Bold" panose="020B0600000101010101" pitchFamily="50" charset="-127"/>
-                  <a:ea typeface="나눔스퀘어 Bold" panose="020B0600000101010101" pitchFamily="50" charset="-127"/>
-                </a:rPr>
-                <a:t>속성</a:t>
-              </a:r>
-              <a:r>
-                <a:rPr lang="en-US" altLang="ko-KR" sz="2000" dirty="0" smtClean="0">
-                  <a:solidFill>
-                    <a:schemeClr val="tx1"/>
-                  </a:solidFill>
-                  <a:latin typeface="나눔스퀘어 Bold" panose="020B0600000101010101" pitchFamily="50" charset="-127"/>
-                  <a:ea typeface="나눔스퀘어 Bold" panose="020B0600000101010101" pitchFamily="50" charset="-127"/>
-                </a:rPr>
-                <a:t>3 &amp; </a:t>
-              </a:r>
-              <a:r>
-                <a:rPr lang="ko-KR" altLang="en-US" sz="2000" dirty="0" smtClean="0">
-                  <a:solidFill>
-                    <a:schemeClr val="tx1"/>
-                  </a:solidFill>
-                  <a:latin typeface="나눔스퀘어 Bold" panose="020B0600000101010101" pitchFamily="50" charset="-127"/>
-                  <a:ea typeface="나눔스퀘어 Bold" panose="020B0600000101010101" pitchFamily="50" charset="-127"/>
-                </a:rPr>
-                <a:t>속성</a:t>
-              </a:r>
-              <a:r>
-                <a:rPr lang="en-US" altLang="ko-KR" sz="2000" dirty="0" smtClean="0">
-                  <a:solidFill>
-                    <a:schemeClr val="tx1"/>
-                  </a:solidFill>
-                  <a:latin typeface="나눔스퀘어 Bold" panose="020B0600000101010101" pitchFamily="50" charset="-127"/>
-                  <a:ea typeface="나눔스퀘어 Bold" panose="020B0600000101010101" pitchFamily="50" charset="-127"/>
-                </a:rPr>
-                <a:t>3</a:t>
-              </a:r>
-              <a:endParaRPr lang="ko-KR" altLang="en-US" sz="2000" dirty="0">
+              <a:endParaRPr lang="ko-KR" altLang="en-US" sz="2800" dirty="0">
                 <a:solidFill>
                   <a:schemeClr val="tx1"/>
                 </a:solidFill>
@@ -12357,13 +13274,6 @@
                 </a:rPr>
                 <a:t>객체</a:t>
               </a:r>
-              <a:endParaRPr lang="ko-KR" altLang="en-US" sz="2400" dirty="0">
-                <a:solidFill>
-                  <a:schemeClr val="tx1"/>
-                </a:solidFill>
-                <a:latin typeface="나눔스퀘어 Bold" panose="020B0600000101010101" pitchFamily="50" charset="-127"/>
-                <a:ea typeface="나눔스퀘어 Bold" panose="020B0600000101010101" pitchFamily="50" charset="-127"/>
-              </a:endParaRPr>
             </a:p>
           </p:txBody>
         </p:sp>

</xml_diff>

<commit_message>
20260818 commit : temp, early
</commit_message>
<xml_diff>
--- a/create_notion_img.pptx
+++ b/create_notion_img.pptx
@@ -248,7 +248,7 @@
           <a:p>
             <a:fld id="{7237CE1A-8831-48B5-BA93-72483C6E34E8}" type="datetimeFigureOut">
               <a:rPr lang="ko-KR" altLang="en-US" smtClean="0"/>
-              <a:t>2026-08-14</a:t>
+              <a:t>26-08-15(Sat)</a:t>
             </a:fld>
             <a:endParaRPr lang="ko-KR" altLang="en-US"/>
           </a:p>
@@ -418,7 +418,7 @@
           <a:p>
             <a:fld id="{7237CE1A-8831-48B5-BA93-72483C6E34E8}" type="datetimeFigureOut">
               <a:rPr lang="ko-KR" altLang="en-US" smtClean="0"/>
-              <a:t>2026-08-14</a:t>
+              <a:t>26-08-15(Sat)</a:t>
             </a:fld>
             <a:endParaRPr lang="ko-KR" altLang="en-US"/>
           </a:p>
@@ -598,7 +598,7 @@
           <a:p>
             <a:fld id="{7237CE1A-8831-48B5-BA93-72483C6E34E8}" type="datetimeFigureOut">
               <a:rPr lang="ko-KR" altLang="en-US" smtClean="0"/>
-              <a:t>2026-08-14</a:t>
+              <a:t>26-08-15(Sat)</a:t>
             </a:fld>
             <a:endParaRPr lang="ko-KR" altLang="en-US"/>
           </a:p>
@@ -768,7 +768,7 @@
           <a:p>
             <a:fld id="{7237CE1A-8831-48B5-BA93-72483C6E34E8}" type="datetimeFigureOut">
               <a:rPr lang="ko-KR" altLang="en-US" smtClean="0"/>
-              <a:t>2026-08-14</a:t>
+              <a:t>26-08-15(Sat)</a:t>
             </a:fld>
             <a:endParaRPr lang="ko-KR" altLang="en-US"/>
           </a:p>
@@ -1014,7 +1014,7 @@
           <a:p>
             <a:fld id="{7237CE1A-8831-48B5-BA93-72483C6E34E8}" type="datetimeFigureOut">
               <a:rPr lang="ko-KR" altLang="en-US" smtClean="0"/>
-              <a:t>2026-08-14</a:t>
+              <a:t>26-08-15(Sat)</a:t>
             </a:fld>
             <a:endParaRPr lang="ko-KR" altLang="en-US"/>
           </a:p>
@@ -1246,7 +1246,7 @@
           <a:p>
             <a:fld id="{7237CE1A-8831-48B5-BA93-72483C6E34E8}" type="datetimeFigureOut">
               <a:rPr lang="ko-KR" altLang="en-US" smtClean="0"/>
-              <a:t>2026-08-14</a:t>
+              <a:t>26-08-15(Sat)</a:t>
             </a:fld>
             <a:endParaRPr lang="ko-KR" altLang="en-US"/>
           </a:p>
@@ -1613,7 +1613,7 @@
           <a:p>
             <a:fld id="{7237CE1A-8831-48B5-BA93-72483C6E34E8}" type="datetimeFigureOut">
               <a:rPr lang="ko-KR" altLang="en-US" smtClean="0"/>
-              <a:t>2026-08-14</a:t>
+              <a:t>26-08-15(Sat)</a:t>
             </a:fld>
             <a:endParaRPr lang="ko-KR" altLang="en-US"/>
           </a:p>
@@ -1731,7 +1731,7 @@
           <a:p>
             <a:fld id="{7237CE1A-8831-48B5-BA93-72483C6E34E8}" type="datetimeFigureOut">
               <a:rPr lang="ko-KR" altLang="en-US" smtClean="0"/>
-              <a:t>2026-08-14</a:t>
+              <a:t>26-08-15(Sat)</a:t>
             </a:fld>
             <a:endParaRPr lang="ko-KR" altLang="en-US"/>
           </a:p>
@@ -1826,7 +1826,7 @@
           <a:p>
             <a:fld id="{7237CE1A-8831-48B5-BA93-72483C6E34E8}" type="datetimeFigureOut">
               <a:rPr lang="ko-KR" altLang="en-US" smtClean="0"/>
-              <a:t>2026-08-14</a:t>
+              <a:t>26-08-15(Sat)</a:t>
             </a:fld>
             <a:endParaRPr lang="ko-KR" altLang="en-US"/>
           </a:p>
@@ -2103,7 +2103,7 @@
           <a:p>
             <a:fld id="{7237CE1A-8831-48B5-BA93-72483C6E34E8}" type="datetimeFigureOut">
               <a:rPr lang="ko-KR" altLang="en-US" smtClean="0"/>
-              <a:t>2026-08-14</a:t>
+              <a:t>26-08-15(Sat)</a:t>
             </a:fld>
             <a:endParaRPr lang="ko-KR" altLang="en-US"/>
           </a:p>
@@ -2356,7 +2356,7 @@
           <a:p>
             <a:fld id="{7237CE1A-8831-48B5-BA93-72483C6E34E8}" type="datetimeFigureOut">
               <a:rPr lang="ko-KR" altLang="en-US" smtClean="0"/>
-              <a:t>2026-08-14</a:t>
+              <a:t>26-08-15(Sat)</a:t>
             </a:fld>
             <a:endParaRPr lang="ko-KR" altLang="en-US"/>
           </a:p>
@@ -2569,7 +2569,7 @@
           <a:p>
             <a:fld id="{7237CE1A-8831-48B5-BA93-72483C6E34E8}" type="datetimeFigureOut">
               <a:rPr lang="ko-KR" altLang="en-US" smtClean="0"/>
-              <a:t>2026-08-14</a:t>
+              <a:t>26-08-15(Sat)</a:t>
             </a:fld>
             <a:endParaRPr lang="ko-KR" altLang="en-US"/>
           </a:p>
@@ -3892,1644 +3892,63 @@
           <a:chExt cx="0" cy="0"/>
         </a:xfrm>
       </p:grpSpPr>
-      <p:grpSp>
-        <p:nvGrpSpPr>
-          <p:cNvPr id="114" name="그룹 113"/>
-          <p:cNvGrpSpPr/>
-          <p:nvPr/>
-        </p:nvGrpSpPr>
-        <p:grpSpPr>
-          <a:xfrm>
-            <a:off x="2120900" y="138525"/>
-            <a:ext cx="6691142" cy="5087448"/>
-            <a:chOff x="2120900" y="138525"/>
-            <a:chExt cx="6691142" cy="5087448"/>
-          </a:xfrm>
-        </p:grpSpPr>
-        <p:sp>
-          <p:nvSpPr>
-            <p:cNvPr id="15" name="직사각형 14"/>
-            <p:cNvSpPr/>
-            <p:nvPr/>
-          </p:nvSpPr>
-          <p:spPr>
-            <a:xfrm>
-              <a:off x="2120900" y="1078637"/>
-              <a:ext cx="6691142" cy="1015663"/>
-            </a:xfrm>
-            <a:prstGeom prst="rect">
-              <a:avLst/>
-            </a:prstGeom>
-          </p:spPr>
-          <p:txBody>
-            <a:bodyPr wrap="square">
-              <a:spAutoFit/>
-            </a:bodyPr>
-            <a:lstStyle/>
-            <a:p>
-              <a:r>
-                <a:rPr lang="en-US" altLang="ko-KR" sz="6000" dirty="0" smtClean="0">
-                  <a:latin typeface="나눔스퀘어 Bold" panose="020B0600000101010101" pitchFamily="50" charset="-127"/>
-                  <a:ea typeface="나눔스퀘어 Bold" panose="020B0600000101010101" pitchFamily="50" charset="-127"/>
-                </a:rPr>
-                <a:t>String </a:t>
-              </a:r>
-              <a:r>
-                <a:rPr lang="en-US" altLang="ko-KR" sz="6000" dirty="0" err="1" smtClean="0">
-                  <a:latin typeface="나눔스퀘어 Bold" panose="020B0600000101010101" pitchFamily="50" charset="-127"/>
-                  <a:ea typeface="나눔스퀘어 Bold" panose="020B0600000101010101" pitchFamily="50" charset="-127"/>
-                </a:rPr>
-                <a:t>str</a:t>
-              </a:r>
-              <a:r>
-                <a:rPr lang="en-US" altLang="ko-KR" sz="6000" dirty="0" smtClean="0">
-                  <a:latin typeface="나눔스퀘어 Bold" panose="020B0600000101010101" pitchFamily="50" charset="-127"/>
-                  <a:ea typeface="나눔스퀘어 Bold" panose="020B0600000101010101" pitchFamily="50" charset="-127"/>
-                </a:rPr>
-                <a:t> = “Hello”</a:t>
-              </a:r>
-              <a:endParaRPr lang="en-US" altLang="ko-KR" sz="6000" dirty="0">
-                <a:latin typeface="나눔스퀘어 Bold" panose="020B0600000101010101" pitchFamily="50" charset="-127"/>
-                <a:ea typeface="나눔스퀘어 Bold" panose="020B0600000101010101" pitchFamily="50" charset="-127"/>
-              </a:endParaRPr>
-            </a:p>
-          </p:txBody>
-        </p:sp>
-        <p:sp>
-          <p:nvSpPr>
-            <p:cNvPr id="24" name="TextBox 23"/>
-            <p:cNvSpPr txBox="1"/>
-            <p:nvPr/>
-          </p:nvSpPr>
-          <p:spPr>
-            <a:xfrm>
-              <a:off x="2465069" y="138526"/>
-              <a:ext cx="1688284" cy="400110"/>
-            </a:xfrm>
-            <a:prstGeom prst="rect">
-              <a:avLst/>
-            </a:prstGeom>
-            <a:noFill/>
-          </p:spPr>
-          <p:txBody>
-            <a:bodyPr wrap="none" rtlCol="0">
-              <a:spAutoFit/>
-            </a:bodyPr>
-            <a:lstStyle/>
-            <a:p>
-              <a:pPr algn="ctr"/>
-              <a:r>
-                <a:rPr lang="en-US" altLang="ko-KR" sz="2000" dirty="0" smtClean="0">
-                  <a:latin typeface="나눔스퀘어 Bold" panose="020B0600000101010101" pitchFamily="50" charset="-127"/>
-                  <a:ea typeface="나눔스퀘어 Bold" panose="020B0600000101010101" pitchFamily="50" charset="-127"/>
-                </a:rPr>
-                <a:t>String </a:t>
-              </a:r>
-              <a:r>
-                <a:rPr lang="ko-KR" altLang="en-US" sz="2000" dirty="0" smtClean="0">
-                  <a:latin typeface="나눔스퀘어 Bold" panose="020B0600000101010101" pitchFamily="50" charset="-127"/>
-                  <a:ea typeface="나눔스퀘어 Bold" panose="020B0600000101010101" pitchFamily="50" charset="-127"/>
-                </a:rPr>
-                <a:t>키워드</a:t>
-              </a:r>
-              <a:endParaRPr lang="ko-KR" altLang="en-US" sz="2000" dirty="0">
-                <a:latin typeface="나눔스퀘어 Bold" panose="020B0600000101010101" pitchFamily="50" charset="-127"/>
-                <a:ea typeface="나눔스퀘어 Bold" panose="020B0600000101010101" pitchFamily="50" charset="-127"/>
-              </a:endParaRPr>
-            </a:p>
-          </p:txBody>
-        </p:sp>
-        <p:sp>
-          <p:nvSpPr>
-            <p:cNvPr id="30" name="TextBox 29"/>
-            <p:cNvSpPr txBox="1"/>
-            <p:nvPr/>
-          </p:nvSpPr>
-          <p:spPr>
-            <a:xfrm>
-              <a:off x="4794036" y="138526"/>
-              <a:ext cx="652743" cy="400110"/>
-            </a:xfrm>
-            <a:prstGeom prst="rect">
-              <a:avLst/>
-            </a:prstGeom>
-            <a:noFill/>
-          </p:spPr>
-          <p:txBody>
-            <a:bodyPr wrap="none" rtlCol="0">
-              <a:spAutoFit/>
-            </a:bodyPr>
-            <a:lstStyle/>
-            <a:p>
-              <a:pPr algn="ctr"/>
-              <a:r>
-                <a:rPr lang="ko-KR" altLang="en-US" sz="2000" smtClean="0">
-                  <a:latin typeface="나눔스퀘어 Bold" panose="020B0600000101010101" pitchFamily="50" charset="-127"/>
-                  <a:ea typeface="나눔스퀘어 Bold" panose="020B0600000101010101" pitchFamily="50" charset="-127"/>
-                </a:rPr>
-                <a:t>변수</a:t>
-              </a:r>
-              <a:endParaRPr lang="ko-KR" altLang="en-US" sz="2000" dirty="0">
-                <a:latin typeface="나눔스퀘어 Bold" panose="020B0600000101010101" pitchFamily="50" charset="-127"/>
-                <a:ea typeface="나눔스퀘어 Bold" panose="020B0600000101010101" pitchFamily="50" charset="-127"/>
-              </a:endParaRPr>
-            </a:p>
-          </p:txBody>
-        </p:sp>
-        <p:sp>
-          <p:nvSpPr>
-            <p:cNvPr id="31" name="아래쪽 화살표 30"/>
-            <p:cNvSpPr/>
-            <p:nvPr/>
-          </p:nvSpPr>
-          <p:spPr>
-            <a:xfrm rot="10800000" flipH="1" flipV="1">
-              <a:off x="3129211" y="538637"/>
-              <a:ext cx="360000" cy="540000"/>
-            </a:xfrm>
-            <a:prstGeom prst="downArrow">
-              <a:avLst/>
-            </a:prstGeom>
-            <a:solidFill>
-              <a:schemeClr val="accent2"/>
-            </a:solidFill>
-            <a:ln>
-              <a:noFill/>
-            </a:ln>
-          </p:spPr>
-          <p:style>
-            <a:lnRef idx="2">
-              <a:schemeClr val="accent1">
-                <a:shade val="50000"/>
-              </a:schemeClr>
-            </a:lnRef>
-            <a:fillRef idx="1">
-              <a:schemeClr val="accent1"/>
-            </a:fillRef>
-            <a:effectRef idx="0">
-              <a:schemeClr val="accent1"/>
-            </a:effectRef>
-            <a:fontRef idx="minor">
-              <a:schemeClr val="lt1"/>
-            </a:fontRef>
-          </p:style>
-          <p:txBody>
-            <a:bodyPr rtlCol="0" anchor="ctr"/>
-            <a:lstStyle/>
-            <a:p>
-              <a:pPr algn="ctr"/>
-              <a:endParaRPr lang="ko-KR" altLang="en-US">
-                <a:latin typeface="나눔스퀘어 Bold" panose="020B0600000101010101" pitchFamily="50" charset="-127"/>
-                <a:ea typeface="나눔스퀘어 Bold" panose="020B0600000101010101" pitchFamily="50" charset="-127"/>
-              </a:endParaRPr>
-            </a:p>
-          </p:txBody>
-        </p:sp>
-        <p:sp>
-          <p:nvSpPr>
-            <p:cNvPr id="32" name="TextBox 31"/>
-            <p:cNvSpPr txBox="1"/>
-            <p:nvPr/>
-          </p:nvSpPr>
-          <p:spPr>
-            <a:xfrm>
-              <a:off x="6561569" y="138525"/>
-              <a:ext cx="2185215" cy="400110"/>
-            </a:xfrm>
-            <a:prstGeom prst="rect">
-              <a:avLst/>
-            </a:prstGeom>
-            <a:noFill/>
-          </p:spPr>
-          <p:txBody>
-            <a:bodyPr wrap="none" rtlCol="0">
-              <a:spAutoFit/>
-            </a:bodyPr>
-            <a:lstStyle/>
-            <a:p>
-              <a:pPr algn="ctr"/>
-              <a:r>
-                <a:rPr lang="ko-KR" altLang="en-US" sz="2000" dirty="0" smtClean="0">
-                  <a:latin typeface="나눔스퀘어 Bold" panose="020B0600000101010101" pitchFamily="50" charset="-127"/>
-                  <a:ea typeface="나눔스퀘어 Bold" panose="020B0600000101010101" pitchFamily="50" charset="-127"/>
-                </a:rPr>
-                <a:t>담은 문자열 데이터</a:t>
-              </a:r>
-              <a:endParaRPr lang="ko-KR" altLang="en-US" sz="2000" dirty="0">
-                <a:latin typeface="나눔스퀘어 Bold" panose="020B0600000101010101" pitchFamily="50" charset="-127"/>
-                <a:ea typeface="나눔스퀘어 Bold" panose="020B0600000101010101" pitchFamily="50" charset="-127"/>
-              </a:endParaRPr>
-            </a:p>
-          </p:txBody>
-        </p:sp>
-        <p:sp>
-          <p:nvSpPr>
-            <p:cNvPr id="33" name="아래쪽 화살표 32"/>
-            <p:cNvSpPr/>
-            <p:nvPr/>
-          </p:nvSpPr>
-          <p:spPr>
-            <a:xfrm rot="10800000" flipH="1" flipV="1">
-              <a:off x="7474177" y="538636"/>
-              <a:ext cx="360000" cy="540000"/>
-            </a:xfrm>
-            <a:prstGeom prst="downArrow">
-              <a:avLst/>
-            </a:prstGeom>
-            <a:solidFill>
-              <a:schemeClr val="accent2"/>
-            </a:solidFill>
-            <a:ln>
-              <a:noFill/>
-            </a:ln>
-          </p:spPr>
-          <p:style>
-            <a:lnRef idx="2">
-              <a:schemeClr val="accent1">
-                <a:shade val="50000"/>
-              </a:schemeClr>
-            </a:lnRef>
-            <a:fillRef idx="1">
-              <a:schemeClr val="accent1"/>
-            </a:fillRef>
-            <a:effectRef idx="0">
-              <a:schemeClr val="accent1"/>
-            </a:effectRef>
-            <a:fontRef idx="minor">
-              <a:schemeClr val="lt1"/>
-            </a:fontRef>
-          </p:style>
-          <p:txBody>
-            <a:bodyPr rtlCol="0" anchor="ctr"/>
-            <a:lstStyle/>
-            <a:p>
-              <a:pPr algn="ctr"/>
-              <a:endParaRPr lang="ko-KR" altLang="en-US">
-                <a:latin typeface="나눔스퀘어 Bold" panose="020B0600000101010101" pitchFamily="50" charset="-127"/>
-                <a:ea typeface="나눔스퀘어 Bold" panose="020B0600000101010101" pitchFamily="50" charset="-127"/>
-              </a:endParaRPr>
-            </a:p>
-          </p:txBody>
-        </p:sp>
-        <p:sp>
-          <p:nvSpPr>
-            <p:cNvPr id="43" name="아래쪽 화살표 42"/>
-            <p:cNvSpPr/>
-            <p:nvPr/>
-          </p:nvSpPr>
-          <p:spPr>
-            <a:xfrm rot="10800000" flipH="1" flipV="1">
-              <a:off x="4940408" y="538637"/>
-              <a:ext cx="360000" cy="540000"/>
-            </a:xfrm>
-            <a:prstGeom prst="downArrow">
-              <a:avLst/>
-            </a:prstGeom>
-            <a:solidFill>
-              <a:schemeClr val="accent2"/>
-            </a:solidFill>
-            <a:ln>
-              <a:noFill/>
-            </a:ln>
-          </p:spPr>
-          <p:style>
-            <a:lnRef idx="2">
-              <a:schemeClr val="accent1">
-                <a:shade val="50000"/>
-              </a:schemeClr>
-            </a:lnRef>
-            <a:fillRef idx="1">
-              <a:schemeClr val="accent1"/>
-            </a:fillRef>
-            <a:effectRef idx="0">
-              <a:schemeClr val="accent1"/>
-            </a:effectRef>
-            <a:fontRef idx="minor">
-              <a:schemeClr val="lt1"/>
-            </a:fontRef>
-          </p:style>
-          <p:txBody>
-            <a:bodyPr rtlCol="0" anchor="ctr"/>
-            <a:lstStyle/>
-            <a:p>
-              <a:pPr algn="ctr"/>
-              <a:endParaRPr lang="ko-KR" altLang="en-US">
-                <a:latin typeface="나눔스퀘어 Bold" panose="020B0600000101010101" pitchFamily="50" charset="-127"/>
-                <a:ea typeface="나눔스퀘어 Bold" panose="020B0600000101010101" pitchFamily="50" charset="-127"/>
-              </a:endParaRPr>
-            </a:p>
-          </p:txBody>
-        </p:sp>
-        <p:grpSp>
-          <p:nvGrpSpPr>
-            <p:cNvPr id="34" name="그룹 33"/>
-            <p:cNvGrpSpPr/>
-            <p:nvPr/>
-          </p:nvGrpSpPr>
-          <p:grpSpPr>
-            <a:xfrm>
-              <a:off x="2442472" y="2634300"/>
-              <a:ext cx="6047998" cy="2591673"/>
-              <a:chOff x="5498280" y="2634304"/>
-              <a:chExt cx="6047998" cy="2591673"/>
-            </a:xfrm>
-          </p:grpSpPr>
-          <p:sp>
-            <p:nvSpPr>
-              <p:cNvPr id="44" name="직사각형 43"/>
-              <p:cNvSpPr>
-                <a:spLocks noChangeAspect="1"/>
-              </p:cNvSpPr>
-              <p:nvPr/>
-            </p:nvSpPr>
-            <p:spPr>
-              <a:xfrm>
-                <a:off x="7226280" y="2634308"/>
-                <a:ext cx="864000" cy="863891"/>
-              </a:xfrm>
-              <a:prstGeom prst="rect">
-                <a:avLst/>
-              </a:prstGeom>
-              <a:noFill/>
-              <a:ln w="19050">
-                <a:solidFill>
-                  <a:schemeClr val="tx1"/>
-                </a:solidFill>
-              </a:ln>
-            </p:spPr>
-            <p:style>
-              <a:lnRef idx="2">
-                <a:schemeClr val="accent1">
-                  <a:shade val="50000"/>
-                </a:schemeClr>
-              </a:lnRef>
-              <a:fillRef idx="1">
-                <a:schemeClr val="accent1"/>
-              </a:fillRef>
-              <a:effectRef idx="0">
-                <a:schemeClr val="accent1"/>
-              </a:effectRef>
-              <a:fontRef idx="minor">
-                <a:schemeClr val="lt1"/>
-              </a:fontRef>
-            </p:style>
-            <p:txBody>
-              <a:bodyPr rtlCol="0" anchor="ctr"/>
-              <a:lstStyle/>
-              <a:p>
-                <a:pPr algn="ctr"/>
-                <a:endParaRPr lang="ko-KR" altLang="en-US" sz="2400">
-                  <a:solidFill>
-                    <a:schemeClr val="tx1"/>
-                  </a:solidFill>
-                  <a:latin typeface="나눔스퀘어 Bold" panose="020B0600000101010101" pitchFamily="50" charset="-127"/>
-                  <a:ea typeface="나눔스퀘어 Bold" panose="020B0600000101010101" pitchFamily="50" charset="-127"/>
-                </a:endParaRPr>
-              </a:p>
-            </p:txBody>
-          </p:sp>
-          <p:sp>
-            <p:nvSpPr>
-              <p:cNvPr id="46" name="직사각형 45"/>
-              <p:cNvSpPr>
-                <a:spLocks noChangeAspect="1"/>
-              </p:cNvSpPr>
-              <p:nvPr/>
-            </p:nvSpPr>
-            <p:spPr>
-              <a:xfrm>
-                <a:off x="8090280" y="2634308"/>
-                <a:ext cx="864000" cy="863891"/>
-              </a:xfrm>
-              <a:prstGeom prst="rect">
-                <a:avLst/>
-              </a:prstGeom>
-              <a:noFill/>
-              <a:ln w="19050">
-                <a:solidFill>
-                  <a:schemeClr val="tx1"/>
-                </a:solidFill>
-              </a:ln>
-            </p:spPr>
-            <p:style>
-              <a:lnRef idx="2">
-                <a:schemeClr val="accent1">
-                  <a:shade val="50000"/>
-                </a:schemeClr>
-              </a:lnRef>
-              <a:fillRef idx="1">
-                <a:schemeClr val="accent1"/>
-              </a:fillRef>
-              <a:effectRef idx="0">
-                <a:schemeClr val="accent1"/>
-              </a:effectRef>
-              <a:fontRef idx="minor">
-                <a:schemeClr val="lt1"/>
-              </a:fontRef>
-            </p:style>
-            <p:txBody>
-              <a:bodyPr rtlCol="0" anchor="ctr"/>
-              <a:lstStyle/>
-              <a:p>
-                <a:pPr algn="ctr"/>
-                <a:endParaRPr lang="ko-KR" altLang="en-US" sz="2400">
-                  <a:solidFill>
-                    <a:schemeClr val="tx1"/>
-                  </a:solidFill>
-                  <a:latin typeface="나눔스퀘어 Bold" panose="020B0600000101010101" pitchFamily="50" charset="-127"/>
-                  <a:ea typeface="나눔스퀘어 Bold" panose="020B0600000101010101" pitchFamily="50" charset="-127"/>
-                </a:endParaRPr>
-              </a:p>
-            </p:txBody>
-          </p:sp>
-          <p:sp>
-            <p:nvSpPr>
-              <p:cNvPr id="48" name="직사각형 47"/>
-              <p:cNvSpPr>
-                <a:spLocks noChangeAspect="1"/>
-              </p:cNvSpPr>
-              <p:nvPr/>
-            </p:nvSpPr>
-            <p:spPr>
-              <a:xfrm>
-                <a:off x="8954279" y="2634308"/>
-                <a:ext cx="864000" cy="863891"/>
-              </a:xfrm>
-              <a:prstGeom prst="rect">
-                <a:avLst/>
-              </a:prstGeom>
-              <a:noFill/>
-              <a:ln w="19050">
-                <a:solidFill>
-                  <a:schemeClr val="tx1"/>
-                </a:solidFill>
-              </a:ln>
-            </p:spPr>
-            <p:style>
-              <a:lnRef idx="2">
-                <a:schemeClr val="accent1">
-                  <a:shade val="50000"/>
-                </a:schemeClr>
-              </a:lnRef>
-              <a:fillRef idx="1">
-                <a:schemeClr val="accent1"/>
-              </a:fillRef>
-              <a:effectRef idx="0">
-                <a:schemeClr val="accent1"/>
-              </a:effectRef>
-              <a:fontRef idx="minor">
-                <a:schemeClr val="lt1"/>
-              </a:fontRef>
-            </p:style>
-            <p:txBody>
-              <a:bodyPr rtlCol="0" anchor="ctr"/>
-              <a:lstStyle/>
-              <a:p>
-                <a:pPr algn="ctr"/>
-                <a:endParaRPr lang="ko-KR" altLang="en-US" sz="2400">
-                  <a:solidFill>
-                    <a:schemeClr val="tx1"/>
-                  </a:solidFill>
-                  <a:latin typeface="나눔스퀘어 Bold" panose="020B0600000101010101" pitchFamily="50" charset="-127"/>
-                  <a:ea typeface="나눔스퀘어 Bold" panose="020B0600000101010101" pitchFamily="50" charset="-127"/>
-                </a:endParaRPr>
-              </a:p>
-            </p:txBody>
-          </p:sp>
-          <p:sp>
-            <p:nvSpPr>
-              <p:cNvPr id="50" name="직사각형 49"/>
-              <p:cNvSpPr>
-                <a:spLocks noChangeAspect="1"/>
-              </p:cNvSpPr>
-              <p:nvPr/>
-            </p:nvSpPr>
-            <p:spPr>
-              <a:xfrm>
-                <a:off x="9818279" y="2634308"/>
-                <a:ext cx="864000" cy="863891"/>
-              </a:xfrm>
-              <a:prstGeom prst="rect">
-                <a:avLst/>
-              </a:prstGeom>
-              <a:noFill/>
-              <a:ln w="19050">
-                <a:solidFill>
-                  <a:schemeClr val="tx1"/>
-                </a:solidFill>
-              </a:ln>
-            </p:spPr>
-            <p:style>
-              <a:lnRef idx="2">
-                <a:schemeClr val="accent1">
-                  <a:shade val="50000"/>
-                </a:schemeClr>
-              </a:lnRef>
-              <a:fillRef idx="1">
-                <a:schemeClr val="accent1"/>
-              </a:fillRef>
-              <a:effectRef idx="0">
-                <a:schemeClr val="accent1"/>
-              </a:effectRef>
-              <a:fontRef idx="minor">
-                <a:schemeClr val="lt1"/>
-              </a:fontRef>
-            </p:style>
-            <p:txBody>
-              <a:bodyPr rtlCol="0" anchor="ctr"/>
-              <a:lstStyle/>
-              <a:p>
-                <a:pPr algn="ctr"/>
-                <a:endParaRPr lang="ko-KR" altLang="en-US" sz="2400">
-                  <a:solidFill>
-                    <a:schemeClr val="tx1"/>
-                  </a:solidFill>
-                  <a:latin typeface="나눔스퀘어 Bold" panose="020B0600000101010101" pitchFamily="50" charset="-127"/>
-                  <a:ea typeface="나눔스퀘어 Bold" panose="020B0600000101010101" pitchFamily="50" charset="-127"/>
-                </a:endParaRPr>
-              </a:p>
-            </p:txBody>
-          </p:sp>
-          <p:sp>
-            <p:nvSpPr>
-              <p:cNvPr id="52" name="직사각형 51"/>
-              <p:cNvSpPr>
-                <a:spLocks noChangeAspect="1"/>
-              </p:cNvSpPr>
-              <p:nvPr/>
-            </p:nvSpPr>
-            <p:spPr>
-              <a:xfrm>
-                <a:off x="10682278" y="2634308"/>
-                <a:ext cx="864000" cy="863891"/>
-              </a:xfrm>
-              <a:prstGeom prst="rect">
-                <a:avLst/>
-              </a:prstGeom>
-              <a:noFill/>
-              <a:ln w="19050">
-                <a:solidFill>
-                  <a:schemeClr val="tx1"/>
-                </a:solidFill>
-              </a:ln>
-            </p:spPr>
-            <p:style>
-              <a:lnRef idx="2">
-                <a:schemeClr val="accent1">
-                  <a:shade val="50000"/>
-                </a:schemeClr>
-              </a:lnRef>
-              <a:fillRef idx="1">
-                <a:schemeClr val="accent1"/>
-              </a:fillRef>
-              <a:effectRef idx="0">
-                <a:schemeClr val="accent1"/>
-              </a:effectRef>
-              <a:fontRef idx="minor">
-                <a:schemeClr val="lt1"/>
-              </a:fontRef>
-            </p:style>
-            <p:txBody>
-              <a:bodyPr rtlCol="0" anchor="ctr"/>
-              <a:lstStyle/>
-              <a:p>
-                <a:pPr algn="ctr"/>
-                <a:endParaRPr lang="ko-KR" altLang="en-US" sz="2400">
-                  <a:solidFill>
-                    <a:schemeClr val="tx1"/>
-                  </a:solidFill>
-                  <a:latin typeface="나눔스퀘어 Bold" panose="020B0600000101010101" pitchFamily="50" charset="-127"/>
-                  <a:ea typeface="나눔스퀘어 Bold" panose="020B0600000101010101" pitchFamily="50" charset="-127"/>
-                </a:endParaRPr>
-              </a:p>
-            </p:txBody>
-          </p:sp>
-          <p:sp>
-            <p:nvSpPr>
-              <p:cNvPr id="54" name="직사각형 53"/>
-              <p:cNvSpPr>
-                <a:spLocks noChangeAspect="1"/>
-              </p:cNvSpPr>
-              <p:nvPr/>
-            </p:nvSpPr>
-            <p:spPr>
-              <a:xfrm>
-                <a:off x="7226280" y="3498199"/>
-                <a:ext cx="864000" cy="863891"/>
-              </a:xfrm>
-              <a:prstGeom prst="rect">
-                <a:avLst/>
-              </a:prstGeom>
-              <a:noFill/>
-              <a:ln w="19050">
-                <a:solidFill>
-                  <a:schemeClr val="tx1"/>
-                </a:solidFill>
-              </a:ln>
-            </p:spPr>
-            <p:style>
-              <a:lnRef idx="2">
-                <a:schemeClr val="accent1">
-                  <a:shade val="50000"/>
-                </a:schemeClr>
-              </a:lnRef>
-              <a:fillRef idx="1">
-                <a:schemeClr val="accent1"/>
-              </a:fillRef>
-              <a:effectRef idx="0">
-                <a:schemeClr val="accent1"/>
-              </a:effectRef>
-              <a:fontRef idx="minor">
-                <a:schemeClr val="lt1"/>
-              </a:fontRef>
-            </p:style>
-            <p:txBody>
-              <a:bodyPr rtlCol="0" anchor="ctr"/>
-              <a:lstStyle/>
-              <a:p>
-                <a:pPr algn="ctr"/>
-                <a:r>
-                  <a:rPr lang="en-US" altLang="ko-KR" sz="2400" dirty="0" err="1">
-                    <a:solidFill>
-                      <a:schemeClr val="tx1"/>
-                    </a:solidFill>
-                    <a:latin typeface="나눔스퀘어 Bold" panose="020B0600000101010101" pitchFamily="50" charset="-127"/>
-                    <a:ea typeface="나눔스퀘어 Bold" panose="020B0600000101010101" pitchFamily="50" charset="-127"/>
-                  </a:rPr>
-                  <a:t>e</a:t>
-                </a:r>
-                <a:endParaRPr lang="ko-KR" altLang="en-US" sz="2400" dirty="0">
-                  <a:solidFill>
-                    <a:schemeClr val="tx1"/>
-                  </a:solidFill>
-                  <a:latin typeface="나눔스퀘어 Bold" panose="020B0600000101010101" pitchFamily="50" charset="-127"/>
-                  <a:ea typeface="나눔스퀘어 Bold" panose="020B0600000101010101" pitchFamily="50" charset="-127"/>
-                </a:endParaRPr>
-              </a:p>
-            </p:txBody>
-          </p:sp>
-          <p:sp>
-            <p:nvSpPr>
-              <p:cNvPr id="56" name="직사각형 55"/>
-              <p:cNvSpPr>
-                <a:spLocks noChangeAspect="1"/>
-              </p:cNvSpPr>
-              <p:nvPr/>
-            </p:nvSpPr>
-            <p:spPr>
-              <a:xfrm>
-                <a:off x="8090280" y="3498199"/>
-                <a:ext cx="864000" cy="863891"/>
-              </a:xfrm>
-              <a:prstGeom prst="rect">
-                <a:avLst/>
-              </a:prstGeom>
-              <a:noFill/>
-              <a:ln w="19050">
-                <a:solidFill>
-                  <a:schemeClr val="tx1"/>
-                </a:solidFill>
-              </a:ln>
-            </p:spPr>
-            <p:style>
-              <a:lnRef idx="2">
-                <a:schemeClr val="accent1">
-                  <a:shade val="50000"/>
-                </a:schemeClr>
-              </a:lnRef>
-              <a:fillRef idx="1">
-                <a:schemeClr val="accent1"/>
-              </a:fillRef>
-              <a:effectRef idx="0">
-                <a:schemeClr val="accent1"/>
-              </a:effectRef>
-              <a:fontRef idx="minor">
-                <a:schemeClr val="lt1"/>
-              </a:fontRef>
-            </p:style>
-            <p:txBody>
-              <a:bodyPr rtlCol="0" anchor="ctr"/>
-              <a:lstStyle/>
-              <a:p>
-                <a:pPr algn="ctr"/>
-                <a:r>
-                  <a:rPr lang="en-US" altLang="ko-KR" sz="2400" dirty="0" err="1">
-                    <a:solidFill>
-                      <a:schemeClr val="tx1"/>
-                    </a:solidFill>
-                    <a:latin typeface="나눔스퀘어 Bold" panose="020B0600000101010101" pitchFamily="50" charset="-127"/>
-                    <a:ea typeface="나눔스퀘어 Bold" panose="020B0600000101010101" pitchFamily="50" charset="-127"/>
-                  </a:rPr>
-                  <a:t>l</a:t>
-                </a:r>
-                <a:endParaRPr lang="ko-KR" altLang="en-US" sz="2400" dirty="0">
-                  <a:solidFill>
-                    <a:schemeClr val="tx1"/>
-                  </a:solidFill>
-                  <a:latin typeface="나눔스퀘어 Bold" panose="020B0600000101010101" pitchFamily="50" charset="-127"/>
-                  <a:ea typeface="나눔스퀘어 Bold" panose="020B0600000101010101" pitchFamily="50" charset="-127"/>
-                </a:endParaRPr>
-              </a:p>
-            </p:txBody>
-          </p:sp>
-          <p:sp>
-            <p:nvSpPr>
-              <p:cNvPr id="60" name="직사각형 59"/>
-              <p:cNvSpPr>
-                <a:spLocks noChangeAspect="1"/>
-              </p:cNvSpPr>
-              <p:nvPr/>
-            </p:nvSpPr>
-            <p:spPr>
-              <a:xfrm>
-                <a:off x="8954279" y="3498199"/>
-                <a:ext cx="864000" cy="863891"/>
-              </a:xfrm>
-              <a:prstGeom prst="rect">
-                <a:avLst/>
-              </a:prstGeom>
-              <a:noFill/>
-              <a:ln w="19050">
-                <a:solidFill>
-                  <a:schemeClr val="tx1"/>
-                </a:solidFill>
-              </a:ln>
-            </p:spPr>
-            <p:style>
-              <a:lnRef idx="2">
-                <a:schemeClr val="accent1">
-                  <a:shade val="50000"/>
-                </a:schemeClr>
-              </a:lnRef>
-              <a:fillRef idx="1">
-                <a:schemeClr val="accent1"/>
-              </a:fillRef>
-              <a:effectRef idx="0">
-                <a:schemeClr val="accent1"/>
-              </a:effectRef>
-              <a:fontRef idx="minor">
-                <a:schemeClr val="lt1"/>
-              </a:fontRef>
-            </p:style>
-            <p:txBody>
-              <a:bodyPr rtlCol="0" anchor="ctr"/>
-              <a:lstStyle/>
-              <a:p>
-                <a:pPr algn="ctr"/>
-                <a:r>
-                  <a:rPr lang="en-US" altLang="ko-KR" sz="2400" dirty="0" err="1">
-                    <a:solidFill>
-                      <a:schemeClr val="tx1"/>
-                    </a:solidFill>
-                    <a:latin typeface="나눔스퀘어 Bold" panose="020B0600000101010101" pitchFamily="50" charset="-127"/>
-                    <a:ea typeface="나눔스퀘어 Bold" panose="020B0600000101010101" pitchFamily="50" charset="-127"/>
-                  </a:rPr>
-                  <a:t>l</a:t>
-                </a:r>
-                <a:endParaRPr lang="ko-KR" altLang="en-US" sz="2400" dirty="0">
-                  <a:solidFill>
-                    <a:schemeClr val="tx1"/>
-                  </a:solidFill>
-                  <a:latin typeface="나눔스퀘어 Bold" panose="020B0600000101010101" pitchFamily="50" charset="-127"/>
-                  <a:ea typeface="나눔스퀘어 Bold" panose="020B0600000101010101" pitchFamily="50" charset="-127"/>
-                </a:endParaRPr>
-              </a:p>
-            </p:txBody>
-          </p:sp>
-          <p:sp>
-            <p:nvSpPr>
-              <p:cNvPr id="63" name="직사각형 62"/>
-              <p:cNvSpPr>
-                <a:spLocks noChangeAspect="1"/>
-              </p:cNvSpPr>
-              <p:nvPr/>
-            </p:nvSpPr>
-            <p:spPr>
-              <a:xfrm>
-                <a:off x="9818279" y="3498199"/>
-                <a:ext cx="864000" cy="863891"/>
-              </a:xfrm>
-              <a:prstGeom prst="rect">
-                <a:avLst/>
-              </a:prstGeom>
-              <a:noFill/>
-              <a:ln w="19050">
-                <a:solidFill>
-                  <a:schemeClr val="tx1"/>
-                </a:solidFill>
-              </a:ln>
-            </p:spPr>
-            <p:style>
-              <a:lnRef idx="2">
-                <a:schemeClr val="accent1">
-                  <a:shade val="50000"/>
-                </a:schemeClr>
-              </a:lnRef>
-              <a:fillRef idx="1">
-                <a:schemeClr val="accent1"/>
-              </a:fillRef>
-              <a:effectRef idx="0">
-                <a:schemeClr val="accent1"/>
-              </a:effectRef>
-              <a:fontRef idx="minor">
-                <a:schemeClr val="lt1"/>
-              </a:fontRef>
-            </p:style>
-            <p:txBody>
-              <a:bodyPr rtlCol="0" anchor="ctr"/>
-              <a:lstStyle/>
-              <a:p>
-                <a:pPr algn="ctr"/>
-                <a:r>
-                  <a:rPr lang="en-US" altLang="ko-KR" sz="2400" dirty="0" err="1">
-                    <a:solidFill>
-                      <a:schemeClr val="tx1"/>
-                    </a:solidFill>
-                    <a:latin typeface="나눔스퀘어 Bold" panose="020B0600000101010101" pitchFamily="50" charset="-127"/>
-                    <a:ea typeface="나눔스퀘어 Bold" panose="020B0600000101010101" pitchFamily="50" charset="-127"/>
-                  </a:rPr>
-                  <a:t>o</a:t>
-                </a:r>
-                <a:endParaRPr lang="ko-KR" altLang="en-US" sz="2400" dirty="0">
-                  <a:solidFill>
-                    <a:schemeClr val="tx1"/>
-                  </a:solidFill>
-                  <a:latin typeface="나눔스퀘어 Bold" panose="020B0600000101010101" pitchFamily="50" charset="-127"/>
-                  <a:ea typeface="나눔스퀘어 Bold" panose="020B0600000101010101" pitchFamily="50" charset="-127"/>
-                </a:endParaRPr>
-              </a:p>
-            </p:txBody>
-          </p:sp>
-          <p:sp>
-            <p:nvSpPr>
-              <p:cNvPr id="65" name="직사각형 64"/>
-              <p:cNvSpPr>
-                <a:spLocks noChangeAspect="1"/>
-              </p:cNvSpPr>
-              <p:nvPr/>
-            </p:nvSpPr>
-            <p:spPr>
-              <a:xfrm>
-                <a:off x="10682278" y="3498199"/>
-                <a:ext cx="864000" cy="863891"/>
-              </a:xfrm>
-              <a:prstGeom prst="rect">
-                <a:avLst/>
-              </a:prstGeom>
-              <a:noFill/>
-              <a:ln w="19050">
-                <a:solidFill>
-                  <a:schemeClr val="tx1"/>
-                </a:solidFill>
-              </a:ln>
-            </p:spPr>
-            <p:style>
-              <a:lnRef idx="2">
-                <a:schemeClr val="accent1">
-                  <a:shade val="50000"/>
-                </a:schemeClr>
-              </a:lnRef>
-              <a:fillRef idx="1">
-                <a:schemeClr val="accent1"/>
-              </a:fillRef>
-              <a:effectRef idx="0">
-                <a:schemeClr val="accent1"/>
-              </a:effectRef>
-              <a:fontRef idx="minor">
-                <a:schemeClr val="lt1"/>
-              </a:fontRef>
-            </p:style>
-            <p:txBody>
-              <a:bodyPr rtlCol="0" anchor="ctr"/>
-              <a:lstStyle/>
-              <a:p>
-                <a:pPr algn="ctr"/>
-                <a:endParaRPr lang="ko-KR" altLang="en-US" sz="2400">
-                  <a:solidFill>
-                    <a:schemeClr val="tx1"/>
-                  </a:solidFill>
-                  <a:latin typeface="나눔스퀘어 Bold" panose="020B0600000101010101" pitchFamily="50" charset="-127"/>
-                  <a:ea typeface="나눔스퀘어 Bold" panose="020B0600000101010101" pitchFamily="50" charset="-127"/>
-                </a:endParaRPr>
-              </a:p>
-            </p:txBody>
-          </p:sp>
-          <p:sp>
-            <p:nvSpPr>
-              <p:cNvPr id="67" name="직사각형 66"/>
-              <p:cNvSpPr>
-                <a:spLocks noChangeAspect="1"/>
-              </p:cNvSpPr>
-              <p:nvPr/>
-            </p:nvSpPr>
-            <p:spPr>
-              <a:xfrm>
-                <a:off x="7226280" y="4362086"/>
-                <a:ext cx="864000" cy="863891"/>
-              </a:xfrm>
-              <a:prstGeom prst="rect">
-                <a:avLst/>
-              </a:prstGeom>
-              <a:noFill/>
-              <a:ln w="19050">
-                <a:solidFill>
-                  <a:schemeClr val="tx1"/>
-                </a:solidFill>
-              </a:ln>
-            </p:spPr>
-            <p:style>
-              <a:lnRef idx="2">
-                <a:schemeClr val="accent1">
-                  <a:shade val="50000"/>
-                </a:schemeClr>
-              </a:lnRef>
-              <a:fillRef idx="1">
-                <a:schemeClr val="accent1"/>
-              </a:fillRef>
-              <a:effectRef idx="0">
-                <a:schemeClr val="accent1"/>
-              </a:effectRef>
-              <a:fontRef idx="minor">
-                <a:schemeClr val="lt1"/>
-              </a:fontRef>
-            </p:style>
-            <p:txBody>
-              <a:bodyPr rtlCol="0" anchor="ctr"/>
-              <a:lstStyle/>
-              <a:p>
-                <a:pPr algn="ctr"/>
-                <a:endParaRPr lang="ko-KR" altLang="en-US" sz="2400">
-                  <a:solidFill>
-                    <a:schemeClr val="tx1"/>
-                  </a:solidFill>
-                  <a:latin typeface="나눔스퀘어 Bold" panose="020B0600000101010101" pitchFamily="50" charset="-127"/>
-                  <a:ea typeface="나눔스퀘어 Bold" panose="020B0600000101010101" pitchFamily="50" charset="-127"/>
-                </a:endParaRPr>
-              </a:p>
-            </p:txBody>
-          </p:sp>
-          <p:sp>
-            <p:nvSpPr>
-              <p:cNvPr id="71" name="직사각형 70"/>
-              <p:cNvSpPr>
-                <a:spLocks noChangeAspect="1"/>
-              </p:cNvSpPr>
-              <p:nvPr/>
-            </p:nvSpPr>
-            <p:spPr>
-              <a:xfrm>
-                <a:off x="8090280" y="4362086"/>
-                <a:ext cx="864000" cy="863891"/>
-              </a:xfrm>
-              <a:prstGeom prst="rect">
-                <a:avLst/>
-              </a:prstGeom>
-              <a:noFill/>
-              <a:ln w="19050">
-                <a:solidFill>
-                  <a:schemeClr val="tx1"/>
-                </a:solidFill>
-              </a:ln>
-            </p:spPr>
-            <p:style>
-              <a:lnRef idx="2">
-                <a:schemeClr val="accent1">
-                  <a:shade val="50000"/>
-                </a:schemeClr>
-              </a:lnRef>
-              <a:fillRef idx="1">
-                <a:schemeClr val="accent1"/>
-              </a:fillRef>
-              <a:effectRef idx="0">
-                <a:schemeClr val="accent1"/>
-              </a:effectRef>
-              <a:fontRef idx="minor">
-                <a:schemeClr val="lt1"/>
-              </a:fontRef>
-            </p:style>
-            <p:txBody>
-              <a:bodyPr rtlCol="0" anchor="ctr"/>
-              <a:lstStyle/>
-              <a:p>
-                <a:pPr algn="ctr"/>
-                <a:endParaRPr lang="ko-KR" altLang="en-US" sz="2400">
-                  <a:solidFill>
-                    <a:schemeClr val="tx1"/>
-                  </a:solidFill>
-                  <a:latin typeface="나눔스퀘어 Bold" panose="020B0600000101010101" pitchFamily="50" charset="-127"/>
-                  <a:ea typeface="나눔스퀘어 Bold" panose="020B0600000101010101" pitchFamily="50" charset="-127"/>
-                </a:endParaRPr>
-              </a:p>
-            </p:txBody>
-          </p:sp>
-          <p:sp>
-            <p:nvSpPr>
-              <p:cNvPr id="73" name="직사각형 72"/>
-              <p:cNvSpPr>
-                <a:spLocks noChangeAspect="1"/>
-              </p:cNvSpPr>
-              <p:nvPr/>
-            </p:nvSpPr>
-            <p:spPr>
-              <a:xfrm>
-                <a:off x="8954279" y="4362086"/>
-                <a:ext cx="864000" cy="863891"/>
-              </a:xfrm>
-              <a:prstGeom prst="rect">
-                <a:avLst/>
-              </a:prstGeom>
-              <a:noFill/>
-              <a:ln w="19050">
-                <a:solidFill>
-                  <a:schemeClr val="tx1"/>
-                </a:solidFill>
-              </a:ln>
-            </p:spPr>
-            <p:style>
-              <a:lnRef idx="2">
-                <a:schemeClr val="accent1">
-                  <a:shade val="50000"/>
-                </a:schemeClr>
-              </a:lnRef>
-              <a:fillRef idx="1">
-                <a:schemeClr val="accent1"/>
-              </a:fillRef>
-              <a:effectRef idx="0">
-                <a:schemeClr val="accent1"/>
-              </a:effectRef>
-              <a:fontRef idx="minor">
-                <a:schemeClr val="lt1"/>
-              </a:fontRef>
-            </p:style>
-            <p:txBody>
-              <a:bodyPr rtlCol="0" anchor="ctr"/>
-              <a:lstStyle/>
-              <a:p>
-                <a:pPr algn="ctr"/>
-                <a:endParaRPr lang="ko-KR" altLang="en-US" sz="2400">
-                  <a:solidFill>
-                    <a:schemeClr val="tx1"/>
-                  </a:solidFill>
-                  <a:latin typeface="나눔스퀘어 Bold" panose="020B0600000101010101" pitchFamily="50" charset="-127"/>
-                  <a:ea typeface="나눔스퀘어 Bold" panose="020B0600000101010101" pitchFamily="50" charset="-127"/>
-                </a:endParaRPr>
-              </a:p>
-            </p:txBody>
-          </p:sp>
-          <p:sp>
-            <p:nvSpPr>
-              <p:cNvPr id="75" name="직사각형 74"/>
-              <p:cNvSpPr>
-                <a:spLocks noChangeAspect="1"/>
-              </p:cNvSpPr>
-              <p:nvPr/>
-            </p:nvSpPr>
-            <p:spPr>
-              <a:xfrm>
-                <a:off x="9818279" y="4362086"/>
-                <a:ext cx="864000" cy="863891"/>
-              </a:xfrm>
-              <a:prstGeom prst="rect">
-                <a:avLst/>
-              </a:prstGeom>
-              <a:noFill/>
-              <a:ln w="19050">
-                <a:solidFill>
-                  <a:schemeClr val="tx1"/>
-                </a:solidFill>
-              </a:ln>
-            </p:spPr>
-            <p:style>
-              <a:lnRef idx="2">
-                <a:schemeClr val="accent1">
-                  <a:shade val="50000"/>
-                </a:schemeClr>
-              </a:lnRef>
-              <a:fillRef idx="1">
-                <a:schemeClr val="accent1"/>
-              </a:fillRef>
-              <a:effectRef idx="0">
-                <a:schemeClr val="accent1"/>
-              </a:effectRef>
-              <a:fontRef idx="minor">
-                <a:schemeClr val="lt1"/>
-              </a:fontRef>
-            </p:style>
-            <p:txBody>
-              <a:bodyPr rtlCol="0" anchor="ctr"/>
-              <a:lstStyle/>
-              <a:p>
-                <a:pPr algn="ctr"/>
-                <a:endParaRPr lang="ko-KR" altLang="en-US" sz="2400">
-                  <a:solidFill>
-                    <a:schemeClr val="tx1"/>
-                  </a:solidFill>
-                  <a:latin typeface="나눔스퀘어 Bold" panose="020B0600000101010101" pitchFamily="50" charset="-127"/>
-                  <a:ea typeface="나눔스퀘어 Bold" panose="020B0600000101010101" pitchFamily="50" charset="-127"/>
-                </a:endParaRPr>
-              </a:p>
-            </p:txBody>
-          </p:sp>
-          <p:sp>
-            <p:nvSpPr>
-              <p:cNvPr id="77" name="직사각형 76"/>
-              <p:cNvSpPr>
-                <a:spLocks noChangeAspect="1"/>
-              </p:cNvSpPr>
-              <p:nvPr/>
-            </p:nvSpPr>
-            <p:spPr>
-              <a:xfrm>
-                <a:off x="10682278" y="4362086"/>
-                <a:ext cx="864000" cy="863891"/>
-              </a:xfrm>
-              <a:prstGeom prst="rect">
-                <a:avLst/>
-              </a:prstGeom>
-              <a:noFill/>
-              <a:ln w="19050">
-                <a:solidFill>
-                  <a:schemeClr val="tx1"/>
-                </a:solidFill>
-              </a:ln>
-            </p:spPr>
-            <p:style>
-              <a:lnRef idx="2">
-                <a:schemeClr val="accent1">
-                  <a:shade val="50000"/>
-                </a:schemeClr>
-              </a:lnRef>
-              <a:fillRef idx="1">
-                <a:schemeClr val="accent1"/>
-              </a:fillRef>
-              <a:effectRef idx="0">
-                <a:schemeClr val="accent1"/>
-              </a:effectRef>
-              <a:fontRef idx="minor">
-                <a:schemeClr val="lt1"/>
-              </a:fontRef>
-            </p:style>
-            <p:txBody>
-              <a:bodyPr rtlCol="0" anchor="ctr"/>
-              <a:lstStyle/>
-              <a:p>
-                <a:pPr algn="ctr"/>
-                <a:endParaRPr lang="ko-KR" altLang="en-US" sz="2400">
-                  <a:solidFill>
-                    <a:schemeClr val="tx1"/>
-                  </a:solidFill>
-                  <a:latin typeface="나눔스퀘어 Bold" panose="020B0600000101010101" pitchFamily="50" charset="-127"/>
-                  <a:ea typeface="나눔스퀘어 Bold" panose="020B0600000101010101" pitchFamily="50" charset="-127"/>
-                </a:endParaRPr>
-              </a:p>
-            </p:txBody>
-          </p:sp>
-          <p:sp>
-            <p:nvSpPr>
-              <p:cNvPr id="79" name="직사각형 78"/>
-              <p:cNvSpPr>
-                <a:spLocks noChangeAspect="1"/>
-              </p:cNvSpPr>
-              <p:nvPr/>
-            </p:nvSpPr>
-            <p:spPr>
-              <a:xfrm>
-                <a:off x="5498280" y="2634304"/>
-                <a:ext cx="864000" cy="863891"/>
-              </a:xfrm>
-              <a:prstGeom prst="rect">
-                <a:avLst/>
-              </a:prstGeom>
-              <a:noFill/>
-              <a:ln w="19050">
-                <a:solidFill>
-                  <a:schemeClr val="tx1"/>
-                </a:solidFill>
-              </a:ln>
-            </p:spPr>
-            <p:style>
-              <a:lnRef idx="2">
-                <a:schemeClr val="accent1">
-                  <a:shade val="50000"/>
-                </a:schemeClr>
-              </a:lnRef>
-              <a:fillRef idx="1">
-                <a:schemeClr val="accent1"/>
-              </a:fillRef>
-              <a:effectRef idx="0">
-                <a:schemeClr val="accent1"/>
-              </a:effectRef>
-              <a:fontRef idx="minor">
-                <a:schemeClr val="lt1"/>
-              </a:fontRef>
-            </p:style>
-            <p:txBody>
-              <a:bodyPr rtlCol="0" anchor="ctr"/>
-              <a:lstStyle/>
-              <a:p>
-                <a:pPr algn="ctr"/>
-                <a:endParaRPr lang="ko-KR" altLang="en-US" sz="2400">
-                  <a:solidFill>
-                    <a:schemeClr val="tx1"/>
-                  </a:solidFill>
-                  <a:latin typeface="나눔스퀘어 Bold" panose="020B0600000101010101" pitchFamily="50" charset="-127"/>
-                  <a:ea typeface="나눔스퀘어 Bold" panose="020B0600000101010101" pitchFamily="50" charset="-127"/>
-                </a:endParaRPr>
-              </a:p>
-            </p:txBody>
-          </p:sp>
-          <p:sp>
-            <p:nvSpPr>
-              <p:cNvPr id="80" name="직사각형 79"/>
-              <p:cNvSpPr>
-                <a:spLocks noChangeAspect="1"/>
-              </p:cNvSpPr>
-              <p:nvPr/>
-            </p:nvSpPr>
-            <p:spPr>
-              <a:xfrm>
-                <a:off x="6362279" y="2634304"/>
-                <a:ext cx="864000" cy="863891"/>
-              </a:xfrm>
-              <a:prstGeom prst="rect">
-                <a:avLst/>
-              </a:prstGeom>
-              <a:noFill/>
-              <a:ln w="19050">
-                <a:solidFill>
-                  <a:schemeClr val="tx1"/>
-                </a:solidFill>
-              </a:ln>
-            </p:spPr>
-            <p:style>
-              <a:lnRef idx="2">
-                <a:schemeClr val="accent1">
-                  <a:shade val="50000"/>
-                </a:schemeClr>
-              </a:lnRef>
-              <a:fillRef idx="1">
-                <a:schemeClr val="accent1"/>
-              </a:fillRef>
-              <a:effectRef idx="0">
-                <a:schemeClr val="accent1"/>
-              </a:effectRef>
-              <a:fontRef idx="minor">
-                <a:schemeClr val="lt1"/>
-              </a:fontRef>
-            </p:style>
-            <p:txBody>
-              <a:bodyPr rtlCol="0" anchor="ctr"/>
-              <a:lstStyle/>
-              <a:p>
-                <a:pPr algn="ctr"/>
-                <a:endParaRPr lang="ko-KR" altLang="en-US" sz="2400">
-                  <a:solidFill>
-                    <a:schemeClr val="tx1"/>
-                  </a:solidFill>
-                  <a:latin typeface="나눔스퀘어 Bold" panose="020B0600000101010101" pitchFamily="50" charset="-127"/>
-                  <a:ea typeface="나눔스퀘어 Bold" panose="020B0600000101010101" pitchFamily="50" charset="-127"/>
-                </a:endParaRPr>
-              </a:p>
-            </p:txBody>
-          </p:sp>
-          <p:sp>
-            <p:nvSpPr>
-              <p:cNvPr id="81" name="직사각형 80"/>
-              <p:cNvSpPr>
-                <a:spLocks noChangeAspect="1"/>
-              </p:cNvSpPr>
-              <p:nvPr/>
-            </p:nvSpPr>
-            <p:spPr>
-              <a:xfrm>
-                <a:off x="5498280" y="3498195"/>
-                <a:ext cx="864000" cy="863891"/>
-              </a:xfrm>
-              <a:prstGeom prst="rect">
-                <a:avLst/>
-              </a:prstGeom>
-              <a:noFill/>
-              <a:ln w="19050">
-                <a:solidFill>
-                  <a:schemeClr val="tx1"/>
-                </a:solidFill>
-              </a:ln>
-            </p:spPr>
-            <p:style>
-              <a:lnRef idx="2">
-                <a:schemeClr val="accent1">
-                  <a:shade val="50000"/>
-                </a:schemeClr>
-              </a:lnRef>
-              <a:fillRef idx="1">
-                <a:schemeClr val="accent1"/>
-              </a:fillRef>
-              <a:effectRef idx="0">
-                <a:schemeClr val="accent1"/>
-              </a:effectRef>
-              <a:fontRef idx="minor">
-                <a:schemeClr val="lt1"/>
-              </a:fontRef>
-            </p:style>
-            <p:txBody>
-              <a:bodyPr rtlCol="0" anchor="ctr"/>
-              <a:lstStyle/>
-              <a:p>
-                <a:pPr algn="ctr"/>
-                <a:endParaRPr lang="ko-KR" altLang="en-US" sz="2400">
-                  <a:solidFill>
-                    <a:schemeClr val="tx1"/>
-                  </a:solidFill>
-                  <a:latin typeface="나눔스퀘어 Bold" panose="020B0600000101010101" pitchFamily="50" charset="-127"/>
-                  <a:ea typeface="나눔스퀘어 Bold" panose="020B0600000101010101" pitchFamily="50" charset="-127"/>
-                </a:endParaRPr>
-              </a:p>
-            </p:txBody>
-          </p:sp>
-          <p:sp>
-            <p:nvSpPr>
-              <p:cNvPr id="82" name="직사각형 81"/>
-              <p:cNvSpPr>
-                <a:spLocks noChangeAspect="1"/>
-              </p:cNvSpPr>
-              <p:nvPr/>
-            </p:nvSpPr>
-            <p:spPr>
-              <a:xfrm>
-                <a:off x="6362279" y="3498195"/>
-                <a:ext cx="864000" cy="863891"/>
-              </a:xfrm>
-              <a:prstGeom prst="rect">
-                <a:avLst/>
-              </a:prstGeom>
-              <a:noFill/>
-              <a:ln w="19050">
-                <a:solidFill>
-                  <a:schemeClr val="tx1"/>
-                </a:solidFill>
-              </a:ln>
-            </p:spPr>
-            <p:style>
-              <a:lnRef idx="2">
-                <a:schemeClr val="accent1">
-                  <a:shade val="50000"/>
-                </a:schemeClr>
-              </a:lnRef>
-              <a:fillRef idx="1">
-                <a:schemeClr val="accent1"/>
-              </a:fillRef>
-              <a:effectRef idx="0">
-                <a:schemeClr val="accent1"/>
-              </a:effectRef>
-              <a:fontRef idx="minor">
-                <a:schemeClr val="lt1"/>
-              </a:fontRef>
-            </p:style>
-            <p:txBody>
-              <a:bodyPr rtlCol="0" anchor="ctr"/>
-              <a:lstStyle/>
-              <a:p>
-                <a:pPr algn="ctr"/>
-                <a:r>
-                  <a:rPr lang="en-US" altLang="ko-KR" sz="2400" dirty="0" err="1">
-                    <a:solidFill>
-                      <a:schemeClr val="tx1"/>
-                    </a:solidFill>
-                    <a:latin typeface="나눔스퀘어 Bold" panose="020B0600000101010101" pitchFamily="50" charset="-127"/>
-                    <a:ea typeface="나눔스퀘어 Bold" panose="020B0600000101010101" pitchFamily="50" charset="-127"/>
-                  </a:rPr>
-                  <a:t>H</a:t>
-                </a:r>
-                <a:endParaRPr lang="ko-KR" altLang="en-US" sz="2400" dirty="0">
-                  <a:solidFill>
-                    <a:schemeClr val="tx1"/>
-                  </a:solidFill>
-                  <a:latin typeface="나눔스퀘어 Bold" panose="020B0600000101010101" pitchFamily="50" charset="-127"/>
-                  <a:ea typeface="나눔스퀘어 Bold" panose="020B0600000101010101" pitchFamily="50" charset="-127"/>
-                </a:endParaRPr>
-              </a:p>
-            </p:txBody>
-          </p:sp>
-          <p:sp>
-            <p:nvSpPr>
-              <p:cNvPr id="83" name="직사각형 82"/>
-              <p:cNvSpPr>
-                <a:spLocks noChangeAspect="1"/>
-              </p:cNvSpPr>
-              <p:nvPr/>
-            </p:nvSpPr>
-            <p:spPr>
-              <a:xfrm>
-                <a:off x="5498280" y="4362082"/>
-                <a:ext cx="864000" cy="863891"/>
-              </a:xfrm>
-              <a:prstGeom prst="rect">
-                <a:avLst/>
-              </a:prstGeom>
-              <a:noFill/>
-              <a:ln w="19050">
-                <a:solidFill>
-                  <a:schemeClr val="tx1"/>
-                </a:solidFill>
-              </a:ln>
-            </p:spPr>
-            <p:style>
-              <a:lnRef idx="2">
-                <a:schemeClr val="accent1">
-                  <a:shade val="50000"/>
-                </a:schemeClr>
-              </a:lnRef>
-              <a:fillRef idx="1">
-                <a:schemeClr val="accent1"/>
-              </a:fillRef>
-              <a:effectRef idx="0">
-                <a:schemeClr val="accent1"/>
-              </a:effectRef>
-              <a:fontRef idx="minor">
-                <a:schemeClr val="lt1"/>
-              </a:fontRef>
-            </p:style>
-            <p:txBody>
-              <a:bodyPr rtlCol="0" anchor="ctr"/>
-              <a:lstStyle/>
-              <a:p>
-                <a:pPr algn="ctr"/>
-                <a:endParaRPr lang="ko-KR" altLang="en-US" sz="2400">
-                  <a:solidFill>
-                    <a:schemeClr val="tx1"/>
-                  </a:solidFill>
-                  <a:latin typeface="나눔스퀘어 Bold" panose="020B0600000101010101" pitchFamily="50" charset="-127"/>
-                  <a:ea typeface="나눔스퀘어 Bold" panose="020B0600000101010101" pitchFamily="50" charset="-127"/>
-                </a:endParaRPr>
-              </a:p>
-            </p:txBody>
-          </p:sp>
-          <p:sp>
-            <p:nvSpPr>
-              <p:cNvPr id="84" name="직사각형 83"/>
-              <p:cNvSpPr>
-                <a:spLocks noChangeAspect="1"/>
-              </p:cNvSpPr>
-              <p:nvPr/>
-            </p:nvSpPr>
-            <p:spPr>
-              <a:xfrm>
-                <a:off x="6362279" y="4362082"/>
-                <a:ext cx="864000" cy="863891"/>
-              </a:xfrm>
-              <a:prstGeom prst="rect">
-                <a:avLst/>
-              </a:prstGeom>
-              <a:noFill/>
-              <a:ln w="19050">
-                <a:solidFill>
-                  <a:schemeClr val="tx1"/>
-                </a:solidFill>
-              </a:ln>
-            </p:spPr>
-            <p:style>
-              <a:lnRef idx="2">
-                <a:schemeClr val="accent1">
-                  <a:shade val="50000"/>
-                </a:schemeClr>
-              </a:lnRef>
-              <a:fillRef idx="1">
-                <a:schemeClr val="accent1"/>
-              </a:fillRef>
-              <a:effectRef idx="0">
-                <a:schemeClr val="accent1"/>
-              </a:effectRef>
-              <a:fontRef idx="minor">
-                <a:schemeClr val="lt1"/>
-              </a:fontRef>
-            </p:style>
-            <p:txBody>
-              <a:bodyPr rtlCol="0" anchor="ctr"/>
-              <a:lstStyle/>
-              <a:p>
-                <a:pPr algn="ctr"/>
-                <a:endParaRPr lang="ko-KR" altLang="en-US" sz="2400">
-                  <a:solidFill>
-                    <a:schemeClr val="tx1"/>
-                  </a:solidFill>
-                  <a:latin typeface="나눔스퀘어 Bold" panose="020B0600000101010101" pitchFamily="50" charset="-127"/>
-                  <a:ea typeface="나눔스퀘어 Bold" panose="020B0600000101010101" pitchFamily="50" charset="-127"/>
-                </a:endParaRPr>
-              </a:p>
-            </p:txBody>
-          </p:sp>
-        </p:grpSp>
-        <p:sp>
-          <p:nvSpPr>
-            <p:cNvPr id="35" name="직사각형 34"/>
-            <p:cNvSpPr/>
-            <p:nvPr/>
-          </p:nvSpPr>
-          <p:spPr>
-            <a:xfrm>
-              <a:off x="3205035" y="3422306"/>
-              <a:ext cx="4522872" cy="1015659"/>
-            </a:xfrm>
-            <a:prstGeom prst="rect">
-              <a:avLst/>
-            </a:prstGeom>
-            <a:noFill/>
-            <a:ln w="57150">
-              <a:solidFill>
-                <a:srgbClr val="FF0000"/>
-              </a:solidFill>
-            </a:ln>
-          </p:spPr>
-          <p:style>
-            <a:lnRef idx="2">
-              <a:schemeClr val="accent1">
-                <a:shade val="50000"/>
-              </a:schemeClr>
-            </a:lnRef>
-            <a:fillRef idx="1">
-              <a:schemeClr val="accent1"/>
-            </a:fillRef>
-            <a:effectRef idx="0">
-              <a:schemeClr val="accent1"/>
-            </a:effectRef>
-            <a:fontRef idx="minor">
-              <a:schemeClr val="lt1"/>
-            </a:fontRef>
-          </p:style>
-          <p:txBody>
-            <a:bodyPr rtlCol="0" anchor="ctr"/>
-            <a:lstStyle/>
-            <a:p>
-              <a:pPr algn="ctr"/>
-              <a:endParaRPr lang="ko-KR" altLang="en-US"/>
-            </a:p>
-          </p:txBody>
-        </p:sp>
-        <p:sp>
-          <p:nvSpPr>
-            <p:cNvPr id="42" name="모서리가 둥근 직사각형 41"/>
-            <p:cNvSpPr/>
-            <p:nvPr/>
-          </p:nvSpPr>
-          <p:spPr>
-            <a:xfrm>
-              <a:off x="4746471" y="3091095"/>
-              <a:ext cx="1440000" cy="540000"/>
-            </a:xfrm>
-            <a:prstGeom prst="roundRect">
-              <a:avLst/>
-            </a:prstGeom>
-            <a:solidFill>
-              <a:schemeClr val="bg2">
-                <a:lumMod val="90000"/>
-              </a:schemeClr>
-            </a:solidFill>
-            <a:ln>
-              <a:noFill/>
-            </a:ln>
-          </p:spPr>
-          <p:style>
-            <a:lnRef idx="2">
-              <a:schemeClr val="accent1">
-                <a:shade val="50000"/>
-              </a:schemeClr>
-            </a:lnRef>
-            <a:fillRef idx="1">
-              <a:schemeClr val="accent1"/>
-            </a:fillRef>
-            <a:effectRef idx="0">
-              <a:schemeClr val="accent1"/>
-            </a:effectRef>
-            <a:fontRef idx="minor">
-              <a:schemeClr val="lt1"/>
-            </a:fontRef>
-          </p:style>
-          <p:txBody>
-            <a:bodyPr rtlCol="0" anchor="ctr"/>
-            <a:lstStyle/>
-            <a:p>
-              <a:pPr algn="ctr"/>
-              <a:r>
-                <a:rPr lang="en-US" altLang="ko-KR" sz="2800" dirty="0" smtClean="0">
-                  <a:solidFill>
-                    <a:schemeClr val="tx1"/>
-                  </a:solidFill>
-                  <a:latin typeface="나눔스퀘어 Bold" panose="020B0600000101010101" pitchFamily="50" charset="-127"/>
-                  <a:ea typeface="나눔스퀘어 Bold" panose="020B0600000101010101" pitchFamily="50" charset="-127"/>
-                </a:rPr>
-                <a:t>“Hello”</a:t>
-              </a:r>
-              <a:endParaRPr lang="ko-KR" altLang="en-US" sz="2800" dirty="0">
-                <a:solidFill>
-                  <a:schemeClr val="tx1"/>
-                </a:solidFill>
-                <a:latin typeface="나눔스퀘어 Bold" panose="020B0600000101010101" pitchFamily="50" charset="-127"/>
-                <a:ea typeface="나눔스퀘어 Bold" panose="020B0600000101010101" pitchFamily="50" charset="-127"/>
-              </a:endParaRPr>
-            </a:p>
-          </p:txBody>
-        </p:sp>
-      </p:grpSp>
+      <p:graphicFrame>
+        <p:nvGraphicFramePr>
+          <p:cNvPr id="13" name="개체 12"/>
+          <p:cNvGraphicFramePr>
+            <a:graphicFrameLocks noChangeAspect="1"/>
+          </p:cNvGraphicFramePr>
+          <p:nvPr>
+            <p:extLst>
+              <p:ext uri="{D42A27DB-BD31-4B8C-83A1-F6EECF244321}">
+                <p14:modId xmlns:p14="http://schemas.microsoft.com/office/powerpoint/2010/main" val="3555952625"/>
+              </p:ext>
+            </p:extLst>
+          </p:nvPr>
+        </p:nvGraphicFramePr>
+        <p:xfrm>
+          <a:off x="2573338" y="719138"/>
+          <a:ext cx="7043737" cy="5418137"/>
+        </p:xfrm>
+        <a:graphic>
+          <a:graphicData uri="http://schemas.openxmlformats.org/presentationml/2006/ole">
+            <mc:AlternateContent xmlns:mc="http://schemas.openxmlformats.org/markup-compatibility/2006">
+              <mc:Choice xmlns:v="urn:schemas-microsoft-com:vml" Requires="v">
+                <p:oleObj spid="_x0000_s1028" name="워크시트" r:id="rId3" imgW="22637898" imgH="17411877" progId="Excel.Sheet.12">
+                  <p:embed/>
+                </p:oleObj>
+              </mc:Choice>
+              <mc:Fallback>
+                <p:oleObj name="워크시트" r:id="rId3" imgW="22637898" imgH="17411877" progId="Excel.Sheet.12">
+                  <p:embed/>
+                  <p:pic>
+                    <p:nvPicPr>
+                      <p:cNvPr id="0" name=""/>
+                      <p:cNvPicPr/>
+                      <p:nvPr/>
+                    </p:nvPicPr>
+                    <p:blipFill>
+                      <a:blip r:embed="rId4"/>
+                      <a:stretch>
+                        <a:fillRect/>
+                      </a:stretch>
+                    </p:blipFill>
+                    <p:spPr>
+                      <a:xfrm>
+                        <a:off x="2573338" y="719138"/>
+                        <a:ext cx="7043737" cy="5418137"/>
+                      </a:xfrm>
+                      <a:prstGeom prst="rect">
+                        <a:avLst/>
+                      </a:prstGeom>
+                    </p:spPr>
+                  </p:pic>
+                </p:oleObj>
+              </mc:Fallback>
+            </mc:AlternateContent>
+          </a:graphicData>
+        </a:graphic>
+      </p:graphicFrame>
     </p:spTree>
     <p:extLst>
       <p:ext uri="{BB962C8B-B14F-4D97-AF65-F5344CB8AC3E}">

</xml_diff>